<commit_message>
chore: daily content 2026-10-11
</commit_message>
<xml_diff>
--- a/pwa/data/latest/slides.pptx
+++ b/pwa/data/latest/slides.pptx
@@ -4143,7 +4143,7 @@
                 </a:solidFill>
                 <a:latin typeface="Arial"/>
               </a:rPr>
-              <a:t>2026 Oct 8  |  매일 아침 탈모 연구 한 편</a:t>
+              <a:t>2026 Oct 9  |  매일 아침 탈모 연구 한 편</a:t>
             </a:r>
           </a:p>
         </p:txBody>
@@ -4263,7 +4263,7 @@
                 </a:solidFill>
                 <a:latin typeface="Arial"/>
               </a:rPr>
-              <a:t>Clinics in dermatology  ·  2026 Oct 8</a:t>
+              <a:t>Clinics in dermatology  ·  2026 Oct 9</a:t>
             </a:r>
           </a:p>
         </p:txBody>
@@ -4913,7 +4913,7 @@
                 </a:solidFill>
                 <a:latin typeface="Arial"/>
               </a:rPr>
-              <a:t>· Recent policy changes have tightened restrictions on shaving waivers and may create career consequences for service members who still require accommodations despite treatment.
+              <a:t>· Recent policy changes have placed greater restrictions on shaving waivers and may create career consequences for service members who continue to require accommodations despite treatment.
 · These policies raise ethical concerns involving justice, beneficence, nonmaleficence, and autonomy.
 · Military safety requirements related to protective equipment must be balanced against the clinical needs of patients with PFB.
 · Laser hair removal may provide meaningful benefit but can recur, permanently alter facial hair growth, and carry additional risks depending on skin type, device selection, and treatment setting.
@@ -5016,7 +5016,7 @@
               <a:t>[출처]
 논문: Military shaving waivers for pseudofolliculitis barbae: Ethical considerations for dermatologists
 게재: Clinics in dermatology
-원문: https://pubmed.ncbi.nlm.nih.gov/42849858/
+원문: https://pubmed.ncbi.nlm.nih.gov/42854877/
 [이미지 출처]
 - Male pattern baldness.jpg / Originally uploaded by Lkinkade (Transferred by XenonX3) / CC BY-SA 2.5
   https://commons.wikimedia.org/wiki/File:Male_pattern_baldness.jpg

</xml_diff>

<commit_message>
chore: daily content 2026-10-12
</commit_message>
<xml_diff>
--- a/pwa/data/latest/slides.pptx
+++ b/pwa/data/latest/slides.pptx
@@ -13,6 +13,8 @@
     <p:sldId id="261" r:id="rId13"/>
     <p:sldId id="262" r:id="rId14"/>
     <p:sldId id="263" r:id="rId15"/>
+    <p:sldId id="264" r:id="rId16"/>
+    <p:sldId id="265" r:id="rId17"/>
   </p:sldIdLst>
   <p:sldSz cx="5559552" cy="9875520" type="screen4x3"/>
   <p:notesSz cx="6858000" cy="9144000"/>
@@ -514,7 +516,7 @@
           </a:p>
           <a:p>
             <a:r>
-              <a:t>대본: 오늘의 논문 Clinics in dermatology에 실린 새 연구입니다</a:t>
+              <a:t>대본: 50% 이 숫자, 탈모 연구가 새로 내놨습니다</a:t>
             </a:r>
           </a:p>
           <a:p>
@@ -594,7 +596,7 @@
           </a:p>
           <a:p>
             <a:r>
-              <a:t>대본: 《Clinics in dermatology》 - Military shaving waivers for pseudofolliculitis barbae: Ethical considerations for dermatologists</a:t>
+              <a:t>대본: 《Dermatology research and practice》 - Double Challenges for Scalp Health: A Review of the Pathogenesis and Treatment Strategies of Coexistence of Seborrheic Dermatitis and Androgenetic Alopecia</a:t>
             </a:r>
           </a:p>
           <a:p>
@@ -674,7 +676,7 @@
           </a:p>
           <a:p>
             <a:r>
-              <a:t>대본: Pseudofolliculitis barbae (PFB) is a chronic inflammatory disorder triggered by shaving and disproportionately affects individuals of African descent.</a:t>
+              <a:t>대본: Androgenetic alopecia (AGA) and seborrheic dermatitis (SD) are two common scalp disorders that frequently impair the quality of life and may coexist in a subset of patients across all genders.</a:t>
             </a:r>
           </a:p>
           <a:p>
@@ -754,7 +756,7 @@
           </a:p>
           <a:p>
             <a:r>
-              <a:t>대본: For service members, medically appropriate management may conflict with military grooming standards requiring a clean-shaven appearance.</a:t>
+              <a:t>대본: SD presents in 40%-50% of all patients diagnosed with AGA.</a:t>
             </a:r>
           </a:p>
           <a:p>
@@ -945,6 +947,156 @@
 </file>
 
 <file path=ppt/notesSlides/notesSlide7.xml><?xml version="1.0" encoding="utf-8"?>
+<p:notes xmlns:a="http://schemas.openxmlformats.org/drawingml/2006/main" xmlns:p="http://schemas.openxmlformats.org/presentationml/2006/main" xmlns:r="http://schemas.openxmlformats.org/officeDocument/2006/relationships">
+  <p:cSld>
+    <p:spTree>
+      <p:nvGrpSpPr>
+        <p:cNvPr id="1" name=""/>
+        <p:cNvGrpSpPr/>
+        <p:nvPr/>
+      </p:nvGrpSpPr>
+      <p:grpSpPr>
+        <a:xfrm>
+          <a:off x="0" y="0"/>
+          <a:ext cx="0" cy="0"/>
+          <a:chOff x="0" y="0"/>
+          <a:chExt cx="0" cy="0"/>
+        </a:xfrm>
+      </p:grpSpPr>
+      <p:sp>
+        <p:nvSpPr>
+          <p:cNvPr id="2" name="Slide Image Placeholder 1"/>
+          <p:cNvSpPr>
+            <a:spLocks noGrp="1"/>
+          </p:cNvSpPr>
+          <p:nvPr>
+            <p:ph type="sldImg" idx="2"/>
+          </p:nvPr>
+        </p:nvSpPr>
+        <p:spPr/>
+      </p:sp>
+      <p:sp>
+        <p:nvSpPr>
+          <p:cNvPr id="3" name="Notes Placeholder 2"/>
+          <p:cNvSpPr>
+            <a:spLocks noGrp="1"/>
+          </p:cNvSpPr>
+          <p:nvPr>
+            <p:ph type="body" idx="3" sz="quarter"/>
+          </p:nvPr>
+        </p:nvSpPr>
+        <p:spPr/>
+        <p:txBody>
+          <a:bodyPr/>
+          <a:lstStyle/>
+          <a:p>
+            <a:r>
+              <a:t>편집 참고용 슬라이드입니다. 영상에는 쓰지 않아도 됩니다.</a:t>
+            </a:r>
+          </a:p>
+          <a:p>
+            <a:r>
+              <a:t>원문 영어 문장을 그대로 발췌했으므로 번역·검수 후 사용하세요.</a:t>
+            </a:r>
+          </a:p>
+        </p:txBody>
+      </p:sp>
+      <p:sp>
+        <p:nvSpPr>
+          <p:cNvPr id="4" name="Slide Number Placeholder 3"/>
+          <p:cNvSpPr>
+            <a:spLocks noGrp="1"/>
+          </p:cNvSpPr>
+          <p:nvPr>
+            <p:ph type="sldNum" idx="5" sz="quarter"/>
+          </p:nvPr>
+        </p:nvSpPr>
+        <p:spPr/>
+      </p:sp>
+    </p:spTree>
+  </p:cSld>
+  <p:clrMapOvr>
+    <a:masterClrMapping/>
+  </p:clrMapOvr>
+</p:notes>
+</file>
+
+<file path=ppt/notesSlides/notesSlide8.xml><?xml version="1.0" encoding="utf-8"?>
+<p:notes xmlns:a="http://schemas.openxmlformats.org/drawingml/2006/main" xmlns:p="http://schemas.openxmlformats.org/presentationml/2006/main" xmlns:r="http://schemas.openxmlformats.org/officeDocument/2006/relationships">
+  <p:cSld>
+    <p:spTree>
+      <p:nvGrpSpPr>
+        <p:cNvPr id="1" name=""/>
+        <p:cNvGrpSpPr/>
+        <p:nvPr/>
+      </p:nvGrpSpPr>
+      <p:grpSpPr>
+        <a:xfrm>
+          <a:off x="0" y="0"/>
+          <a:ext cx="0" cy="0"/>
+          <a:chOff x="0" y="0"/>
+          <a:chExt cx="0" cy="0"/>
+        </a:xfrm>
+      </p:grpSpPr>
+      <p:sp>
+        <p:nvSpPr>
+          <p:cNvPr id="2" name="Slide Image Placeholder 1"/>
+          <p:cNvSpPr>
+            <a:spLocks noGrp="1"/>
+          </p:cNvSpPr>
+          <p:nvPr>
+            <p:ph type="sldImg" idx="2"/>
+          </p:nvPr>
+        </p:nvSpPr>
+        <p:spPr/>
+      </p:sp>
+      <p:sp>
+        <p:nvSpPr>
+          <p:cNvPr id="3" name="Notes Placeholder 2"/>
+          <p:cNvSpPr>
+            <a:spLocks noGrp="1"/>
+          </p:cNvSpPr>
+          <p:nvPr>
+            <p:ph type="body" idx="3" sz="quarter"/>
+          </p:nvPr>
+        </p:nvSpPr>
+        <p:spPr/>
+        <p:txBody>
+          <a:bodyPr/>
+          <a:lstStyle/>
+          <a:p>
+            <a:r>
+              <a:t>편집 참고용 슬라이드입니다. 영상에는 쓰지 않아도 됩니다.</a:t>
+            </a:r>
+          </a:p>
+          <a:p>
+            <a:r>
+              <a:t>원문 영어 문장을 그대로 발췌했으므로 번역·검수 후 사용하세요.</a:t>
+            </a:r>
+          </a:p>
+        </p:txBody>
+      </p:sp>
+      <p:sp>
+        <p:nvSpPr>
+          <p:cNvPr id="4" name="Slide Number Placeholder 3"/>
+          <p:cNvSpPr>
+            <a:spLocks noGrp="1"/>
+          </p:cNvSpPr>
+          <p:nvPr>
+            <p:ph type="sldNum" idx="5" sz="quarter"/>
+          </p:nvPr>
+        </p:nvSpPr>
+        <p:spPr/>
+      </p:sp>
+    </p:spTree>
+  </p:cSld>
+  <p:clrMapOvr>
+    <a:masterClrMapping/>
+  </p:clrMapOvr>
+</p:notes>
+</file>
+
+<file path=ppt/notesSlides/notesSlide9.xml><?xml version="1.0" encoding="utf-8"?>
 <p:notes xmlns:a="http://schemas.openxmlformats.org/drawingml/2006/main" xmlns:p="http://schemas.openxmlformats.org/presentationml/2006/main" xmlns:r="http://schemas.openxmlformats.org/officeDocument/2006/relationships">
   <p:cSld>
     <p:spTree>
@@ -4038,7 +4190,7 @@
                 </a:solidFill>
                 <a:latin typeface="Arial"/>
               </a:rPr>
-              <a:t>CLINICS IN DERMATOLOGY</a:t>
+              <a:t>DERMATOLOGY RESEARCH AND PRACTICE</a:t>
             </a:r>
           </a:p>
         </p:txBody>
@@ -4073,7 +4225,7 @@
                 </a:solidFill>
                 <a:latin typeface="Arial"/>
               </a:rPr>
-              <a:t>오늘의 논문</a:t>
+              <a:t>50%</a:t>
             </a:r>
           </a:p>
         </p:txBody>
@@ -4108,7 +4260,7 @@
                 </a:solidFill>
                 <a:latin typeface="Arial"/>
               </a:rPr>
-              <a:t>Clinics in dermatology에 실린 새 연구입니다</a:t>
+              <a:t>이 숫자, 탈모 연구가 새로 내놨습니다</a:t>
             </a:r>
           </a:p>
         </p:txBody>
@@ -4143,7 +4295,119 @@
                 </a:solidFill>
                 <a:latin typeface="Arial"/>
               </a:rPr>
-              <a:t>2026 Oct 9  |  매일 아침 탈모 연구 한 편</a:t>
+              <a:t>2026  |  매일 아침 탈모 연구 한 편</a:t>
+            </a:r>
+          </a:p>
+        </p:txBody>
+      </p:sp>
+    </p:spTree>
+  </p:cSld>
+  <p:clrMapOvr>
+    <a:masterClrMapping/>
+  </p:clrMapOvr>
+</p:sld>
+</file>
+
+<file path=ppt/slides/slide10.xml><?xml version="1.0" encoding="utf-8"?>
+<p:sld xmlns:a="http://schemas.openxmlformats.org/drawingml/2006/main" xmlns:p="http://schemas.openxmlformats.org/presentationml/2006/main" xmlns:r="http://schemas.openxmlformats.org/officeDocument/2006/relationships">
+  <p:cSld>
+    <p:bg>
+      <p:bgPr>
+        <a:solidFill>
+          <a:srgbClr val="12142A"/>
+        </a:solidFill>
+        <a:effectLst/>
+      </p:bgPr>
+    </p:bg>
+    <p:spTree>
+      <p:nvGrpSpPr>
+        <p:cNvPr id="1" name=""/>
+        <p:cNvGrpSpPr/>
+        <p:nvPr/>
+      </p:nvGrpSpPr>
+      <p:grpSpPr/>
+      <p:sp>
+        <p:nvSpPr>
+          <p:cNvPr id="2" name="TextBox 1"/>
+          <p:cNvSpPr txBox="1"/>
+          <p:nvPr/>
+        </p:nvSpPr>
+        <p:spPr>
+          <a:xfrm>
+            <a:off x="365760" y="731520"/>
+            <a:ext cx="4828032" cy="548640"/>
+          </a:xfrm>
+          <a:prstGeom prst="rect">
+            <a:avLst/>
+          </a:prstGeom>
+          <a:noFill/>
+        </p:spPr>
+        <p:txBody>
+          <a:bodyPr wrap="square" anchor="ctr">
+            <a:spAutoFit/>
+          </a:bodyPr>
+          <a:lstStyle/>
+          <a:p>
+            <a:pPr algn="ctr"/>
+            <a:r>
+              <a:rPr sz="2200" b="1">
+                <a:solidFill>
+                  <a:srgbClr val="FF6B6B"/>
+                </a:solidFill>
+                <a:latin typeface="Arial"/>
+              </a:rPr>
+              <a:t>출처</a:t>
+            </a:r>
+          </a:p>
+        </p:txBody>
+      </p:sp>
+      <p:sp>
+        <p:nvSpPr>
+          <p:cNvPr id="3" name="TextBox 2"/>
+          <p:cNvSpPr txBox="1"/>
+          <p:nvPr/>
+        </p:nvSpPr>
+        <p:spPr>
+          <a:xfrm>
+            <a:off x="365760" y="1463040"/>
+            <a:ext cx="4828032" cy="7680960"/>
+          </a:xfrm>
+          <a:prstGeom prst="rect">
+            <a:avLst/>
+          </a:prstGeom>
+          <a:noFill/>
+        </p:spPr>
+        <p:txBody>
+          <a:bodyPr wrap="square" anchor="t">
+            <a:spAutoFit/>
+          </a:bodyPr>
+          <a:lstStyle/>
+          <a:p>
+            <a:pPr algn="l"/>
+            <a:r>
+              <a:rPr sz="1000" b="0">
+                <a:solidFill>
+                  <a:srgbClr val="D5D8EA"/>
+                </a:solidFill>
+                <a:latin typeface="Arial"/>
+              </a:rPr>
+              <a:t>[출처]
+논문: Double Challenges for Scalp Health: A Review of the Pathogenesis and Treatment Strategies of Coexistence of Seborrheic Dermatitis and Androgenetic Alopecia
+게재: Dermatology research and practice
+원문: https://pubmed.ncbi.nlm.nih.gov/42857554/
+[이미지 출처]
+- Male pattern baldness.jpg / Originally uploaded by Lkinkade (Transferred by XenonX3) / CC BY-SA 2.5
+  https://commons.wikimedia.org/wiki/File:Male_pattern_baldness.jpg
+- Male-pattern hair loss.jpg / BlaiserPascal / CC BY-SA 4.0
+  https://commons.wikimedia.org/wiki/File:Male-pattern_hair_loss.jpg
+※ CC BY-SA 이미지가 포함되어 있습니다. 저작자 표시가 필수이며,
+  동일조건변경허락(ShareAlike) 조항이 영상 전체에 적용될 수 있으니
+  상업적 이용 시 해당 이미지를 교체하는 편이 안전합니다.
+[논문 본문 그림·표]
+- PubMed Central PMC13650735 (재사용 가능 라이선스)
+  https://www.ncbi.nlm.nih.gov/pmc/articles/PMC13650735/
+  ※ 오픈액세스 논문의 그림·표이며, 위 원문 출처를 함께 표기하세요.
+</a:t>
             </a:r>
           </a:p>
         </p:txBody>
@@ -4228,7 +4492,7 @@
                 </a:solidFill>
                 <a:latin typeface="Arial"/>
               </a:rPr>
-              <a:t>Military shaving waivers for pseudofolliculitis barbae: Ethical considerations for dermatologists</a:t>
+              <a:t>Double Challenges for Scalp Health: A Review of the Pathogenesis and Treatment Strategies of Coexistence of Seborrheic Dermatitis and Androgenetic Alopecia</a:t>
             </a:r>
           </a:p>
         </p:txBody>
@@ -4263,7 +4527,7 @@
                 </a:solidFill>
                 <a:latin typeface="Arial"/>
               </a:rPr>
-              <a:t>Clinics in dermatology  ·  2026 Oct 9</a:t>
+              <a:t>Dermatology research and practice  ·  2026</a:t>
             </a:r>
           </a:p>
         </p:txBody>
@@ -4392,7 +4656,7 @@
                 </a:solidFill>
                 <a:latin typeface="Arial"/>
               </a:rPr>
-              <a:t>Pseudofolliculitis barbae (PFB) is a chronic inflammatory disorder triggered by shaving and disproportionately affects individuals of African descent.</a:t>
+              <a:t>Androgenetic alopecia (AGA) and seborrheic dermatitis (SD) are two common scalp disorders that frequently impair the quality of life and may coexist in a subset of patients across all genders.</a:t>
             </a:r>
           </a:p>
         </p:txBody>
@@ -4521,7 +4785,7 @@
                 </a:solidFill>
                 <a:latin typeface="Arial"/>
               </a:rPr>
-              <a:t>For service members, medically appropriate management may conflict with military grooming standards requiring a clean-shaven appearance.</a:t>
+              <a:t>SD presents in 40%-50% of all patients diagnosed with AGA.</a:t>
             </a:r>
           </a:p>
         </p:txBody>
@@ -4807,7 +5071,7 @@
                 </a:solidFill>
                 <a:latin typeface="Arial"/>
               </a:rPr>
-              <a:t>◆ 배경 — Background (자동 구분)</a:t>
+              <a:t>◆ 배경 — 1. Introduction</a:t>
             </a:r>
           </a:p>
         </p:txBody>
@@ -4842,8 +5106,9 @@
                 </a:solidFill>
                 <a:latin typeface="Arial"/>
               </a:rPr>
-              <a:t>· Pseudofolliculitis barbae (PFB) is a chronic inflammatory disorder triggered by shaving and disproportionately affects individuals of African descent.
-· For service members, medically appropriate management may conflict with military grooming standards requiring a clean-shaven appearance.</a:t>
+              <a:t>· Seborrheic dermatitis (SD) is a common, recurrent, chronic inflammatory skin disease that predominantly affects sebaceous gland‐rich areas, particularly the scalp, and is characterized by yellow‐red patches covered with greasy, yellowish scales or crusts and varying degrees of pruritus.
+· Androgenetic alopecia (AGA), formerly known as seborrheic alopecia, is a progressive androgen‐dependent disorder characterized by hair follicle miniaturization with a typical patterned distribution.
+· Although SD and AGA are distinct conditions, both exhibit high prevalence and incidence rates, with a predilection for young adults and older men.</a:t>
             </a:r>
           </a:p>
         </p:txBody>
@@ -4878,7 +5143,7 @@
                 </a:solidFill>
                 <a:latin typeface="Arial"/>
               </a:rPr>
-              <a:t>◆ 주요 결과 — Results (자동 구분)</a:t>
+              <a:t>◆ 그 밖의 내용 — 2. Clinical and Epidemiological Overlap Between SD and AGA</a:t>
             </a:r>
           </a:p>
         </p:txBody>
@@ -4913,11 +5178,8 @@
                 </a:solidFill>
                 <a:latin typeface="Arial"/>
               </a:rPr>
-              <a:t>· Recent policy changes have placed greater restrictions on shaving waivers and may create career consequences for service members who continue to require accommodations despite treatment.
-· These policies raise ethical concerns involving justice, beneficence, nonmaleficence, and autonomy.
-· Military safety requirements related to protective equipment must be balanced against the clinical needs of patients with PFB.
-· Laser hair removal may provide meaningful benefit but can recur, permanently alter facial hair growth, and carry additional risks depending on skin type, device selection, and treatment setting.
-· Dermatologists should provide accurate medical assessments, support medically necessary accommodations, and use shared decision-making so that treatment remains guided by clinical need and patient preference rather than institutional pressure.</a:t>
+              <a:t>· In a study by Jang et al. involving 1218 patients with AGA, SD was the most common concomitant disease in both sexes, with a prevalence of 51.2% in men and 45.7% in women.
+· Another study reported an SD prevalence of 42.1% among patients with AGA, with both prevalence and severity scores increasing in parallel with AGA severity.</a:t>
             </a:r>
           </a:p>
         </p:txBody>
@@ -4956,8 +5218,8 @@
         </p:nvSpPr>
         <p:spPr>
           <a:xfrm>
-            <a:off x="365760" y="731520"/>
-            <a:ext cx="4828032" cy="548640"/>
+            <a:off x="365760" y="457200"/>
+            <a:ext cx="4828032" cy="457200"/>
           </a:xfrm>
           <a:prstGeom prst="rect">
             <a:avLst/>
@@ -4970,15 +5232,15 @@
           </a:bodyPr>
           <a:lstStyle/>
           <a:p>
-            <a:pPr algn="ctr"/>
-            <a:r>
-              <a:rPr sz="2200" b="1">
+            <a:pPr algn="l"/>
+            <a:r>
+              <a:rPr sz="1600" b="1">
                 <a:solidFill>
                   <a:srgbClr val="FF6B6B"/>
                 </a:solidFill>
                 <a:latin typeface="Arial"/>
               </a:rPr>
-              <a:t>출처</a:t>
+              <a:t>본문 요약 (편집용)</a:t>
             </a:r>
           </a:p>
         </p:txBody>
@@ -4991,8 +5253,8 @@
         </p:nvSpPr>
         <p:spPr>
           <a:xfrm>
-            <a:off x="365760" y="1463040"/>
-            <a:ext cx="4828032" cy="7680960"/>
+            <a:off x="365760" y="1097280"/>
+            <a:ext cx="4828032" cy="457200"/>
           </a:xfrm>
           <a:prstGeom prst="rect">
             <a:avLst/>
@@ -5007,25 +5269,249 @@
           <a:p>
             <a:pPr algn="l"/>
             <a:r>
+              <a:rPr sz="1300" b="1">
+                <a:solidFill>
+                  <a:srgbClr val="FFFFFF"/>
+                </a:solidFill>
+                <a:latin typeface="Arial"/>
+              </a:rPr>
+              <a:t>◆ 그 밖의 내용 — 3. Mechanism of Association Between SD and AGA</a:t>
+            </a:r>
+          </a:p>
+        </p:txBody>
+      </p:sp>
+      <p:sp>
+        <p:nvSpPr>
+          <p:cNvPr id="4" name="TextBox 3"/>
+          <p:cNvSpPr txBox="1"/>
+          <p:nvPr/>
+        </p:nvSpPr>
+        <p:spPr>
+          <a:xfrm>
+            <a:off x="457200" y="1600200"/>
+            <a:ext cx="4736592" cy="3566160"/>
+          </a:xfrm>
+          <a:prstGeom prst="rect">
+            <a:avLst/>
+          </a:prstGeom>
+          <a:noFill/>
+        </p:spPr>
+        <p:txBody>
+          <a:bodyPr wrap="square" anchor="t">
+            <a:spAutoFit/>
+          </a:bodyPr>
+          <a:lstStyle/>
+          <a:p>
+            <a:pPr algn="l"/>
+            <a:r>
               <a:rPr sz="1000" b="0">
                 <a:solidFill>
                   <a:srgbClr val="D5D8EA"/>
                 </a:solidFill>
                 <a:latin typeface="Arial"/>
               </a:rPr>
-              <a:t>[출처]
-논문: Military shaving waivers for pseudofolliculitis barbae: Ethical considerations for dermatologists
-게재: Clinics in dermatology
-원문: https://pubmed.ncbi.nlm.nih.gov/42854877/
-[이미지 출처]
-- Male pattern baldness.jpg / Originally uploaded by Lkinkade (Transferred by XenonX3) / CC BY-SA 2.5
-  https://commons.wikimedia.org/wiki/File:Male_pattern_baldness.jpg
-- Male-pattern hair loss.jpg / BlaiserPascal / CC BY-SA 4.0
-  https://commons.wikimedia.org/wiki/File:Male-pattern_hair_loss.jpg
-※ CC BY-SA 이미지가 포함되어 있습니다. 저작자 표시가 필수이며,
-  동일조건변경허락(ShareAlike) 조항이 영상 전체에 적용될 수 있으니
-  상업적 이용 시 해당 이미지를 교체하는 편이 안전합니다.
-</a:t>
+              <a:t>· Evidence from the UK Biobank and twin studies has confirmed that the heritability of AGA in males is estimated at 62%–80%.</a:t>
+            </a:r>
+          </a:p>
+        </p:txBody>
+      </p:sp>
+      <p:sp>
+        <p:nvSpPr>
+          <p:cNvPr id="5" name="TextBox 4"/>
+          <p:cNvSpPr txBox="1"/>
+          <p:nvPr/>
+        </p:nvSpPr>
+        <p:spPr>
+          <a:xfrm>
+            <a:off x="365760" y="5303520"/>
+            <a:ext cx="4828032" cy="457200"/>
+          </a:xfrm>
+          <a:prstGeom prst="rect">
+            <a:avLst/>
+          </a:prstGeom>
+          <a:noFill/>
+        </p:spPr>
+        <p:txBody>
+          <a:bodyPr wrap="square" anchor="t">
+            <a:spAutoFit/>
+          </a:bodyPr>
+          <a:lstStyle/>
+          <a:p>
+            <a:pPr algn="l"/>
+            <a:r>
+              <a:rPr sz="1300" b="1">
+                <a:solidFill>
+                  <a:srgbClr val="FFFFFF"/>
+                </a:solidFill>
+                <a:latin typeface="Arial"/>
+              </a:rPr>
+              <a:t>◆ 그 밖의 내용 — 4. Integrated Mechanism of SD–AGA Coexistence</a:t>
+            </a:r>
+          </a:p>
+        </p:txBody>
+      </p:sp>
+      <p:sp>
+        <p:nvSpPr>
+          <p:cNvPr id="6" name="TextBox 5"/>
+          <p:cNvSpPr txBox="1"/>
+          <p:nvPr/>
+        </p:nvSpPr>
+        <p:spPr>
+          <a:xfrm>
+            <a:off x="457200" y="5806440"/>
+            <a:ext cx="4736592" cy="3566160"/>
+          </a:xfrm>
+          <a:prstGeom prst="rect">
+            <a:avLst/>
+          </a:prstGeom>
+          <a:noFill/>
+        </p:spPr>
+        <p:txBody>
+          <a:bodyPr wrap="square" anchor="t">
+            <a:spAutoFit/>
+          </a:bodyPr>
+          <a:lstStyle/>
+          <a:p>
+            <a:pPr algn="l"/>
+            <a:r>
+              <a:rPr sz="1000" b="0">
+                <a:solidFill>
+                  <a:srgbClr val="D5D8EA"/>
+                </a:solidFill>
+                <a:latin typeface="Arial"/>
+              </a:rPr>
+              <a:t>· Based on the aforementioned information, we have summarized the coexistence mechanism between SD and AGA.</a:t>
+            </a:r>
+          </a:p>
+        </p:txBody>
+      </p:sp>
+    </p:spTree>
+  </p:cSld>
+  <p:clrMapOvr>
+    <a:masterClrMapping/>
+  </p:clrMapOvr>
+</p:sld>
+</file>
+
+<file path=ppt/slides/slide9.xml><?xml version="1.0" encoding="utf-8"?>
+<p:sld xmlns:a="http://schemas.openxmlformats.org/drawingml/2006/main" xmlns:p="http://schemas.openxmlformats.org/presentationml/2006/main" xmlns:r="http://schemas.openxmlformats.org/officeDocument/2006/relationships">
+  <p:cSld>
+    <p:bg>
+      <p:bgPr>
+        <a:solidFill>
+          <a:srgbClr val="12142A"/>
+        </a:solidFill>
+        <a:effectLst/>
+      </p:bgPr>
+    </p:bg>
+    <p:spTree>
+      <p:nvGrpSpPr>
+        <p:cNvPr id="1" name=""/>
+        <p:cNvGrpSpPr/>
+        <p:nvPr/>
+      </p:nvGrpSpPr>
+      <p:grpSpPr/>
+      <p:sp>
+        <p:nvSpPr>
+          <p:cNvPr id="2" name="TextBox 1"/>
+          <p:cNvSpPr txBox="1"/>
+          <p:nvPr/>
+        </p:nvSpPr>
+        <p:spPr>
+          <a:xfrm>
+            <a:off x="365760" y="457200"/>
+            <a:ext cx="4828032" cy="457200"/>
+          </a:xfrm>
+          <a:prstGeom prst="rect">
+            <a:avLst/>
+          </a:prstGeom>
+          <a:noFill/>
+        </p:spPr>
+        <p:txBody>
+          <a:bodyPr wrap="square" anchor="ctr">
+            <a:spAutoFit/>
+          </a:bodyPr>
+          <a:lstStyle/>
+          <a:p>
+            <a:pPr algn="l"/>
+            <a:r>
+              <a:rPr sz="1600" b="1">
+                <a:solidFill>
+                  <a:srgbClr val="FF6B6B"/>
+                </a:solidFill>
+                <a:latin typeface="Arial"/>
+              </a:rPr>
+              <a:t>본문 요약 (편집용)</a:t>
+            </a:r>
+          </a:p>
+        </p:txBody>
+      </p:sp>
+      <p:sp>
+        <p:nvSpPr>
+          <p:cNvPr id="3" name="TextBox 2"/>
+          <p:cNvSpPr txBox="1"/>
+          <p:nvPr/>
+        </p:nvSpPr>
+        <p:spPr>
+          <a:xfrm>
+            <a:off x="365760" y="1097280"/>
+            <a:ext cx="4828032" cy="457200"/>
+          </a:xfrm>
+          <a:prstGeom prst="rect">
+            <a:avLst/>
+          </a:prstGeom>
+          <a:noFill/>
+        </p:spPr>
+        <p:txBody>
+          <a:bodyPr wrap="square" anchor="t">
+            <a:spAutoFit/>
+          </a:bodyPr>
+          <a:lstStyle/>
+          <a:p>
+            <a:pPr algn="l"/>
+            <a:r>
+              <a:rPr sz="1300" b="1">
+                <a:solidFill>
+                  <a:srgbClr val="FFFFFF"/>
+                </a:solidFill>
+                <a:latin typeface="Arial"/>
+              </a:rPr>
+              <a:t>◆ 그 밖의 내용 — 5. Comprehensive Treatment Strategies Based on Target Synergy and Prospects</a:t>
+            </a:r>
+          </a:p>
+        </p:txBody>
+      </p:sp>
+      <p:sp>
+        <p:nvSpPr>
+          <p:cNvPr id="4" name="TextBox 3"/>
+          <p:cNvSpPr txBox="1"/>
+          <p:nvPr/>
+        </p:nvSpPr>
+        <p:spPr>
+          <a:xfrm>
+            <a:off x="457200" y="1600200"/>
+            <a:ext cx="4736592" cy="3566160"/>
+          </a:xfrm>
+          <a:prstGeom prst="rect">
+            <a:avLst/>
+          </a:prstGeom>
+          <a:noFill/>
+        </p:spPr>
+        <p:txBody>
+          <a:bodyPr wrap="square" anchor="t">
+            <a:spAutoFit/>
+          </a:bodyPr>
+          <a:lstStyle/>
+          <a:p>
+            <a:pPr algn="l"/>
+            <a:r>
+              <a:rPr sz="1000" b="0">
+                <a:solidFill>
+                  <a:srgbClr val="D5D8EA"/>
+                </a:solidFill>
+                <a:latin typeface="Arial"/>
+              </a:rPr>
+              <a:t>· One study reported that daily use of a 1% zinc pyrithione shampoo for 26 weeks resulted in moderate and sustained improvement in hair growth.</a:t>
             </a:r>
           </a:p>
         </p:txBody>

</xml_diff>

<commit_message>
chore: daily content 2026-10-13
</commit_message>
<xml_diff>
--- a/pwa/data/latest/slides.pptx
+++ b/pwa/data/latest/slides.pptx
@@ -15,6 +15,8 @@
     <p:sldId id="263" r:id="rId15"/>
     <p:sldId id="264" r:id="rId16"/>
     <p:sldId id="265" r:id="rId17"/>
+    <p:sldId id="266" r:id="rId18"/>
+    <p:sldId id="267" r:id="rId19"/>
   </p:sldIdLst>
   <p:sldSz cx="5559552" cy="9875520" type="screen4x3"/>
   <p:notesSz cx="6858000" cy="9144000"/>
@@ -516,12 +518,162 @@
           </a:p>
           <a:p>
             <a:r>
-              <a:t>대본: 50% 이 숫자, 탈모 연구가 새로 내놨습니다</a:t>
+              <a:t>대본: 오늘의 논문 Frontiers in immunology에 실린 새 연구입니다</a:t>
             </a:r>
           </a:p>
           <a:p>
             <a:r>
               <a:t>연출 노트: 0.5초 안에 스크롤을 멈추게 하는 구간. 숫자를 크게 읽어준다.</a:t>
+            </a:r>
+          </a:p>
+        </p:txBody>
+      </p:sp>
+      <p:sp>
+        <p:nvSpPr>
+          <p:cNvPr id="4" name="Slide Number Placeholder 3"/>
+          <p:cNvSpPr>
+            <a:spLocks noGrp="1"/>
+          </p:cNvSpPr>
+          <p:nvPr>
+            <p:ph type="sldNum" idx="5" sz="quarter"/>
+          </p:nvPr>
+        </p:nvSpPr>
+        <p:spPr/>
+      </p:sp>
+    </p:spTree>
+  </p:cSld>
+  <p:clrMapOvr>
+    <a:masterClrMapping/>
+  </p:clrMapOvr>
+</p:notes>
+</file>
+
+<file path=ppt/notesSlides/notesSlide10.xml><?xml version="1.0" encoding="utf-8"?>
+<p:notes xmlns:a="http://schemas.openxmlformats.org/drawingml/2006/main" xmlns:p="http://schemas.openxmlformats.org/presentationml/2006/main" xmlns:r="http://schemas.openxmlformats.org/officeDocument/2006/relationships">
+  <p:cSld>
+    <p:spTree>
+      <p:nvGrpSpPr>
+        <p:cNvPr id="1" name=""/>
+        <p:cNvGrpSpPr/>
+        <p:nvPr/>
+      </p:nvGrpSpPr>
+      <p:grpSpPr>
+        <a:xfrm>
+          <a:off x="0" y="0"/>
+          <a:ext cx="0" cy="0"/>
+          <a:chOff x="0" y="0"/>
+          <a:chExt cx="0" cy="0"/>
+        </a:xfrm>
+      </p:grpSpPr>
+      <p:sp>
+        <p:nvSpPr>
+          <p:cNvPr id="2" name="Slide Image Placeholder 1"/>
+          <p:cNvSpPr>
+            <a:spLocks noGrp="1"/>
+          </p:cNvSpPr>
+          <p:nvPr>
+            <p:ph type="sldImg" idx="2"/>
+          </p:nvPr>
+        </p:nvSpPr>
+        <p:spPr/>
+      </p:sp>
+      <p:sp>
+        <p:nvSpPr>
+          <p:cNvPr id="3" name="Notes Placeholder 2"/>
+          <p:cNvSpPr>
+            <a:spLocks noGrp="1"/>
+          </p:cNvSpPr>
+          <p:nvPr>
+            <p:ph type="body" idx="3" sz="quarter"/>
+          </p:nvPr>
+        </p:nvSpPr>
+        <p:spPr/>
+        <p:txBody>
+          <a:bodyPr/>
+          <a:lstStyle/>
+          <a:p>
+            <a:r>
+              <a:t>편집 참고용 슬라이드입니다. 영상에는 쓰지 않아도 됩니다.</a:t>
+            </a:r>
+          </a:p>
+          <a:p>
+            <a:r>
+              <a:t>원문 영어 문장을 그대로 발췌했으므로 번역·검수 후 사용하세요.</a:t>
+            </a:r>
+          </a:p>
+        </p:txBody>
+      </p:sp>
+      <p:sp>
+        <p:nvSpPr>
+          <p:cNvPr id="4" name="Slide Number Placeholder 3"/>
+          <p:cNvSpPr>
+            <a:spLocks noGrp="1"/>
+          </p:cNvSpPr>
+          <p:nvPr>
+            <p:ph type="sldNum" idx="5" sz="quarter"/>
+          </p:nvPr>
+        </p:nvSpPr>
+        <p:spPr/>
+      </p:sp>
+    </p:spTree>
+  </p:cSld>
+  <p:clrMapOvr>
+    <a:masterClrMapping/>
+  </p:clrMapOvr>
+</p:notes>
+</file>
+
+<file path=ppt/notesSlides/notesSlide11.xml><?xml version="1.0" encoding="utf-8"?>
+<p:notes xmlns:a="http://schemas.openxmlformats.org/drawingml/2006/main" xmlns:p="http://schemas.openxmlformats.org/presentationml/2006/main" xmlns:r="http://schemas.openxmlformats.org/officeDocument/2006/relationships">
+  <p:cSld>
+    <p:spTree>
+      <p:nvGrpSpPr>
+        <p:cNvPr id="1" name=""/>
+        <p:cNvGrpSpPr/>
+        <p:nvPr/>
+      </p:nvGrpSpPr>
+      <p:grpSpPr>
+        <a:xfrm>
+          <a:off x="0" y="0"/>
+          <a:ext cx="0" cy="0"/>
+          <a:chOff x="0" y="0"/>
+          <a:chExt cx="0" cy="0"/>
+        </a:xfrm>
+      </p:grpSpPr>
+      <p:sp>
+        <p:nvSpPr>
+          <p:cNvPr id="2" name="Slide Image Placeholder 1"/>
+          <p:cNvSpPr>
+            <a:spLocks noGrp="1"/>
+          </p:cNvSpPr>
+          <p:nvPr>
+            <p:ph type="sldImg" idx="2"/>
+          </p:nvPr>
+        </p:nvSpPr>
+        <p:spPr/>
+      </p:sp>
+      <p:sp>
+        <p:nvSpPr>
+          <p:cNvPr id="3" name="Notes Placeholder 2"/>
+          <p:cNvSpPr>
+            <a:spLocks noGrp="1"/>
+          </p:cNvSpPr>
+          <p:nvPr>
+            <p:ph type="body" idx="3" sz="quarter"/>
+          </p:nvPr>
+        </p:nvSpPr>
+        <p:spPr/>
+        <p:txBody>
+          <a:bodyPr/>
+          <a:lstStyle/>
+          <a:p>
+            <a:r>
+              <a:t>편집 참고용 슬라이드입니다. 영상에는 쓰지 않아도 됩니다.</a:t>
+            </a:r>
+          </a:p>
+          <a:p>
+            <a:r>
+              <a:t>원문 영어 문장을 그대로 발췌했으므로 번역·검수 후 사용하세요.</a:t>
             </a:r>
           </a:p>
         </p:txBody>
@@ -596,7 +748,7 @@
           </a:p>
           <a:p>
             <a:r>
-              <a:t>대본: 《Dermatology research and practice》 - Double Challenges for Scalp Health: A Review of the Pathogenesis and Treatment Strategies of Coexistence of Seborrheic Dermatitis and Androgenetic Alopecia</a:t>
+              <a:t>대본: 《Frontiers in immunology》 - Translating umbilical cord blood extracellular vesicles into a novel therapy for postpartum alopecia: a mechanistic and preclinical review</a:t>
             </a:r>
           </a:p>
           <a:p>
@@ -676,7 +828,7 @@
           </a:p>
           <a:p>
             <a:r>
-              <a:t>대본: Androgenetic alopecia (AGA) and seborrheic dermatitis (SD) are two common scalp disorders that frequently impair the quality of life and may coexist in a subset of patients across all genders.</a:t>
+              <a:t>대본: Postpartum alopecia (PPA) is a common physiological hair loss in women, characterized by complex pathogenesis involving abrupt postpartum hormonal withdrawal, disrupted hair follicle cycling, local microenvironmental inflammation, and oxidative stress.</a:t>
             </a:r>
           </a:p>
           <a:p>
@@ -751,17 +903,17 @@
           <a:lstStyle/>
           <a:p>
             <a:r>
-              <a:t>[key_finding_2] 약 10초</a:t>
-            </a:r>
-          </a:p>
-          <a:p>
-            <a:r>
-              <a:t>대본: SD presents in 40%-50% of all patients diagnosed with AGA.</a:t>
-            </a:r>
-          </a:p>
-          <a:p>
-            <a:r>
-              <a:t>연출 노트: 핵심 포인트 2.</a:t>
+              <a:t>[paper_table] 약 8초</a:t>
+            </a:r>
+          </a:p>
+          <a:p>
+            <a:r>
+              <a:t>대본: 표로 보면 이렇습니다. Summary of UCB-EV studies for hair regeneration with categorized evidence levels.</a:t>
+            </a:r>
+          </a:p>
+          <a:p>
+            <a:r>
+              <a:t>연출 노트: 핵심 숫자 한 칸만 짚어준다. 표는 셀을 직접 수정할 수 있다.</a:t>
             </a:r>
           </a:p>
         </p:txBody>
@@ -831,17 +983,17 @@
           <a:lstStyle/>
           <a:p>
             <a:r>
-              <a:t>[my_take] 약 10초</a:t>
-            </a:r>
-          </a:p>
-          <a:p>
-            <a:r>
-              <a:t>대본: 탈모 연구, 매일 쉽게 정리해드립니다 🙂</a:t>
-            </a:r>
-          </a:p>
-          <a:p>
-            <a:r>
-              <a:t>연출 노트: 본인 사진 + 코멘트. 문구를 직접 바꿔 쓰세요.</a:t>
+              <a:t>[key_finding_2] 약 10초</a:t>
+            </a:r>
+          </a:p>
+          <a:p>
+            <a:r>
+              <a:t>대본: Umbilical cord blood-derived extracellular vesicles (UCB-EVs)-nanosized, lipid-bilayer-enclosed particles enriched with microRNAs, growth factors, and proteins-have shown considerable promise in regenerative medicine owing to their low immunogenicity, high biocompatibility, and tissue-repair capacity.</a:t>
+            </a:r>
+          </a:p>
+          <a:p>
+            <a:r>
+              <a:t>연출 노트: 핵심 포인트 2.</a:t>
             </a:r>
           </a:p>
         </p:txBody>
@@ -911,17 +1063,17 @@
           <a:lstStyle/>
           <a:p>
             <a:r>
-              <a:t>[cta] 약 8초</a:t>
-            </a:r>
-          </a:p>
-          <a:p>
-            <a:r>
-              <a:t>대본: 더 자세한 내용은 원문 링크에서 확인하세요. 매일 새로운 탈모 연구, 팔로우하고 놓치지 마세요!</a:t>
-            </a:r>
-          </a:p>
-          <a:p>
-            <a:r>
-              <a:t>연출 노트: 원문 링크는 고정 댓글로 안내.</a:t>
+              <a:t>[my_take] 약 10초</a:t>
+            </a:r>
+          </a:p>
+          <a:p>
+            <a:r>
+              <a:t>대본: 탈모 연구, 매일 쉽게 정리해드립니다 🙂</a:t>
+            </a:r>
+          </a:p>
+          <a:p>
+            <a:r>
+              <a:t>연출 노트: 본인 사진 + 코멘트. 문구를 직접 바꿔 쓰세요.</a:t>
             </a:r>
           </a:p>
         </p:txBody>
@@ -991,12 +1143,17 @@
           <a:lstStyle/>
           <a:p>
             <a:r>
-              <a:t>편집 참고용 슬라이드입니다. 영상에는 쓰지 않아도 됩니다.</a:t>
-            </a:r>
-          </a:p>
-          <a:p>
-            <a:r>
-              <a:t>원문 영어 문장을 그대로 발췌했으므로 번역·검수 후 사용하세요.</a:t>
+              <a:t>[cta] 약 8초</a:t>
+            </a:r>
+          </a:p>
+          <a:p>
+            <a:r>
+              <a:t>대본: 더 자세한 내용은 원문 링크에서 확인하세요. 매일 새로운 탈모 연구, 팔로우하고 놓치지 마세요!</a:t>
+            </a:r>
+          </a:p>
+          <a:p>
+            <a:r>
+              <a:t>연출 노트: 원문 링크는 고정 댓글로 안내.</a:t>
             </a:r>
           </a:p>
         </p:txBody>
@@ -4190,7 +4347,7 @@
                 </a:solidFill>
                 <a:latin typeface="Arial"/>
               </a:rPr>
-              <a:t>DERMATOLOGY RESEARCH AND PRACTICE</a:t>
+              <a:t>FRONTIERS IN IMMUNOLOGY</a:t>
             </a:r>
           </a:p>
         </p:txBody>
@@ -4225,7 +4382,7 @@
                 </a:solidFill>
                 <a:latin typeface="Arial"/>
               </a:rPr>
-              <a:t>50%</a:t>
+              <a:t>오늘의 논문</a:t>
             </a:r>
           </a:p>
         </p:txBody>
@@ -4260,7 +4417,7 @@
                 </a:solidFill>
                 <a:latin typeface="Arial"/>
               </a:rPr>
-              <a:t>이 숫자, 탈모 연구가 새로 내놨습니다</a:t>
+              <a:t>Frontiers in immunology에 실린 새 연구입니다</a:t>
             </a:r>
           </a:p>
         </p:txBody>
@@ -4334,6 +4491,340 @@
         </p:nvSpPr>
         <p:spPr>
           <a:xfrm>
+            <a:off x="365760" y="457200"/>
+            <a:ext cx="4828032" cy="457200"/>
+          </a:xfrm>
+          <a:prstGeom prst="rect">
+            <a:avLst/>
+          </a:prstGeom>
+          <a:noFill/>
+        </p:spPr>
+        <p:txBody>
+          <a:bodyPr wrap="square" anchor="ctr">
+            <a:spAutoFit/>
+          </a:bodyPr>
+          <a:lstStyle/>
+          <a:p>
+            <a:pPr algn="l"/>
+            <a:r>
+              <a:rPr sz="1600" b="1">
+                <a:solidFill>
+                  <a:srgbClr val="FF6B6B"/>
+                </a:solidFill>
+                <a:latin typeface="Arial"/>
+              </a:rPr>
+              <a:t>본문 요약 (편집용)</a:t>
+            </a:r>
+          </a:p>
+        </p:txBody>
+      </p:sp>
+      <p:sp>
+        <p:nvSpPr>
+          <p:cNvPr id="3" name="TextBox 2"/>
+          <p:cNvSpPr txBox="1"/>
+          <p:nvPr/>
+        </p:nvSpPr>
+        <p:spPr>
+          <a:xfrm>
+            <a:off x="365760" y="1097280"/>
+            <a:ext cx="4828032" cy="457200"/>
+          </a:xfrm>
+          <a:prstGeom prst="rect">
+            <a:avLst/>
+          </a:prstGeom>
+          <a:noFill/>
+        </p:spPr>
+        <p:txBody>
+          <a:bodyPr wrap="square" anchor="t">
+            <a:spAutoFit/>
+          </a:bodyPr>
+          <a:lstStyle/>
+          <a:p>
+            <a:pPr algn="l"/>
+            <a:r>
+              <a:rPr sz="1300" b="1">
+                <a:solidFill>
+                  <a:srgbClr val="FFFFFF"/>
+                </a:solidFill>
+                <a:latin typeface="Arial"/>
+              </a:rPr>
+              <a:t>◆ 그 밖의 내용 — Preclinical evidence for UCB-EVs in treating postpartum hair loss</a:t>
+            </a:r>
+          </a:p>
+        </p:txBody>
+      </p:sp>
+      <p:sp>
+        <p:nvSpPr>
+          <p:cNvPr id="4" name="TextBox 3"/>
+          <p:cNvSpPr txBox="1"/>
+          <p:nvPr/>
+        </p:nvSpPr>
+        <p:spPr>
+          <a:xfrm>
+            <a:off x="457200" y="1600200"/>
+            <a:ext cx="4736592" cy="3566160"/>
+          </a:xfrm>
+          <a:prstGeom prst="rect">
+            <a:avLst/>
+          </a:prstGeom>
+          <a:noFill/>
+        </p:spPr>
+        <p:txBody>
+          <a:bodyPr wrap="square" anchor="t">
+            <a:spAutoFit/>
+          </a:bodyPr>
+          <a:lstStyle/>
+          <a:p>
+            <a:pPr algn="l"/>
+            <a:r>
+              <a:rPr sz="1000" b="0">
+                <a:solidFill>
+                  <a:srgbClr val="D5D8EA"/>
+                </a:solidFill>
+                <a:latin typeface="Arial"/>
+              </a:rPr>
+              <a:t>· When DPCs, the master regulators of hair follicle cycling, were treated with UCB-EVs at a concentration of 50 μg/mL for 48 hours, significant cellular responses were observed, including a 45% increase in proliferation and a 35% reduction in apoptosis (55).</a:t>
+            </a:r>
+          </a:p>
+        </p:txBody>
+      </p:sp>
+      <p:sp>
+        <p:nvSpPr>
+          <p:cNvPr id="5" name="TextBox 4"/>
+          <p:cNvSpPr txBox="1"/>
+          <p:nvPr/>
+        </p:nvSpPr>
+        <p:spPr>
+          <a:xfrm>
+            <a:off x="365760" y="5303520"/>
+            <a:ext cx="4828032" cy="457200"/>
+          </a:xfrm>
+          <a:prstGeom prst="rect">
+            <a:avLst/>
+          </a:prstGeom>
+          <a:noFill/>
+        </p:spPr>
+        <p:txBody>
+          <a:bodyPr wrap="square" anchor="t">
+            <a:spAutoFit/>
+          </a:bodyPr>
+          <a:lstStyle/>
+          <a:p>
+            <a:pPr algn="l"/>
+            <a:r>
+              <a:rPr sz="1300" b="1">
+                <a:solidFill>
+                  <a:srgbClr val="FFFFFF"/>
+                </a:solidFill>
+                <a:latin typeface="Arial"/>
+              </a:rPr>
+              <a:t>◆ 결론 — Clinical translation challenges and future directions of UCB-EVs for postpartum hair loss</a:t>
+            </a:r>
+          </a:p>
+        </p:txBody>
+      </p:sp>
+      <p:sp>
+        <p:nvSpPr>
+          <p:cNvPr id="6" name="TextBox 5"/>
+          <p:cNvSpPr txBox="1"/>
+          <p:nvPr/>
+        </p:nvSpPr>
+        <p:spPr>
+          <a:xfrm>
+            <a:off x="457200" y="5806440"/>
+            <a:ext cx="4736592" cy="3566160"/>
+          </a:xfrm>
+          <a:prstGeom prst="rect">
+            <a:avLst/>
+          </a:prstGeom>
+          <a:noFill/>
+        </p:spPr>
+        <p:txBody>
+          <a:bodyPr wrap="square" anchor="t">
+            <a:spAutoFit/>
+          </a:bodyPr>
+          <a:lstStyle/>
+          <a:p>
+            <a:pPr algn="l"/>
+            <a:r>
+              <a:rPr sz="1000" b="0">
+                <a:solidFill>
+                  <a:srgbClr val="D5D8EA"/>
+                </a:solidFill>
+                <a:latin typeface="Arial"/>
+              </a:rPr>
+              <a:t>· A primary hurdle is the limited volume of UCB obtainable per unit, as a single cord blood donation yields only approximately 10^10 to 10^11 EV particles.
+· For instance, the use of a chemically defined, xeno- and blood-free culture medium, such as Oxium™EXO, has been shown to increase small EV (sEV) secretion from MSCs by three-fold, consistently across multiple harvest time points and different cell sources, yielding an enrichment of particles within the 51–200 nm range (71).
+· Preclinical safety evaluations using non-human primates have shown that high-dose intravenous administration of human UCB-MSC-derived exosomes (3.85 × 10^12 particles) did not cause significant adverse effects on general clinical conditions, hematology, coagulation, or immune organs, and did not induce major changes in immunoglobulins or cytokines (79).</a:t>
+            </a:r>
+          </a:p>
+        </p:txBody>
+      </p:sp>
+    </p:spTree>
+  </p:cSld>
+  <p:clrMapOvr>
+    <a:masterClrMapping/>
+  </p:clrMapOvr>
+</p:sld>
+</file>
+
+<file path=ppt/slides/slide11.xml><?xml version="1.0" encoding="utf-8"?>
+<p:sld xmlns:a="http://schemas.openxmlformats.org/drawingml/2006/main" xmlns:p="http://schemas.openxmlformats.org/presentationml/2006/main" xmlns:r="http://schemas.openxmlformats.org/officeDocument/2006/relationships">
+  <p:cSld>
+    <p:bg>
+      <p:bgPr>
+        <a:solidFill>
+          <a:srgbClr val="12142A"/>
+        </a:solidFill>
+        <a:effectLst/>
+      </p:bgPr>
+    </p:bg>
+    <p:spTree>
+      <p:nvGrpSpPr>
+        <p:cNvPr id="1" name=""/>
+        <p:cNvGrpSpPr/>
+        <p:nvPr/>
+      </p:nvGrpSpPr>
+      <p:grpSpPr/>
+      <p:sp>
+        <p:nvSpPr>
+          <p:cNvPr id="2" name="TextBox 1"/>
+          <p:cNvSpPr txBox="1"/>
+          <p:nvPr/>
+        </p:nvSpPr>
+        <p:spPr>
+          <a:xfrm>
+            <a:off x="365760" y="457200"/>
+            <a:ext cx="4828032" cy="457200"/>
+          </a:xfrm>
+          <a:prstGeom prst="rect">
+            <a:avLst/>
+          </a:prstGeom>
+          <a:noFill/>
+        </p:spPr>
+        <p:txBody>
+          <a:bodyPr wrap="square" anchor="ctr">
+            <a:spAutoFit/>
+          </a:bodyPr>
+          <a:lstStyle/>
+          <a:p>
+            <a:pPr algn="l"/>
+            <a:r>
+              <a:rPr sz="1600" b="1">
+                <a:solidFill>
+                  <a:srgbClr val="FF6B6B"/>
+                </a:solidFill>
+                <a:latin typeface="Arial"/>
+              </a:rPr>
+              <a:t>본문 요약 (편집용)</a:t>
+            </a:r>
+          </a:p>
+        </p:txBody>
+      </p:sp>
+      <p:sp>
+        <p:nvSpPr>
+          <p:cNvPr id="3" name="TextBox 2"/>
+          <p:cNvSpPr txBox="1"/>
+          <p:nvPr/>
+        </p:nvSpPr>
+        <p:spPr>
+          <a:xfrm>
+            <a:off x="365760" y="1097280"/>
+            <a:ext cx="4828032" cy="457200"/>
+          </a:xfrm>
+          <a:prstGeom prst="rect">
+            <a:avLst/>
+          </a:prstGeom>
+          <a:noFill/>
+        </p:spPr>
+        <p:txBody>
+          <a:bodyPr wrap="square" anchor="t">
+            <a:spAutoFit/>
+          </a:bodyPr>
+          <a:lstStyle/>
+          <a:p>
+            <a:pPr algn="l"/>
+            <a:r>
+              <a:rPr sz="1300" b="1">
+                <a:solidFill>
+                  <a:srgbClr val="FFFFFF"/>
+                </a:solidFill>
+                <a:latin typeface="Arial"/>
+              </a:rPr>
+              <a:t>◆ 결론 — Conclusion</a:t>
+            </a:r>
+          </a:p>
+        </p:txBody>
+      </p:sp>
+      <p:sp>
+        <p:nvSpPr>
+          <p:cNvPr id="4" name="TextBox 3"/>
+          <p:cNvSpPr txBox="1"/>
+          <p:nvPr/>
+        </p:nvSpPr>
+        <p:spPr>
+          <a:xfrm>
+            <a:off x="457200" y="1600200"/>
+            <a:ext cx="4736592" cy="3566160"/>
+          </a:xfrm>
+          <a:prstGeom prst="rect">
+            <a:avLst/>
+          </a:prstGeom>
+          <a:noFill/>
+        </p:spPr>
+        <p:txBody>
+          <a:bodyPr wrap="square" anchor="t">
+            <a:spAutoFit/>
+          </a:bodyPr>
+          <a:lstStyle/>
+          <a:p>
+            <a:pPr algn="l"/>
+            <a:r>
+              <a:rPr sz="1000" b="0">
+                <a:solidFill>
+                  <a:srgbClr val="D5D8EA"/>
+                </a:solidFill>
+                <a:latin typeface="Arial"/>
+              </a:rPr>
+              <a:t>· Transcriptomic analyses have revealed the involvement of immune cells and ferroptosis in frontal fibrosing alopecia (81).</a:t>
+            </a:r>
+          </a:p>
+        </p:txBody>
+      </p:sp>
+    </p:spTree>
+  </p:cSld>
+  <p:clrMapOvr>
+    <a:masterClrMapping/>
+  </p:clrMapOvr>
+</p:sld>
+</file>
+
+<file path=ppt/slides/slide12.xml><?xml version="1.0" encoding="utf-8"?>
+<p:sld xmlns:a="http://schemas.openxmlformats.org/drawingml/2006/main" xmlns:p="http://schemas.openxmlformats.org/presentationml/2006/main" xmlns:r="http://schemas.openxmlformats.org/officeDocument/2006/relationships">
+  <p:cSld>
+    <p:bg>
+      <p:bgPr>
+        <a:solidFill>
+          <a:srgbClr val="12142A"/>
+        </a:solidFill>
+        <a:effectLst/>
+      </p:bgPr>
+    </p:bg>
+    <p:spTree>
+      <p:nvGrpSpPr>
+        <p:cNvPr id="1" name=""/>
+        <p:cNvGrpSpPr/>
+        <p:nvPr/>
+      </p:nvGrpSpPr>
+      <p:grpSpPr/>
+      <p:sp>
+        <p:nvSpPr>
+          <p:cNvPr id="2" name="TextBox 1"/>
+          <p:cNvSpPr txBox="1"/>
+          <p:nvPr/>
+        </p:nvSpPr>
+        <p:spPr>
+          <a:xfrm>
             <a:off x="365760" y="731520"/>
             <a:ext cx="4828032" cy="548640"/>
           </a:xfrm>
@@ -4392,9 +4883,9 @@
                 <a:latin typeface="Arial"/>
               </a:rPr>
               <a:t>[출처]
-논문: Double Challenges for Scalp Health: A Review of the Pathogenesis and Treatment Strategies of Coexistence of Seborrheic Dermatitis and Androgenetic Alopecia
-게재: Dermatology research and practice
-원문: https://pubmed.ncbi.nlm.nih.gov/42857554/
+논문: Translating umbilical cord blood extracellular vesicles into a novel therapy for postpartum alopecia: a mechanistic and preclinical review
+게재: Frontiers in immunology
+원문: https://pubmed.ncbi.nlm.nih.gov/42857222/
 [이미지 출처]
 - Male pattern baldness.jpg / Originally uploaded by Lkinkade (Transferred by XenonX3) / CC BY-SA 2.5
   https://commons.wikimedia.org/wiki/File:Male_pattern_baldness.jpg
@@ -4404,8 +4895,9 @@
   동일조건변경허락(ShareAlike) 조항이 영상 전체에 적용될 수 있으니
   상업적 이용 시 해당 이미지를 교체하는 편이 안전합니다.
 [논문 본문 그림·표]
-- PubMed Central PMC13650735 (재사용 가능 라이선스)
-  https://www.ncbi.nlm.nih.gov/pmc/articles/PMC13650735/
+- PubMed Central PMC13651770 (재사용 가능 라이선스)
+  https://www.ncbi.nlm.nih.gov/pmc/articles/PMC13651770/
+  · Table 1
   ※ 오픈액세스 논문의 그림·표이며, 위 원문 출처를 함께 표기하세요.
 </a:t>
             </a:r>
@@ -4492,7 +4984,7 @@
                 </a:solidFill>
                 <a:latin typeface="Arial"/>
               </a:rPr>
-              <a:t>Double Challenges for Scalp Health: A Review of the Pathogenesis and Treatment Strategies of Coexistence of Seborrheic Dermatitis and Androgenetic Alopecia</a:t>
+              <a:t>Translating umbilical cord blood extracellular vesicles into a novel therapy for postpartum alopecia: a mechanistic and preclinical review</a:t>
             </a:r>
           </a:p>
         </p:txBody>
@@ -4527,7 +5019,7 @@
                 </a:solidFill>
                 <a:latin typeface="Arial"/>
               </a:rPr>
-              <a:t>Dermatology research and practice  ·  2026</a:t>
+              <a:t>Frontiers in immunology  ·  2026</a:t>
             </a:r>
           </a:p>
         </p:txBody>
@@ -4656,7 +5148,7 @@
                 </a:solidFill>
                 <a:latin typeface="Arial"/>
               </a:rPr>
-              <a:t>Androgenetic alopecia (AGA) and seborrheic dermatitis (SD) are two common scalp disorders that frequently impair the quality of life and may coexist in a subset of patients across all genders.</a:t>
+              <a:t>Postpartum alopecia (PPA) is a common physiological hair loss in women, characterized by complex pathogenesis involving abrupt postpartum hormonal withdrawal, disrupted hair follicle cycling, local microenvironmental inflammation, and oxidative stress.</a:t>
             </a:r>
           </a:p>
         </p:txBody>
@@ -4670,6 +5162,550 @@
 </file>
 
 <file path=ppt/slides/slide4.xml><?xml version="1.0" encoding="utf-8"?>
+<p:sld xmlns:a="http://schemas.openxmlformats.org/drawingml/2006/main" xmlns:p="http://schemas.openxmlformats.org/presentationml/2006/main" xmlns:r="http://schemas.openxmlformats.org/officeDocument/2006/relationships">
+  <p:cSld>
+    <p:bg>
+      <p:bgPr>
+        <a:solidFill>
+          <a:srgbClr val="12142A"/>
+        </a:solidFill>
+        <a:effectLst/>
+      </p:bgPr>
+    </p:bg>
+    <p:spTree>
+      <p:nvGrpSpPr>
+        <p:cNvPr id="1" name=""/>
+        <p:cNvGrpSpPr/>
+        <p:nvPr/>
+      </p:nvGrpSpPr>
+      <p:grpSpPr/>
+      <p:sp>
+        <p:nvSpPr>
+          <p:cNvPr id="2" name="TextBox 1"/>
+          <p:cNvSpPr txBox="1"/>
+          <p:nvPr/>
+        </p:nvSpPr>
+        <p:spPr>
+          <a:xfrm>
+            <a:off x="365760" y="1097280"/>
+            <a:ext cx="4828032" cy="548640"/>
+          </a:xfrm>
+          <a:prstGeom prst="rect">
+            <a:avLst/>
+          </a:prstGeom>
+          <a:noFill/>
+        </p:spPr>
+        <p:txBody>
+          <a:bodyPr wrap="square" anchor="ctr">
+            <a:spAutoFit/>
+          </a:bodyPr>
+          <a:lstStyle/>
+          <a:p>
+            <a:pPr algn="ctr"/>
+            <a:r>
+              <a:rPr sz="2000" b="1">
+                <a:solidFill>
+                  <a:srgbClr val="FF6B6B"/>
+                </a:solidFill>
+                <a:latin typeface="Arial"/>
+              </a:rPr>
+              <a:t>논문 Table 1</a:t>
+            </a:r>
+          </a:p>
+        </p:txBody>
+      </p:sp>
+      <p:sp>
+        <p:nvSpPr>
+          <p:cNvPr id="3" name="TextBox 2"/>
+          <p:cNvSpPr txBox="1"/>
+          <p:nvPr/>
+        </p:nvSpPr>
+        <p:spPr>
+          <a:xfrm>
+            <a:off x="365760" y="1737360"/>
+            <a:ext cx="4828032" cy="914400"/>
+          </a:xfrm>
+          <a:prstGeom prst="rect">
+            <a:avLst/>
+          </a:prstGeom>
+          <a:noFill/>
+        </p:spPr>
+        <p:txBody>
+          <a:bodyPr wrap="square" anchor="ctr">
+            <a:spAutoFit/>
+          </a:bodyPr>
+          <a:lstStyle/>
+          <a:p>
+            <a:pPr algn="ctr"/>
+            <a:r>
+              <a:rPr sz="1300" b="0">
+                <a:solidFill>
+                  <a:srgbClr val="AAAFCD"/>
+                </a:solidFill>
+                <a:latin typeface="Arial"/>
+              </a:rPr>
+              <a:t>Summary of UCB-EV studies for hair regeneration with categorized evidence levels.</a:t>
+            </a:r>
+          </a:p>
+        </p:txBody>
+      </p:sp>
+      <p:graphicFrame>
+        <p:nvGraphicFramePr>
+          <p:cNvPr id="4" name="Table 3"/>
+          <p:cNvGraphicFramePr>
+            <a:graphicFrameLocks noGrp="1"/>
+          </p:cNvGraphicFramePr>
+          <p:nvPr/>
+        </p:nvGraphicFramePr>
+        <p:xfrm>
+          <a:off x="320040" y="2926080"/>
+          <a:ext cx="4919472" cy="3017520"/>
+        </p:xfrm>
+        <a:graphic>
+          <a:graphicData uri="http://schemas.openxmlformats.org/drawingml/2006/table">
+            <a:tbl>
+              <a:tblPr firstRow="1" bandRow="1">
+                <a:tableStyleId>{5C22544A-7EE6-4342-B048-85BDC9FD1C3A}</a:tableStyleId>
+              </a:tblPr>
+              <a:tblGrid>
+                <a:gridCol w="1229868"/>
+                <a:gridCol w="1229868"/>
+                <a:gridCol w="1229868"/>
+                <a:gridCol w="1229868"/>
+              </a:tblGrid>
+              <a:tr h="502920">
+                <a:tc>
+                  <a:txBody>
+                    <a:bodyPr/>
+                    <a:lstStyle/>
+                    <a:p>
+                      <a:pPr>
+                        <a:defRPr sz="1200" b="1">
+                          <a:latin typeface="Arial"/>
+                        </a:defRPr>
+                      </a:pPr>
+                      <a:r>
+                        <a:t>EV source</a:t>
+                      </a:r>
+                    </a:p>
+                  </a:txBody>
+                  <a:tcPr/>
+                </a:tc>
+                <a:tc>
+                  <a:txBody>
+                    <a:bodyPr/>
+                    <a:lstStyle/>
+                    <a:p>
+                      <a:pPr>
+                        <a:defRPr sz="1200" b="1">
+                          <a:latin typeface="Arial"/>
+                        </a:defRPr>
+                      </a:pPr>
+                      <a:r>
+                        <a:t>Model</a:t>
+                      </a:r>
+                    </a:p>
+                  </a:txBody>
+                  <a:tcPr/>
+                </a:tc>
+                <a:tc>
+                  <a:txBody>
+                    <a:bodyPr/>
+                    <a:lstStyle/>
+                    <a:p>
+                      <a:pPr>
+                        <a:defRPr sz="1200" b="1">
+                          <a:latin typeface="Arial"/>
+                        </a:defRPr>
+                      </a:pPr>
+                      <a:r>
+                        <a:t>Intervention main mechanism/outcome</a:t>
+                      </a:r>
+                    </a:p>
+                  </a:txBody>
+                  <a:tcPr/>
+                </a:tc>
+                <a:tc>
+                  <a:txBody>
+                    <a:bodyPr/>
+                    <a:lstStyle/>
+                    <a:p>
+                      <a:pPr>
+                        <a:defRPr sz="1200" b="1">
+                          <a:latin typeface="Arial"/>
+                        </a:defRPr>
+                      </a:pPr>
+                      <a:r>
+                        <a:t>Evidence level</a:t>
+                      </a:r>
+                    </a:p>
+                  </a:txBody>
+                  <a:tcPr/>
+                </a:tc>
+              </a:tr>
+              <a:tr h="502920">
+                <a:tc>
+                  <a:txBody>
+                    <a:bodyPr/>
+                    <a:lstStyle/>
+                    <a:p>
+                      <a:pPr>
+                        <a:defRPr sz="1100" b="0">
+                          <a:latin typeface="Arial"/>
+                        </a:defRPr>
+                      </a:pPr>
+                      <a:r>
+                        <a:t>UCB-EVs</a:t>
+                      </a:r>
+                    </a:p>
+                  </a:txBody>
+                  <a:tcPr/>
+                </a:tc>
+                <a:tc>
+                  <a:txBody>
+                    <a:bodyPr/>
+                    <a:lstStyle/>
+                    <a:p>
+                      <a:pPr>
+                        <a:defRPr sz="1100" b="0">
+                          <a:latin typeface="Arial"/>
+                        </a:defRPr>
+                      </a:pPr>
+                      <a:r>
+                        <a:t>HumanDPC/HFK coculture</a:t>
+                      </a:r>
+                    </a:p>
+                  </a:txBody>
+                  <a:tcPr/>
+                </a:tc>
+                <a:tc>
+                  <a:txBody>
+                    <a:bodyPr/>
+                    <a:lstStyle/>
+                    <a:p>
+                      <a:pPr>
+                        <a:defRPr sz="1100" b="0">
+                          <a:latin typeface="Arial"/>
+                        </a:defRPr>
+                      </a:pPr>
+                      <a:r>
+                        <a:t>50 μg/mL for 48 h</a:t>
+                      </a:r>
+                    </a:p>
+                  </a:txBody>
+                  <a:tcPr/>
+                </a:tc>
+                <a:tc>
+                  <a:txBody>
+                    <a:bodyPr/>
+                    <a:lstStyle/>
+                    <a:p>
+                      <a:pPr>
+                        <a:defRPr sz="1100" b="0">
+                          <a:latin typeface="Arial"/>
+                        </a:defRPr>
+                      </a:pPr>
+                      <a:r>
+                        <a:t>Proliferation ↑45%, apoptosis ↓35%, Vers</a:t>
+                      </a:r>
+                    </a:p>
+                  </a:txBody>
+                  <a:tcPr/>
+                </a:tc>
+              </a:tr>
+              <a:tr h="502920">
+                <a:tc>
+                  <a:txBody>
+                    <a:bodyPr/>
+                    <a:lstStyle/>
+                    <a:p>
+                      <a:pPr>
+                        <a:defRPr sz="1100" b="0">
+                          <a:latin typeface="Arial"/>
+                        </a:defRPr>
+                      </a:pPr>
+                      <a:r>
+                        <a:t>UCB-EVs</a:t>
+                      </a:r>
+                    </a:p>
+                  </a:txBody>
+                  <a:tcPr/>
+                </a:tc>
+                <a:tc>
+                  <a:txBody>
+                    <a:bodyPr/>
+                    <a:lstStyle/>
+                    <a:p>
+                      <a:pPr>
+                        <a:defRPr sz="1100" b="0">
+                          <a:latin typeface="Arial"/>
+                        </a:defRPr>
+                      </a:pPr>
+                      <a:r>
+                        <a:t>Cortisol/DHT-inducedtelogen cell model</a:t>
+                      </a:r>
+                    </a:p>
+                  </a:txBody>
+                  <a:tcPr/>
+                </a:tc>
+                <a:tc>
+                  <a:txBody>
+                    <a:bodyPr/>
+                    <a:lstStyle/>
+                    <a:p>
+                      <a:pPr>
+                        <a:defRPr sz="1100" b="0">
+                          <a:latin typeface="Arial"/>
+                        </a:defRPr>
+                      </a:pPr>
+                      <a:r>
+                        <a:t>In vitro treatment</a:t>
+                      </a:r>
+                    </a:p>
+                  </a:txBody>
+                  <a:tcPr/>
+                </a:tc>
+                <a:tc>
+                  <a:txBody>
+                    <a:bodyPr/>
+                    <a:lstStyle/>
+                    <a:p>
+                      <a:pPr>
+                        <a:defRPr sz="1100" b="0">
+                          <a:latin typeface="Arial"/>
+                        </a:defRPr>
+                      </a:pPr>
+                      <a:r>
+                        <a:t>Hair shaft elongation ↑30%, restoration </a:t>
+                      </a:r>
+                    </a:p>
+                  </a:txBody>
+                  <a:tcPr/>
+                </a:tc>
+              </a:tr>
+              <a:tr h="502920">
+                <a:tc>
+                  <a:txBody>
+                    <a:bodyPr/>
+                    <a:lstStyle/>
+                    <a:p>
+                      <a:pPr>
+                        <a:defRPr sz="1100" b="0">
+                          <a:latin typeface="Arial"/>
+                        </a:defRPr>
+                      </a:pPr>
+                      <a:r>
+                        <a:t>UCB-EVs</a:t>
+                      </a:r>
+                    </a:p>
+                  </a:txBody>
+                  <a:tcPr/>
+                </a:tc>
+                <a:tc>
+                  <a:txBody>
+                    <a:bodyPr/>
+                    <a:lstStyle/>
+                    <a:p>
+                      <a:pPr>
+                        <a:defRPr sz="1100" b="0">
+                          <a:latin typeface="Arial"/>
+                        </a:defRPr>
+                      </a:pPr>
+                      <a:r>
+                        <a:t>C57BL/6 PPA mouse model</a:t>
+                      </a:r>
+                    </a:p>
+                  </a:txBody>
+                  <a:tcPr/>
+                </a:tc>
+                <a:tc>
+                  <a:txBody>
+                    <a:bodyPr/>
+                    <a:lstStyle/>
+                    <a:p>
+                      <a:pPr>
+                        <a:defRPr sz="1100" b="0">
+                          <a:latin typeface="Arial"/>
+                        </a:defRPr>
+                      </a:pPr>
+                      <a:r>
+                        <a:t>Intradermal injection every 3 days ×4</a:t>
+                      </a:r>
+                    </a:p>
+                  </a:txBody>
+                  <a:tcPr/>
+                </a:tc>
+                <a:tc>
+                  <a:txBody>
+                    <a:bodyPr/>
+                    <a:lstStyle/>
+                    <a:p>
+                      <a:pPr>
+                        <a:defRPr sz="1100" b="0">
+                          <a:latin typeface="Arial"/>
+                        </a:defRPr>
+                      </a:pPr>
+                      <a:r>
+                        <a:t>Hair coverage ≈80% vs 30%, hair density </a:t>
+                      </a:r>
+                    </a:p>
+                  </a:txBody>
+                  <a:tcPr/>
+                </a:tc>
+              </a:tr>
+              <a:tr h="502920">
+                <a:tc>
+                  <a:txBody>
+                    <a:bodyPr/>
+                    <a:lstStyle/>
+                    <a:p>
+                      <a:pPr>
+                        <a:defRPr sz="1100" b="0">
+                          <a:latin typeface="Arial"/>
+                        </a:defRPr>
+                      </a:pPr>
+                      <a:r>
+                        <a:t>UCB-EVs</a:t>
+                      </a:r>
+                    </a:p>
+                  </a:txBody>
+                  <a:tcPr/>
+                </a:tc>
+                <a:tc>
+                  <a:txBody>
+                    <a:bodyPr/>
+                    <a:lstStyle/>
+                    <a:p>
+                      <a:pPr>
+                        <a:defRPr sz="1100" b="0">
+                          <a:latin typeface="Arial"/>
+                        </a:defRPr>
+                      </a:pPr>
+                      <a:r>
+                        <a:t>vs 2%minoxidilMouse model</a:t>
+                      </a:r>
+                    </a:p>
+                  </a:txBody>
+                  <a:tcPr/>
+                </a:tc>
+                <a:tc>
+                  <a:txBody>
+                    <a:bodyPr/>
+                    <a:lstStyle/>
+                    <a:p>
+                      <a:pPr>
+                        <a:defRPr sz="1100" b="0">
+                          <a:latin typeface="Arial"/>
+                        </a:defRPr>
+                      </a:pPr>
+                      <a:r>
+                        <a:t>Local injectionComparable hair coverage </a:t>
+                      </a:r>
+                    </a:p>
+                  </a:txBody>
+                  <a:tcPr/>
+                </a:tc>
+                <a:tc>
+                  <a:txBody>
+                    <a:bodyPr/>
+                    <a:lstStyle/>
+                    <a:p>
+                      <a:pPr>
+                        <a:defRPr sz="1100" b="0">
+                          <a:latin typeface="Arial"/>
+                        </a:defRPr>
+                      </a:pPr>
+                      <a:r>
+                        <a:t>hUCMSC-derived exosomes AGA animal model</a:t>
+                      </a:r>
+                    </a:p>
+                  </a:txBody>
+                  <a:tcPr/>
+                </a:tc>
+              </a:tr>
+              <a:tr h="502920">
+                <a:tc>
+                  <a:txBody>
+                    <a:bodyPr/>
+                    <a:lstStyle/>
+                    <a:p>
+                      <a:pPr>
+                        <a:defRPr sz="1100" b="0">
+                          <a:latin typeface="Arial"/>
+                        </a:defRPr>
+                      </a:pPr>
+                      <a:r>
+                        <a:t>UCB-MSC-EVs</a:t>
+                      </a:r>
+                    </a:p>
+                  </a:txBody>
+                  <a:tcPr/>
+                </a:tc>
+                <a:tc>
+                  <a:txBody>
+                    <a:bodyPr/>
+                    <a:lstStyle/>
+                    <a:p>
+                      <a:pPr>
+                        <a:defRPr sz="1100" b="0">
+                          <a:latin typeface="Arial"/>
+                        </a:defRPr>
+                      </a:pPr>
+                      <a:r>
+                        <a:t>Mouse wound healing model</a:t>
+                      </a:r>
+                    </a:p>
+                  </a:txBody>
+                  <a:tcPr/>
+                </a:tc>
+                <a:tc>
+                  <a:txBody>
+                    <a:bodyPr/>
+                    <a:lstStyle/>
+                    <a:p>
+                      <a:pPr>
+                        <a:defRPr sz="1100" b="0">
+                          <a:latin typeface="Arial"/>
+                        </a:defRPr>
+                      </a:pPr>
+                      <a:r>
+                        <a:t>Local treatment</a:t>
+                      </a:r>
+                    </a:p>
+                  </a:txBody>
+                  <a:tcPr/>
+                </a:tc>
+                <a:tc>
+                  <a:txBody>
+                    <a:bodyPr/>
+                    <a:lstStyle/>
+                    <a:p>
+                      <a:pPr>
+                        <a:defRPr sz="1100" b="0">
+                          <a:latin typeface="Arial"/>
+                        </a:defRPr>
+                      </a:pPr>
+                      <a:r>
+                        <a:t>Angiogenesis, ECM remodeling Indirect (w</a:t>
+                      </a:r>
+                    </a:p>
+                  </a:txBody>
+                  <a:tcPr/>
+                </a:tc>
+              </a:tr>
+            </a:tbl>
+          </a:graphicData>
+        </a:graphic>
+      </p:graphicFrame>
+    </p:spTree>
+  </p:cSld>
+  <p:clrMapOvr>
+    <a:masterClrMapping/>
+  </p:clrMapOvr>
+</p:sld>
+</file>
+
+<file path=ppt/slides/slide5.xml><?xml version="1.0" encoding="utf-8"?>
 <p:sld xmlns:a="http://schemas.openxmlformats.org/drawingml/2006/main" xmlns:p="http://schemas.openxmlformats.org/presentationml/2006/main" xmlns:r="http://schemas.openxmlformats.org/officeDocument/2006/relationships">
   <p:cSld>
     <p:bg>
@@ -4785,7 +5821,7 @@
                 </a:solidFill>
                 <a:latin typeface="Arial"/>
               </a:rPr>
-              <a:t>SD presents in 40%-50% of all patients diagnosed with AGA.</a:t>
+              <a:t>Umbilical cord blood-derived extracellular vesicles (UCB-EVs)-nanosized, lipid-bilayer-enclosed particles enriched with microRNAs, growth factors, and proteins-have shown considerable promise in regenerative medicine owing to their low immunogenicity, high biocompatibility, and tissue-repair capacity.</a:t>
             </a:r>
           </a:p>
         </p:txBody>
@@ -4798,7 +5834,7 @@
 </p:sld>
 </file>
 
-<file path=ppt/slides/slide5.xml><?xml version="1.0" encoding="utf-8"?>
+<file path=ppt/slides/slide6.xml><?xml version="1.0" encoding="utf-8"?>
 <p:sld xmlns:a="http://schemas.openxmlformats.org/drawingml/2006/main" xmlns:p="http://schemas.openxmlformats.org/presentationml/2006/main" xmlns:r="http://schemas.openxmlformats.org/officeDocument/2006/relationships">
   <p:cSld>
     <p:bg>
@@ -4927,7 +5963,7 @@
 </p:sld>
 </file>
 
-<file path=ppt/slides/slide6.xml><?xml version="1.0" encoding="utf-8"?>
+<file path=ppt/slides/slide7.xml><?xml version="1.0" encoding="utf-8"?>
 <p:sld xmlns:a="http://schemas.openxmlformats.org/drawingml/2006/main" xmlns:p="http://schemas.openxmlformats.org/presentationml/2006/main" xmlns:r="http://schemas.openxmlformats.org/officeDocument/2006/relationships">
   <p:cSld>
     <p:bg>
@@ -4976,210 +6012,6 @@
                 <a:latin typeface="Arial"/>
               </a:rPr>
               <a:t>더 자세한 내용은 원문 링크에서 확인하세요. 매일 새로운 탈모 연구, 팔로우하고 놓치지 마세요!</a:t>
-            </a:r>
-          </a:p>
-        </p:txBody>
-      </p:sp>
-    </p:spTree>
-  </p:cSld>
-  <p:clrMapOvr>
-    <a:masterClrMapping/>
-  </p:clrMapOvr>
-</p:sld>
-</file>
-
-<file path=ppt/slides/slide7.xml><?xml version="1.0" encoding="utf-8"?>
-<p:sld xmlns:a="http://schemas.openxmlformats.org/drawingml/2006/main" xmlns:p="http://schemas.openxmlformats.org/presentationml/2006/main" xmlns:r="http://schemas.openxmlformats.org/officeDocument/2006/relationships">
-  <p:cSld>
-    <p:bg>
-      <p:bgPr>
-        <a:solidFill>
-          <a:srgbClr val="12142A"/>
-        </a:solidFill>
-        <a:effectLst/>
-      </p:bgPr>
-    </p:bg>
-    <p:spTree>
-      <p:nvGrpSpPr>
-        <p:cNvPr id="1" name=""/>
-        <p:cNvGrpSpPr/>
-        <p:nvPr/>
-      </p:nvGrpSpPr>
-      <p:grpSpPr/>
-      <p:sp>
-        <p:nvSpPr>
-          <p:cNvPr id="2" name="TextBox 1"/>
-          <p:cNvSpPr txBox="1"/>
-          <p:nvPr/>
-        </p:nvSpPr>
-        <p:spPr>
-          <a:xfrm>
-            <a:off x="365760" y="457200"/>
-            <a:ext cx="4828032" cy="457200"/>
-          </a:xfrm>
-          <a:prstGeom prst="rect">
-            <a:avLst/>
-          </a:prstGeom>
-          <a:noFill/>
-        </p:spPr>
-        <p:txBody>
-          <a:bodyPr wrap="square" anchor="ctr">
-            <a:spAutoFit/>
-          </a:bodyPr>
-          <a:lstStyle/>
-          <a:p>
-            <a:pPr algn="l"/>
-            <a:r>
-              <a:rPr sz="1600" b="1">
-                <a:solidFill>
-                  <a:srgbClr val="FF6B6B"/>
-                </a:solidFill>
-                <a:latin typeface="Arial"/>
-              </a:rPr>
-              <a:t>본문 요약 (편집용)</a:t>
-            </a:r>
-          </a:p>
-        </p:txBody>
-      </p:sp>
-      <p:sp>
-        <p:nvSpPr>
-          <p:cNvPr id="3" name="TextBox 2"/>
-          <p:cNvSpPr txBox="1"/>
-          <p:nvPr/>
-        </p:nvSpPr>
-        <p:spPr>
-          <a:xfrm>
-            <a:off x="365760" y="1097280"/>
-            <a:ext cx="4828032" cy="457200"/>
-          </a:xfrm>
-          <a:prstGeom prst="rect">
-            <a:avLst/>
-          </a:prstGeom>
-          <a:noFill/>
-        </p:spPr>
-        <p:txBody>
-          <a:bodyPr wrap="square" anchor="t">
-            <a:spAutoFit/>
-          </a:bodyPr>
-          <a:lstStyle/>
-          <a:p>
-            <a:pPr algn="l"/>
-            <a:r>
-              <a:rPr sz="1300" b="1">
-                <a:solidFill>
-                  <a:srgbClr val="FFFFFF"/>
-                </a:solidFill>
-                <a:latin typeface="Arial"/>
-              </a:rPr>
-              <a:t>◆ 배경 — 1. Introduction</a:t>
-            </a:r>
-          </a:p>
-        </p:txBody>
-      </p:sp>
-      <p:sp>
-        <p:nvSpPr>
-          <p:cNvPr id="4" name="TextBox 3"/>
-          <p:cNvSpPr txBox="1"/>
-          <p:nvPr/>
-        </p:nvSpPr>
-        <p:spPr>
-          <a:xfrm>
-            <a:off x="457200" y="1600200"/>
-            <a:ext cx="4736592" cy="3566160"/>
-          </a:xfrm>
-          <a:prstGeom prst="rect">
-            <a:avLst/>
-          </a:prstGeom>
-          <a:noFill/>
-        </p:spPr>
-        <p:txBody>
-          <a:bodyPr wrap="square" anchor="t">
-            <a:spAutoFit/>
-          </a:bodyPr>
-          <a:lstStyle/>
-          <a:p>
-            <a:pPr algn="l"/>
-            <a:r>
-              <a:rPr sz="1000" b="0">
-                <a:solidFill>
-                  <a:srgbClr val="D5D8EA"/>
-                </a:solidFill>
-                <a:latin typeface="Arial"/>
-              </a:rPr>
-              <a:t>· Seborrheic dermatitis (SD) is a common, recurrent, chronic inflammatory skin disease that predominantly affects sebaceous gland‐rich areas, particularly the scalp, and is characterized by yellow‐red patches covered with greasy, yellowish scales or crusts and varying degrees of pruritus.
-· Androgenetic alopecia (AGA), formerly known as seborrheic alopecia, is a progressive androgen‐dependent disorder characterized by hair follicle miniaturization with a typical patterned distribution.
-· Although SD and AGA are distinct conditions, both exhibit high prevalence and incidence rates, with a predilection for young adults and older men.</a:t>
-            </a:r>
-          </a:p>
-        </p:txBody>
-      </p:sp>
-      <p:sp>
-        <p:nvSpPr>
-          <p:cNvPr id="5" name="TextBox 4"/>
-          <p:cNvSpPr txBox="1"/>
-          <p:nvPr/>
-        </p:nvSpPr>
-        <p:spPr>
-          <a:xfrm>
-            <a:off x="365760" y="5303520"/>
-            <a:ext cx="4828032" cy="457200"/>
-          </a:xfrm>
-          <a:prstGeom prst="rect">
-            <a:avLst/>
-          </a:prstGeom>
-          <a:noFill/>
-        </p:spPr>
-        <p:txBody>
-          <a:bodyPr wrap="square" anchor="t">
-            <a:spAutoFit/>
-          </a:bodyPr>
-          <a:lstStyle/>
-          <a:p>
-            <a:pPr algn="l"/>
-            <a:r>
-              <a:rPr sz="1300" b="1">
-                <a:solidFill>
-                  <a:srgbClr val="FFFFFF"/>
-                </a:solidFill>
-                <a:latin typeface="Arial"/>
-              </a:rPr>
-              <a:t>◆ 그 밖의 내용 — 2. Clinical and Epidemiological Overlap Between SD and AGA</a:t>
-            </a:r>
-          </a:p>
-        </p:txBody>
-      </p:sp>
-      <p:sp>
-        <p:nvSpPr>
-          <p:cNvPr id="6" name="TextBox 5"/>
-          <p:cNvSpPr txBox="1"/>
-          <p:nvPr/>
-        </p:nvSpPr>
-        <p:spPr>
-          <a:xfrm>
-            <a:off x="457200" y="5806440"/>
-            <a:ext cx="4736592" cy="3566160"/>
-          </a:xfrm>
-          <a:prstGeom prst="rect">
-            <a:avLst/>
-          </a:prstGeom>
-          <a:noFill/>
-        </p:spPr>
-        <p:txBody>
-          <a:bodyPr wrap="square" anchor="t">
-            <a:spAutoFit/>
-          </a:bodyPr>
-          <a:lstStyle/>
-          <a:p>
-            <a:pPr algn="l"/>
-            <a:r>
-              <a:rPr sz="1000" b="0">
-                <a:solidFill>
-                  <a:srgbClr val="D5D8EA"/>
-                </a:solidFill>
-                <a:latin typeface="Arial"/>
-              </a:rPr>
-              <a:t>· In a study by Jang et al. involving 1218 patients with AGA, SD was the most common concomitant disease in both sexes, with a prevalence of 51.2% in men and 45.7% in women.
-· Another study reported an SD prevalence of 42.1% among patients with AGA, with both prevalence and severity scores increasing in parallel with AGA severity.</a:t>
             </a:r>
           </a:p>
         </p:txBody>
@@ -5275,7 +6107,7 @@
                 </a:solidFill>
                 <a:latin typeface="Arial"/>
               </a:rPr>
-              <a:t>◆ 그 밖의 내용 — 3. Mechanism of Association Between SD and AGA</a:t>
+              <a:t>◆ 배경 — Introduction</a:t>
             </a:r>
           </a:p>
         </p:txBody>
@@ -5310,7 +6142,9 @@
                 </a:solidFill>
                 <a:latin typeface="Arial"/>
               </a:rPr>
-              <a:t>· Evidence from the UK Biobank and twin studies has confirmed that the heritability of AGA in males is estimated at 62%–80%.</a:t>
+              <a:t>· Female postpartum alopecia (PPA) represents a significant clinical and psychosocial challenge, emerging as one of the most common dermatological conditions affecting women in the postpartum period.
+· Epidemiological data indicates that the prevalence of PPA is remarkably high, with studies suggesting that over 90% of postpartum women experience some degree of hair loss (3).
+· At the molecular level, UCB-EVs are enriched with specific miRNAs, such as miR-21-5p and let-7b-5p, which are capable of targeting and modulating key signaling pathways critical for hair follicle biology (2).</a:t>
             </a:r>
           </a:p>
         </p:txBody>
@@ -5345,7 +6179,7 @@
                 </a:solidFill>
                 <a:latin typeface="Arial"/>
               </a:rPr>
-              <a:t>◆ 그 밖의 내용 — 4. Integrated Mechanism of SD–AGA Coexistence</a:t>
+              <a:t>◆ 그 밖의 내용 — Biological characteristics and preparation of UCB-EVs</a:t>
             </a:r>
           </a:p>
         </p:txBody>
@@ -5380,7 +6214,8 @@
                 </a:solidFill>
                 <a:latin typeface="Arial"/>
               </a:rPr>
-              <a:t>· Based on the aforementioned information, we have summarized the coexistence mechanism between SD and AGA.</a:t>
+              <a:t>· They are broadly classified into exosomes (30–150 nm), microvesicles (100–1000 nm), and apoptotic bodies (&gt;1000 nm) based on their biogenesis and size (9).
+· This typically involves a combination of techniques: This typically involves a combination of techniques: dynamic light scattering (DLS), also known as photon correlation spectroscopy, which measures time-dependent fluctuations in scattered light caused by Brownian motion of particles to determine the hydrodynamic diameter and polydispersity index (PDI) of EVs (21); Nanoparticle tracking analysis (NTA) to determine particle size distribution and concentration (13, 14); Western blot analysis to confirm the presence of EV protein markers such as CD63, CD81, and TSG101 (13, 15); and transmission electron microscopy (TEM) or cryo-electron microscopy (cryo-EM) to verify the characteristic spherical, lipid bilayer morphology of the vesicles (14, 22).</a:t>
             </a:r>
           </a:p>
         </p:txBody>
@@ -5476,7 +6311,7 @@
                 </a:solidFill>
                 <a:latin typeface="Arial"/>
               </a:rPr>
-              <a:t>◆ 그 밖의 내용 — 5. Comprehensive Treatment Strategies Based on Target Synergy and Prospects</a:t>
+              <a:t>◆ 고찰 — Pathogenesis of postpartum hair loss in women and limitations of current treatments</a:t>
             </a:r>
           </a:p>
         </p:txBody>
@@ -5511,7 +6346,80 @@
                 </a:solidFill>
                 <a:latin typeface="Arial"/>
               </a:rPr>
-              <a:t>· One study reported that daily use of a 1% zinc pyrithione shampoo for 26 weeks resulted in moderate and sustained improvement in hair growth.</a:t>
+              <a:t>· In fact, the prevalence of thyroid abnormalities in patients with telogen effluvium has been documented to be between 5.7% and 17%, underscoring the importance of screening for postpartum thyroiditis in patients presenting with persistent postpartum hair loss (30).
+· Studies show that low ferritin is significantly associated with telogen effluvium, and vitamin D, which acts as a hormone, is crucial for proper hair follicle cycling through its involvement in signaling pathways of growth and differentiation (33–35).
+· Evidence from other forms of alopecia, such as that seen in COVID-19, suggests that severe systemic inflammation can dramatically increase the risk of telogen effluvium, with patients exhibiting higher levels of inflammatory biomarkers like C-reactive protein and IL-1β correlating with increased hair shedding (36).
+· These cytokines directly inhibit the proliferation of hair follicle stem cells and keratinocytes, by activating signaling cascades, most notably the JAK-STAT pathway (38–40).</a:t>
+            </a:r>
+          </a:p>
+        </p:txBody>
+      </p:sp>
+      <p:sp>
+        <p:nvSpPr>
+          <p:cNvPr id="5" name="TextBox 4"/>
+          <p:cNvSpPr txBox="1"/>
+          <p:nvPr/>
+        </p:nvSpPr>
+        <p:spPr>
+          <a:xfrm>
+            <a:off x="365760" y="5303520"/>
+            <a:ext cx="4828032" cy="457200"/>
+          </a:xfrm>
+          <a:prstGeom prst="rect">
+            <a:avLst/>
+          </a:prstGeom>
+          <a:noFill/>
+        </p:spPr>
+        <p:txBody>
+          <a:bodyPr wrap="square" anchor="t">
+            <a:spAutoFit/>
+          </a:bodyPr>
+          <a:lstStyle/>
+          <a:p>
+            <a:pPr algn="l"/>
+            <a:r>
+              <a:rPr sz="1300" b="1">
+                <a:solidFill>
+                  <a:srgbClr val="FFFFFF"/>
+                </a:solidFill>
+                <a:latin typeface="Arial"/>
+              </a:rPr>
+              <a:t>◆ 그 밖의 내용 — Molecular mechanisms of UCB-EVs in promoting hair follicle regeneration</a:t>
+            </a:r>
+          </a:p>
+        </p:txBody>
+      </p:sp>
+      <p:sp>
+        <p:nvSpPr>
+          <p:cNvPr id="6" name="TextBox 5"/>
+          <p:cNvSpPr txBox="1"/>
+          <p:nvPr/>
+        </p:nvSpPr>
+        <p:spPr>
+          <a:xfrm>
+            <a:off x="457200" y="5806440"/>
+            <a:ext cx="4736592" cy="3566160"/>
+          </a:xfrm>
+          <a:prstGeom prst="rect">
+            <a:avLst/>
+          </a:prstGeom>
+          <a:noFill/>
+        </p:spPr>
+        <p:txBody>
+          <a:bodyPr wrap="square" anchor="t">
+            <a:spAutoFit/>
+          </a:bodyPr>
+          <a:lstStyle/>
+          <a:p>
+            <a:pPr algn="l"/>
+            <a:r>
+              <a:rPr sz="1000" b="0">
+                <a:solidFill>
+                  <a:srgbClr val="D5D8EA"/>
+                </a:solidFill>
+                <a:latin typeface="Arial"/>
+              </a:rPr>
+              <a:t>· Table 1Summary of UCB-EV studies for hair regeneration with categorized evidence levels.EV sourceModelIntervention main mechanism/outcomeEvidence levelUCB-EVsHumanDPC/HFK coculture50 μg/mL for 48 hProliferation ↑45%, apoptosis ↓35%, Versican/ALP ↑,Wnt/β- catenin activation Direct (in vitro, PPA-related cells)UCB-EVsCortisol/DHT-inducedtelogen cell modelIn vitro treatmentHair shaft elongation ↑30%, restoration of Ki67/PCNA Direct (in vitro, hormonal/stress-induced telogen)UCB-EVsC57BL/6 PPA mouse modelIntradermal injection every 3 days ×4Hair coverage ≈80% vs 30%, hair density ↑2-fold, follicle number ↑50%, anagen 20%→65%, CD31 ↑ Direct (in vivo, PPA model)UCB-EVsvs 2%minoxidilMouse modelLocal injectionComparable hair coverage at day 14; at day 21, anagen60% (UCB-EVs) vs 40% (minoxidil)Direct comparative (model type to be specified)hUCMSC-derived exosomes AGA animal model Local administration Rescue from DHT damage, enlarged follicles, telogen→anagen, Wnt/β-catenin activation Indirect (other EV source, AGA model)Macrophage-derived EVs Balb/c mice Injection Wnt3a/7b activation, DPC proliferation/migration ↑, VEGF/KGF ↑ Indirect (other EV source, generic hair growth)Fibroblast-derived EVs Ex vivo human hair follicles In vitro culture Hair shaft elongation, Wnt/βcatenin activationIndirect (other EV source, follicle culture)UCB-MSC-EVsMouse wound healing modelLocal treatmentAngiogenesis, ECM remodeling Indirect (wound healing model)Direct evidence indicates that the intervention was UCB-EV and the model was PPA or PPA-related; indirect evidence indicates other EV sources or non-PPA models.</a:t>
             </a:r>
           </a:p>
         </p:txBody>

</xml_diff>

<commit_message>
chore: daily content 2026-10-14
</commit_message>
<xml_diff>
--- a/pwa/data/latest/slides.pptx
+++ b/pwa/data/latest/slides.pptx
@@ -15,8 +15,6 @@
     <p:sldId id="263" r:id="rId15"/>
     <p:sldId id="264" r:id="rId16"/>
     <p:sldId id="265" r:id="rId17"/>
-    <p:sldId id="266" r:id="rId18"/>
-    <p:sldId id="267" r:id="rId19"/>
   </p:sldIdLst>
   <p:sldSz cx="5559552" cy="9875520" type="screen4x3"/>
   <p:notesSz cx="6858000" cy="9144000"/>
@@ -518,162 +516,12 @@
           </a:p>
           <a:p>
             <a:r>
-              <a:t>대본: 오늘의 논문 Frontiers in immunology에 실린 새 연구입니다</a:t>
+              <a:t>대본: 35.9% 이 숫자, 탈모 연구가 새로 내놨습니다</a:t>
             </a:r>
           </a:p>
           <a:p>
             <a:r>
               <a:t>연출 노트: 0.5초 안에 스크롤을 멈추게 하는 구간. 숫자를 크게 읽어준다.</a:t>
-            </a:r>
-          </a:p>
-        </p:txBody>
-      </p:sp>
-      <p:sp>
-        <p:nvSpPr>
-          <p:cNvPr id="4" name="Slide Number Placeholder 3"/>
-          <p:cNvSpPr>
-            <a:spLocks noGrp="1"/>
-          </p:cNvSpPr>
-          <p:nvPr>
-            <p:ph type="sldNum" idx="5" sz="quarter"/>
-          </p:nvPr>
-        </p:nvSpPr>
-        <p:spPr/>
-      </p:sp>
-    </p:spTree>
-  </p:cSld>
-  <p:clrMapOvr>
-    <a:masterClrMapping/>
-  </p:clrMapOvr>
-</p:notes>
-</file>
-
-<file path=ppt/notesSlides/notesSlide10.xml><?xml version="1.0" encoding="utf-8"?>
-<p:notes xmlns:a="http://schemas.openxmlformats.org/drawingml/2006/main" xmlns:p="http://schemas.openxmlformats.org/presentationml/2006/main" xmlns:r="http://schemas.openxmlformats.org/officeDocument/2006/relationships">
-  <p:cSld>
-    <p:spTree>
-      <p:nvGrpSpPr>
-        <p:cNvPr id="1" name=""/>
-        <p:cNvGrpSpPr/>
-        <p:nvPr/>
-      </p:nvGrpSpPr>
-      <p:grpSpPr>
-        <a:xfrm>
-          <a:off x="0" y="0"/>
-          <a:ext cx="0" cy="0"/>
-          <a:chOff x="0" y="0"/>
-          <a:chExt cx="0" cy="0"/>
-        </a:xfrm>
-      </p:grpSpPr>
-      <p:sp>
-        <p:nvSpPr>
-          <p:cNvPr id="2" name="Slide Image Placeholder 1"/>
-          <p:cNvSpPr>
-            <a:spLocks noGrp="1"/>
-          </p:cNvSpPr>
-          <p:nvPr>
-            <p:ph type="sldImg" idx="2"/>
-          </p:nvPr>
-        </p:nvSpPr>
-        <p:spPr/>
-      </p:sp>
-      <p:sp>
-        <p:nvSpPr>
-          <p:cNvPr id="3" name="Notes Placeholder 2"/>
-          <p:cNvSpPr>
-            <a:spLocks noGrp="1"/>
-          </p:cNvSpPr>
-          <p:nvPr>
-            <p:ph type="body" idx="3" sz="quarter"/>
-          </p:nvPr>
-        </p:nvSpPr>
-        <p:spPr/>
-        <p:txBody>
-          <a:bodyPr/>
-          <a:lstStyle/>
-          <a:p>
-            <a:r>
-              <a:t>편집 참고용 슬라이드입니다. 영상에는 쓰지 않아도 됩니다.</a:t>
-            </a:r>
-          </a:p>
-          <a:p>
-            <a:r>
-              <a:t>원문 영어 문장을 그대로 발췌했으므로 번역·검수 후 사용하세요.</a:t>
-            </a:r>
-          </a:p>
-        </p:txBody>
-      </p:sp>
-      <p:sp>
-        <p:nvSpPr>
-          <p:cNvPr id="4" name="Slide Number Placeholder 3"/>
-          <p:cNvSpPr>
-            <a:spLocks noGrp="1"/>
-          </p:cNvSpPr>
-          <p:nvPr>
-            <p:ph type="sldNum" idx="5" sz="quarter"/>
-          </p:nvPr>
-        </p:nvSpPr>
-        <p:spPr/>
-      </p:sp>
-    </p:spTree>
-  </p:cSld>
-  <p:clrMapOvr>
-    <a:masterClrMapping/>
-  </p:clrMapOvr>
-</p:notes>
-</file>
-
-<file path=ppt/notesSlides/notesSlide11.xml><?xml version="1.0" encoding="utf-8"?>
-<p:notes xmlns:a="http://schemas.openxmlformats.org/drawingml/2006/main" xmlns:p="http://schemas.openxmlformats.org/presentationml/2006/main" xmlns:r="http://schemas.openxmlformats.org/officeDocument/2006/relationships">
-  <p:cSld>
-    <p:spTree>
-      <p:nvGrpSpPr>
-        <p:cNvPr id="1" name=""/>
-        <p:cNvGrpSpPr/>
-        <p:nvPr/>
-      </p:nvGrpSpPr>
-      <p:grpSpPr>
-        <a:xfrm>
-          <a:off x="0" y="0"/>
-          <a:ext cx="0" cy="0"/>
-          <a:chOff x="0" y="0"/>
-          <a:chExt cx="0" cy="0"/>
-        </a:xfrm>
-      </p:grpSpPr>
-      <p:sp>
-        <p:nvSpPr>
-          <p:cNvPr id="2" name="Slide Image Placeholder 1"/>
-          <p:cNvSpPr>
-            <a:spLocks noGrp="1"/>
-          </p:cNvSpPr>
-          <p:nvPr>
-            <p:ph type="sldImg" idx="2"/>
-          </p:nvPr>
-        </p:nvSpPr>
-        <p:spPr/>
-      </p:sp>
-      <p:sp>
-        <p:nvSpPr>
-          <p:cNvPr id="3" name="Notes Placeholder 2"/>
-          <p:cNvSpPr>
-            <a:spLocks noGrp="1"/>
-          </p:cNvSpPr>
-          <p:nvPr>
-            <p:ph type="body" idx="3" sz="quarter"/>
-          </p:nvPr>
-        </p:nvSpPr>
-        <p:spPr/>
-        <p:txBody>
-          <a:bodyPr/>
-          <a:lstStyle/>
-          <a:p>
-            <a:r>
-              <a:t>편집 참고용 슬라이드입니다. 영상에는 쓰지 않아도 됩니다.</a:t>
-            </a:r>
-          </a:p>
-          <a:p>
-            <a:r>
-              <a:t>원문 영어 문장을 그대로 발췌했으므로 번역·검수 후 사용하세요.</a:t>
             </a:r>
           </a:p>
         </p:txBody>
@@ -748,7 +596,7 @@
           </a:p>
           <a:p>
             <a:r>
-              <a:t>대본: 《Frontiers in immunology》 - Translating umbilical cord blood extracellular vesicles into a novel therapy for postpartum alopecia: a mechanistic and preclinical review</a:t>
+              <a:t>대본: 《Clinical, cosmetic and investigational dermatology》 - Exploratory Identification of Multidimensional Treatment-Response Profiles in Androgenetic Alopecia Treated with Combined Scalp Microneedling and Topical Minoxidil Using Unsupervised Clustering</a:t>
             </a:r>
           </a:p>
           <a:p>
@@ -828,7 +676,7 @@
           </a:p>
           <a:p>
             <a:r>
-              <a:t>대본: Postpartum alopecia (PPA) is a common physiological hair loss in women, characterized by complex pathogenesis involving abrupt postpartum hormonal withdrawal, disrupted hair follicle cycling, local microenvironmental inflammation, and oxidative stress.</a:t>
+              <a:t>대본: Methods: In this prospective cohort study, 156 patients with AGA received standardized combination therapy (microneedling 1.0 mm depth, biweekly; 5% topical minoxidil, twice daily) for 24 weeks, with longitudinal trichoscopic, molecular and clinical assessments.</a:t>
             </a:r>
           </a:p>
           <a:p>
@@ -903,17 +751,17 @@
           <a:lstStyle/>
           <a:p>
             <a:r>
-              <a:t>[paper_table] 약 8초</a:t>
-            </a:r>
-          </a:p>
-          <a:p>
-            <a:r>
-              <a:t>대본: 표로 보면 이렇습니다. Summary of UCB-EV studies for hair regeneration with categorized evidence levels.</a:t>
-            </a:r>
-          </a:p>
-          <a:p>
-            <a:r>
-              <a:t>연출 노트: 핵심 숫자 한 칸만 짚어준다. 표는 셀을 직접 수정할 수 있다.</a:t>
+              <a:t>[key_finding_2] 약 10초</a:t>
+            </a:r>
+          </a:p>
+          <a:p>
+            <a:r>
+              <a:t>대본: Results: Silhouette analysis indicated weak global cluster structure (k=2, 0.274; k=3, 0.168); a three-cluster solution was retained as an exploratory, clinically motivated grouping and labelled Robust (n=45, 28.8%), Moderate (n=56, 35.9%) and Limited (n=55, 35.3%) responders.</a:t>
+            </a:r>
+          </a:p>
+          <a:p>
+            <a:r>
+              <a:t>연출 노트: 핵심 포인트 2.</a:t>
             </a:r>
           </a:p>
         </p:txBody>
@@ -983,17 +831,17 @@
           <a:lstStyle/>
           <a:p>
             <a:r>
-              <a:t>[key_finding_2] 약 10초</a:t>
-            </a:r>
-          </a:p>
-          <a:p>
-            <a:r>
-              <a:t>대본: Umbilical cord blood-derived extracellular vesicles (UCB-EVs)-nanosized, lipid-bilayer-enclosed particles enriched with microRNAs, growth factors, and proteins-have shown considerable promise in regenerative medicine owing to their low immunogenicity, high biocompatibility, and tissue-repair capacity.</a:t>
-            </a:r>
-          </a:p>
-          <a:p>
-            <a:r>
-              <a:t>연출 노트: 핵심 포인트 2.</a:t>
+              <a:t>[my_take] 약 10초</a:t>
+            </a:r>
+          </a:p>
+          <a:p>
+            <a:r>
+              <a:t>대본: 탈모 연구, 매일 쉽게 정리해드립니다 🙂</a:t>
+            </a:r>
+          </a:p>
+          <a:p>
+            <a:r>
+              <a:t>연출 노트: 본인 사진 + 코멘트. 문구를 직접 바꿔 쓰세요.</a:t>
             </a:r>
           </a:p>
         </p:txBody>
@@ -1063,17 +911,17 @@
           <a:lstStyle/>
           <a:p>
             <a:r>
-              <a:t>[my_take] 약 10초</a:t>
-            </a:r>
-          </a:p>
-          <a:p>
-            <a:r>
-              <a:t>대본: 탈모 연구, 매일 쉽게 정리해드립니다 🙂</a:t>
-            </a:r>
-          </a:p>
-          <a:p>
-            <a:r>
-              <a:t>연출 노트: 본인 사진 + 코멘트. 문구를 직접 바꿔 쓰세요.</a:t>
+              <a:t>[cta] 약 8초</a:t>
+            </a:r>
+          </a:p>
+          <a:p>
+            <a:r>
+              <a:t>대본: 더 자세한 내용은 원문 링크에서 확인하세요. 매일 새로운 탈모 연구, 팔로우하고 놓치지 마세요!</a:t>
+            </a:r>
+          </a:p>
+          <a:p>
+            <a:r>
+              <a:t>연출 노트: 원문 링크는 고정 댓글로 안내.</a:t>
             </a:r>
           </a:p>
         </p:txBody>
@@ -1143,17 +991,12 @@
           <a:lstStyle/>
           <a:p>
             <a:r>
-              <a:t>[cta] 약 8초</a:t>
-            </a:r>
-          </a:p>
-          <a:p>
-            <a:r>
-              <a:t>대본: 더 자세한 내용은 원문 링크에서 확인하세요. 매일 새로운 탈모 연구, 팔로우하고 놓치지 마세요!</a:t>
-            </a:r>
-          </a:p>
-          <a:p>
-            <a:r>
-              <a:t>연출 노트: 원문 링크는 고정 댓글로 안내.</a:t>
+              <a:t>편집 참고용 슬라이드입니다. 영상에는 쓰지 않아도 됩니다.</a:t>
+            </a:r>
+          </a:p>
+          <a:p>
+            <a:r>
+              <a:t>원문 영어 문장을 그대로 발췌했으므로 번역·검수 후 사용하세요.</a:t>
             </a:r>
           </a:p>
         </p:txBody>
@@ -4347,7 +4190,7 @@
                 </a:solidFill>
                 <a:latin typeface="Arial"/>
               </a:rPr>
-              <a:t>FRONTIERS IN IMMUNOLOGY</a:t>
+              <a:t>CLINICAL, COSMETIC AND INVESTIGATIONAL D</a:t>
             </a:r>
           </a:p>
         </p:txBody>
@@ -4382,7 +4225,7 @@
                 </a:solidFill>
                 <a:latin typeface="Arial"/>
               </a:rPr>
-              <a:t>오늘의 논문</a:t>
+              <a:t>35.9%</a:t>
             </a:r>
           </a:p>
         </p:txBody>
@@ -4417,7 +4260,7 @@
                 </a:solidFill>
                 <a:latin typeface="Arial"/>
               </a:rPr>
-              <a:t>Frontiers in immunology에 실린 새 연구입니다</a:t>
+              <a:t>이 숫자, 탈모 연구가 새로 내놨습니다</a:t>
             </a:r>
           </a:p>
         </p:txBody>
@@ -4491,340 +4334,6 @@
         </p:nvSpPr>
         <p:spPr>
           <a:xfrm>
-            <a:off x="365760" y="457200"/>
-            <a:ext cx="4828032" cy="457200"/>
-          </a:xfrm>
-          <a:prstGeom prst="rect">
-            <a:avLst/>
-          </a:prstGeom>
-          <a:noFill/>
-        </p:spPr>
-        <p:txBody>
-          <a:bodyPr wrap="square" anchor="ctr">
-            <a:spAutoFit/>
-          </a:bodyPr>
-          <a:lstStyle/>
-          <a:p>
-            <a:pPr algn="l"/>
-            <a:r>
-              <a:rPr sz="1600" b="1">
-                <a:solidFill>
-                  <a:srgbClr val="FF6B6B"/>
-                </a:solidFill>
-                <a:latin typeface="Arial"/>
-              </a:rPr>
-              <a:t>본문 요약 (편집용)</a:t>
-            </a:r>
-          </a:p>
-        </p:txBody>
-      </p:sp>
-      <p:sp>
-        <p:nvSpPr>
-          <p:cNvPr id="3" name="TextBox 2"/>
-          <p:cNvSpPr txBox="1"/>
-          <p:nvPr/>
-        </p:nvSpPr>
-        <p:spPr>
-          <a:xfrm>
-            <a:off x="365760" y="1097280"/>
-            <a:ext cx="4828032" cy="457200"/>
-          </a:xfrm>
-          <a:prstGeom prst="rect">
-            <a:avLst/>
-          </a:prstGeom>
-          <a:noFill/>
-        </p:spPr>
-        <p:txBody>
-          <a:bodyPr wrap="square" anchor="t">
-            <a:spAutoFit/>
-          </a:bodyPr>
-          <a:lstStyle/>
-          <a:p>
-            <a:pPr algn="l"/>
-            <a:r>
-              <a:rPr sz="1300" b="1">
-                <a:solidFill>
-                  <a:srgbClr val="FFFFFF"/>
-                </a:solidFill>
-                <a:latin typeface="Arial"/>
-              </a:rPr>
-              <a:t>◆ 그 밖의 내용 — Preclinical evidence for UCB-EVs in treating postpartum hair loss</a:t>
-            </a:r>
-          </a:p>
-        </p:txBody>
-      </p:sp>
-      <p:sp>
-        <p:nvSpPr>
-          <p:cNvPr id="4" name="TextBox 3"/>
-          <p:cNvSpPr txBox="1"/>
-          <p:nvPr/>
-        </p:nvSpPr>
-        <p:spPr>
-          <a:xfrm>
-            <a:off x="457200" y="1600200"/>
-            <a:ext cx="4736592" cy="3566160"/>
-          </a:xfrm>
-          <a:prstGeom prst="rect">
-            <a:avLst/>
-          </a:prstGeom>
-          <a:noFill/>
-        </p:spPr>
-        <p:txBody>
-          <a:bodyPr wrap="square" anchor="t">
-            <a:spAutoFit/>
-          </a:bodyPr>
-          <a:lstStyle/>
-          <a:p>
-            <a:pPr algn="l"/>
-            <a:r>
-              <a:rPr sz="1000" b="0">
-                <a:solidFill>
-                  <a:srgbClr val="D5D8EA"/>
-                </a:solidFill>
-                <a:latin typeface="Arial"/>
-              </a:rPr>
-              <a:t>· When DPCs, the master regulators of hair follicle cycling, were treated with UCB-EVs at a concentration of 50 μg/mL for 48 hours, significant cellular responses were observed, including a 45% increase in proliferation and a 35% reduction in apoptosis (55).</a:t>
-            </a:r>
-          </a:p>
-        </p:txBody>
-      </p:sp>
-      <p:sp>
-        <p:nvSpPr>
-          <p:cNvPr id="5" name="TextBox 4"/>
-          <p:cNvSpPr txBox="1"/>
-          <p:nvPr/>
-        </p:nvSpPr>
-        <p:spPr>
-          <a:xfrm>
-            <a:off x="365760" y="5303520"/>
-            <a:ext cx="4828032" cy="457200"/>
-          </a:xfrm>
-          <a:prstGeom prst="rect">
-            <a:avLst/>
-          </a:prstGeom>
-          <a:noFill/>
-        </p:spPr>
-        <p:txBody>
-          <a:bodyPr wrap="square" anchor="t">
-            <a:spAutoFit/>
-          </a:bodyPr>
-          <a:lstStyle/>
-          <a:p>
-            <a:pPr algn="l"/>
-            <a:r>
-              <a:rPr sz="1300" b="1">
-                <a:solidFill>
-                  <a:srgbClr val="FFFFFF"/>
-                </a:solidFill>
-                <a:latin typeface="Arial"/>
-              </a:rPr>
-              <a:t>◆ 결론 — Clinical translation challenges and future directions of UCB-EVs for postpartum hair loss</a:t>
-            </a:r>
-          </a:p>
-        </p:txBody>
-      </p:sp>
-      <p:sp>
-        <p:nvSpPr>
-          <p:cNvPr id="6" name="TextBox 5"/>
-          <p:cNvSpPr txBox="1"/>
-          <p:nvPr/>
-        </p:nvSpPr>
-        <p:spPr>
-          <a:xfrm>
-            <a:off x="457200" y="5806440"/>
-            <a:ext cx="4736592" cy="3566160"/>
-          </a:xfrm>
-          <a:prstGeom prst="rect">
-            <a:avLst/>
-          </a:prstGeom>
-          <a:noFill/>
-        </p:spPr>
-        <p:txBody>
-          <a:bodyPr wrap="square" anchor="t">
-            <a:spAutoFit/>
-          </a:bodyPr>
-          <a:lstStyle/>
-          <a:p>
-            <a:pPr algn="l"/>
-            <a:r>
-              <a:rPr sz="1000" b="0">
-                <a:solidFill>
-                  <a:srgbClr val="D5D8EA"/>
-                </a:solidFill>
-                <a:latin typeface="Arial"/>
-              </a:rPr>
-              <a:t>· A primary hurdle is the limited volume of UCB obtainable per unit, as a single cord blood donation yields only approximately 10^10 to 10^11 EV particles.
-· For instance, the use of a chemically defined, xeno- and blood-free culture medium, such as Oxium™EXO, has been shown to increase small EV (sEV) secretion from MSCs by three-fold, consistently across multiple harvest time points and different cell sources, yielding an enrichment of particles within the 51–200 nm range (71).
-· Preclinical safety evaluations using non-human primates have shown that high-dose intravenous administration of human UCB-MSC-derived exosomes (3.85 × 10^12 particles) did not cause significant adverse effects on general clinical conditions, hematology, coagulation, or immune organs, and did not induce major changes in immunoglobulins or cytokines (79).</a:t>
-            </a:r>
-          </a:p>
-        </p:txBody>
-      </p:sp>
-    </p:spTree>
-  </p:cSld>
-  <p:clrMapOvr>
-    <a:masterClrMapping/>
-  </p:clrMapOvr>
-</p:sld>
-</file>
-
-<file path=ppt/slides/slide11.xml><?xml version="1.0" encoding="utf-8"?>
-<p:sld xmlns:a="http://schemas.openxmlformats.org/drawingml/2006/main" xmlns:p="http://schemas.openxmlformats.org/presentationml/2006/main" xmlns:r="http://schemas.openxmlformats.org/officeDocument/2006/relationships">
-  <p:cSld>
-    <p:bg>
-      <p:bgPr>
-        <a:solidFill>
-          <a:srgbClr val="12142A"/>
-        </a:solidFill>
-        <a:effectLst/>
-      </p:bgPr>
-    </p:bg>
-    <p:spTree>
-      <p:nvGrpSpPr>
-        <p:cNvPr id="1" name=""/>
-        <p:cNvGrpSpPr/>
-        <p:nvPr/>
-      </p:nvGrpSpPr>
-      <p:grpSpPr/>
-      <p:sp>
-        <p:nvSpPr>
-          <p:cNvPr id="2" name="TextBox 1"/>
-          <p:cNvSpPr txBox="1"/>
-          <p:nvPr/>
-        </p:nvSpPr>
-        <p:spPr>
-          <a:xfrm>
-            <a:off x="365760" y="457200"/>
-            <a:ext cx="4828032" cy="457200"/>
-          </a:xfrm>
-          <a:prstGeom prst="rect">
-            <a:avLst/>
-          </a:prstGeom>
-          <a:noFill/>
-        </p:spPr>
-        <p:txBody>
-          <a:bodyPr wrap="square" anchor="ctr">
-            <a:spAutoFit/>
-          </a:bodyPr>
-          <a:lstStyle/>
-          <a:p>
-            <a:pPr algn="l"/>
-            <a:r>
-              <a:rPr sz="1600" b="1">
-                <a:solidFill>
-                  <a:srgbClr val="FF6B6B"/>
-                </a:solidFill>
-                <a:latin typeface="Arial"/>
-              </a:rPr>
-              <a:t>본문 요약 (편집용)</a:t>
-            </a:r>
-          </a:p>
-        </p:txBody>
-      </p:sp>
-      <p:sp>
-        <p:nvSpPr>
-          <p:cNvPr id="3" name="TextBox 2"/>
-          <p:cNvSpPr txBox="1"/>
-          <p:nvPr/>
-        </p:nvSpPr>
-        <p:spPr>
-          <a:xfrm>
-            <a:off x="365760" y="1097280"/>
-            <a:ext cx="4828032" cy="457200"/>
-          </a:xfrm>
-          <a:prstGeom prst="rect">
-            <a:avLst/>
-          </a:prstGeom>
-          <a:noFill/>
-        </p:spPr>
-        <p:txBody>
-          <a:bodyPr wrap="square" anchor="t">
-            <a:spAutoFit/>
-          </a:bodyPr>
-          <a:lstStyle/>
-          <a:p>
-            <a:pPr algn="l"/>
-            <a:r>
-              <a:rPr sz="1300" b="1">
-                <a:solidFill>
-                  <a:srgbClr val="FFFFFF"/>
-                </a:solidFill>
-                <a:latin typeface="Arial"/>
-              </a:rPr>
-              <a:t>◆ 결론 — Conclusion</a:t>
-            </a:r>
-          </a:p>
-        </p:txBody>
-      </p:sp>
-      <p:sp>
-        <p:nvSpPr>
-          <p:cNvPr id="4" name="TextBox 3"/>
-          <p:cNvSpPr txBox="1"/>
-          <p:nvPr/>
-        </p:nvSpPr>
-        <p:spPr>
-          <a:xfrm>
-            <a:off x="457200" y="1600200"/>
-            <a:ext cx="4736592" cy="3566160"/>
-          </a:xfrm>
-          <a:prstGeom prst="rect">
-            <a:avLst/>
-          </a:prstGeom>
-          <a:noFill/>
-        </p:spPr>
-        <p:txBody>
-          <a:bodyPr wrap="square" anchor="t">
-            <a:spAutoFit/>
-          </a:bodyPr>
-          <a:lstStyle/>
-          <a:p>
-            <a:pPr algn="l"/>
-            <a:r>
-              <a:rPr sz="1000" b="0">
-                <a:solidFill>
-                  <a:srgbClr val="D5D8EA"/>
-                </a:solidFill>
-                <a:latin typeface="Arial"/>
-              </a:rPr>
-              <a:t>· Transcriptomic analyses have revealed the involvement of immune cells and ferroptosis in frontal fibrosing alopecia (81).</a:t>
-            </a:r>
-          </a:p>
-        </p:txBody>
-      </p:sp>
-    </p:spTree>
-  </p:cSld>
-  <p:clrMapOvr>
-    <a:masterClrMapping/>
-  </p:clrMapOvr>
-</p:sld>
-</file>
-
-<file path=ppt/slides/slide12.xml><?xml version="1.0" encoding="utf-8"?>
-<p:sld xmlns:a="http://schemas.openxmlformats.org/drawingml/2006/main" xmlns:p="http://schemas.openxmlformats.org/presentationml/2006/main" xmlns:r="http://schemas.openxmlformats.org/officeDocument/2006/relationships">
-  <p:cSld>
-    <p:bg>
-      <p:bgPr>
-        <a:solidFill>
-          <a:srgbClr val="12142A"/>
-        </a:solidFill>
-        <a:effectLst/>
-      </p:bgPr>
-    </p:bg>
-    <p:spTree>
-      <p:nvGrpSpPr>
-        <p:cNvPr id="1" name=""/>
-        <p:cNvGrpSpPr/>
-        <p:nvPr/>
-      </p:nvGrpSpPr>
-      <p:grpSpPr/>
-      <p:sp>
-        <p:nvSpPr>
-          <p:cNvPr id="2" name="TextBox 1"/>
-          <p:cNvSpPr txBox="1"/>
-          <p:nvPr/>
-        </p:nvSpPr>
-        <p:spPr>
-          <a:xfrm>
             <a:off x="365760" y="731520"/>
             <a:ext cx="4828032" cy="548640"/>
           </a:xfrm>
@@ -4883,9 +4392,9 @@
                 <a:latin typeface="Arial"/>
               </a:rPr>
               <a:t>[출처]
-논문: Translating umbilical cord blood extracellular vesicles into a novel therapy for postpartum alopecia: a mechanistic and preclinical review
-게재: Frontiers in immunology
-원문: https://pubmed.ncbi.nlm.nih.gov/42857222/
+논문: Exploratory Identification of Multidimensional Treatment-Response Profiles in Androgenetic Alopecia Treated with Combined Scalp Microneedling and Topical Minoxidil Using Unsupervised Clustering
+게재: Clinical, cosmetic and investigational dermatology
+원문: https://pubmed.ncbi.nlm.nih.gov/42866572/
 [이미지 출처]
 - Male pattern baldness.jpg / Originally uploaded by Lkinkade (Transferred by XenonX3) / CC BY-SA 2.5
   https://commons.wikimedia.org/wiki/File:Male_pattern_baldness.jpg
@@ -4894,11 +4403,6 @@
 ※ CC BY-SA 이미지가 포함되어 있습니다. 저작자 표시가 필수이며,
   동일조건변경허락(ShareAlike) 조항이 영상 전체에 적용될 수 있으니
   상업적 이용 시 해당 이미지를 교체하는 편이 안전합니다.
-[논문 본문 그림·표]
-- PubMed Central PMC13651770 (재사용 가능 라이선스)
-  https://www.ncbi.nlm.nih.gov/pmc/articles/PMC13651770/
-  · Table 1
-  ※ 오픈액세스 논문의 그림·표이며, 위 원문 출처를 함께 표기하세요.
 </a:t>
             </a:r>
           </a:p>
@@ -4984,7 +4488,7 @@
                 </a:solidFill>
                 <a:latin typeface="Arial"/>
               </a:rPr>
-              <a:t>Translating umbilical cord blood extracellular vesicles into a novel therapy for postpartum alopecia: a mechanistic and preclinical review</a:t>
+              <a:t>Exploratory Identification of Multidimensional Treatment-Response Profiles in Androgenetic Alopecia Treated with Combined Scalp Microneedling and Topical Minoxidil Using Unsupervised Clustering</a:t>
             </a:r>
           </a:p>
         </p:txBody>
@@ -5019,7 +4523,7 @@
                 </a:solidFill>
                 <a:latin typeface="Arial"/>
               </a:rPr>
-              <a:t>Frontiers in immunology  ·  2026</a:t>
+              <a:t>Clinical, cosmetic and investigational dermatology  ·  2026</a:t>
             </a:r>
           </a:p>
         </p:txBody>
@@ -5148,7 +4652,7 @@
                 </a:solidFill>
                 <a:latin typeface="Arial"/>
               </a:rPr>
-              <a:t>Postpartum alopecia (PPA) is a common physiological hair loss in women, characterized by complex pathogenesis involving abrupt postpartum hormonal withdrawal, disrupted hair follicle cycling, local microenvironmental inflammation, and oxidative stress.</a:t>
+              <a:t>Methods: In this prospective cohort study, 156 patients with AGA received standardized combination therapy (microneedling 1.0 mm depth, biweekly; 5% topical minoxidil, twice daily) for 24 weeks, with longitudinal trichoscopic, molecular and clinical assessments.</a:t>
             </a:r>
           </a:p>
         </p:txBody>
@@ -5162,550 +4666,6 @@
 </file>
 
 <file path=ppt/slides/slide4.xml><?xml version="1.0" encoding="utf-8"?>
-<p:sld xmlns:a="http://schemas.openxmlformats.org/drawingml/2006/main" xmlns:p="http://schemas.openxmlformats.org/presentationml/2006/main" xmlns:r="http://schemas.openxmlformats.org/officeDocument/2006/relationships">
-  <p:cSld>
-    <p:bg>
-      <p:bgPr>
-        <a:solidFill>
-          <a:srgbClr val="12142A"/>
-        </a:solidFill>
-        <a:effectLst/>
-      </p:bgPr>
-    </p:bg>
-    <p:spTree>
-      <p:nvGrpSpPr>
-        <p:cNvPr id="1" name=""/>
-        <p:cNvGrpSpPr/>
-        <p:nvPr/>
-      </p:nvGrpSpPr>
-      <p:grpSpPr/>
-      <p:sp>
-        <p:nvSpPr>
-          <p:cNvPr id="2" name="TextBox 1"/>
-          <p:cNvSpPr txBox="1"/>
-          <p:nvPr/>
-        </p:nvSpPr>
-        <p:spPr>
-          <a:xfrm>
-            <a:off x="365760" y="1097280"/>
-            <a:ext cx="4828032" cy="548640"/>
-          </a:xfrm>
-          <a:prstGeom prst="rect">
-            <a:avLst/>
-          </a:prstGeom>
-          <a:noFill/>
-        </p:spPr>
-        <p:txBody>
-          <a:bodyPr wrap="square" anchor="ctr">
-            <a:spAutoFit/>
-          </a:bodyPr>
-          <a:lstStyle/>
-          <a:p>
-            <a:pPr algn="ctr"/>
-            <a:r>
-              <a:rPr sz="2000" b="1">
-                <a:solidFill>
-                  <a:srgbClr val="FF6B6B"/>
-                </a:solidFill>
-                <a:latin typeface="Arial"/>
-              </a:rPr>
-              <a:t>논문 Table 1</a:t>
-            </a:r>
-          </a:p>
-        </p:txBody>
-      </p:sp>
-      <p:sp>
-        <p:nvSpPr>
-          <p:cNvPr id="3" name="TextBox 2"/>
-          <p:cNvSpPr txBox="1"/>
-          <p:nvPr/>
-        </p:nvSpPr>
-        <p:spPr>
-          <a:xfrm>
-            <a:off x="365760" y="1737360"/>
-            <a:ext cx="4828032" cy="914400"/>
-          </a:xfrm>
-          <a:prstGeom prst="rect">
-            <a:avLst/>
-          </a:prstGeom>
-          <a:noFill/>
-        </p:spPr>
-        <p:txBody>
-          <a:bodyPr wrap="square" anchor="ctr">
-            <a:spAutoFit/>
-          </a:bodyPr>
-          <a:lstStyle/>
-          <a:p>
-            <a:pPr algn="ctr"/>
-            <a:r>
-              <a:rPr sz="1300" b="0">
-                <a:solidFill>
-                  <a:srgbClr val="AAAFCD"/>
-                </a:solidFill>
-                <a:latin typeface="Arial"/>
-              </a:rPr>
-              <a:t>Summary of UCB-EV studies for hair regeneration with categorized evidence levels.</a:t>
-            </a:r>
-          </a:p>
-        </p:txBody>
-      </p:sp>
-      <p:graphicFrame>
-        <p:nvGraphicFramePr>
-          <p:cNvPr id="4" name="Table 3"/>
-          <p:cNvGraphicFramePr>
-            <a:graphicFrameLocks noGrp="1"/>
-          </p:cNvGraphicFramePr>
-          <p:nvPr/>
-        </p:nvGraphicFramePr>
-        <p:xfrm>
-          <a:off x="320040" y="2926080"/>
-          <a:ext cx="4919472" cy="3017520"/>
-        </p:xfrm>
-        <a:graphic>
-          <a:graphicData uri="http://schemas.openxmlformats.org/drawingml/2006/table">
-            <a:tbl>
-              <a:tblPr firstRow="1" bandRow="1">
-                <a:tableStyleId>{5C22544A-7EE6-4342-B048-85BDC9FD1C3A}</a:tableStyleId>
-              </a:tblPr>
-              <a:tblGrid>
-                <a:gridCol w="1229868"/>
-                <a:gridCol w="1229868"/>
-                <a:gridCol w="1229868"/>
-                <a:gridCol w="1229868"/>
-              </a:tblGrid>
-              <a:tr h="502920">
-                <a:tc>
-                  <a:txBody>
-                    <a:bodyPr/>
-                    <a:lstStyle/>
-                    <a:p>
-                      <a:pPr>
-                        <a:defRPr sz="1200" b="1">
-                          <a:latin typeface="Arial"/>
-                        </a:defRPr>
-                      </a:pPr>
-                      <a:r>
-                        <a:t>EV source</a:t>
-                      </a:r>
-                    </a:p>
-                  </a:txBody>
-                  <a:tcPr/>
-                </a:tc>
-                <a:tc>
-                  <a:txBody>
-                    <a:bodyPr/>
-                    <a:lstStyle/>
-                    <a:p>
-                      <a:pPr>
-                        <a:defRPr sz="1200" b="1">
-                          <a:latin typeface="Arial"/>
-                        </a:defRPr>
-                      </a:pPr>
-                      <a:r>
-                        <a:t>Model</a:t>
-                      </a:r>
-                    </a:p>
-                  </a:txBody>
-                  <a:tcPr/>
-                </a:tc>
-                <a:tc>
-                  <a:txBody>
-                    <a:bodyPr/>
-                    <a:lstStyle/>
-                    <a:p>
-                      <a:pPr>
-                        <a:defRPr sz="1200" b="1">
-                          <a:latin typeface="Arial"/>
-                        </a:defRPr>
-                      </a:pPr>
-                      <a:r>
-                        <a:t>Intervention main mechanism/outcome</a:t>
-                      </a:r>
-                    </a:p>
-                  </a:txBody>
-                  <a:tcPr/>
-                </a:tc>
-                <a:tc>
-                  <a:txBody>
-                    <a:bodyPr/>
-                    <a:lstStyle/>
-                    <a:p>
-                      <a:pPr>
-                        <a:defRPr sz="1200" b="1">
-                          <a:latin typeface="Arial"/>
-                        </a:defRPr>
-                      </a:pPr>
-                      <a:r>
-                        <a:t>Evidence level</a:t>
-                      </a:r>
-                    </a:p>
-                  </a:txBody>
-                  <a:tcPr/>
-                </a:tc>
-              </a:tr>
-              <a:tr h="502920">
-                <a:tc>
-                  <a:txBody>
-                    <a:bodyPr/>
-                    <a:lstStyle/>
-                    <a:p>
-                      <a:pPr>
-                        <a:defRPr sz="1100" b="0">
-                          <a:latin typeface="Arial"/>
-                        </a:defRPr>
-                      </a:pPr>
-                      <a:r>
-                        <a:t>UCB-EVs</a:t>
-                      </a:r>
-                    </a:p>
-                  </a:txBody>
-                  <a:tcPr/>
-                </a:tc>
-                <a:tc>
-                  <a:txBody>
-                    <a:bodyPr/>
-                    <a:lstStyle/>
-                    <a:p>
-                      <a:pPr>
-                        <a:defRPr sz="1100" b="0">
-                          <a:latin typeface="Arial"/>
-                        </a:defRPr>
-                      </a:pPr>
-                      <a:r>
-                        <a:t>HumanDPC/HFK coculture</a:t>
-                      </a:r>
-                    </a:p>
-                  </a:txBody>
-                  <a:tcPr/>
-                </a:tc>
-                <a:tc>
-                  <a:txBody>
-                    <a:bodyPr/>
-                    <a:lstStyle/>
-                    <a:p>
-                      <a:pPr>
-                        <a:defRPr sz="1100" b="0">
-                          <a:latin typeface="Arial"/>
-                        </a:defRPr>
-                      </a:pPr>
-                      <a:r>
-                        <a:t>50 μg/mL for 48 h</a:t>
-                      </a:r>
-                    </a:p>
-                  </a:txBody>
-                  <a:tcPr/>
-                </a:tc>
-                <a:tc>
-                  <a:txBody>
-                    <a:bodyPr/>
-                    <a:lstStyle/>
-                    <a:p>
-                      <a:pPr>
-                        <a:defRPr sz="1100" b="0">
-                          <a:latin typeface="Arial"/>
-                        </a:defRPr>
-                      </a:pPr>
-                      <a:r>
-                        <a:t>Proliferation ↑45%, apoptosis ↓35%, Vers</a:t>
-                      </a:r>
-                    </a:p>
-                  </a:txBody>
-                  <a:tcPr/>
-                </a:tc>
-              </a:tr>
-              <a:tr h="502920">
-                <a:tc>
-                  <a:txBody>
-                    <a:bodyPr/>
-                    <a:lstStyle/>
-                    <a:p>
-                      <a:pPr>
-                        <a:defRPr sz="1100" b="0">
-                          <a:latin typeface="Arial"/>
-                        </a:defRPr>
-                      </a:pPr>
-                      <a:r>
-                        <a:t>UCB-EVs</a:t>
-                      </a:r>
-                    </a:p>
-                  </a:txBody>
-                  <a:tcPr/>
-                </a:tc>
-                <a:tc>
-                  <a:txBody>
-                    <a:bodyPr/>
-                    <a:lstStyle/>
-                    <a:p>
-                      <a:pPr>
-                        <a:defRPr sz="1100" b="0">
-                          <a:latin typeface="Arial"/>
-                        </a:defRPr>
-                      </a:pPr>
-                      <a:r>
-                        <a:t>Cortisol/DHT-inducedtelogen cell model</a:t>
-                      </a:r>
-                    </a:p>
-                  </a:txBody>
-                  <a:tcPr/>
-                </a:tc>
-                <a:tc>
-                  <a:txBody>
-                    <a:bodyPr/>
-                    <a:lstStyle/>
-                    <a:p>
-                      <a:pPr>
-                        <a:defRPr sz="1100" b="0">
-                          <a:latin typeface="Arial"/>
-                        </a:defRPr>
-                      </a:pPr>
-                      <a:r>
-                        <a:t>In vitro treatment</a:t>
-                      </a:r>
-                    </a:p>
-                  </a:txBody>
-                  <a:tcPr/>
-                </a:tc>
-                <a:tc>
-                  <a:txBody>
-                    <a:bodyPr/>
-                    <a:lstStyle/>
-                    <a:p>
-                      <a:pPr>
-                        <a:defRPr sz="1100" b="0">
-                          <a:latin typeface="Arial"/>
-                        </a:defRPr>
-                      </a:pPr>
-                      <a:r>
-                        <a:t>Hair shaft elongation ↑30%, restoration </a:t>
-                      </a:r>
-                    </a:p>
-                  </a:txBody>
-                  <a:tcPr/>
-                </a:tc>
-              </a:tr>
-              <a:tr h="502920">
-                <a:tc>
-                  <a:txBody>
-                    <a:bodyPr/>
-                    <a:lstStyle/>
-                    <a:p>
-                      <a:pPr>
-                        <a:defRPr sz="1100" b="0">
-                          <a:latin typeface="Arial"/>
-                        </a:defRPr>
-                      </a:pPr>
-                      <a:r>
-                        <a:t>UCB-EVs</a:t>
-                      </a:r>
-                    </a:p>
-                  </a:txBody>
-                  <a:tcPr/>
-                </a:tc>
-                <a:tc>
-                  <a:txBody>
-                    <a:bodyPr/>
-                    <a:lstStyle/>
-                    <a:p>
-                      <a:pPr>
-                        <a:defRPr sz="1100" b="0">
-                          <a:latin typeface="Arial"/>
-                        </a:defRPr>
-                      </a:pPr>
-                      <a:r>
-                        <a:t>C57BL/6 PPA mouse model</a:t>
-                      </a:r>
-                    </a:p>
-                  </a:txBody>
-                  <a:tcPr/>
-                </a:tc>
-                <a:tc>
-                  <a:txBody>
-                    <a:bodyPr/>
-                    <a:lstStyle/>
-                    <a:p>
-                      <a:pPr>
-                        <a:defRPr sz="1100" b="0">
-                          <a:latin typeface="Arial"/>
-                        </a:defRPr>
-                      </a:pPr>
-                      <a:r>
-                        <a:t>Intradermal injection every 3 days ×4</a:t>
-                      </a:r>
-                    </a:p>
-                  </a:txBody>
-                  <a:tcPr/>
-                </a:tc>
-                <a:tc>
-                  <a:txBody>
-                    <a:bodyPr/>
-                    <a:lstStyle/>
-                    <a:p>
-                      <a:pPr>
-                        <a:defRPr sz="1100" b="0">
-                          <a:latin typeface="Arial"/>
-                        </a:defRPr>
-                      </a:pPr>
-                      <a:r>
-                        <a:t>Hair coverage ≈80% vs 30%, hair density </a:t>
-                      </a:r>
-                    </a:p>
-                  </a:txBody>
-                  <a:tcPr/>
-                </a:tc>
-              </a:tr>
-              <a:tr h="502920">
-                <a:tc>
-                  <a:txBody>
-                    <a:bodyPr/>
-                    <a:lstStyle/>
-                    <a:p>
-                      <a:pPr>
-                        <a:defRPr sz="1100" b="0">
-                          <a:latin typeface="Arial"/>
-                        </a:defRPr>
-                      </a:pPr>
-                      <a:r>
-                        <a:t>UCB-EVs</a:t>
-                      </a:r>
-                    </a:p>
-                  </a:txBody>
-                  <a:tcPr/>
-                </a:tc>
-                <a:tc>
-                  <a:txBody>
-                    <a:bodyPr/>
-                    <a:lstStyle/>
-                    <a:p>
-                      <a:pPr>
-                        <a:defRPr sz="1100" b="0">
-                          <a:latin typeface="Arial"/>
-                        </a:defRPr>
-                      </a:pPr>
-                      <a:r>
-                        <a:t>vs 2%minoxidilMouse model</a:t>
-                      </a:r>
-                    </a:p>
-                  </a:txBody>
-                  <a:tcPr/>
-                </a:tc>
-                <a:tc>
-                  <a:txBody>
-                    <a:bodyPr/>
-                    <a:lstStyle/>
-                    <a:p>
-                      <a:pPr>
-                        <a:defRPr sz="1100" b="0">
-                          <a:latin typeface="Arial"/>
-                        </a:defRPr>
-                      </a:pPr>
-                      <a:r>
-                        <a:t>Local injectionComparable hair coverage </a:t>
-                      </a:r>
-                    </a:p>
-                  </a:txBody>
-                  <a:tcPr/>
-                </a:tc>
-                <a:tc>
-                  <a:txBody>
-                    <a:bodyPr/>
-                    <a:lstStyle/>
-                    <a:p>
-                      <a:pPr>
-                        <a:defRPr sz="1100" b="0">
-                          <a:latin typeface="Arial"/>
-                        </a:defRPr>
-                      </a:pPr>
-                      <a:r>
-                        <a:t>hUCMSC-derived exosomes AGA animal model</a:t>
-                      </a:r>
-                    </a:p>
-                  </a:txBody>
-                  <a:tcPr/>
-                </a:tc>
-              </a:tr>
-              <a:tr h="502920">
-                <a:tc>
-                  <a:txBody>
-                    <a:bodyPr/>
-                    <a:lstStyle/>
-                    <a:p>
-                      <a:pPr>
-                        <a:defRPr sz="1100" b="0">
-                          <a:latin typeface="Arial"/>
-                        </a:defRPr>
-                      </a:pPr>
-                      <a:r>
-                        <a:t>UCB-MSC-EVs</a:t>
-                      </a:r>
-                    </a:p>
-                  </a:txBody>
-                  <a:tcPr/>
-                </a:tc>
-                <a:tc>
-                  <a:txBody>
-                    <a:bodyPr/>
-                    <a:lstStyle/>
-                    <a:p>
-                      <a:pPr>
-                        <a:defRPr sz="1100" b="0">
-                          <a:latin typeface="Arial"/>
-                        </a:defRPr>
-                      </a:pPr>
-                      <a:r>
-                        <a:t>Mouse wound healing model</a:t>
-                      </a:r>
-                    </a:p>
-                  </a:txBody>
-                  <a:tcPr/>
-                </a:tc>
-                <a:tc>
-                  <a:txBody>
-                    <a:bodyPr/>
-                    <a:lstStyle/>
-                    <a:p>
-                      <a:pPr>
-                        <a:defRPr sz="1100" b="0">
-                          <a:latin typeface="Arial"/>
-                        </a:defRPr>
-                      </a:pPr>
-                      <a:r>
-                        <a:t>Local treatment</a:t>
-                      </a:r>
-                    </a:p>
-                  </a:txBody>
-                  <a:tcPr/>
-                </a:tc>
-                <a:tc>
-                  <a:txBody>
-                    <a:bodyPr/>
-                    <a:lstStyle/>
-                    <a:p>
-                      <a:pPr>
-                        <a:defRPr sz="1100" b="0">
-                          <a:latin typeface="Arial"/>
-                        </a:defRPr>
-                      </a:pPr>
-                      <a:r>
-                        <a:t>Angiogenesis, ECM remodeling Indirect (w</a:t>
-                      </a:r>
-                    </a:p>
-                  </a:txBody>
-                  <a:tcPr/>
-                </a:tc>
-              </a:tr>
-            </a:tbl>
-          </a:graphicData>
-        </a:graphic>
-      </p:graphicFrame>
-    </p:spTree>
-  </p:cSld>
-  <p:clrMapOvr>
-    <a:masterClrMapping/>
-  </p:clrMapOvr>
-</p:sld>
-</file>
-
-<file path=ppt/slides/slide5.xml><?xml version="1.0" encoding="utf-8"?>
 <p:sld xmlns:a="http://schemas.openxmlformats.org/drawingml/2006/main" xmlns:p="http://schemas.openxmlformats.org/presentationml/2006/main" xmlns:r="http://schemas.openxmlformats.org/officeDocument/2006/relationships">
   <p:cSld>
     <p:bg>
@@ -5821,7 +4781,7 @@
                 </a:solidFill>
                 <a:latin typeface="Arial"/>
               </a:rPr>
-              <a:t>Umbilical cord blood-derived extracellular vesicles (UCB-EVs)-nanosized, lipid-bilayer-enclosed particles enriched with microRNAs, growth factors, and proteins-have shown considerable promise in regenerative medicine owing to their low immunogenicity, high biocompatibility, and tissue-repair capacity.</a:t>
+              <a:t>Results: Silhouette analysis indicated weak global cluster structure (k=2, 0.274; k=3, 0.168); a three-cluster solution was retained as an exploratory, clinically motivated grouping and labelled Robust (n=45, 28.8%), Moderate (n=56, 35.9%) and Limited (n=55, 35.3%) responders.</a:t>
             </a:r>
           </a:p>
         </p:txBody>
@@ -5834,7 +4794,7 @@
 </p:sld>
 </file>
 
-<file path=ppt/slides/slide6.xml><?xml version="1.0" encoding="utf-8"?>
+<file path=ppt/slides/slide5.xml><?xml version="1.0" encoding="utf-8"?>
 <p:sld xmlns:a="http://schemas.openxmlformats.org/drawingml/2006/main" xmlns:p="http://schemas.openxmlformats.org/presentationml/2006/main" xmlns:r="http://schemas.openxmlformats.org/officeDocument/2006/relationships">
   <p:cSld>
     <p:bg>
@@ -5963,7 +4923,7 @@
 </p:sld>
 </file>
 
-<file path=ppt/slides/slide7.xml><?xml version="1.0" encoding="utf-8"?>
+<file path=ppt/slides/slide6.xml><?xml version="1.0" encoding="utf-8"?>
 <p:sld xmlns:a="http://schemas.openxmlformats.org/drawingml/2006/main" xmlns:p="http://schemas.openxmlformats.org/presentationml/2006/main" xmlns:r="http://schemas.openxmlformats.org/officeDocument/2006/relationships">
   <p:cSld>
     <p:bg>
@@ -6012,6 +4972,207 @@
                 <a:latin typeface="Arial"/>
               </a:rPr>
               <a:t>더 자세한 내용은 원문 링크에서 확인하세요. 매일 새로운 탈모 연구, 팔로우하고 놓치지 마세요!</a:t>
+            </a:r>
+          </a:p>
+        </p:txBody>
+      </p:sp>
+    </p:spTree>
+  </p:cSld>
+  <p:clrMapOvr>
+    <a:masterClrMapping/>
+  </p:clrMapOvr>
+</p:sld>
+</file>
+
+<file path=ppt/slides/slide7.xml><?xml version="1.0" encoding="utf-8"?>
+<p:sld xmlns:a="http://schemas.openxmlformats.org/drawingml/2006/main" xmlns:p="http://schemas.openxmlformats.org/presentationml/2006/main" xmlns:r="http://schemas.openxmlformats.org/officeDocument/2006/relationships">
+  <p:cSld>
+    <p:bg>
+      <p:bgPr>
+        <a:solidFill>
+          <a:srgbClr val="12142A"/>
+        </a:solidFill>
+        <a:effectLst/>
+      </p:bgPr>
+    </p:bg>
+    <p:spTree>
+      <p:nvGrpSpPr>
+        <p:cNvPr id="1" name=""/>
+        <p:cNvGrpSpPr/>
+        <p:nvPr/>
+      </p:nvGrpSpPr>
+      <p:grpSpPr/>
+      <p:sp>
+        <p:nvSpPr>
+          <p:cNvPr id="2" name="TextBox 1"/>
+          <p:cNvSpPr txBox="1"/>
+          <p:nvPr/>
+        </p:nvSpPr>
+        <p:spPr>
+          <a:xfrm>
+            <a:off x="365760" y="457200"/>
+            <a:ext cx="4828032" cy="457200"/>
+          </a:xfrm>
+          <a:prstGeom prst="rect">
+            <a:avLst/>
+          </a:prstGeom>
+          <a:noFill/>
+        </p:spPr>
+        <p:txBody>
+          <a:bodyPr wrap="square" anchor="ctr">
+            <a:spAutoFit/>
+          </a:bodyPr>
+          <a:lstStyle/>
+          <a:p>
+            <a:pPr algn="l"/>
+            <a:r>
+              <a:rPr sz="1600" b="1">
+                <a:solidFill>
+                  <a:srgbClr val="FF6B6B"/>
+                </a:solidFill>
+                <a:latin typeface="Arial"/>
+              </a:rPr>
+              <a:t>본문 요약 (편집용)</a:t>
+            </a:r>
+          </a:p>
+        </p:txBody>
+      </p:sp>
+      <p:sp>
+        <p:nvSpPr>
+          <p:cNvPr id="3" name="TextBox 2"/>
+          <p:cNvSpPr txBox="1"/>
+          <p:nvPr/>
+        </p:nvSpPr>
+        <p:spPr>
+          <a:xfrm>
+            <a:off x="365760" y="1097280"/>
+            <a:ext cx="4828032" cy="457200"/>
+          </a:xfrm>
+          <a:prstGeom prst="rect">
+            <a:avLst/>
+          </a:prstGeom>
+          <a:noFill/>
+        </p:spPr>
+        <p:txBody>
+          <a:bodyPr wrap="square" anchor="t">
+            <a:spAutoFit/>
+          </a:bodyPr>
+          <a:lstStyle/>
+          <a:p>
+            <a:pPr algn="l"/>
+            <a:r>
+              <a:rPr sz="1300" b="1">
+                <a:solidFill>
+                  <a:srgbClr val="FFFFFF"/>
+                </a:solidFill>
+                <a:latin typeface="Arial"/>
+              </a:rPr>
+              <a:t>◆ 배경 — Background</a:t>
+            </a:r>
+          </a:p>
+        </p:txBody>
+      </p:sp>
+      <p:sp>
+        <p:nvSpPr>
+          <p:cNvPr id="4" name="TextBox 3"/>
+          <p:cNvSpPr txBox="1"/>
+          <p:nvPr/>
+        </p:nvSpPr>
+        <p:spPr>
+          <a:xfrm>
+            <a:off x="457200" y="1600200"/>
+            <a:ext cx="4736592" cy="3566160"/>
+          </a:xfrm>
+          <a:prstGeom prst="rect">
+            <a:avLst/>
+          </a:prstGeom>
+          <a:noFill/>
+        </p:spPr>
+        <p:txBody>
+          <a:bodyPr wrap="square" anchor="t">
+            <a:spAutoFit/>
+          </a:bodyPr>
+          <a:lstStyle/>
+          <a:p>
+            <a:pPr algn="l"/>
+            <a:r>
+              <a:rPr sz="1000" b="0">
+                <a:solidFill>
+                  <a:srgbClr val="D5D8EA"/>
+                </a:solidFill>
+                <a:latin typeface="Arial"/>
+              </a:rPr>
+              <a:t>· Combination therapy with scalp microneedling and topical minoxidil is more effective than minoxidil alone in androgenetic alopecia (AGA), yet treatment responses vary considerably among patients and the multidimensional structure of this heterogeneity remains poorly characterized.</a:t>
+            </a:r>
+          </a:p>
+        </p:txBody>
+      </p:sp>
+      <p:sp>
+        <p:nvSpPr>
+          <p:cNvPr id="5" name="TextBox 4"/>
+          <p:cNvSpPr txBox="1"/>
+          <p:nvPr/>
+        </p:nvSpPr>
+        <p:spPr>
+          <a:xfrm>
+            <a:off x="365760" y="5303520"/>
+            <a:ext cx="4828032" cy="457200"/>
+          </a:xfrm>
+          <a:prstGeom prst="rect">
+            <a:avLst/>
+          </a:prstGeom>
+          <a:noFill/>
+        </p:spPr>
+        <p:txBody>
+          <a:bodyPr wrap="square" anchor="t">
+            <a:spAutoFit/>
+          </a:bodyPr>
+          <a:lstStyle/>
+          <a:p>
+            <a:pPr algn="l"/>
+            <a:r>
+              <a:rPr sz="1300" b="1">
+                <a:solidFill>
+                  <a:srgbClr val="FFFFFF"/>
+                </a:solidFill>
+                <a:latin typeface="Arial"/>
+              </a:rPr>
+              <a:t>◆ 배경 — Objective</a:t>
+            </a:r>
+          </a:p>
+        </p:txBody>
+      </p:sp>
+      <p:sp>
+        <p:nvSpPr>
+          <p:cNvPr id="6" name="TextBox 5"/>
+          <p:cNvSpPr txBox="1"/>
+          <p:nvPr/>
+        </p:nvSpPr>
+        <p:spPr>
+          <a:xfrm>
+            <a:off x="457200" y="5806440"/>
+            <a:ext cx="4736592" cy="3566160"/>
+          </a:xfrm>
+          <a:prstGeom prst="rect">
+            <a:avLst/>
+          </a:prstGeom>
+          <a:noFill/>
+        </p:spPr>
+        <p:txBody>
+          <a:bodyPr wrap="square" anchor="t">
+            <a:spAutoFit/>
+          </a:bodyPr>
+          <a:lstStyle/>
+          <a:p>
+            <a:pPr algn="l"/>
+            <a:r>
+              <a:rPr sz="1000" b="0">
+                <a:solidFill>
+                  <a:srgbClr val="D5D8EA"/>
+                </a:solidFill>
+                <a:latin typeface="Arial"/>
+              </a:rPr>
+              <a:t>· To explore whether unsupervised clustering identifies distinct multidimensional treatment-response profiles during combination therapy and to describe their clinical and molecular characteristics as a hypothesis-generating basis for personalized management.</a:t>
             </a:r>
           </a:p>
         </p:txBody>
@@ -6107,7 +5268,7 @@
                 </a:solidFill>
                 <a:latin typeface="Arial"/>
               </a:rPr>
-              <a:t>◆ 배경 — Introduction</a:t>
+              <a:t>◆ 연구 방법 — Methods</a:t>
             </a:r>
           </a:p>
         </p:txBody>
@@ -6142,9 +5303,8 @@
                 </a:solidFill>
                 <a:latin typeface="Arial"/>
               </a:rPr>
-              <a:t>· Female postpartum alopecia (PPA) represents a significant clinical and psychosocial challenge, emerging as one of the most common dermatological conditions affecting women in the postpartum period.
-· Epidemiological data indicates that the prevalence of PPA is remarkably high, with studies suggesting that over 90% of postpartum women experience some degree of hair loss (3).
-· At the molecular level, UCB-EVs are enriched with specific miRNAs, such as miR-21-5p and let-7b-5p, which are capable of targeting and modulating key signaling pathways critical for hair follicle biology (2).</a:t>
+              <a:t>· In this prospective cohort study, 156 patients with AGA received standardized combination therapy (microneedling 1.0 mm depth, biweekly; 5% topical minoxidil, twice daily) for 24 weeks, with longitudinal trichoscopic, molecular and clinical assessments.
+· K-means clustering was applied to ten standardized treatment-response (change-from-baseline) variables; the number of clusters was examined by silhouette, gap-statistic and bootstrap-stability analyses, and between-profile differences were tested with assumption-appropriate methods and reported with effect sizes.</a:t>
             </a:r>
           </a:p>
         </p:txBody>
@@ -6179,7 +5339,7 @@
                 </a:solidFill>
                 <a:latin typeface="Arial"/>
               </a:rPr>
-              <a:t>◆ 그 밖의 내용 — Biological characteristics and preparation of UCB-EVs</a:t>
+              <a:t>◆ 주요 결과 — Results</a:t>
             </a:r>
           </a:p>
         </p:txBody>
@@ -6214,8 +5374,9 @@
                 </a:solidFill>
                 <a:latin typeface="Arial"/>
               </a:rPr>
-              <a:t>· They are broadly classified into exosomes (30–150 nm), microvesicles (100–1000 nm), and apoptotic bodies (&gt;1000 nm) based on their biogenesis and size (9).
-· This typically involves a combination of techniques: This typically involves a combination of techniques: dynamic light scattering (DLS), also known as photon correlation spectroscopy, which measures time-dependent fluctuations in scattered light caused by Brownian motion of particles to determine the hydrodynamic diameter and polydispersity index (PDI) of EVs (21); Nanoparticle tracking analysis (NTA) to determine particle size distribution and concentration (13, 14); Western blot analysis to confirm the presence of EV protein markers such as CD63, CD81, and TSG101 (13, 15); and transmission electron microscopy (TEM) or cryo-electron microscopy (cryo-EM) to verify the characteristic spherical, lipid bilayer morphology of the vesicles (14, 22).</a:t>
+              <a:t>· Silhouette analysis indicated weak global cluster structure (k=2, 0.274; k=3, 0.168); a three-cluster solution was retained as an exploratory, clinically motivated grouping and labelled Robust (n=45, 28.8%), Moderate (n=56, 35.9%) and Limited (n=55, 35.3%) responders.
+· Profiles differed across the response variables that defined them, including hair-density change (36.25±19.07 vs 17.76±10.93 hairs/cm2 for Robust vs Limited; ε2=0.19) and Wnt10b transcript change (0.80±0.37 vs 0.27±0.19; ε2=0.34).
+· Baseline clinical and molecular parameters, including LEF-1 and IGF-1, did not differ across profiles and did not predict profile membership.</a:t>
             </a:r>
           </a:p>
         </p:txBody>
@@ -6311,7 +5472,7 @@
                 </a:solidFill>
                 <a:latin typeface="Arial"/>
               </a:rPr>
-              <a:t>◆ 고찰 — Pathogenesis of postpartum hair loss in women and limitations of current treatments</a:t>
+              <a:t>◆ 결론 — Conclusion</a:t>
             </a:r>
           </a:p>
         </p:txBody>
@@ -6346,80 +5507,8 @@
                 </a:solidFill>
                 <a:latin typeface="Arial"/>
               </a:rPr>
-              <a:t>· In fact, the prevalence of thyroid abnormalities in patients with telogen effluvium has been documented to be between 5.7% and 17%, underscoring the importance of screening for postpartum thyroiditis in patients presenting with persistent postpartum hair loss (30).
-· Studies show that low ferritin is significantly associated with telogen effluvium, and vitamin D, which acts as a hormone, is crucial for proper hair follicle cycling through its involvement in signaling pathways of growth and differentiation (33–35).
-· Evidence from other forms of alopecia, such as that seen in COVID-19, suggests that severe systemic inflammation can dramatically increase the risk of telogen effluvium, with patients exhibiting higher levels of inflammatory biomarkers like C-reactive protein and IL-1β correlating with increased hair shedding (36).
-· These cytokines directly inhibit the proliferation of hair follicle stem cells and keratinocytes, by activating signaling cascades, most notably the JAK-STAT pathway (38–40).</a:t>
-            </a:r>
-          </a:p>
-        </p:txBody>
-      </p:sp>
-      <p:sp>
-        <p:nvSpPr>
-          <p:cNvPr id="5" name="TextBox 4"/>
-          <p:cNvSpPr txBox="1"/>
-          <p:nvPr/>
-        </p:nvSpPr>
-        <p:spPr>
-          <a:xfrm>
-            <a:off x="365760" y="5303520"/>
-            <a:ext cx="4828032" cy="457200"/>
-          </a:xfrm>
-          <a:prstGeom prst="rect">
-            <a:avLst/>
-          </a:prstGeom>
-          <a:noFill/>
-        </p:spPr>
-        <p:txBody>
-          <a:bodyPr wrap="square" anchor="t">
-            <a:spAutoFit/>
-          </a:bodyPr>
-          <a:lstStyle/>
-          <a:p>
-            <a:pPr algn="l"/>
-            <a:r>
-              <a:rPr sz="1300" b="1">
-                <a:solidFill>
-                  <a:srgbClr val="FFFFFF"/>
-                </a:solidFill>
-                <a:latin typeface="Arial"/>
-              </a:rPr>
-              <a:t>◆ 그 밖의 내용 — Molecular mechanisms of UCB-EVs in promoting hair follicle regeneration</a:t>
-            </a:r>
-          </a:p>
-        </p:txBody>
-      </p:sp>
-      <p:sp>
-        <p:nvSpPr>
-          <p:cNvPr id="6" name="TextBox 5"/>
-          <p:cNvSpPr txBox="1"/>
-          <p:nvPr/>
-        </p:nvSpPr>
-        <p:spPr>
-          <a:xfrm>
-            <a:off x="457200" y="5806440"/>
-            <a:ext cx="4736592" cy="3566160"/>
-          </a:xfrm>
-          <a:prstGeom prst="rect">
-            <a:avLst/>
-          </a:prstGeom>
-          <a:noFill/>
-        </p:spPr>
-        <p:txBody>
-          <a:bodyPr wrap="square" anchor="t">
-            <a:spAutoFit/>
-          </a:bodyPr>
-          <a:lstStyle/>
-          <a:p>
-            <a:pPr algn="l"/>
-            <a:r>
-              <a:rPr sz="1000" b="0">
-                <a:solidFill>
-                  <a:srgbClr val="D5D8EA"/>
-                </a:solidFill>
-                <a:latin typeface="Arial"/>
-              </a:rPr>
-              <a:t>· Table 1Summary of UCB-EV studies for hair regeneration with categorized evidence levels.EV sourceModelIntervention main mechanism/outcomeEvidence levelUCB-EVsHumanDPC/HFK coculture50 μg/mL for 48 hProliferation ↑45%, apoptosis ↓35%, Versican/ALP ↑,Wnt/β- catenin activation Direct (in vitro, PPA-related cells)UCB-EVsCortisol/DHT-inducedtelogen cell modelIn vitro treatmentHair shaft elongation ↑30%, restoration of Ki67/PCNA Direct (in vitro, hormonal/stress-induced telogen)UCB-EVsC57BL/6 PPA mouse modelIntradermal injection every 3 days ×4Hair coverage ≈80% vs 30%, hair density ↑2-fold, follicle number ↑50%, anagen 20%→65%, CD31 ↑ Direct (in vivo, PPA model)UCB-EVsvs 2%minoxidilMouse modelLocal injectionComparable hair coverage at day 14; at day 21, anagen60% (UCB-EVs) vs 40% (minoxidil)Direct comparative (model type to be specified)hUCMSC-derived exosomes AGA animal model Local administration Rescue from DHT damage, enlarged follicles, telogen→anagen, Wnt/β-catenin activation Indirect (other EV source, AGA model)Macrophage-derived EVs Balb/c mice Injection Wnt3a/7b activation, DPC proliferation/migration ↑, VEGF/KGF ↑ Indirect (other EV source, generic hair growth)Fibroblast-derived EVs Ex vivo human hair follicles In vitro culture Hair shaft elongation, Wnt/βcatenin activationIndirect (other EV source, follicle culture)UCB-MSC-EVsMouse wound healing modelLocal treatmentAngiogenesis, ECM remodeling Indirect (wound healing model)Direct evidence indicates that the intervention was UCB-EV and the model was PPA or PPA-related; indirect evidence indicates other EV sources or non-PPA models.</a:t>
+              <a:t>· Unsupervised clustering identified three clinically interpretable treatment-response profiles accompanied by graded differences in Wnt/β-catenin-associated transcript changes.
+· Because the profiles showed weak internal separation and could not be predicted from baseline characteristics, these hypothesis-generating findings suggest, rather than demonstrate, multidimensional structure in treatment response and require validation in independent, controlled cohorts before any clinical application.</a:t>
             </a:r>
           </a:p>
         </p:txBody>

</xml_diff>

<commit_message>
chore: daily content 2026-10-15
</commit_message>
<xml_diff>
--- a/pwa/data/latest/slides.pptx
+++ b/pwa/data/latest/slides.pptx
@@ -14,7 +14,6 @@
     <p:sldId id="262" r:id="rId14"/>
     <p:sldId id="263" r:id="rId15"/>
     <p:sldId id="264" r:id="rId16"/>
-    <p:sldId id="265" r:id="rId17"/>
   </p:sldIdLst>
   <p:sldSz cx="5559552" cy="9875520" type="screen4x3"/>
   <p:notesSz cx="6858000" cy="9144000"/>
@@ -516,7 +515,7 @@
           </a:p>
           <a:p>
             <a:r>
-              <a:t>대본: 35.9% 이 숫자, 탈모 연구가 새로 내놨습니다</a:t>
+              <a:t>대본: 미녹시딜 오늘 나온 최신 연구를 정리했습니다</a:t>
             </a:r>
           </a:p>
           <a:p>
@@ -596,7 +595,7 @@
           </a:p>
           <a:p>
             <a:r>
-              <a:t>대본: 《Clinical, cosmetic and investigational dermatology》 - Exploratory Identification of Multidimensional Treatment-Response Profiles in Androgenetic Alopecia Treated with Combined Scalp Microneedling and Topical Minoxidil Using Unsupervised Clustering</a:t>
+              <a:t>대본: 《Current oncology reports》 - Minoxidil and Prostaglandin Analogs for Chemotherapy-Induced Alopecia: A Scoping Review</a:t>
             </a:r>
           </a:p>
           <a:p>
@@ -676,7 +675,7 @@
           </a:p>
           <a:p>
             <a:r>
-              <a:t>대본: Methods: In this prospective cohort study, 156 patients with AGA received standardized combination therapy (microneedling 1.0 mm depth, biweekly; 5% topical minoxidil, twice daily) for 24 weeks, with longitudinal trichoscopic, molecular and clinical assessments.</a:t>
+              <a:t>대본: Background: Chemotherapy-induced alopecia (CIA) is common, distressing, and markedly impairs patients' quality of life.</a:t>
             </a:r>
           </a:p>
           <a:p>
@@ -756,7 +755,7 @@
           </a:p>
           <a:p>
             <a:r>
-              <a:t>대본: Results: Silhouette analysis indicated weak global cluster structure (k=2, 0.274; k=3, 0.168); a three-cluster solution was retained as an exploratory, clinically motivated grouping and labelled Robust (n=45, 28.8%), Moderate (n=56, 35.9%) and Limited (n=55, 35.3%) responders.</a:t>
+              <a:t>대본: Although scalp cooling is the only approved preventive strategy, its effectiveness and accessibility remain limited.</a:t>
             </a:r>
           </a:p>
           <a:p>
@@ -1022,81 +1021,6 @@
 </file>
 
 <file path=ppt/notesSlides/notesSlide8.xml><?xml version="1.0" encoding="utf-8"?>
-<p:notes xmlns:a="http://schemas.openxmlformats.org/drawingml/2006/main" xmlns:p="http://schemas.openxmlformats.org/presentationml/2006/main" xmlns:r="http://schemas.openxmlformats.org/officeDocument/2006/relationships">
-  <p:cSld>
-    <p:spTree>
-      <p:nvGrpSpPr>
-        <p:cNvPr id="1" name=""/>
-        <p:cNvGrpSpPr/>
-        <p:nvPr/>
-      </p:nvGrpSpPr>
-      <p:grpSpPr>
-        <a:xfrm>
-          <a:off x="0" y="0"/>
-          <a:ext cx="0" cy="0"/>
-          <a:chOff x="0" y="0"/>
-          <a:chExt cx="0" cy="0"/>
-        </a:xfrm>
-      </p:grpSpPr>
-      <p:sp>
-        <p:nvSpPr>
-          <p:cNvPr id="2" name="Slide Image Placeholder 1"/>
-          <p:cNvSpPr>
-            <a:spLocks noGrp="1"/>
-          </p:cNvSpPr>
-          <p:nvPr>
-            <p:ph type="sldImg" idx="2"/>
-          </p:nvPr>
-        </p:nvSpPr>
-        <p:spPr/>
-      </p:sp>
-      <p:sp>
-        <p:nvSpPr>
-          <p:cNvPr id="3" name="Notes Placeholder 2"/>
-          <p:cNvSpPr>
-            <a:spLocks noGrp="1"/>
-          </p:cNvSpPr>
-          <p:nvPr>
-            <p:ph type="body" idx="3" sz="quarter"/>
-          </p:nvPr>
-        </p:nvSpPr>
-        <p:spPr/>
-        <p:txBody>
-          <a:bodyPr/>
-          <a:lstStyle/>
-          <a:p>
-            <a:r>
-              <a:t>편집 참고용 슬라이드입니다. 영상에는 쓰지 않아도 됩니다.</a:t>
-            </a:r>
-          </a:p>
-          <a:p>
-            <a:r>
-              <a:t>원문 영어 문장을 그대로 발췌했으므로 번역·검수 후 사용하세요.</a:t>
-            </a:r>
-          </a:p>
-        </p:txBody>
-      </p:sp>
-      <p:sp>
-        <p:nvSpPr>
-          <p:cNvPr id="4" name="Slide Number Placeholder 3"/>
-          <p:cNvSpPr>
-            <a:spLocks noGrp="1"/>
-          </p:cNvSpPr>
-          <p:nvPr>
-            <p:ph type="sldNum" idx="5" sz="quarter"/>
-          </p:nvPr>
-        </p:nvSpPr>
-        <p:spPr/>
-      </p:sp>
-    </p:spTree>
-  </p:cSld>
-  <p:clrMapOvr>
-    <a:masterClrMapping/>
-  </p:clrMapOvr>
-</p:notes>
-</file>
-
-<file path=ppt/notesSlides/notesSlide9.xml><?xml version="1.0" encoding="utf-8"?>
 <p:notes xmlns:a="http://schemas.openxmlformats.org/drawingml/2006/main" xmlns:p="http://schemas.openxmlformats.org/presentationml/2006/main" xmlns:r="http://schemas.openxmlformats.org/officeDocument/2006/relationships">
   <p:cSld>
     <p:spTree>
@@ -4190,7 +4114,7 @@
                 </a:solidFill>
                 <a:latin typeface="Arial"/>
               </a:rPr>
-              <a:t>CLINICAL, COSMETIC AND INVESTIGATIONAL D</a:t>
+              <a:t>CURRENT ONCOLOGY REPORTS</a:t>
             </a:r>
           </a:p>
         </p:txBody>
@@ -4225,7 +4149,7 @@
                 </a:solidFill>
                 <a:latin typeface="Arial"/>
               </a:rPr>
-              <a:t>35.9%</a:t>
+              <a:t>미녹시딜</a:t>
             </a:r>
           </a:p>
         </p:txBody>
@@ -4260,7 +4184,7 @@
                 </a:solidFill>
                 <a:latin typeface="Arial"/>
               </a:rPr>
-              <a:t>이 숫자, 탈모 연구가 새로 내놨습니다</a:t>
+              <a:t>오늘 나온 최신 연구를 정리했습니다</a:t>
             </a:r>
           </a:p>
         </p:txBody>
@@ -4295,115 +4219,7 @@
                 </a:solidFill>
                 <a:latin typeface="Arial"/>
               </a:rPr>
-              <a:t>2026  |  매일 아침 탈모 연구 한 편</a:t>
-            </a:r>
-          </a:p>
-        </p:txBody>
-      </p:sp>
-    </p:spTree>
-  </p:cSld>
-  <p:clrMapOvr>
-    <a:masterClrMapping/>
-  </p:clrMapOvr>
-</p:sld>
-</file>
-
-<file path=ppt/slides/slide10.xml><?xml version="1.0" encoding="utf-8"?>
-<p:sld xmlns:a="http://schemas.openxmlformats.org/drawingml/2006/main" xmlns:p="http://schemas.openxmlformats.org/presentationml/2006/main" xmlns:r="http://schemas.openxmlformats.org/officeDocument/2006/relationships">
-  <p:cSld>
-    <p:bg>
-      <p:bgPr>
-        <a:solidFill>
-          <a:srgbClr val="12142A"/>
-        </a:solidFill>
-        <a:effectLst/>
-      </p:bgPr>
-    </p:bg>
-    <p:spTree>
-      <p:nvGrpSpPr>
-        <p:cNvPr id="1" name=""/>
-        <p:cNvGrpSpPr/>
-        <p:nvPr/>
-      </p:nvGrpSpPr>
-      <p:grpSpPr/>
-      <p:sp>
-        <p:nvSpPr>
-          <p:cNvPr id="2" name="TextBox 1"/>
-          <p:cNvSpPr txBox="1"/>
-          <p:nvPr/>
-        </p:nvSpPr>
-        <p:spPr>
-          <a:xfrm>
-            <a:off x="365760" y="731520"/>
-            <a:ext cx="4828032" cy="548640"/>
-          </a:xfrm>
-          <a:prstGeom prst="rect">
-            <a:avLst/>
-          </a:prstGeom>
-          <a:noFill/>
-        </p:spPr>
-        <p:txBody>
-          <a:bodyPr wrap="square" anchor="ctr">
-            <a:spAutoFit/>
-          </a:bodyPr>
-          <a:lstStyle/>
-          <a:p>
-            <a:pPr algn="ctr"/>
-            <a:r>
-              <a:rPr sz="2200" b="1">
-                <a:solidFill>
-                  <a:srgbClr val="FF6B6B"/>
-                </a:solidFill>
-                <a:latin typeface="Arial"/>
-              </a:rPr>
-              <a:t>출처</a:t>
-            </a:r>
-          </a:p>
-        </p:txBody>
-      </p:sp>
-      <p:sp>
-        <p:nvSpPr>
-          <p:cNvPr id="3" name="TextBox 2"/>
-          <p:cNvSpPr txBox="1"/>
-          <p:nvPr/>
-        </p:nvSpPr>
-        <p:spPr>
-          <a:xfrm>
-            <a:off x="365760" y="1463040"/>
-            <a:ext cx="4828032" cy="7680960"/>
-          </a:xfrm>
-          <a:prstGeom prst="rect">
-            <a:avLst/>
-          </a:prstGeom>
-          <a:noFill/>
-        </p:spPr>
-        <p:txBody>
-          <a:bodyPr wrap="square" anchor="t">
-            <a:spAutoFit/>
-          </a:bodyPr>
-          <a:lstStyle/>
-          <a:p>
-            <a:pPr algn="l"/>
-            <a:r>
-              <a:rPr sz="1000" b="0">
-                <a:solidFill>
-                  <a:srgbClr val="D5D8EA"/>
-                </a:solidFill>
-                <a:latin typeface="Arial"/>
-              </a:rPr>
-              <a:t>[출처]
-논문: Exploratory Identification of Multidimensional Treatment-Response Profiles in Androgenetic Alopecia Treated with Combined Scalp Microneedling and Topical Minoxidil Using Unsupervised Clustering
-게재: Clinical, cosmetic and investigational dermatology
-원문: https://pubmed.ncbi.nlm.nih.gov/42866572/
-[이미지 출처]
-- Male pattern baldness.jpg / Originally uploaded by Lkinkade (Transferred by XenonX3) / CC BY-SA 2.5
-  https://commons.wikimedia.org/wiki/File:Male_pattern_baldness.jpg
-- Male-pattern hair loss.jpg / BlaiserPascal / CC BY-SA 4.0
-  https://commons.wikimedia.org/wiki/File:Male-pattern_hair_loss.jpg
-※ CC BY-SA 이미지가 포함되어 있습니다. 저작자 표시가 필수이며,
-  동일조건변경허락(ShareAlike) 조항이 영상 전체에 적용될 수 있으니
-  상업적 이용 시 해당 이미지를 교체하는 편이 안전합니다.
-</a:t>
+              <a:t>2026 Oct 14  |  매일 아침 탈모 연구 한 편</a:t>
             </a:r>
           </a:p>
         </p:txBody>
@@ -4488,7 +4304,7 @@
                 </a:solidFill>
                 <a:latin typeface="Arial"/>
               </a:rPr>
-              <a:t>Exploratory Identification of Multidimensional Treatment-Response Profiles in Androgenetic Alopecia Treated with Combined Scalp Microneedling and Topical Minoxidil Using Unsupervised Clustering</a:t>
+              <a:t>Minoxidil and Prostaglandin Analogs for Chemotherapy-Induced Alopecia: A Scoping Review</a:t>
             </a:r>
           </a:p>
         </p:txBody>
@@ -4523,7 +4339,7 @@
                 </a:solidFill>
                 <a:latin typeface="Arial"/>
               </a:rPr>
-              <a:t>Clinical, cosmetic and investigational dermatology  ·  2026</a:t>
+              <a:t>Current oncology reports  ·  2026 Oct 14</a:t>
             </a:r>
           </a:p>
         </p:txBody>
@@ -4652,7 +4468,7 @@
                 </a:solidFill>
                 <a:latin typeface="Arial"/>
               </a:rPr>
-              <a:t>Methods: In this prospective cohort study, 156 patients with AGA received standardized combination therapy (microneedling 1.0 mm depth, biweekly; 5% topical minoxidil, twice daily) for 24 weeks, with longitudinal trichoscopic, molecular and clinical assessments.</a:t>
+              <a:t>Background: Chemotherapy-induced alopecia (CIA) is common, distressing, and markedly impairs patients' quality of life.</a:t>
             </a:r>
           </a:p>
         </p:txBody>
@@ -4781,7 +4597,7 @@
                 </a:solidFill>
                 <a:latin typeface="Arial"/>
               </a:rPr>
-              <a:t>Results: Silhouette analysis indicated weak global cluster structure (k=2, 0.274; k=3, 0.168); a three-cluster solution was retained as an exploratory, clinically motivated grouping and labelled Robust (n=45, 28.8%), Moderate (n=56, 35.9%) and Limited (n=55, 35.3%) responders.</a:t>
+              <a:t>Although scalp cooling is the only approved preventive strategy, its effectiveness and accessibility remain limited.</a:t>
             </a:r>
           </a:p>
         </p:txBody>
@@ -5102,7 +4918,9 @@
                 </a:solidFill>
                 <a:latin typeface="Arial"/>
               </a:rPr>
-              <a:t>· Combination therapy with scalp microneedling and topical minoxidil is more effective than minoxidil alone in androgenetic alopecia (AGA), yet treatment responses vary considerably among patients and the multidimensional structure of this heterogeneity remains poorly characterized.</a:t>
+              <a:t>· Chemotherapy-induced alopecia (CIA) is common, distressing, and markedly impairs patients' quality of life.
+· Although scalp cooling is the only approved preventive strategy, its effectiveness and accessibility remain limited.
+· Therefore, alternative pharmacologic approaches, such as minoxidil and prostaglandin analogs, have been explored.</a:t>
             </a:r>
           </a:p>
         </p:txBody>
@@ -5137,7 +4955,7 @@
                 </a:solidFill>
                 <a:latin typeface="Arial"/>
               </a:rPr>
-              <a:t>◆ 배경 — Objective</a:t>
+              <a:t>◆ 연구 방법 — Methods</a:t>
             </a:r>
           </a:p>
         </p:txBody>
@@ -5172,7 +4990,10 @@
                 </a:solidFill>
                 <a:latin typeface="Arial"/>
               </a:rPr>
-              <a:t>· To explore whether unsupervised clustering identifies distinct multidimensional treatment-response profiles during combination therapy and to describe their clinical and molecular characteristics as a hypothesis-generating basis for personalized management.</a:t>
+              <a:t>· This scoping review aimed to explore the available evidence on minoxidil's efficacy and safety and the potential role of prostaglandin analogs in alopecia.
+· PubMed, Cochrane Library, Medical Online, and Ichushi-Web were comprehensively searched from inception to February 2026.
+· Studies evaluating minoxidil in CIA and prostaglandin analogs in any alopecia type were included.
+· Case reports, case series, and non-human studies were excluded.</a:t>
             </a:r>
           </a:p>
         </p:txBody>
@@ -5268,7 +5089,7 @@
                 </a:solidFill>
                 <a:latin typeface="Arial"/>
               </a:rPr>
-              <a:t>◆ 연구 방법 — Methods</a:t>
+              <a:t>◆ 주요 결과 — Results</a:t>
             </a:r>
           </a:p>
         </p:txBody>
@@ -5303,8 +5124,12 @@
                 </a:solidFill>
                 <a:latin typeface="Arial"/>
               </a:rPr>
-              <a:t>· In this prospective cohort study, 156 patients with AGA received standardized combination therapy (microneedling 1.0 mm depth, biweekly; 5% topical minoxidil, twice daily) for 24 weeks, with longitudinal trichoscopic, molecular and clinical assessments.
-· K-means clustering was applied to ten standardized treatment-response (change-from-baseline) variables; the number of clusters was examined by silhouette, gap-statistic and bootstrap-stability analyses, and between-profile differences were tested with assumption-appropriate methods and reported with effect sizes.</a:t>
+              <a:t>· Five studies evaluated minoxidil in CIA, including two randomized controlled trials and three retrospective studies on prophylactic and therapeutic use, respectively.
+· Prophylactic topical minoxidil did not markedly prevent CIA but was associated with earlier hair regrowth.
+· In contrast, therapeutic use-particularly of oral minoxidil-improved hair density and treatment response.
+· No serious adverse events were reported, although cardiovascular effects remain a concern with oral formulations.
+· Two randomized controlled trials evaluated prostaglandin analogs in non-chemotherapy-related alopecia and showed markedly improved hair density and regrowth.
+· However, no study directly assessed their efficacy in CIA.</a:t>
             </a:r>
           </a:p>
         </p:txBody>
@@ -5339,7 +5164,7 @@
                 </a:solidFill>
                 <a:latin typeface="Arial"/>
               </a:rPr>
-              <a:t>◆ 주요 결과 — Results</a:t>
+              <a:t>◆ 결론 — Conclusions</a:t>
             </a:r>
           </a:p>
         </p:txBody>
@@ -5374,9 +5199,9 @@
                 </a:solidFill>
                 <a:latin typeface="Arial"/>
               </a:rPr>
-              <a:t>· Silhouette analysis indicated weak global cluster structure (k=2, 0.274; k=3, 0.168); a three-cluster solution was retained as an exploratory, clinically motivated grouping and labelled Robust (n=45, 28.8%), Moderate (n=56, 35.9%) and Limited (n=55, 35.3%) responders.
-· Profiles differed across the response variables that defined them, including hair-density change (36.25±19.07 vs 17.76±10.93 hairs/cm2 for Robust vs Limited; ε2=0.19) and Wnt10b transcript change (0.80±0.37 vs 0.27±0.19; ε2=0.34).
-· Baseline clinical and molecular parameters, including LEF-1 and IGF-1, did not differ across profiles and did not predict profile membership.</a:t>
+              <a:t>· Minoxidil may be beneficial for hair regrowth in CIA but shows limited preventive efficacy.
+· Prostaglandin analogs are promising but untested in this setting.
+· Future studies should evaluate their role, particularly in combination with minoxidil, to address the current evidence gap and improve outcomes for patients with CIA.</a:t>
             </a:r>
           </a:p>
         </p:txBody>
@@ -5415,8 +5240,8 @@
         </p:nvSpPr>
         <p:spPr>
           <a:xfrm>
-            <a:off x="365760" y="457200"/>
-            <a:ext cx="4828032" cy="457200"/>
+            <a:off x="365760" y="731520"/>
+            <a:ext cx="4828032" cy="548640"/>
           </a:xfrm>
           <a:prstGeom prst="rect">
             <a:avLst/>
@@ -5429,15 +5254,15 @@
           </a:bodyPr>
           <a:lstStyle/>
           <a:p>
-            <a:pPr algn="l"/>
-            <a:r>
-              <a:rPr sz="1600" b="1">
+            <a:pPr algn="ctr"/>
+            <a:r>
+              <a:rPr sz="2200" b="1">
                 <a:solidFill>
                   <a:srgbClr val="FF6B6B"/>
                 </a:solidFill>
                 <a:latin typeface="Arial"/>
               </a:rPr>
-              <a:t>본문 요약 (편집용)</a:t>
+              <a:t>출처</a:t>
             </a:r>
           </a:p>
         </p:txBody>
@@ -5450,8 +5275,8 @@
         </p:nvSpPr>
         <p:spPr>
           <a:xfrm>
-            <a:off x="365760" y="1097280"/>
-            <a:ext cx="4828032" cy="457200"/>
+            <a:off x="365760" y="1463040"/>
+            <a:ext cx="4828032" cy="7680960"/>
           </a:xfrm>
           <a:prstGeom prst="rect">
             <a:avLst/>
@@ -5466,49 +5291,25 @@
           <a:p>
             <a:pPr algn="l"/>
             <a:r>
-              <a:rPr sz="1300" b="1">
-                <a:solidFill>
-                  <a:srgbClr val="FFFFFF"/>
-                </a:solidFill>
-                <a:latin typeface="Arial"/>
-              </a:rPr>
-              <a:t>◆ 결론 — Conclusion</a:t>
-            </a:r>
-          </a:p>
-        </p:txBody>
-      </p:sp>
-      <p:sp>
-        <p:nvSpPr>
-          <p:cNvPr id="4" name="TextBox 3"/>
-          <p:cNvSpPr txBox="1"/>
-          <p:nvPr/>
-        </p:nvSpPr>
-        <p:spPr>
-          <a:xfrm>
-            <a:off x="457200" y="1600200"/>
-            <a:ext cx="4736592" cy="3566160"/>
-          </a:xfrm>
-          <a:prstGeom prst="rect">
-            <a:avLst/>
-          </a:prstGeom>
-          <a:noFill/>
-        </p:spPr>
-        <p:txBody>
-          <a:bodyPr wrap="square" anchor="t">
-            <a:spAutoFit/>
-          </a:bodyPr>
-          <a:lstStyle/>
-          <a:p>
-            <a:pPr algn="l"/>
-            <a:r>
               <a:rPr sz="1000" b="0">
                 <a:solidFill>
                   <a:srgbClr val="D5D8EA"/>
                 </a:solidFill>
                 <a:latin typeface="Arial"/>
               </a:rPr>
-              <a:t>· Unsupervised clustering identified three clinically interpretable treatment-response profiles accompanied by graded differences in Wnt/β-catenin-associated transcript changes.
-· Because the profiles showed weak internal separation and could not be predicted from baseline characteristics, these hypothesis-generating findings suggest, rather than demonstrate, multidimensional structure in treatment response and require validation in independent, controlled cohorts before any clinical application.</a:t>
+              <a:t>[출처]
+논문: Minoxidil and Prostaglandin Analogs for Chemotherapy-Induced Alopecia: A Scoping Review
+게재: Current oncology reports
+원문: https://pubmed.ncbi.nlm.nih.gov/42873375/
+[이미지 출처]
+- Male pattern baldness.jpg / Originally uploaded by Lkinkade (Transferred by XenonX3) / CC BY-SA 2.5
+  https://commons.wikimedia.org/wiki/File:Male_pattern_baldness.jpg
+- Male-pattern hair loss.jpg / BlaiserPascal / CC BY-SA 4.0
+  https://commons.wikimedia.org/wiki/File:Male-pattern_hair_loss.jpg
+※ CC BY-SA 이미지가 포함되어 있습니다. 저작자 표시가 필수이며,
+  동일조건변경허락(ShareAlike) 조항이 영상 전체에 적용될 수 있으니
+  상업적 이용 시 해당 이미지를 교체하는 편이 안전합니다.
+</a:t>
             </a:r>
           </a:p>
         </p:txBody>

</xml_diff>

<commit_message>
chore: daily content 2026-10-16
</commit_message>
<xml_diff>
--- a/pwa/data/latest/slides.pptx
+++ b/pwa/data/latest/slides.pptx
@@ -13,7 +13,6 @@
     <p:sldId id="261" r:id="rId13"/>
     <p:sldId id="262" r:id="rId14"/>
     <p:sldId id="263" r:id="rId15"/>
-    <p:sldId id="264" r:id="rId16"/>
   </p:sldIdLst>
   <p:sldSz cx="5559552" cy="9875520" type="screen4x3"/>
   <p:notesSz cx="6858000" cy="9144000"/>
@@ -515,7 +514,7 @@
           </a:p>
           <a:p>
             <a:r>
-              <a:t>대본: 미녹시딜 오늘 나온 최신 연구를 정리했습니다</a:t>
+              <a:t>대본: 피나스테리드 오늘 나온 최신 연구를 정리했습니다</a:t>
             </a:r>
           </a:p>
           <a:p>
@@ -595,7 +594,7 @@
           </a:p>
           <a:p>
             <a:r>
-              <a:t>대본: 《Current oncology reports》 - Minoxidil and Prostaglandin Analogs for Chemotherapy-Induced Alopecia: A Scoping Review</a:t>
+              <a:t>대본: 《Journal of public health (Oxford, England)》 - Finasteride and depression: the high cost of failed regulation</a:t>
             </a:r>
           </a:p>
           <a:p>
@@ -675,7 +674,7 @@
           </a:p>
           <a:p>
             <a:r>
-              <a:t>대본: Background: Chemotherapy-induced alopecia (CIA) is common, distressing, and markedly impairs patients' quality of life.</a:t>
+              <a:t>대본: This essay examines the costs of regulatory failure by highlighting the serious neuropsychiatric risks associated with finasteride, a popular hair-loss medication that can cause long-lasting depression and suicidal thoughts.</a:t>
             </a:r>
           </a:p>
           <a:p>
@@ -755,7 +754,7 @@
           </a:p>
           <a:p>
             <a:r>
-              <a:t>대본: Although scalp cooling is the only approved preventive strategy, its effectiveness and accessibility remain limited.</a:t>
+              <a:t>대본: In the United States, illustrative estimates suggest that hundreds of thousands of users may experience depression, over a thousand may die by suicide, and the associated societal costs may approach several billion dollars annually.</a:t>
             </a:r>
           </a:p>
           <a:p>
@@ -946,81 +945,6 @@
 </file>
 
 <file path=ppt/notesSlides/notesSlide7.xml><?xml version="1.0" encoding="utf-8"?>
-<p:notes xmlns:a="http://schemas.openxmlformats.org/drawingml/2006/main" xmlns:p="http://schemas.openxmlformats.org/presentationml/2006/main" xmlns:r="http://schemas.openxmlformats.org/officeDocument/2006/relationships">
-  <p:cSld>
-    <p:spTree>
-      <p:nvGrpSpPr>
-        <p:cNvPr id="1" name=""/>
-        <p:cNvGrpSpPr/>
-        <p:nvPr/>
-      </p:nvGrpSpPr>
-      <p:grpSpPr>
-        <a:xfrm>
-          <a:off x="0" y="0"/>
-          <a:ext cx="0" cy="0"/>
-          <a:chOff x="0" y="0"/>
-          <a:chExt cx="0" cy="0"/>
-        </a:xfrm>
-      </p:grpSpPr>
-      <p:sp>
-        <p:nvSpPr>
-          <p:cNvPr id="2" name="Slide Image Placeholder 1"/>
-          <p:cNvSpPr>
-            <a:spLocks noGrp="1"/>
-          </p:cNvSpPr>
-          <p:nvPr>
-            <p:ph type="sldImg" idx="2"/>
-          </p:nvPr>
-        </p:nvSpPr>
-        <p:spPr/>
-      </p:sp>
-      <p:sp>
-        <p:nvSpPr>
-          <p:cNvPr id="3" name="Notes Placeholder 2"/>
-          <p:cNvSpPr>
-            <a:spLocks noGrp="1"/>
-          </p:cNvSpPr>
-          <p:nvPr>
-            <p:ph type="body" idx="3" sz="quarter"/>
-          </p:nvPr>
-        </p:nvSpPr>
-        <p:spPr/>
-        <p:txBody>
-          <a:bodyPr/>
-          <a:lstStyle/>
-          <a:p>
-            <a:r>
-              <a:t>편집 참고용 슬라이드입니다. 영상에는 쓰지 않아도 됩니다.</a:t>
-            </a:r>
-          </a:p>
-          <a:p>
-            <a:r>
-              <a:t>원문 영어 문장을 그대로 발췌했으므로 번역·검수 후 사용하세요.</a:t>
-            </a:r>
-          </a:p>
-        </p:txBody>
-      </p:sp>
-      <p:sp>
-        <p:nvSpPr>
-          <p:cNvPr id="4" name="Slide Number Placeholder 3"/>
-          <p:cNvSpPr>
-            <a:spLocks noGrp="1"/>
-          </p:cNvSpPr>
-          <p:nvPr>
-            <p:ph type="sldNum" idx="5" sz="quarter"/>
-          </p:nvPr>
-        </p:nvSpPr>
-        <p:spPr/>
-      </p:sp>
-    </p:spTree>
-  </p:cSld>
-  <p:clrMapOvr>
-    <a:masterClrMapping/>
-  </p:clrMapOvr>
-</p:notes>
-</file>
-
-<file path=ppt/notesSlides/notesSlide8.xml><?xml version="1.0" encoding="utf-8"?>
 <p:notes xmlns:a="http://schemas.openxmlformats.org/drawingml/2006/main" xmlns:p="http://schemas.openxmlformats.org/presentationml/2006/main" xmlns:r="http://schemas.openxmlformats.org/officeDocument/2006/relationships">
   <p:cSld>
     <p:spTree>
@@ -4114,7 +4038,7 @@
                 </a:solidFill>
                 <a:latin typeface="Arial"/>
               </a:rPr>
-              <a:t>CURRENT ONCOLOGY REPORTS</a:t>
+              <a:t>JOURNAL OF PUBLIC HEALTH (OXFORD, ENGLAN</a:t>
             </a:r>
           </a:p>
         </p:txBody>
@@ -4149,7 +4073,7 @@
                 </a:solidFill>
                 <a:latin typeface="Arial"/>
               </a:rPr>
-              <a:t>미녹시딜</a:t>
+              <a:t>피나스테리드</a:t>
             </a:r>
           </a:p>
         </p:txBody>
@@ -4219,7 +4143,7 @@
                 </a:solidFill>
                 <a:latin typeface="Arial"/>
               </a:rPr>
-              <a:t>2026 Oct 14  |  매일 아침 탈모 연구 한 편</a:t>
+              <a:t>2026 Oct 15  |  매일 아침 탈모 연구 한 편</a:t>
             </a:r>
           </a:p>
         </p:txBody>
@@ -4304,7 +4228,7 @@
                 </a:solidFill>
                 <a:latin typeface="Arial"/>
               </a:rPr>
-              <a:t>Minoxidil and Prostaglandin Analogs for Chemotherapy-Induced Alopecia: A Scoping Review</a:t>
+              <a:t>Finasteride and depression: the high cost of failed regulation</a:t>
             </a:r>
           </a:p>
         </p:txBody>
@@ -4339,7 +4263,7 @@
                 </a:solidFill>
                 <a:latin typeface="Arial"/>
               </a:rPr>
-              <a:t>Current oncology reports  ·  2026 Oct 14</a:t>
+              <a:t>Journal of public health (Oxford, England)  ·  2026 Oct 15</a:t>
             </a:r>
           </a:p>
         </p:txBody>
@@ -4468,7 +4392,7 @@
                 </a:solidFill>
                 <a:latin typeface="Arial"/>
               </a:rPr>
-              <a:t>Background: Chemotherapy-induced alopecia (CIA) is common, distressing, and markedly impairs patients' quality of life.</a:t>
+              <a:t>This essay examines the costs of regulatory failure by highlighting the serious neuropsychiatric risks associated with finasteride, a popular hair-loss medication that can cause long-lasting depression and suicidal thoughts.</a:t>
             </a:r>
           </a:p>
         </p:txBody>
@@ -4597,7 +4521,7 @@
                 </a:solidFill>
                 <a:latin typeface="Arial"/>
               </a:rPr>
-              <a:t>Although scalp cooling is the only approved preventive strategy, its effectiveness and accessibility remain limited.</a:t>
+              <a:t>In the United States, illustrative estimates suggest that hundreds of thousands of users may experience depression, over a thousand may die by suicide, and the associated societal costs may approach several billion dollars annually.</a:t>
             </a:r>
           </a:p>
         </p:txBody>
@@ -4883,7 +4807,7 @@
                 </a:solidFill>
                 <a:latin typeface="Arial"/>
               </a:rPr>
-              <a:t>◆ 배경 — Background</a:t>
+              <a:t>◆ 배경 — Background (자동 구분)</a:t>
             </a:r>
           </a:p>
         </p:txBody>
@@ -4918,9 +4842,8 @@
                 </a:solidFill>
                 <a:latin typeface="Arial"/>
               </a:rPr>
-              <a:t>· Chemotherapy-induced alopecia (CIA) is common, distressing, and markedly impairs patients' quality of life.
-· Although scalp cooling is the only approved preventive strategy, its effectiveness and accessibility remain limited.
-· Therefore, alternative pharmacologic approaches, such as minoxidil and prostaglandin analogs, have been explored.</a:t>
+              <a:t>· This essay examines the costs of regulatory failure by highlighting the serious neuropsychiatric risks associated with finasteride, a popular hair-loss medication that can cause long-lasting depression and suicidal thoughts.
+· In the United States, illustrative estimates suggest that hundreds of thousands of users may experience depression, over a thousand may die by suicide, and the associated societal costs may approach several billion dollars annually.</a:t>
             </a:r>
           </a:p>
         </p:txBody>
@@ -4955,7 +4878,7 @@
                 </a:solidFill>
                 <a:latin typeface="Arial"/>
               </a:rPr>
-              <a:t>◆ 연구 방법 — Methods</a:t>
+              <a:t>◆ 주요 결과 — Results (자동 구분)</a:t>
             </a:r>
           </a:p>
         </p:txBody>
@@ -4990,10 +4913,11 @@
                 </a:solidFill>
                 <a:latin typeface="Arial"/>
               </a:rPr>
-              <a:t>· This scoping review aimed to explore the available evidence on minoxidil's efficacy and safety and the potential role of prostaglandin analogs in alopecia.
-· PubMed, Cochrane Library, Medical Online, and Ichushi-Web were comprehensively searched from inception to February 2026.
-· Studies evaluating minoxidil in CIA and prostaglandin analogs in any alopecia type were included.
-· Case reports, case series, and non-human studies were excluded.</a:t>
+              <a:t>· The article criticizes the FDA and the pharmaceutical industry for failing to conduct or require thorough post-marketing safety studies despite early warning signs.
+· The author concludes that public health must take precedence over corporate interests and shareholder duties.
+· To prevent future similar events, the article proposes regulatory reform that mandates ongoing surveillance.
+· Regulators must require manufacturers to commit to continuous safety monitoring and formal studies after a medication is approved.
+· Regulators must enforce these post-approval study requirements with clear timelines, rather than relying on industry self-discipline, to rebuild public trust and protect citizens from drug safety failures.</a:t>
             </a:r>
           </a:p>
         </p:txBody>
@@ -5032,214 +4956,6 @@
         </p:nvSpPr>
         <p:spPr>
           <a:xfrm>
-            <a:off x="365760" y="457200"/>
-            <a:ext cx="4828032" cy="457200"/>
-          </a:xfrm>
-          <a:prstGeom prst="rect">
-            <a:avLst/>
-          </a:prstGeom>
-          <a:noFill/>
-        </p:spPr>
-        <p:txBody>
-          <a:bodyPr wrap="square" anchor="ctr">
-            <a:spAutoFit/>
-          </a:bodyPr>
-          <a:lstStyle/>
-          <a:p>
-            <a:pPr algn="l"/>
-            <a:r>
-              <a:rPr sz="1600" b="1">
-                <a:solidFill>
-                  <a:srgbClr val="FF6B6B"/>
-                </a:solidFill>
-                <a:latin typeface="Arial"/>
-              </a:rPr>
-              <a:t>본문 요약 (편집용)</a:t>
-            </a:r>
-          </a:p>
-        </p:txBody>
-      </p:sp>
-      <p:sp>
-        <p:nvSpPr>
-          <p:cNvPr id="3" name="TextBox 2"/>
-          <p:cNvSpPr txBox="1"/>
-          <p:nvPr/>
-        </p:nvSpPr>
-        <p:spPr>
-          <a:xfrm>
-            <a:off x="365760" y="1097280"/>
-            <a:ext cx="4828032" cy="457200"/>
-          </a:xfrm>
-          <a:prstGeom prst="rect">
-            <a:avLst/>
-          </a:prstGeom>
-          <a:noFill/>
-        </p:spPr>
-        <p:txBody>
-          <a:bodyPr wrap="square" anchor="t">
-            <a:spAutoFit/>
-          </a:bodyPr>
-          <a:lstStyle/>
-          <a:p>
-            <a:pPr algn="l"/>
-            <a:r>
-              <a:rPr sz="1300" b="1">
-                <a:solidFill>
-                  <a:srgbClr val="FFFFFF"/>
-                </a:solidFill>
-                <a:latin typeface="Arial"/>
-              </a:rPr>
-              <a:t>◆ 주요 결과 — Results</a:t>
-            </a:r>
-          </a:p>
-        </p:txBody>
-      </p:sp>
-      <p:sp>
-        <p:nvSpPr>
-          <p:cNvPr id="4" name="TextBox 3"/>
-          <p:cNvSpPr txBox="1"/>
-          <p:nvPr/>
-        </p:nvSpPr>
-        <p:spPr>
-          <a:xfrm>
-            <a:off x="457200" y="1600200"/>
-            <a:ext cx="4736592" cy="3566160"/>
-          </a:xfrm>
-          <a:prstGeom prst="rect">
-            <a:avLst/>
-          </a:prstGeom>
-          <a:noFill/>
-        </p:spPr>
-        <p:txBody>
-          <a:bodyPr wrap="square" anchor="t">
-            <a:spAutoFit/>
-          </a:bodyPr>
-          <a:lstStyle/>
-          <a:p>
-            <a:pPr algn="l"/>
-            <a:r>
-              <a:rPr sz="1000" b="0">
-                <a:solidFill>
-                  <a:srgbClr val="D5D8EA"/>
-                </a:solidFill>
-                <a:latin typeface="Arial"/>
-              </a:rPr>
-              <a:t>· Five studies evaluated minoxidil in CIA, including two randomized controlled trials and three retrospective studies on prophylactic and therapeutic use, respectively.
-· Prophylactic topical minoxidil did not markedly prevent CIA but was associated with earlier hair regrowth.
-· In contrast, therapeutic use-particularly of oral minoxidil-improved hair density and treatment response.
-· No serious adverse events were reported, although cardiovascular effects remain a concern with oral formulations.
-· Two randomized controlled trials evaluated prostaglandin analogs in non-chemotherapy-related alopecia and showed markedly improved hair density and regrowth.
-· However, no study directly assessed their efficacy in CIA.</a:t>
-            </a:r>
-          </a:p>
-        </p:txBody>
-      </p:sp>
-      <p:sp>
-        <p:nvSpPr>
-          <p:cNvPr id="5" name="TextBox 4"/>
-          <p:cNvSpPr txBox="1"/>
-          <p:nvPr/>
-        </p:nvSpPr>
-        <p:spPr>
-          <a:xfrm>
-            <a:off x="365760" y="5303520"/>
-            <a:ext cx="4828032" cy="457200"/>
-          </a:xfrm>
-          <a:prstGeom prst="rect">
-            <a:avLst/>
-          </a:prstGeom>
-          <a:noFill/>
-        </p:spPr>
-        <p:txBody>
-          <a:bodyPr wrap="square" anchor="t">
-            <a:spAutoFit/>
-          </a:bodyPr>
-          <a:lstStyle/>
-          <a:p>
-            <a:pPr algn="l"/>
-            <a:r>
-              <a:rPr sz="1300" b="1">
-                <a:solidFill>
-                  <a:srgbClr val="FFFFFF"/>
-                </a:solidFill>
-                <a:latin typeface="Arial"/>
-              </a:rPr>
-              <a:t>◆ 결론 — Conclusions</a:t>
-            </a:r>
-          </a:p>
-        </p:txBody>
-      </p:sp>
-      <p:sp>
-        <p:nvSpPr>
-          <p:cNvPr id="6" name="TextBox 5"/>
-          <p:cNvSpPr txBox="1"/>
-          <p:nvPr/>
-        </p:nvSpPr>
-        <p:spPr>
-          <a:xfrm>
-            <a:off x="457200" y="5806440"/>
-            <a:ext cx="4736592" cy="3566160"/>
-          </a:xfrm>
-          <a:prstGeom prst="rect">
-            <a:avLst/>
-          </a:prstGeom>
-          <a:noFill/>
-        </p:spPr>
-        <p:txBody>
-          <a:bodyPr wrap="square" anchor="t">
-            <a:spAutoFit/>
-          </a:bodyPr>
-          <a:lstStyle/>
-          <a:p>
-            <a:pPr algn="l"/>
-            <a:r>
-              <a:rPr sz="1000" b="0">
-                <a:solidFill>
-                  <a:srgbClr val="D5D8EA"/>
-                </a:solidFill>
-                <a:latin typeface="Arial"/>
-              </a:rPr>
-              <a:t>· Minoxidil may be beneficial for hair regrowth in CIA but shows limited preventive efficacy.
-· Prostaglandin analogs are promising but untested in this setting.
-· Future studies should evaluate their role, particularly in combination with minoxidil, to address the current evidence gap and improve outcomes for patients with CIA.</a:t>
-            </a:r>
-          </a:p>
-        </p:txBody>
-      </p:sp>
-    </p:spTree>
-  </p:cSld>
-  <p:clrMapOvr>
-    <a:masterClrMapping/>
-  </p:clrMapOvr>
-</p:sld>
-</file>
-
-<file path=ppt/slides/slide9.xml><?xml version="1.0" encoding="utf-8"?>
-<p:sld xmlns:a="http://schemas.openxmlformats.org/drawingml/2006/main" xmlns:p="http://schemas.openxmlformats.org/presentationml/2006/main" xmlns:r="http://schemas.openxmlformats.org/officeDocument/2006/relationships">
-  <p:cSld>
-    <p:bg>
-      <p:bgPr>
-        <a:solidFill>
-          <a:srgbClr val="12142A"/>
-        </a:solidFill>
-        <a:effectLst/>
-      </p:bgPr>
-    </p:bg>
-    <p:spTree>
-      <p:nvGrpSpPr>
-        <p:cNvPr id="1" name=""/>
-        <p:cNvGrpSpPr/>
-        <p:nvPr/>
-      </p:nvGrpSpPr>
-      <p:grpSpPr/>
-      <p:sp>
-        <p:nvSpPr>
-          <p:cNvPr id="2" name="TextBox 1"/>
-          <p:cNvSpPr txBox="1"/>
-          <p:nvPr/>
-        </p:nvSpPr>
-        <p:spPr>
-          <a:xfrm>
             <a:off x="365760" y="731520"/>
             <a:ext cx="4828032" cy="548640"/>
           </a:xfrm>
@@ -5298,9 +5014,9 @@
                 <a:latin typeface="Arial"/>
               </a:rPr>
               <a:t>[출처]
-논문: Minoxidil and Prostaglandin Analogs for Chemotherapy-Induced Alopecia: A Scoping Review
-게재: Current oncology reports
-원문: https://pubmed.ncbi.nlm.nih.gov/42873375/
+논문: Finasteride and depression: the high cost of failed regulation
+게재: Journal of public health (Oxford, England)
+원문: https://pubmed.ncbi.nlm.nih.gov/42878119/
 [이미지 출처]
 - Male pattern baldness.jpg / Originally uploaded by Lkinkade (Transferred by XenonX3) / CC BY-SA 2.5
   https://commons.wikimedia.org/wiki/File:Male_pattern_baldness.jpg

</xml_diff>

<commit_message>
chore: daily content 2026-10-17
</commit_message>
<xml_diff>
--- a/pwa/data/latest/slides.pptx
+++ b/pwa/data/latest/slides.pptx
@@ -13,6 +13,7 @@
     <p:sldId id="261" r:id="rId13"/>
     <p:sldId id="262" r:id="rId14"/>
     <p:sldId id="263" r:id="rId15"/>
+    <p:sldId id="264" r:id="rId16"/>
   </p:sldIdLst>
   <p:sldSz cx="5559552" cy="9875520" type="screen4x3"/>
   <p:notesSz cx="6858000" cy="9144000"/>
@@ -514,7 +515,7 @@
           </a:p>
           <a:p>
             <a:r>
-              <a:t>대본: 피나스테리드 오늘 나온 최신 연구를 정리했습니다</a:t>
+              <a:t>대본: 남성형 탈모 오늘 나온 최신 연구를 정리했습니다</a:t>
             </a:r>
           </a:p>
           <a:p>
@@ -594,7 +595,7 @@
           </a:p>
           <a:p>
             <a:r>
-              <a:t>대본: 《Journal of public health (Oxford, England)》 - Finasteride and depression: the high cost of failed regulation</a:t>
+              <a:t>대본: 《Expert opinion on drug discovery》 - Targeting fibroimmune remodeling in androgenetic alopecia: emerging opportunities for RNA-based drug discovery</a:t>
             </a:r>
           </a:p>
           <a:p>
@@ -674,7 +675,7 @@
           </a:p>
           <a:p>
             <a:r>
-              <a:t>대본: This essay examines the costs of regulatory failure by highlighting the serious neuropsychiatric risks associated with finasteride, a popular hair-loss medication that can cause long-lasting depression and suicidal thoughts.</a:t>
+              <a:t>대본: Introduction: Current treatments for androgenetic alopecia (AGA) primarily suppress androgen signaling or stimulate hair growth.</a:t>
             </a:r>
           </a:p>
           <a:p>
@@ -754,7 +755,7 @@
           </a:p>
           <a:p>
             <a:r>
-              <a:t>대본: In the United States, illustrative estimates suggest that hundreds of thousands of users may experience depression, over a thousand may die by suicide, and the associated societal costs may approach several billion dollars annually.</a:t>
+              <a:t>대본: Recent single-cell and spatial transcriptomic studies identify fibroimmune remodeling as a potential source of new AGA targets.</a:t>
             </a:r>
           </a:p>
           <a:p>
@@ -945,6 +946,81 @@
 </file>
 
 <file path=ppt/notesSlides/notesSlide7.xml><?xml version="1.0" encoding="utf-8"?>
+<p:notes xmlns:a="http://schemas.openxmlformats.org/drawingml/2006/main" xmlns:p="http://schemas.openxmlformats.org/presentationml/2006/main" xmlns:r="http://schemas.openxmlformats.org/officeDocument/2006/relationships">
+  <p:cSld>
+    <p:spTree>
+      <p:nvGrpSpPr>
+        <p:cNvPr id="1" name=""/>
+        <p:cNvGrpSpPr/>
+        <p:nvPr/>
+      </p:nvGrpSpPr>
+      <p:grpSpPr>
+        <a:xfrm>
+          <a:off x="0" y="0"/>
+          <a:ext cx="0" cy="0"/>
+          <a:chOff x="0" y="0"/>
+          <a:chExt cx="0" cy="0"/>
+        </a:xfrm>
+      </p:grpSpPr>
+      <p:sp>
+        <p:nvSpPr>
+          <p:cNvPr id="2" name="Slide Image Placeholder 1"/>
+          <p:cNvSpPr>
+            <a:spLocks noGrp="1"/>
+          </p:cNvSpPr>
+          <p:nvPr>
+            <p:ph type="sldImg" idx="2"/>
+          </p:nvPr>
+        </p:nvSpPr>
+        <p:spPr/>
+      </p:sp>
+      <p:sp>
+        <p:nvSpPr>
+          <p:cNvPr id="3" name="Notes Placeholder 2"/>
+          <p:cNvSpPr>
+            <a:spLocks noGrp="1"/>
+          </p:cNvSpPr>
+          <p:nvPr>
+            <p:ph type="body" idx="3" sz="quarter"/>
+          </p:nvPr>
+        </p:nvSpPr>
+        <p:spPr/>
+        <p:txBody>
+          <a:bodyPr/>
+          <a:lstStyle/>
+          <a:p>
+            <a:r>
+              <a:t>편집 참고용 슬라이드입니다. 영상에는 쓰지 않아도 됩니다.</a:t>
+            </a:r>
+          </a:p>
+          <a:p>
+            <a:r>
+              <a:t>원문 영어 문장을 그대로 발췌했으므로 번역·검수 후 사용하세요.</a:t>
+            </a:r>
+          </a:p>
+        </p:txBody>
+      </p:sp>
+      <p:sp>
+        <p:nvSpPr>
+          <p:cNvPr id="4" name="Slide Number Placeholder 3"/>
+          <p:cNvSpPr>
+            <a:spLocks noGrp="1"/>
+          </p:cNvSpPr>
+          <p:nvPr>
+            <p:ph type="sldNum" idx="5" sz="quarter"/>
+          </p:nvPr>
+        </p:nvSpPr>
+        <p:spPr/>
+      </p:sp>
+    </p:spTree>
+  </p:cSld>
+  <p:clrMapOvr>
+    <a:masterClrMapping/>
+  </p:clrMapOvr>
+</p:notes>
+</file>
+
+<file path=ppt/notesSlides/notesSlide8.xml><?xml version="1.0" encoding="utf-8"?>
 <p:notes xmlns:a="http://schemas.openxmlformats.org/drawingml/2006/main" xmlns:p="http://schemas.openxmlformats.org/presentationml/2006/main" xmlns:r="http://schemas.openxmlformats.org/officeDocument/2006/relationships">
   <p:cSld>
     <p:spTree>
@@ -4038,7 +4114,7 @@
                 </a:solidFill>
                 <a:latin typeface="Arial"/>
               </a:rPr>
-              <a:t>JOURNAL OF PUBLIC HEALTH (OXFORD, ENGLAN</a:t>
+              <a:t>EXPERT OPINION ON DRUG DISCOVERY</a:t>
             </a:r>
           </a:p>
         </p:txBody>
@@ -4073,7 +4149,7 @@
                 </a:solidFill>
                 <a:latin typeface="Arial"/>
               </a:rPr>
-              <a:t>피나스테리드</a:t>
+              <a:t>남성형 탈모</a:t>
             </a:r>
           </a:p>
         </p:txBody>
@@ -4228,7 +4304,7 @@
                 </a:solidFill>
                 <a:latin typeface="Arial"/>
               </a:rPr>
-              <a:t>Finasteride and depression: the high cost of failed regulation</a:t>
+              <a:t>Targeting fibroimmune remodeling in androgenetic alopecia: emerging opportunities for RNA-based drug discovery</a:t>
             </a:r>
           </a:p>
         </p:txBody>
@@ -4263,7 +4339,7 @@
                 </a:solidFill>
                 <a:latin typeface="Arial"/>
               </a:rPr>
-              <a:t>Journal of public health (Oxford, England)  ·  2026 Oct 15</a:t>
+              <a:t>Expert opinion on drug discovery  ·  2026 Oct 15</a:t>
             </a:r>
           </a:p>
         </p:txBody>
@@ -4392,7 +4468,7 @@
                 </a:solidFill>
                 <a:latin typeface="Arial"/>
               </a:rPr>
-              <a:t>This essay examines the costs of regulatory failure by highlighting the serious neuropsychiatric risks associated with finasteride, a popular hair-loss medication that can cause long-lasting depression and suicidal thoughts.</a:t>
+              <a:t>Introduction: Current treatments for androgenetic alopecia (AGA) primarily suppress androgen signaling or stimulate hair growth.</a:t>
             </a:r>
           </a:p>
         </p:txBody>
@@ -4521,7 +4597,7 @@
                 </a:solidFill>
                 <a:latin typeface="Arial"/>
               </a:rPr>
-              <a:t>In the United States, illustrative estimates suggest that hundreds of thousands of users may experience depression, over a thousand may die by suicide, and the associated societal costs may approach several billion dollars annually.</a:t>
+              <a:t>Recent single-cell and spatial transcriptomic studies identify fibroimmune remodeling as a potential source of new AGA targets.</a:t>
             </a:r>
           </a:p>
         </p:txBody>
@@ -4842,8 +4918,8 @@
                 </a:solidFill>
                 <a:latin typeface="Arial"/>
               </a:rPr>
-              <a:t>· This essay examines the costs of regulatory failure by highlighting the serious neuropsychiatric risks associated with finasteride, a popular hair-loss medication that can cause long-lasting depression and suicidal thoughts.
-· In the United States, illustrative estimates suggest that hundreds of thousands of users may experience depression, over a thousand may die by suicide, and the associated societal costs may approach several billion dollars annually.</a:t>
+              <a:t>· Introduction: Current treatments for androgenetic alopecia (AGA) primarily suppress androgen signaling or stimulate hair growth.
+· Recent single-cell and spatial transcriptomic studies identify fibroimmune remodeling as a potential source of new AGA targets.</a:t>
             </a:r>
           </a:p>
         </p:txBody>
@@ -4913,11 +4989,11 @@
                 </a:solidFill>
                 <a:latin typeface="Arial"/>
               </a:rPr>
-              <a:t>· The article criticizes the FDA and the pharmaceutical industry for failing to conduct or require thorough post-marketing safety studies despite early warning signs.
-· The author concludes that public health must take precedence over corporate interests and shareholder duties.
-· To prevent future similar events, the article proposes regulatory reform that mandates ongoing surveillance.
-· Regulators must require manufacturers to commit to continuous safety monitoring and formal studies after a medication is approved.
-· Regulators must enforce these post-approval study requirements with clear timelines, rather than relying on industry self-discipline, to rebuild public trust and protect citizens from drug safety failures.</a:t>
+              <a:t>· Areas covered: This review integrates transcriptomic and mechanistic evidence linking androgen-responsive fibroblasts, immune-cell recruitment, and extracellular matrix remodeling, in male and female pattern hair loss.
+· Herein, the authors assessed published human scalp, cell and animal studies of JAK/STAT, TGF-β, CXCL12-CXCR4/ACKR3, and DKK3-CKAP4, and evaluated RNA therapeutic modalities and delivery barriers.
+· Literature was identified primarily through PubMed in the last 20 years.
+· Expert opinion: Fibroimmune remodeling should be viewed as a complementary, rather than alternative, framework to androgen biology.
+· The most promising drug discovery strategy is to identify molecularly defined patient subsets and locally inhibit nodal mediators that couple fibroblast activation to inflammation and matrix remodeling.</a:t>
             </a:r>
           </a:p>
         </p:txBody>
@@ -4956,6 +5032,137 @@
         </p:nvSpPr>
         <p:spPr>
           <a:xfrm>
+            <a:off x="365760" y="457200"/>
+            <a:ext cx="4828032" cy="457200"/>
+          </a:xfrm>
+          <a:prstGeom prst="rect">
+            <a:avLst/>
+          </a:prstGeom>
+          <a:noFill/>
+        </p:spPr>
+        <p:txBody>
+          <a:bodyPr wrap="square" anchor="ctr">
+            <a:spAutoFit/>
+          </a:bodyPr>
+          <a:lstStyle/>
+          <a:p>
+            <a:pPr algn="l"/>
+            <a:r>
+              <a:rPr sz="1600" b="1">
+                <a:solidFill>
+                  <a:srgbClr val="FF6B6B"/>
+                </a:solidFill>
+                <a:latin typeface="Arial"/>
+              </a:rPr>
+              <a:t>본문 요약 (편집용)</a:t>
+            </a:r>
+          </a:p>
+        </p:txBody>
+      </p:sp>
+      <p:sp>
+        <p:nvSpPr>
+          <p:cNvPr id="3" name="TextBox 2"/>
+          <p:cNvSpPr txBox="1"/>
+          <p:nvPr/>
+        </p:nvSpPr>
+        <p:spPr>
+          <a:xfrm>
+            <a:off x="365760" y="1097280"/>
+            <a:ext cx="4828032" cy="457200"/>
+          </a:xfrm>
+          <a:prstGeom prst="rect">
+            <a:avLst/>
+          </a:prstGeom>
+          <a:noFill/>
+        </p:spPr>
+        <p:txBody>
+          <a:bodyPr wrap="square" anchor="t">
+            <a:spAutoFit/>
+          </a:bodyPr>
+          <a:lstStyle/>
+          <a:p>
+            <a:pPr algn="l"/>
+            <a:r>
+              <a:rPr sz="1300" b="1">
+                <a:solidFill>
+                  <a:srgbClr val="FFFFFF"/>
+                </a:solidFill>
+                <a:latin typeface="Arial"/>
+              </a:rPr>
+              <a:t>◆ 결론 — Conclusion (자동 구분)</a:t>
+            </a:r>
+          </a:p>
+        </p:txBody>
+      </p:sp>
+      <p:sp>
+        <p:nvSpPr>
+          <p:cNvPr id="4" name="TextBox 3"/>
+          <p:cNvSpPr txBox="1"/>
+          <p:nvPr/>
+        </p:nvSpPr>
+        <p:spPr>
+          <a:xfrm>
+            <a:off x="457200" y="1600200"/>
+            <a:ext cx="4736592" cy="3566160"/>
+          </a:xfrm>
+          <a:prstGeom prst="rect">
+            <a:avLst/>
+          </a:prstGeom>
+          <a:noFill/>
+        </p:spPr>
+        <p:txBody>
+          <a:bodyPr wrap="square" anchor="t">
+            <a:spAutoFit/>
+          </a:bodyPr>
+          <a:lstStyle/>
+          <a:p>
+            <a:pPr algn="l"/>
+            <a:r>
+              <a:rPr sz="1000" b="0">
+                <a:solidFill>
+                  <a:srgbClr val="D5D8EA"/>
+                </a:solidFill>
+                <a:latin typeface="Arial"/>
+              </a:rPr>
+              <a:t>· RNA therapeutics are well suited to otherwise difficult-to-drug intracellular targets, but progress will require human spatial validation, rigorous target prioritization, reproducible delivery, and pharmacodynamic biomarkers demonstrating restoration of the regenerative follicular niche.</a:t>
+            </a:r>
+          </a:p>
+        </p:txBody>
+      </p:sp>
+    </p:spTree>
+  </p:cSld>
+  <p:clrMapOvr>
+    <a:masterClrMapping/>
+  </p:clrMapOvr>
+</p:sld>
+</file>
+
+<file path=ppt/slides/slide9.xml><?xml version="1.0" encoding="utf-8"?>
+<p:sld xmlns:a="http://schemas.openxmlformats.org/drawingml/2006/main" xmlns:p="http://schemas.openxmlformats.org/presentationml/2006/main" xmlns:r="http://schemas.openxmlformats.org/officeDocument/2006/relationships">
+  <p:cSld>
+    <p:bg>
+      <p:bgPr>
+        <a:solidFill>
+          <a:srgbClr val="12142A"/>
+        </a:solidFill>
+        <a:effectLst/>
+      </p:bgPr>
+    </p:bg>
+    <p:spTree>
+      <p:nvGrpSpPr>
+        <p:cNvPr id="1" name=""/>
+        <p:cNvGrpSpPr/>
+        <p:nvPr/>
+      </p:nvGrpSpPr>
+      <p:grpSpPr/>
+      <p:sp>
+        <p:nvSpPr>
+          <p:cNvPr id="2" name="TextBox 1"/>
+          <p:cNvSpPr txBox="1"/>
+          <p:nvPr/>
+        </p:nvSpPr>
+        <p:spPr>
+          <a:xfrm>
             <a:off x="365760" y="731520"/>
             <a:ext cx="4828032" cy="548640"/>
           </a:xfrm>
@@ -5014,9 +5221,9 @@
                 <a:latin typeface="Arial"/>
               </a:rPr>
               <a:t>[출처]
-논문: Finasteride and depression: the high cost of failed regulation
-게재: Journal of public health (Oxford, England)
-원문: https://pubmed.ncbi.nlm.nih.gov/42878119/
+논문: Targeting fibroimmune remodeling in androgenetic alopecia: emerging opportunities for RNA-based drug discovery
+게재: Expert opinion on drug discovery
+원문: https://pubmed.ncbi.nlm.nih.gov/42885144/
 [이미지 출처]
 - Male pattern baldness.jpg / Originally uploaded by Lkinkade (Transferred by XenonX3) / CC BY-SA 2.5
   https://commons.wikimedia.org/wiki/File:Male_pattern_baldness.jpg

</xml_diff>

<commit_message>
chore: daily content 2026-10-18
</commit_message>
<xml_diff>
--- a/pwa/data/latest/slides.pptx
+++ b/pwa/data/latest/slides.pptx
@@ -13,7 +13,6 @@
     <p:sldId id="261" r:id="rId13"/>
     <p:sldId id="262" r:id="rId14"/>
     <p:sldId id="263" r:id="rId15"/>
-    <p:sldId id="264" r:id="rId16"/>
   </p:sldIdLst>
   <p:sldSz cx="5559552" cy="9875520" type="screen4x3"/>
   <p:notesSz cx="6858000" cy="9144000"/>
@@ -515,7 +514,7 @@
           </a:p>
           <a:p>
             <a:r>
-              <a:t>대본: 남성형 탈모 오늘 나온 최신 연구를 정리했습니다</a:t>
+              <a:t>대본: 100% 이 숫자, 탈모 연구가 새로 내놨습니다</a:t>
             </a:r>
           </a:p>
           <a:p>
@@ -595,7 +594,7 @@
           </a:p>
           <a:p>
             <a:r>
-              <a:t>대본: 《Expert opinion on drug discovery》 - Targeting fibroimmune remodeling in androgenetic alopecia: emerging opportunities for RNA-based drug discovery</a:t>
+              <a:t>대본: 《Current opinion in supportive and palliative care》 - Persistent chemotherapy-induced alopecia: a scoping review</a:t>
             </a:r>
           </a:p>
           <a:p>
@@ -675,7 +674,7 @@
           </a:p>
           <a:p>
             <a:r>
-              <a:t>대본: Introduction: Current treatments for androgenetic alopecia (AGA) primarily suppress androgen signaling or stimulate hair growth.</a:t>
+              <a:t>대본: The most common study type was case reports (12/39, 30.8%).</a:t>
             </a:r>
           </a:p>
           <a:p>
@@ -755,7 +754,7 @@
           </a:p>
           <a:p>
             <a:r>
-              <a:t>대본: Recent single-cell and spatial transcriptomic studies identify fibroimmune remodeling as a potential source of new AGA targets.</a:t>
+              <a:t>대본: Only 2/39 (5.1%) were randomized controlled trials (RCTs).</a:t>
             </a:r>
           </a:p>
           <a:p>
@@ -946,81 +945,6 @@
 </file>
 
 <file path=ppt/notesSlides/notesSlide7.xml><?xml version="1.0" encoding="utf-8"?>
-<p:notes xmlns:a="http://schemas.openxmlformats.org/drawingml/2006/main" xmlns:p="http://schemas.openxmlformats.org/presentationml/2006/main" xmlns:r="http://schemas.openxmlformats.org/officeDocument/2006/relationships">
-  <p:cSld>
-    <p:spTree>
-      <p:nvGrpSpPr>
-        <p:cNvPr id="1" name=""/>
-        <p:cNvGrpSpPr/>
-        <p:nvPr/>
-      </p:nvGrpSpPr>
-      <p:grpSpPr>
-        <a:xfrm>
-          <a:off x="0" y="0"/>
-          <a:ext cx="0" cy="0"/>
-          <a:chOff x="0" y="0"/>
-          <a:chExt cx="0" cy="0"/>
-        </a:xfrm>
-      </p:grpSpPr>
-      <p:sp>
-        <p:nvSpPr>
-          <p:cNvPr id="2" name="Slide Image Placeholder 1"/>
-          <p:cNvSpPr>
-            <a:spLocks noGrp="1"/>
-          </p:cNvSpPr>
-          <p:nvPr>
-            <p:ph type="sldImg" idx="2"/>
-          </p:nvPr>
-        </p:nvSpPr>
-        <p:spPr/>
-      </p:sp>
-      <p:sp>
-        <p:nvSpPr>
-          <p:cNvPr id="3" name="Notes Placeholder 2"/>
-          <p:cNvSpPr>
-            <a:spLocks noGrp="1"/>
-          </p:cNvSpPr>
-          <p:nvPr>
-            <p:ph type="body" idx="3" sz="quarter"/>
-          </p:nvPr>
-        </p:nvSpPr>
-        <p:spPr/>
-        <p:txBody>
-          <a:bodyPr/>
-          <a:lstStyle/>
-          <a:p>
-            <a:r>
-              <a:t>편집 참고용 슬라이드입니다. 영상에는 쓰지 않아도 됩니다.</a:t>
-            </a:r>
-          </a:p>
-          <a:p>
-            <a:r>
-              <a:t>원문 영어 문장을 그대로 발췌했으므로 번역·검수 후 사용하세요.</a:t>
-            </a:r>
-          </a:p>
-        </p:txBody>
-      </p:sp>
-      <p:sp>
-        <p:nvSpPr>
-          <p:cNvPr id="4" name="Slide Number Placeholder 3"/>
-          <p:cNvSpPr>
-            <a:spLocks noGrp="1"/>
-          </p:cNvSpPr>
-          <p:nvPr>
-            <p:ph type="sldNum" idx="5" sz="quarter"/>
-          </p:nvPr>
-        </p:nvSpPr>
-        <p:spPr/>
-      </p:sp>
-    </p:spTree>
-  </p:cSld>
-  <p:clrMapOvr>
-    <a:masterClrMapping/>
-  </p:clrMapOvr>
-</p:notes>
-</file>
-
-<file path=ppt/notesSlides/notesSlide8.xml><?xml version="1.0" encoding="utf-8"?>
 <p:notes xmlns:a="http://schemas.openxmlformats.org/drawingml/2006/main" xmlns:p="http://schemas.openxmlformats.org/presentationml/2006/main" xmlns:r="http://schemas.openxmlformats.org/officeDocument/2006/relationships">
   <p:cSld>
     <p:spTree>
@@ -4114,7 +4038,7 @@
                 </a:solidFill>
                 <a:latin typeface="Arial"/>
               </a:rPr>
-              <a:t>EXPERT OPINION ON DRUG DISCOVERY</a:t>
+              <a:t>CURRENT OPINION IN SUPPORTIVE AND PALLIA</a:t>
             </a:r>
           </a:p>
         </p:txBody>
@@ -4149,7 +4073,7 @@
                 </a:solidFill>
                 <a:latin typeface="Arial"/>
               </a:rPr>
-              <a:t>남성형 탈모</a:t>
+              <a:t>100%</a:t>
             </a:r>
           </a:p>
         </p:txBody>
@@ -4184,7 +4108,7 @@
                 </a:solidFill>
                 <a:latin typeface="Arial"/>
               </a:rPr>
-              <a:t>오늘 나온 최신 연구를 정리했습니다</a:t>
+              <a:t>이 숫자, 탈모 연구가 새로 내놨습니다</a:t>
             </a:r>
           </a:p>
         </p:txBody>
@@ -4219,7 +4143,7 @@
                 </a:solidFill>
                 <a:latin typeface="Arial"/>
               </a:rPr>
-              <a:t>2026 Oct 15  |  매일 아침 탈모 연구 한 편</a:t>
+              <a:t>2026 Oct 16  |  매일 아침 탈모 연구 한 편</a:t>
             </a:r>
           </a:p>
         </p:txBody>
@@ -4304,7 +4228,7 @@
                 </a:solidFill>
                 <a:latin typeface="Arial"/>
               </a:rPr>
-              <a:t>Targeting fibroimmune remodeling in androgenetic alopecia: emerging opportunities for RNA-based drug discovery</a:t>
+              <a:t>Persistent chemotherapy-induced alopecia: a scoping review</a:t>
             </a:r>
           </a:p>
         </p:txBody>
@@ -4339,7 +4263,7 @@
                 </a:solidFill>
                 <a:latin typeface="Arial"/>
               </a:rPr>
-              <a:t>Expert opinion on drug discovery  ·  2026 Oct 15</a:t>
+              <a:t>Current opinion in supportive and palliative care  ·  2026 Oct 16</a:t>
             </a:r>
           </a:p>
         </p:txBody>
@@ -4468,7 +4392,7 @@
                 </a:solidFill>
                 <a:latin typeface="Arial"/>
               </a:rPr>
-              <a:t>Introduction: Current treatments for androgenetic alopecia (AGA) primarily suppress androgen signaling or stimulate hair growth.</a:t>
+              <a:t>The most common study type was case reports (12/39, 30.8%).</a:t>
             </a:r>
           </a:p>
         </p:txBody>
@@ -4597,7 +4521,7 @@
                 </a:solidFill>
                 <a:latin typeface="Arial"/>
               </a:rPr>
-              <a:t>Recent single-cell and spatial transcriptomic studies identify fibroimmune remodeling as a potential source of new AGA targets.</a:t>
+              <a:t>Only 2/39 (5.1%) were randomized controlled trials (RCTs).</a:t>
             </a:r>
           </a:p>
         </p:txBody>
@@ -4883,7 +4807,7 @@
                 </a:solidFill>
                 <a:latin typeface="Arial"/>
               </a:rPr>
-              <a:t>◆ 배경 — Background (자동 구분)</a:t>
+              <a:t>◆ 그 밖의 내용 — Purpose Of Review</a:t>
             </a:r>
           </a:p>
         </p:txBody>
@@ -4918,8 +4842,8 @@
                 </a:solidFill>
                 <a:latin typeface="Arial"/>
               </a:rPr>
-              <a:t>· Introduction: Current treatments for androgenetic alopecia (AGA) primarily suppress androgen signaling or stimulate hair growth.
-· Recent single-cell and spatial transcriptomic studies identify fibroimmune remodeling as a potential source of new AGA targets.</a:t>
+              <a:t>· Persistent chemotherapy-induced alopecia (pCIA) is defined as incomplete hair growth ≥6 months after chemotherapy completion.
+· This scoping review aimed to identify gaps for future research by mapping pCIA's incidence, risk factors, quality-of-life (QoL) impacts, presentation, prevention, and management.</a:t>
             </a:r>
           </a:p>
         </p:txBody>
@@ -4954,7 +4878,7 @@
                 </a:solidFill>
                 <a:latin typeface="Arial"/>
               </a:rPr>
-              <a:t>◆ 주요 결과 — Results (자동 구분)</a:t>
+              <a:t>◆ 주요 결과 — Findings</a:t>
             </a:r>
           </a:p>
         </p:txBody>
@@ -4989,11 +4913,12 @@
                 </a:solidFill>
                 <a:latin typeface="Arial"/>
               </a:rPr>
-              <a:t>· Areas covered: This review integrates transcriptomic and mechanistic evidence linking androgen-responsive fibroblasts, immune-cell recruitment, and extracellular matrix remodeling, in male and female pattern hair loss.
-· Herein, the authors assessed published human scalp, cell and animal studies of JAK/STAT, TGF-β, CXCL12-CXCR4/ACKR3, and DKK3-CKAP4, and evaluated RNA therapeutic modalities and delivery barriers.
-· Literature was identified primarily through PubMed in the last 20 years.
-· Expert opinion: Fibroimmune remodeling should be viewed as a complementary, rather than alternative, framework to androgen biology.
-· The most promising drug discovery strategy is to identify molecularly defined patient subsets and locally inhibit nodal mediators that couple fibroblast activation to inflammation and matrix remodeling.</a:t>
+              <a:t>· Thirty-nine articles were included.
+· The most common study type was case reports (12/39, 30.8%).
+· Only 2/39 (5.1%) were randomized controlled trials (RCTs).
+· Most studies (27/39, 69.2%) reported pCIA in patients with breast cancer.
+· Alkylating agents, taxanes, and anthracyclines were most frequently reported to be associated with pCIA.
+· All six studies that evaluated QoL reported that pCIA negatively affected patients' psychological, functional, and social well-being.</a:t>
             </a:r>
           </a:p>
         </p:txBody>
@@ -5032,137 +4957,6 @@
         </p:nvSpPr>
         <p:spPr>
           <a:xfrm>
-            <a:off x="365760" y="457200"/>
-            <a:ext cx="4828032" cy="457200"/>
-          </a:xfrm>
-          <a:prstGeom prst="rect">
-            <a:avLst/>
-          </a:prstGeom>
-          <a:noFill/>
-        </p:spPr>
-        <p:txBody>
-          <a:bodyPr wrap="square" anchor="ctr">
-            <a:spAutoFit/>
-          </a:bodyPr>
-          <a:lstStyle/>
-          <a:p>
-            <a:pPr algn="l"/>
-            <a:r>
-              <a:rPr sz="1600" b="1">
-                <a:solidFill>
-                  <a:srgbClr val="FF6B6B"/>
-                </a:solidFill>
-                <a:latin typeface="Arial"/>
-              </a:rPr>
-              <a:t>본문 요약 (편집용)</a:t>
-            </a:r>
-          </a:p>
-        </p:txBody>
-      </p:sp>
-      <p:sp>
-        <p:nvSpPr>
-          <p:cNvPr id="3" name="TextBox 2"/>
-          <p:cNvSpPr txBox="1"/>
-          <p:nvPr/>
-        </p:nvSpPr>
-        <p:spPr>
-          <a:xfrm>
-            <a:off x="365760" y="1097280"/>
-            <a:ext cx="4828032" cy="457200"/>
-          </a:xfrm>
-          <a:prstGeom prst="rect">
-            <a:avLst/>
-          </a:prstGeom>
-          <a:noFill/>
-        </p:spPr>
-        <p:txBody>
-          <a:bodyPr wrap="square" anchor="t">
-            <a:spAutoFit/>
-          </a:bodyPr>
-          <a:lstStyle/>
-          <a:p>
-            <a:pPr algn="l"/>
-            <a:r>
-              <a:rPr sz="1300" b="1">
-                <a:solidFill>
-                  <a:srgbClr val="FFFFFF"/>
-                </a:solidFill>
-                <a:latin typeface="Arial"/>
-              </a:rPr>
-              <a:t>◆ 결론 — Conclusion (자동 구분)</a:t>
-            </a:r>
-          </a:p>
-        </p:txBody>
-      </p:sp>
-      <p:sp>
-        <p:nvSpPr>
-          <p:cNvPr id="4" name="TextBox 3"/>
-          <p:cNvSpPr txBox="1"/>
-          <p:nvPr/>
-        </p:nvSpPr>
-        <p:spPr>
-          <a:xfrm>
-            <a:off x="457200" y="1600200"/>
-            <a:ext cx="4736592" cy="3566160"/>
-          </a:xfrm>
-          <a:prstGeom prst="rect">
-            <a:avLst/>
-          </a:prstGeom>
-          <a:noFill/>
-        </p:spPr>
-        <p:txBody>
-          <a:bodyPr wrap="square" anchor="t">
-            <a:spAutoFit/>
-          </a:bodyPr>
-          <a:lstStyle/>
-          <a:p>
-            <a:pPr algn="l"/>
-            <a:r>
-              <a:rPr sz="1000" b="0">
-                <a:solidFill>
-                  <a:srgbClr val="D5D8EA"/>
-                </a:solidFill>
-                <a:latin typeface="Arial"/>
-              </a:rPr>
-              <a:t>· RNA therapeutics are well suited to otherwise difficult-to-drug intracellular targets, but progress will require human spatial validation, rigorous target prioritization, reproducible delivery, and pharmacodynamic biomarkers demonstrating restoration of the regenerative follicular niche.</a:t>
-            </a:r>
-          </a:p>
-        </p:txBody>
-      </p:sp>
-    </p:spTree>
-  </p:cSld>
-  <p:clrMapOvr>
-    <a:masterClrMapping/>
-  </p:clrMapOvr>
-</p:sld>
-</file>
-
-<file path=ppt/slides/slide9.xml><?xml version="1.0" encoding="utf-8"?>
-<p:sld xmlns:a="http://schemas.openxmlformats.org/drawingml/2006/main" xmlns:p="http://schemas.openxmlformats.org/presentationml/2006/main" xmlns:r="http://schemas.openxmlformats.org/officeDocument/2006/relationships">
-  <p:cSld>
-    <p:bg>
-      <p:bgPr>
-        <a:solidFill>
-          <a:srgbClr val="12142A"/>
-        </a:solidFill>
-        <a:effectLst/>
-      </p:bgPr>
-    </p:bg>
-    <p:spTree>
-      <p:nvGrpSpPr>
-        <p:cNvPr id="1" name=""/>
-        <p:cNvGrpSpPr/>
-        <p:nvPr/>
-      </p:nvGrpSpPr>
-      <p:grpSpPr/>
-      <p:sp>
-        <p:nvSpPr>
-          <p:cNvPr id="2" name="TextBox 1"/>
-          <p:cNvSpPr txBox="1"/>
-          <p:nvPr/>
-        </p:nvSpPr>
-        <p:spPr>
-          <a:xfrm>
             <a:off x="365760" y="731520"/>
             <a:ext cx="4828032" cy="548640"/>
           </a:xfrm>
@@ -5221,9 +5015,9 @@
                 <a:latin typeface="Arial"/>
               </a:rPr>
               <a:t>[출처]
-논문: Targeting fibroimmune remodeling in androgenetic alopecia: emerging opportunities for RNA-based drug discovery
-게재: Expert opinion on drug discovery
-원문: https://pubmed.ncbi.nlm.nih.gov/42885144/
+논문: Persistent chemotherapy-induced alopecia: a scoping review
+게재: Current opinion in supportive and palliative care
+원문: https://pubmed.ncbi.nlm.nih.gov/42888908/
 [이미지 출처]
 - Male pattern baldness.jpg / Originally uploaded by Lkinkade (Transferred by XenonX3) / CC BY-SA 2.5
   https://commons.wikimedia.org/wiki/File:Male_pattern_baldness.jpg

</xml_diff>

<commit_message>
chore: daily content 2026-10-19
</commit_message>
<xml_diff>
--- a/pwa/data/latest/slides.pptx
+++ b/pwa/data/latest/slides.pptx
@@ -13,6 +13,7 @@
     <p:sldId id="261" r:id="rId13"/>
     <p:sldId id="262" r:id="rId14"/>
     <p:sldId id="263" r:id="rId15"/>
+    <p:sldId id="264" r:id="rId16"/>
   </p:sldIdLst>
   <p:sldSz cx="5559552" cy="9875520" type="screen4x3"/>
   <p:notesSz cx="6858000" cy="9144000"/>
@@ -514,7 +515,7 @@
           </a:p>
           <a:p>
             <a:r>
-              <a:t>대본: 100% 이 숫자, 탈모 연구가 새로 내놨습니다</a:t>
+              <a:t>대본: 남성형 탈모 오늘 나온 최신 연구를 정리했습니다</a:t>
             </a:r>
           </a:p>
           <a:p>
@@ -594,7 +595,7 @@
           </a:p>
           <a:p>
             <a:r>
-              <a:t>대본: 《Current opinion in supportive and palliative care》 - Persistent chemotherapy-induced alopecia: a scoping review</a:t>
+              <a:t>대본: 《Colloids and surfaces. B, Biointerfaces》 - Transdermal L-arginine and hyaluronic acid delivery to treat androgenetic alopecia through dual hormone modulation and anti-inflammatory action</a:t>
             </a:r>
           </a:p>
           <a:p>
@@ -674,7 +675,7 @@
           </a:p>
           <a:p>
             <a:r>
-              <a:t>대본: The most common study type was case reports (12/39, 30.8%).</a:t>
+              <a:t>대본: Androgenetic alopecia (AGA) is a common hair loss disorder caused by genetic susceptibility and androgen-driven follicular miniaturization.</a:t>
             </a:r>
           </a:p>
           <a:p>
@@ -754,7 +755,7 @@
           </a:p>
           <a:p>
             <a:r>
-              <a:t>대본: Only 2/39 (5.1%) were randomized controlled trials (RCTs).</a:t>
+              <a:t>대본: Current FDA-approved therapies, including finasteride and minoxidil, are limited by adverse effects.</a:t>
             </a:r>
           </a:p>
           <a:p>
@@ -945,6 +946,81 @@
 </file>
 
 <file path=ppt/notesSlides/notesSlide7.xml><?xml version="1.0" encoding="utf-8"?>
+<p:notes xmlns:a="http://schemas.openxmlformats.org/drawingml/2006/main" xmlns:p="http://schemas.openxmlformats.org/presentationml/2006/main" xmlns:r="http://schemas.openxmlformats.org/officeDocument/2006/relationships">
+  <p:cSld>
+    <p:spTree>
+      <p:nvGrpSpPr>
+        <p:cNvPr id="1" name=""/>
+        <p:cNvGrpSpPr/>
+        <p:nvPr/>
+      </p:nvGrpSpPr>
+      <p:grpSpPr>
+        <a:xfrm>
+          <a:off x="0" y="0"/>
+          <a:ext cx="0" cy="0"/>
+          <a:chOff x="0" y="0"/>
+          <a:chExt cx="0" cy="0"/>
+        </a:xfrm>
+      </p:grpSpPr>
+      <p:sp>
+        <p:nvSpPr>
+          <p:cNvPr id="2" name="Slide Image Placeholder 1"/>
+          <p:cNvSpPr>
+            <a:spLocks noGrp="1"/>
+          </p:cNvSpPr>
+          <p:nvPr>
+            <p:ph type="sldImg" idx="2"/>
+          </p:nvPr>
+        </p:nvSpPr>
+        <p:spPr/>
+      </p:sp>
+      <p:sp>
+        <p:nvSpPr>
+          <p:cNvPr id="3" name="Notes Placeholder 2"/>
+          <p:cNvSpPr>
+            <a:spLocks noGrp="1"/>
+          </p:cNvSpPr>
+          <p:nvPr>
+            <p:ph type="body" idx="3" sz="quarter"/>
+          </p:nvPr>
+        </p:nvSpPr>
+        <p:spPr/>
+        <p:txBody>
+          <a:bodyPr/>
+          <a:lstStyle/>
+          <a:p>
+            <a:r>
+              <a:t>편집 참고용 슬라이드입니다. 영상에는 쓰지 않아도 됩니다.</a:t>
+            </a:r>
+          </a:p>
+          <a:p>
+            <a:r>
+              <a:t>원문 영어 문장을 그대로 발췌했으므로 번역·검수 후 사용하세요.</a:t>
+            </a:r>
+          </a:p>
+        </p:txBody>
+      </p:sp>
+      <p:sp>
+        <p:nvSpPr>
+          <p:cNvPr id="4" name="Slide Number Placeholder 3"/>
+          <p:cNvSpPr>
+            <a:spLocks noGrp="1"/>
+          </p:cNvSpPr>
+          <p:nvPr>
+            <p:ph type="sldNum" idx="5" sz="quarter"/>
+          </p:nvPr>
+        </p:nvSpPr>
+        <p:spPr/>
+      </p:sp>
+    </p:spTree>
+  </p:cSld>
+  <p:clrMapOvr>
+    <a:masterClrMapping/>
+  </p:clrMapOvr>
+</p:notes>
+</file>
+
+<file path=ppt/notesSlides/notesSlide8.xml><?xml version="1.0" encoding="utf-8"?>
 <p:notes xmlns:a="http://schemas.openxmlformats.org/drawingml/2006/main" xmlns:p="http://schemas.openxmlformats.org/presentationml/2006/main" xmlns:r="http://schemas.openxmlformats.org/officeDocument/2006/relationships">
   <p:cSld>
     <p:spTree>
@@ -4038,7 +4114,7 @@
                 </a:solidFill>
                 <a:latin typeface="Arial"/>
               </a:rPr>
-              <a:t>CURRENT OPINION IN SUPPORTIVE AND PALLIA</a:t>
+              <a:t>COLLOIDS AND SURFACES. B, BIOINTERFACES</a:t>
             </a:r>
           </a:p>
         </p:txBody>
@@ -4073,7 +4149,7 @@
                 </a:solidFill>
                 <a:latin typeface="Arial"/>
               </a:rPr>
-              <a:t>100%</a:t>
+              <a:t>남성형 탈모</a:t>
             </a:r>
           </a:p>
         </p:txBody>
@@ -4108,7 +4184,7 @@
                 </a:solidFill>
                 <a:latin typeface="Arial"/>
               </a:rPr>
-              <a:t>이 숫자, 탈모 연구가 새로 내놨습니다</a:t>
+              <a:t>오늘 나온 최신 연구를 정리했습니다</a:t>
             </a:r>
           </a:p>
         </p:txBody>
@@ -4143,7 +4219,7 @@
                 </a:solidFill>
                 <a:latin typeface="Arial"/>
               </a:rPr>
-              <a:t>2026 Oct 16  |  매일 아침 탈모 연구 한 편</a:t>
+              <a:t>2026 Oct 15  |  매일 아침 탈모 연구 한 편</a:t>
             </a:r>
           </a:p>
         </p:txBody>
@@ -4228,7 +4304,7 @@
                 </a:solidFill>
                 <a:latin typeface="Arial"/>
               </a:rPr>
-              <a:t>Persistent chemotherapy-induced alopecia: a scoping review</a:t>
+              <a:t>Transdermal L-arginine and hyaluronic acid delivery to treat androgenetic alopecia through dual hormone modulation and anti-inflammatory action</a:t>
             </a:r>
           </a:p>
         </p:txBody>
@@ -4263,7 +4339,7 @@
                 </a:solidFill>
                 <a:latin typeface="Arial"/>
               </a:rPr>
-              <a:t>Current opinion in supportive and palliative care  ·  2026 Oct 16</a:t>
+              <a:t>Colloids and surfaces. B, Biointerfaces  ·  2026 Oct 15</a:t>
             </a:r>
           </a:p>
         </p:txBody>
@@ -4392,7 +4468,7 @@
                 </a:solidFill>
                 <a:latin typeface="Arial"/>
               </a:rPr>
-              <a:t>The most common study type was case reports (12/39, 30.8%).</a:t>
+              <a:t>Androgenetic alopecia (AGA) is a common hair loss disorder caused by genetic susceptibility and androgen-driven follicular miniaturization.</a:t>
             </a:r>
           </a:p>
         </p:txBody>
@@ -4521,7 +4597,7 @@
                 </a:solidFill>
                 <a:latin typeface="Arial"/>
               </a:rPr>
-              <a:t>Only 2/39 (5.1%) were randomized controlled trials (RCTs).</a:t>
+              <a:t>Current FDA-approved therapies, including finasteride and minoxidil, are limited by adverse effects.</a:t>
             </a:r>
           </a:p>
         </p:txBody>
@@ -4807,7 +4883,7 @@
                 </a:solidFill>
                 <a:latin typeface="Arial"/>
               </a:rPr>
-              <a:t>◆ 그 밖의 내용 — Purpose Of Review</a:t>
+              <a:t>◆ 배경 — Background (자동 구분)</a:t>
             </a:r>
           </a:p>
         </p:txBody>
@@ -4842,8 +4918,8 @@
                 </a:solidFill>
                 <a:latin typeface="Arial"/>
               </a:rPr>
-              <a:t>· Persistent chemotherapy-induced alopecia (pCIA) is defined as incomplete hair growth ≥6 months after chemotherapy completion.
-· This scoping review aimed to identify gaps for future research by mapping pCIA's incidence, risk factors, quality-of-life (QoL) impacts, presentation, prevention, and management.</a:t>
+              <a:t>· Androgenetic alopecia (AGA) is a common hair loss disorder caused by genetic susceptibility and androgen-driven follicular miniaturization.
+· Current FDA-approved therapies, including finasteride and minoxidil, are limited by adverse effects.</a:t>
             </a:r>
           </a:p>
         </p:txBody>
@@ -4878,7 +4954,7 @@
                 </a:solidFill>
                 <a:latin typeface="Arial"/>
               </a:rPr>
-              <a:t>◆ 주요 결과 — Findings</a:t>
+              <a:t>◆ 연구 방법 — Methods (자동 구분)</a:t>
             </a:r>
           </a:p>
         </p:txBody>
@@ -4913,12 +4989,7 @@
                 </a:solidFill>
                 <a:latin typeface="Arial"/>
               </a:rPr>
-              <a:t>· Thirty-nine articles were included.
-· The most common study type was case reports (12/39, 30.8%).
-· Only 2/39 (5.1%) were randomized controlled trials (RCTs).
-· Most studies (27/39, 69.2%) reported pCIA in patients with breast cancer.
-· Alkylating agents, taxanes, and anthracyclines were most frequently reported to be associated with pCIA.
-· All six studies that evaluated QoL reported that pCIA negatively affected patients' psychological, functional, and social well-being.</a:t>
+              <a:t>· Here, we developed a hyaluronic acid-based liposomal transdermal delivery system loaded with L-arginine (HL@L-Arg) to enhance cutaneous delivery and promote endogenous nitric oxide (NO) production through nitric oxide synthase.</a:t>
             </a:r>
           </a:p>
         </p:txBody>
@@ -4957,6 +5028,209 @@
         </p:nvSpPr>
         <p:spPr>
           <a:xfrm>
+            <a:off x="365760" y="457200"/>
+            <a:ext cx="4828032" cy="457200"/>
+          </a:xfrm>
+          <a:prstGeom prst="rect">
+            <a:avLst/>
+          </a:prstGeom>
+          <a:noFill/>
+        </p:spPr>
+        <p:txBody>
+          <a:bodyPr wrap="square" anchor="ctr">
+            <a:spAutoFit/>
+          </a:bodyPr>
+          <a:lstStyle/>
+          <a:p>
+            <a:pPr algn="l"/>
+            <a:r>
+              <a:rPr sz="1600" b="1">
+                <a:solidFill>
+                  <a:srgbClr val="FF6B6B"/>
+                </a:solidFill>
+                <a:latin typeface="Arial"/>
+              </a:rPr>
+              <a:t>본문 요약 (편집용)</a:t>
+            </a:r>
+          </a:p>
+        </p:txBody>
+      </p:sp>
+      <p:sp>
+        <p:nvSpPr>
+          <p:cNvPr id="3" name="TextBox 2"/>
+          <p:cNvSpPr txBox="1"/>
+          <p:nvPr/>
+        </p:nvSpPr>
+        <p:spPr>
+          <a:xfrm>
+            <a:off x="365760" y="1097280"/>
+            <a:ext cx="4828032" cy="457200"/>
+          </a:xfrm>
+          <a:prstGeom prst="rect">
+            <a:avLst/>
+          </a:prstGeom>
+          <a:noFill/>
+        </p:spPr>
+        <p:txBody>
+          <a:bodyPr wrap="square" anchor="t">
+            <a:spAutoFit/>
+          </a:bodyPr>
+          <a:lstStyle/>
+          <a:p>
+            <a:pPr algn="l"/>
+            <a:r>
+              <a:rPr sz="1300" b="1">
+                <a:solidFill>
+                  <a:srgbClr val="FFFFFF"/>
+                </a:solidFill>
+                <a:latin typeface="Arial"/>
+              </a:rPr>
+              <a:t>◆ 주요 결과 — Results (자동 구분)</a:t>
+            </a:r>
+          </a:p>
+        </p:txBody>
+      </p:sp>
+      <p:sp>
+        <p:nvSpPr>
+          <p:cNvPr id="4" name="TextBox 3"/>
+          <p:cNvSpPr txBox="1"/>
+          <p:nvPr/>
+        </p:nvSpPr>
+        <p:spPr>
+          <a:xfrm>
+            <a:off x="457200" y="1600200"/>
+            <a:ext cx="4736592" cy="3566160"/>
+          </a:xfrm>
+          <a:prstGeom prst="rect">
+            <a:avLst/>
+          </a:prstGeom>
+          <a:noFill/>
+        </p:spPr>
+        <p:txBody>
+          <a:bodyPr wrap="square" anchor="t">
+            <a:spAutoFit/>
+          </a:bodyPr>
+          <a:lstStyle/>
+          <a:p>
+            <a:pPr algn="l"/>
+            <a:r>
+              <a:rPr sz="1000" b="0">
+                <a:solidFill>
+                  <a:srgbClr val="D5D8EA"/>
+                </a:solidFill>
+                <a:latin typeface="Arial"/>
+              </a:rPr>
+              <a:t>· Transcriptomic analysis indicated significant changes in pathways related to inflammatory responses, Wnt signaling, and steroid hormone biosynthesis.
+· Mechanistically, HL@L-Arg inhibited 5α-reductase activity and reduced dihydrotestosterone (DHT) production while promoting endogenous NO generation.
+· In an AGA mouse model, HL@L-Arg reduced TNF-α, IL-6, and androgen receptor (AR) expression, increased VEGF and Ki67 levels, and markedly promoted hair regeneration.</a:t>
+            </a:r>
+          </a:p>
+        </p:txBody>
+      </p:sp>
+      <p:sp>
+        <p:nvSpPr>
+          <p:cNvPr id="5" name="TextBox 4"/>
+          <p:cNvSpPr txBox="1"/>
+          <p:nvPr/>
+        </p:nvSpPr>
+        <p:spPr>
+          <a:xfrm>
+            <a:off x="365760" y="5303520"/>
+            <a:ext cx="4828032" cy="457200"/>
+          </a:xfrm>
+          <a:prstGeom prst="rect">
+            <a:avLst/>
+          </a:prstGeom>
+          <a:noFill/>
+        </p:spPr>
+        <p:txBody>
+          <a:bodyPr wrap="square" anchor="t">
+            <a:spAutoFit/>
+          </a:bodyPr>
+          <a:lstStyle/>
+          <a:p>
+            <a:pPr algn="l"/>
+            <a:r>
+              <a:rPr sz="1300" b="1">
+                <a:solidFill>
+                  <a:srgbClr val="FFFFFF"/>
+                </a:solidFill>
+                <a:latin typeface="Arial"/>
+              </a:rPr>
+              <a:t>◆ 결론 — Conclusion (자동 구분)</a:t>
+            </a:r>
+          </a:p>
+        </p:txBody>
+      </p:sp>
+      <p:sp>
+        <p:nvSpPr>
+          <p:cNvPr id="6" name="TextBox 5"/>
+          <p:cNvSpPr txBox="1"/>
+          <p:nvPr/>
+        </p:nvSpPr>
+        <p:spPr>
+          <a:xfrm>
+            <a:off x="457200" y="5806440"/>
+            <a:ext cx="4736592" cy="3566160"/>
+          </a:xfrm>
+          <a:prstGeom prst="rect">
+            <a:avLst/>
+          </a:prstGeom>
+          <a:noFill/>
+        </p:spPr>
+        <p:txBody>
+          <a:bodyPr wrap="square" anchor="t">
+            <a:spAutoFit/>
+          </a:bodyPr>
+          <a:lstStyle/>
+          <a:p>
+            <a:pPr algn="l"/>
+            <a:r>
+              <a:rPr sz="1000" b="0">
+                <a:solidFill>
+                  <a:srgbClr val="D5D8EA"/>
+                </a:solidFill>
+                <a:latin typeface="Arial"/>
+              </a:rPr>
+              <a:t>· Collectively, transdermal L-Arg delivery represents a promising endogenous NO-based therapeutic strategy for AGA through DHT suppression, regulation of the follicular microenvironment, and anti-inflammatory activity.</a:t>
+            </a:r>
+          </a:p>
+        </p:txBody>
+      </p:sp>
+    </p:spTree>
+  </p:cSld>
+  <p:clrMapOvr>
+    <a:masterClrMapping/>
+  </p:clrMapOvr>
+</p:sld>
+</file>
+
+<file path=ppt/slides/slide9.xml><?xml version="1.0" encoding="utf-8"?>
+<p:sld xmlns:a="http://schemas.openxmlformats.org/drawingml/2006/main" xmlns:p="http://schemas.openxmlformats.org/presentationml/2006/main" xmlns:r="http://schemas.openxmlformats.org/officeDocument/2006/relationships">
+  <p:cSld>
+    <p:bg>
+      <p:bgPr>
+        <a:solidFill>
+          <a:srgbClr val="12142A"/>
+        </a:solidFill>
+        <a:effectLst/>
+      </p:bgPr>
+    </p:bg>
+    <p:spTree>
+      <p:nvGrpSpPr>
+        <p:cNvPr id="1" name=""/>
+        <p:cNvGrpSpPr/>
+        <p:nvPr/>
+      </p:nvGrpSpPr>
+      <p:grpSpPr/>
+      <p:sp>
+        <p:nvSpPr>
+          <p:cNvPr id="2" name="TextBox 1"/>
+          <p:cNvSpPr txBox="1"/>
+          <p:nvPr/>
+        </p:nvSpPr>
+        <p:spPr>
+          <a:xfrm>
             <a:off x="365760" y="731520"/>
             <a:ext cx="4828032" cy="548640"/>
           </a:xfrm>
@@ -5015,9 +5289,9 @@
                 <a:latin typeface="Arial"/>
               </a:rPr>
               <a:t>[출처]
-논문: Persistent chemotherapy-induced alopecia: a scoping review
-게재: Current opinion in supportive and palliative care
-원문: https://pubmed.ncbi.nlm.nih.gov/42888908/
+논문: Transdermal L-arginine and hyaluronic acid delivery to treat androgenetic alopecia through dual hormone modulation and anti-inflammatory action
+게재: Colloids and surfaces. B, Biointerfaces
+원문: https://pubmed.ncbi.nlm.nih.gov/42892175/
 [이미지 출처]
 - Male pattern baldness.jpg / Originally uploaded by Lkinkade (Transferred by XenonX3) / CC BY-SA 2.5
   https://commons.wikimedia.org/wiki/File:Male_pattern_baldness.jpg

</xml_diff>

<commit_message>
chore: daily content 2026-10-20
</commit_message>
<xml_diff>
--- a/pwa/data/latest/slides.pptx
+++ b/pwa/data/latest/slides.pptx
@@ -515,7 +515,7 @@
           </a:p>
           <a:p>
             <a:r>
-              <a:t>대본: 남성형 탈모 오늘 나온 최신 연구를 정리했습니다</a:t>
+              <a:t>대본: 97% 이 숫자, 탈모 연구가 새로 내놨습니다</a:t>
             </a:r>
           </a:p>
           <a:p>
@@ -595,7 +595,7 @@
           </a:p>
           <a:p>
             <a:r>
-              <a:t>대본: 《Colloids and surfaces. B, Biointerfaces》 - Transdermal L-arginine and hyaluronic acid delivery to treat androgenetic alopecia through dual hormone modulation and anti-inflammatory action</a:t>
+              <a:t>대본: 《Supportive care in cancer : official journal of the Multinational Association of Supportive Care in Cancer》 - Comparative efficacy of interventions for preventing chemotherapy-induced alopecia: a systematic review and network meta-analysis</a:t>
             </a:r>
           </a:p>
           <a:p>
@@ -675,7 +675,7 @@
           </a:p>
           <a:p>
             <a:r>
-              <a:t>대본: Androgenetic alopecia (AGA) is a common hair loss disorder caused by genetic susceptibility and androgen-driven follicular miniaturization.</a:t>
+              <a:t>대본: Randomized controlled trials evaluating interventions to prevent CIA in cancer patients and reporting hair preservation outcomes (as defined by individual trials, including CTCAE grade &lt; 2, &lt; 30 to &lt; 50% hair loss, or WHO grade 0-2) were included.</a:t>
             </a:r>
           </a:p>
           <a:p>
@@ -755,7 +755,7 @@
           </a:p>
           <a:p>
             <a:r>
-              <a:t>대본: Current FDA-approved therapies, including finasteride and minoxidil, are limited by adverse effects.</a:t>
+              <a:t>대본: Scalp hypothermia was divided into three groups based on duration post-chemotherapy: short (0-45 min), traditional (46-90 min), and prolonged (&gt; 90 min).</a:t>
             </a:r>
           </a:p>
           <a:p>
@@ -4114,7 +4114,7 @@
                 </a:solidFill>
                 <a:latin typeface="Arial"/>
               </a:rPr>
-              <a:t>COLLOIDS AND SURFACES. B, BIOINTERFACES</a:t>
+              <a:t>SUPPORTIVE CARE IN CANCER : OFFICIAL JOU</a:t>
             </a:r>
           </a:p>
         </p:txBody>
@@ -4149,7 +4149,7 @@
                 </a:solidFill>
                 <a:latin typeface="Arial"/>
               </a:rPr>
-              <a:t>남성형 탈모</a:t>
+              <a:t>97%</a:t>
             </a:r>
           </a:p>
         </p:txBody>
@@ -4184,7 +4184,7 @@
                 </a:solidFill>
                 <a:latin typeface="Arial"/>
               </a:rPr>
-              <a:t>오늘 나온 최신 연구를 정리했습니다</a:t>
+              <a:t>이 숫자, 탈모 연구가 새로 내놨습니다</a:t>
             </a:r>
           </a:p>
         </p:txBody>
@@ -4219,7 +4219,7 @@
                 </a:solidFill>
                 <a:latin typeface="Arial"/>
               </a:rPr>
-              <a:t>2026 Oct 15  |  매일 아침 탈모 연구 한 편</a:t>
+              <a:t>2026 Oct 19  |  매일 아침 탈모 연구 한 편</a:t>
             </a:r>
           </a:p>
         </p:txBody>
@@ -4304,7 +4304,7 @@
                 </a:solidFill>
                 <a:latin typeface="Arial"/>
               </a:rPr>
-              <a:t>Transdermal L-arginine and hyaluronic acid delivery to treat androgenetic alopecia through dual hormone modulation and anti-inflammatory action</a:t>
+              <a:t>Comparative efficacy of interventions for preventing chemotherapy-induced alopecia: a systematic review and network meta-analysis</a:t>
             </a:r>
           </a:p>
         </p:txBody>
@@ -4339,7 +4339,7 @@
                 </a:solidFill>
                 <a:latin typeface="Arial"/>
               </a:rPr>
-              <a:t>Colloids and surfaces. B, Biointerfaces  ·  2026 Oct 15</a:t>
+              <a:t>Supportive care in cancer : official journal of the Multinational Association of Supportive Care in Cancer  ·  2026 Oct 19</a:t>
             </a:r>
           </a:p>
         </p:txBody>
@@ -4468,7 +4468,7 @@
                 </a:solidFill>
                 <a:latin typeface="Arial"/>
               </a:rPr>
-              <a:t>Androgenetic alopecia (AGA) is a common hair loss disorder caused by genetic susceptibility and androgen-driven follicular miniaturization.</a:t>
+              <a:t>Randomized controlled trials evaluating interventions to prevent CIA in cancer patients and reporting hair preservation outcomes (as defined by individual trials, including CTCAE grade &lt; 2, &lt; 30 to &lt; 50% hair loss, or WHO grade 0-2) were included.</a:t>
             </a:r>
           </a:p>
         </p:txBody>
@@ -4597,7 +4597,7 @@
                 </a:solidFill>
                 <a:latin typeface="Arial"/>
               </a:rPr>
-              <a:t>Current FDA-approved therapies, including finasteride and minoxidil, are limited by adverse effects.</a:t>
+              <a:t>Scalp hypothermia was divided into three groups based on duration post-chemotherapy: short (0-45 min), traditional (46-90 min), and prolonged (&gt; 90 min).</a:t>
             </a:r>
           </a:p>
         </p:txBody>
@@ -4883,7 +4883,7 @@
                 </a:solidFill>
                 <a:latin typeface="Arial"/>
               </a:rPr>
-              <a:t>◆ 배경 — Background (자동 구분)</a:t>
+              <a:t>◆ 배경 — Purpose</a:t>
             </a:r>
           </a:p>
         </p:txBody>
@@ -4918,8 +4918,8 @@
                 </a:solidFill>
                 <a:latin typeface="Arial"/>
               </a:rPr>
-              <a:t>· Androgenetic alopecia (AGA) is a common hair loss disorder caused by genetic susceptibility and androgen-driven follicular miniaturization.
-· Current FDA-approved therapies, including finasteride and minoxidil, are limited by adverse effects.</a:t>
+              <a:t>· Chemotherapy-induced alopecia (CIA) negatively affects patients' appearance and emotional well-being.
+· This network meta-analysis aimed to compare the efficacy of different preventive interventions for CIA.</a:t>
             </a:r>
           </a:p>
         </p:txBody>
@@ -4954,7 +4954,7 @@
                 </a:solidFill>
                 <a:latin typeface="Arial"/>
               </a:rPr>
-              <a:t>◆ 연구 방법 — Methods (자동 구분)</a:t>
+              <a:t>◆ 연구 방법 — Methods</a:t>
             </a:r>
           </a:p>
         </p:txBody>
@@ -4989,7 +4989,12 @@
                 </a:solidFill>
                 <a:latin typeface="Arial"/>
               </a:rPr>
-              <a:t>· Here, we developed a hyaluronic acid-based liposomal transdermal delivery system loaded with L-arginine (HL@L-Arg) to enhance cutaneous delivery and promote endogenous nitric oxide (NO) production through nitric oxide synthase.</a:t>
+              <a:t>· We searched PubMed, Embase, CENTRAL, and EBSCO Open Dissertations from inception to March 2025.
+· Randomized controlled trials evaluating interventions to prevent CIA in cancer patients and reporting hair preservation outcomes (as defined by individual trials, including CTCAE grade &lt; 2, &lt; 30 to &lt; 50% hair loss, or WHO grade 0-2) were included.
+· Scalp hypothermia was divided into three groups based on duration post-chemotherapy: short (0-45 min), traditional (46-90 min), and prolonged (&gt; 90 min).
+· Risk of bias was assessed using Cochrane RoB2.
+· Risk ratios (RRs) with 95% confidence intervals (CIs) were pooled using a random-effects model.
+· Interventions were ranked with surface under the cumulative ranking curve (SUCRA), and certainty of evidence was evaluated using CINeMA.</a:t>
             </a:r>
           </a:p>
         </p:txBody>
@@ -5085,7 +5090,7 @@
                 </a:solidFill>
                 <a:latin typeface="Arial"/>
               </a:rPr>
-              <a:t>◆ 주요 결과 — Results (자동 구분)</a:t>
+              <a:t>◆ 주요 결과 — Results</a:t>
             </a:r>
           </a:p>
         </p:txBody>
@@ -5120,9 +5125,11 @@
                 </a:solidFill>
                 <a:latin typeface="Arial"/>
               </a:rPr>
-              <a:t>· Transcriptomic analysis indicated significant changes in pathways related to inflammatory responses, Wnt signaling, and steroid hormone biosynthesis.
-· Mechanistically, HL@L-Arg inhibited 5α-reductase activity and reduced dihydrotestosterone (DHT) production while promoting endogenous NO generation.
-· In an AGA mouse model, HL@L-Arg reduced TNF-α, IL-6, and androgen receptor (AR) expression, increased VEGF and Ki67 levels, and markedly promoted hair regeneration.</a:t>
+              <a:t>· Of 6696 articles identified, 12 (n = 736) evaluating nine interventions (three scalp hypothermia durations, scalp compression, four pharmacological agents, and usual care) were included.
+· Network meta-analysis indicated that prolonged-scalp hypothermia significantly improved hair preservation compared with usual care (RR = 24.66; 95%CI = 7.07-86.05; low certainty of evidence) and traditional scalp hypothermia (RR = 2.13; 95%CI = 1.15-3.93; very low certainty of evidence), and pharmacological agents (RRs ranging from 14.06 to 23.83; low certainty).
+· However, prolonged-scalp hypothermia tended to show better hair preservation than short duration, though not statistically significant (RR = 2.06, 95%CI = 0.78-5.39).
+· Based on SUCRA, prolonged-scalp hypothermia (97.0%) had the highest ranking, followed by short scalp hypothermia (78.6%) and traditional scalp hypothermia (76.8%).
+· Most studies were rated as having high risk of bias, and the certainty of evidence was graded as low to very low.</a:t>
             </a:r>
           </a:p>
         </p:txBody>
@@ -5157,7 +5164,7 @@
                 </a:solidFill>
                 <a:latin typeface="Arial"/>
               </a:rPr>
-              <a:t>◆ 결론 — Conclusion (자동 구분)</a:t>
+              <a:t>◆ 결론 — Conclusion</a:t>
             </a:r>
           </a:p>
         </p:txBody>
@@ -5192,7 +5199,9 @@
                 </a:solidFill>
                 <a:latin typeface="Arial"/>
               </a:rPr>
-              <a:t>· Collectively, transdermal L-Arg delivery represents a promising endogenous NO-based therapeutic strategy for AGA through DHT suppression, regulation of the follicular microenvironment, and anti-inflammatory activity.</a:t>
+              <a:t>· Current low certainty evidence suggests that scalp hypothermia could prevent CIA.
+· Prolonged-scalp hypothermia provides a higher degree of protection, whereas a short duration demonstrates a weaker protective effect.
+· However, this difference was not statistically significant.</a:t>
             </a:r>
           </a:p>
         </p:txBody>
@@ -5289,9 +5298,9 @@
                 <a:latin typeface="Arial"/>
               </a:rPr>
               <a:t>[출처]
-논문: Transdermal L-arginine and hyaluronic acid delivery to treat androgenetic alopecia through dual hormone modulation and anti-inflammatory action
-게재: Colloids and surfaces. B, Biointerfaces
-원문: https://pubmed.ncbi.nlm.nih.gov/42892175/
+논문: Comparative efficacy of interventions for preventing chemotherapy-induced alopecia: a systematic review and network meta-analysis
+게재: Supportive care in cancer : official journal of the Multinational Association of Supportive Care in Cancer
+원문: https://pubmed.ncbi.nlm.nih.gov/42895661/
 [이미지 출처]
 - Male pattern baldness.jpg / Originally uploaded by Lkinkade (Transferred by XenonX3) / CC BY-SA 2.5
   https://commons.wikimedia.org/wiki/File:Male_pattern_baldness.jpg

</xml_diff>

<commit_message>
chore: daily content 2026-10-21
</commit_message>
<xml_diff>
--- a/pwa/data/latest/slides.pptx
+++ b/pwa/data/latest/slides.pptx
@@ -515,7 +515,7 @@
           </a:p>
           <a:p>
             <a:r>
-              <a:t>대본: 97% 이 숫자, 탈모 연구가 새로 내놨습니다</a:t>
+              <a:t>대본: 오늘의 논문 Journal of cutaneous pathology에 실린 새 연구입니다</a:t>
             </a:r>
           </a:p>
           <a:p>
@@ -595,7 +595,7 @@
           </a:p>
           <a:p>
             <a:r>
-              <a:t>대본: 《Supportive care in cancer : official journal of the Multinational Association of Supportive Care in Cancer》 - Comparative efficacy of interventions for preventing chemotherapy-induced alopecia: a systematic review and network meta-analysis</a:t>
+              <a:t>대본: 《Journal of cutaneous pathology》 - Novel Potential Histologic Clues to Mechanical Alopecia: A Comparative Study of Traction Alopecia, Trichotillomania, and Approximately Age/Gender Matched Controls</a:t>
             </a:r>
           </a:p>
           <a:p>
@@ -675,7 +675,7 @@
           </a:p>
           <a:p>
             <a:r>
-              <a:t>대본: Randomized controlled trials evaluating interventions to prevent CIA in cancer patients and reporting hair preservation outcomes (as defined by individual trials, including CTCAE grade &lt; 2, &lt; 30 to &lt; 50% hair loss, or WHO grade 0-2) were included.</a:t>
+              <a:t>대본: A blinded, retrospective, qualitative, and semiquantitative study was performed comparing horizontally processed scalp biopsy sections of clinicopathologically confirmed TA (n = 16) and TTM (n = 9) to nearly matched controls (n = 15).</a:t>
             </a:r>
           </a:p>
           <a:p>
@@ -755,7 +755,7 @@
           </a:p>
           <a:p>
             <a:r>
-              <a:t>대본: Scalp hypothermia was divided into three groups based on duration post-chemotherapy: short (0-45 min), traditional (46-90 min), and prolonged (&gt; 90 min).</a:t>
+              <a:t>대본: Vectorially warped sebaceous lobules were observed predominately in TA (p = 0.0002), while collapse of the inner root sheath of the lower follicular isthmus and surface lichenification were primarily seen in TTM (p &lt; 0.0002).</a:t>
             </a:r>
           </a:p>
           <a:p>
@@ -4114,7 +4114,7 @@
                 </a:solidFill>
                 <a:latin typeface="Arial"/>
               </a:rPr>
-              <a:t>SUPPORTIVE CARE IN CANCER : OFFICIAL JOU</a:t>
+              <a:t>JOURNAL OF CUTANEOUS PATHOLOGY</a:t>
             </a:r>
           </a:p>
         </p:txBody>
@@ -4149,7 +4149,7 @@
                 </a:solidFill>
                 <a:latin typeface="Arial"/>
               </a:rPr>
-              <a:t>97%</a:t>
+              <a:t>오늘의 논문</a:t>
             </a:r>
           </a:p>
         </p:txBody>
@@ -4184,7 +4184,7 @@
                 </a:solidFill>
                 <a:latin typeface="Arial"/>
               </a:rPr>
-              <a:t>이 숫자, 탈모 연구가 새로 내놨습니다</a:t>
+              <a:t>Journal of cutaneous pathology에 실린 새 연구입니다</a:t>
             </a:r>
           </a:p>
         </p:txBody>
@@ -4219,7 +4219,7 @@
                 </a:solidFill>
                 <a:latin typeface="Arial"/>
               </a:rPr>
-              <a:t>2026 Oct 19  |  매일 아침 탈모 연구 한 편</a:t>
+              <a:t>2026 Oct 20  |  매일 아침 탈모 연구 한 편</a:t>
             </a:r>
           </a:p>
         </p:txBody>
@@ -4304,7 +4304,7 @@
                 </a:solidFill>
                 <a:latin typeface="Arial"/>
               </a:rPr>
-              <a:t>Comparative efficacy of interventions for preventing chemotherapy-induced alopecia: a systematic review and network meta-analysis</a:t>
+              <a:t>Novel Potential Histologic Clues to Mechanical Alopecia: A Comparative Study of Traction Alopecia, Trichotillomania, and Approximately Age/Gender Matched Controls</a:t>
             </a:r>
           </a:p>
         </p:txBody>
@@ -4339,7 +4339,7 @@
                 </a:solidFill>
                 <a:latin typeface="Arial"/>
               </a:rPr>
-              <a:t>Supportive care in cancer : official journal of the Multinational Association of Supportive Care in Cancer  ·  2026 Oct 19</a:t>
+              <a:t>Journal of cutaneous pathology  ·  2026 Oct 20</a:t>
             </a:r>
           </a:p>
         </p:txBody>
@@ -4468,7 +4468,7 @@
                 </a:solidFill>
                 <a:latin typeface="Arial"/>
               </a:rPr>
-              <a:t>Randomized controlled trials evaluating interventions to prevent CIA in cancer patients and reporting hair preservation outcomes (as defined by individual trials, including CTCAE grade &lt; 2, &lt; 30 to &lt; 50% hair loss, or WHO grade 0-2) were included.</a:t>
+              <a:t>A blinded, retrospective, qualitative, and semiquantitative study was performed comparing horizontally processed scalp biopsy sections of clinicopathologically confirmed TA (n = 16) and TTM (n = 9) to nearly matched controls (n = 15).</a:t>
             </a:r>
           </a:p>
         </p:txBody>
@@ -4597,7 +4597,7 @@
                 </a:solidFill>
                 <a:latin typeface="Arial"/>
               </a:rPr>
-              <a:t>Scalp hypothermia was divided into three groups based on duration post-chemotherapy: short (0-45 min), traditional (46-90 min), and prolonged (&gt; 90 min).</a:t>
+              <a:t>Vectorially warped sebaceous lobules were observed predominately in TA (p = 0.0002), while collapse of the inner root sheath of the lower follicular isthmus and surface lichenification were primarily seen in TTM (p &lt; 0.0002).</a:t>
             </a:r>
           </a:p>
         </p:txBody>
@@ -4883,7 +4883,7 @@
                 </a:solidFill>
                 <a:latin typeface="Arial"/>
               </a:rPr>
-              <a:t>◆ 배경 — Purpose</a:t>
+              <a:t>◆ 배경 — Background (자동 구분)</a:t>
             </a:r>
           </a:p>
         </p:txBody>
@@ -4918,8 +4918,8 @@
                 </a:solidFill>
                 <a:latin typeface="Arial"/>
               </a:rPr>
-              <a:t>· Chemotherapy-induced alopecia (CIA) negatively affects patients' appearance and emotional well-being.
-· This network meta-analysis aimed to compare the efficacy of different preventive interventions for CIA.</a:t>
+              <a:t>· Mechanical stress on the pilosebaceous unit can contribute to mechanical alopecia (MA) as seen with traction alopecia (TA) and trichotillomania (TTM).
+· While some histological features that point to TA and TTM have been described, these may be absent in biopsies obtained at earlier stages of disease.</a:t>
             </a:r>
           </a:p>
         </p:txBody>
@@ -4954,7 +4954,7 @@
                 </a:solidFill>
                 <a:latin typeface="Arial"/>
               </a:rPr>
-              <a:t>◆ 연구 방법 — Methods</a:t>
+              <a:t>◆ 연구 방법 — Methods (자동 구분)</a:t>
             </a:r>
           </a:p>
         </p:txBody>
@@ -4989,12 +4989,8 @@
                 </a:solidFill>
                 <a:latin typeface="Arial"/>
               </a:rPr>
-              <a:t>· We searched PubMed, Embase, CENTRAL, and EBSCO Open Dissertations from inception to March 2025.
-· Randomized controlled trials evaluating interventions to prevent CIA in cancer patients and reporting hair preservation outcomes (as defined by individual trials, including CTCAE grade &lt; 2, &lt; 30 to &lt; 50% hair loss, or WHO grade 0-2) were included.
-· Scalp hypothermia was divided into three groups based on duration post-chemotherapy: short (0-45 min), traditional (46-90 min), and prolonged (&gt; 90 min).
-· Risk of bias was assessed using Cochrane RoB2.
-· Risk ratios (RRs) with 95% confidence intervals (CIs) were pooled using a random-effects model.
-· Interventions were ranked with surface under the cumulative ranking curve (SUCRA), and certainty of evidence was evaluated using CINeMA.</a:t>
+              <a:t>· A blinded, retrospective, qualitative, and semiquantitative study was performed comparing horizontally processed scalp biopsy sections of clinicopathologically confirmed TA (n = 16) and TTM (n = 9) to nearly matched controls (n = 15).
+· Further validation studies in larger cohorts are warranted to assess their diagnostic utility in the recognition of MA.</a:t>
             </a:r>
           </a:p>
         </p:txBody>
@@ -5090,7 +5086,7 @@
                 </a:solidFill>
                 <a:latin typeface="Arial"/>
               </a:rPr>
-              <a:t>◆ 주요 결과 — Results</a:t>
+              <a:t>◆ 주요 결과 — Results (자동 구분)</a:t>
             </a:r>
           </a:p>
         </p:txBody>
@@ -5125,83 +5121,11 @@
                 </a:solidFill>
                 <a:latin typeface="Arial"/>
               </a:rPr>
-              <a:t>· Of 6696 articles identified, 12 (n = 736) evaluating nine interventions (three scalp hypothermia durations, scalp compression, four pharmacological agents, and usual care) were included.
-· Network meta-analysis indicated that prolonged-scalp hypothermia significantly improved hair preservation compared with usual care (RR = 24.66; 95%CI = 7.07-86.05; low certainty of evidence) and traditional scalp hypothermia (RR = 2.13; 95%CI = 1.15-3.93; very low certainty of evidence), and pharmacological agents (RRs ranging from 14.06 to 23.83; low certainty).
-· However, prolonged-scalp hypothermia tended to show better hair preservation than short duration, though not statistically significant (RR = 2.06, 95%CI = 0.78-5.39).
-· Based on SUCRA, prolonged-scalp hypothermia (97.0%) had the highest ranking, followed by short scalp hypothermia (78.6%) and traditional scalp hypothermia (76.8%).
-· Most studies were rated as having high risk of bias, and the certainty of evidence was graded as low to very low.</a:t>
-            </a:r>
-          </a:p>
-        </p:txBody>
-      </p:sp>
-      <p:sp>
-        <p:nvSpPr>
-          <p:cNvPr id="5" name="TextBox 4"/>
-          <p:cNvSpPr txBox="1"/>
-          <p:nvPr/>
-        </p:nvSpPr>
-        <p:spPr>
-          <a:xfrm>
-            <a:off x="365760" y="5303520"/>
-            <a:ext cx="4828032" cy="457200"/>
-          </a:xfrm>
-          <a:prstGeom prst="rect">
-            <a:avLst/>
-          </a:prstGeom>
-          <a:noFill/>
-        </p:spPr>
-        <p:txBody>
-          <a:bodyPr wrap="square" anchor="t">
-            <a:spAutoFit/>
-          </a:bodyPr>
-          <a:lstStyle/>
-          <a:p>
-            <a:pPr algn="l"/>
-            <a:r>
-              <a:rPr sz="1300" b="1">
-                <a:solidFill>
-                  <a:srgbClr val="FFFFFF"/>
-                </a:solidFill>
-                <a:latin typeface="Arial"/>
-              </a:rPr>
-              <a:t>◆ 결론 — Conclusion</a:t>
-            </a:r>
-          </a:p>
-        </p:txBody>
-      </p:sp>
-      <p:sp>
-        <p:nvSpPr>
-          <p:cNvPr id="6" name="TextBox 5"/>
-          <p:cNvSpPr txBox="1"/>
-          <p:nvPr/>
-        </p:nvSpPr>
-        <p:spPr>
-          <a:xfrm>
-            <a:off x="457200" y="5806440"/>
-            <a:ext cx="4736592" cy="3566160"/>
-          </a:xfrm>
-          <a:prstGeom prst="rect">
-            <a:avLst/>
-          </a:prstGeom>
-          <a:noFill/>
-        </p:spPr>
-        <p:txBody>
-          <a:bodyPr wrap="square" anchor="t">
-            <a:spAutoFit/>
-          </a:bodyPr>
-          <a:lstStyle/>
-          <a:p>
-            <a:pPr algn="l"/>
-            <a:r>
-              <a:rPr sz="1000" b="0">
-                <a:solidFill>
-                  <a:srgbClr val="D5D8EA"/>
-                </a:solidFill>
-                <a:latin typeface="Arial"/>
-              </a:rPr>
-              <a:t>· Current low certainty evidence suggests that scalp hypothermia could prevent CIA.
-· Prolonged-scalp hypothermia provides a higher degree of protection, whereas a short duration demonstrates a weaker protective effect.
-· However, this difference was not statistically significant.</a:t>
+              <a:t>· Additional anomalies of the pilosebaceous unit have been observed that may assist in the histopathological detection of MA.
+· Translocation of sebocytes into the follicular canal was seen in both TA and TTM, supporting a shared underlying mechanism.
+· Vectorially warped sebaceous lobules were observed predominately in TA (p = 0.0002), while collapse of the inner root sheath of the lower follicular isthmus and surface lichenification were primarily seen in TTM (p &lt; 0.0002).
+· Lateral impingement of the follicular canal was seen in both TA and TTM (p &lt; 0.0001), although more commonly in TA.
+· These alterations were observed in the absence of other previously described features.</a:t>
             </a:r>
           </a:p>
         </p:txBody>
@@ -5298,9 +5222,9 @@
                 <a:latin typeface="Arial"/>
               </a:rPr>
               <a:t>[출처]
-논문: Comparative efficacy of interventions for preventing chemotherapy-induced alopecia: a systematic review and network meta-analysis
-게재: Supportive care in cancer : official journal of the Multinational Association of Supportive Care in Cancer
-원문: https://pubmed.ncbi.nlm.nih.gov/42895661/
+논문: Novel Potential Histologic Clues to Mechanical Alopecia: A Comparative Study of Traction Alopecia, Trichotillomania, and Approximately Age/Gender Matched Controls
+게재: Journal of cutaneous pathology
+원문: https://pubmed.ncbi.nlm.nih.gov/42899449/
 [이미지 출처]
 - Male pattern baldness.jpg / Originally uploaded by Lkinkade (Transferred by XenonX3) / CC BY-SA 2.5
   https://commons.wikimedia.org/wiki/File:Male_pattern_baldness.jpg

</xml_diff>

<commit_message>
chore: daily content 2026-10-22
</commit_message>
<xml_diff>
--- a/pwa/data/latest/slides.pptx
+++ b/pwa/data/latest/slides.pptx
@@ -515,7 +515,7 @@
           </a:p>
           <a:p>
             <a:r>
-              <a:t>대본: 오늘의 논문 Journal of cutaneous pathology에 실린 새 연구입니다</a:t>
+              <a:t>대본: 91% 이 숫자, 탈모 연구가 새로 내놨습니다</a:t>
             </a:r>
           </a:p>
           <a:p>
@@ -595,7 +595,7 @@
           </a:p>
           <a:p>
             <a:r>
-              <a:t>대본: 《Journal of cutaneous pathology》 - Novel Potential Histologic Clues to Mechanical Alopecia: A Comparative Study of Traction Alopecia, Trichotillomania, and Approximately Age/Gender Matched Controls</a:t>
+              <a:t>대본: 《Journal of cutaneous pathology》 - Mast Cell Infiltration Helps Distinguish Fibrosing Alopecia in a Pattern Distribution From Androgenetic Alopecia in Scalp Biopsy</a:t>
             </a:r>
           </a:p>
           <a:p>
@@ -675,7 +675,7 @@
           </a:p>
           <a:p>
             <a:r>
-              <a:t>대본: A blinded, retrospective, qualitative, and semiquantitative study was performed comparing horizontally processed scalp biopsy sections of clinicopathologically confirmed TA (n = 16) and TTM (n = 9) to nearly matched controls (n = 15).</a:t>
+              <a:t>대본: Method: A total of 56 patients diagnosed with AGA, FAPD, or LPP were enrolled.</a:t>
             </a:r>
           </a:p>
           <a:p>
@@ -755,7 +755,7 @@
           </a:p>
           <a:p>
             <a:r>
-              <a:t>대본: Vectorially warped sebaceous lobules were observed predominately in TA (p = 0.0002), while collapse of the inner root sheath of the lower follicular isthmus and surface lichenification were primarily seen in TTM (p &lt; 0.0002).</a:t>
+              <a:t>대본: Result: The majority of participants (91%) were female, with a mean age of 44.3 years.</a:t>
             </a:r>
           </a:p>
           <a:p>
@@ -4149,7 +4149,7 @@
                 </a:solidFill>
                 <a:latin typeface="Arial"/>
               </a:rPr>
-              <a:t>오늘의 논문</a:t>
+              <a:t>91%</a:t>
             </a:r>
           </a:p>
         </p:txBody>
@@ -4184,7 +4184,7 @@
                 </a:solidFill>
                 <a:latin typeface="Arial"/>
               </a:rPr>
-              <a:t>Journal of cutaneous pathology에 실린 새 연구입니다</a:t>
+              <a:t>이 숫자, 탈모 연구가 새로 내놨습니다</a:t>
             </a:r>
           </a:p>
         </p:txBody>
@@ -4304,7 +4304,7 @@
                 </a:solidFill>
                 <a:latin typeface="Arial"/>
               </a:rPr>
-              <a:t>Novel Potential Histologic Clues to Mechanical Alopecia: A Comparative Study of Traction Alopecia, Trichotillomania, and Approximately Age/Gender Matched Controls</a:t>
+              <a:t>Mast Cell Infiltration Helps Distinguish Fibrosing Alopecia in a Pattern Distribution From Androgenetic Alopecia in Scalp Biopsy</a:t>
             </a:r>
           </a:p>
         </p:txBody>
@@ -4468,7 +4468,7 @@
                 </a:solidFill>
                 <a:latin typeface="Arial"/>
               </a:rPr>
-              <a:t>A blinded, retrospective, qualitative, and semiquantitative study was performed comparing horizontally processed scalp biopsy sections of clinicopathologically confirmed TA (n = 16) and TTM (n = 9) to nearly matched controls (n = 15).</a:t>
+              <a:t>Method: A total of 56 patients diagnosed with AGA, FAPD, or LPP were enrolled.</a:t>
             </a:r>
           </a:p>
         </p:txBody>
@@ -4597,7 +4597,7 @@
                 </a:solidFill>
                 <a:latin typeface="Arial"/>
               </a:rPr>
-              <a:t>Vectorially warped sebaceous lobules were observed predominately in TA (p = 0.0002), while collapse of the inner root sheath of the lower follicular isthmus and surface lichenification were primarily seen in TTM (p &lt; 0.0002).</a:t>
+              <a:t>Result: The majority of participants (91%) were female, with a mean age of 44.3 years.</a:t>
             </a:r>
           </a:p>
         </p:txBody>
@@ -4883,7 +4883,7 @@
                 </a:solidFill>
                 <a:latin typeface="Arial"/>
               </a:rPr>
-              <a:t>◆ 배경 — Background (자동 구분)</a:t>
+              <a:t>◆ 배경 — Background</a:t>
             </a:r>
           </a:p>
         </p:txBody>
@@ -4918,8 +4918,9 @@
                 </a:solidFill>
                 <a:latin typeface="Arial"/>
               </a:rPr>
-              <a:t>· Mechanical stress on the pilosebaceous unit can contribute to mechanical alopecia (MA) as seen with traction alopecia (TA) and trichotillomania (TTM).
-· While some histological features that point to TA and TTM have been described, these may be absent in biopsies obtained at earlier stages of disease.</a:t>
+              <a:t>· Mast cells are key regulators of cutaneous inflammation and are known to accumulate in response to various immunological stimuli.
+· Although their role in several dermatological conditions has been established, their specific contribution to different forms of alopecia-particularly scarring versus nonscarring types-remains incompletely understood.
+· This study aimed to compare the degree of mast cell infiltration across three distinct types of alopecia: androgenetic alopecia (AGA), fibrosing alopecia in a pattern distribution (FAPD), and lichen planopilaris (LPP).</a:t>
             </a:r>
           </a:p>
         </p:txBody>
@@ -4954,7 +4955,7 @@
                 </a:solidFill>
                 <a:latin typeface="Arial"/>
               </a:rPr>
-              <a:t>◆ 연구 방법 — Methods (자동 구분)</a:t>
+              <a:t>◆ 연구 방법 — Method</a:t>
             </a:r>
           </a:p>
         </p:txBody>
@@ -4989,8 +4990,10 @@
                 </a:solidFill>
                 <a:latin typeface="Arial"/>
               </a:rPr>
-              <a:t>· A blinded, retrospective, qualitative, and semiquantitative study was performed comparing horizontally processed scalp biopsy sections of clinicopathologically confirmed TA (n = 16) and TTM (n = 9) to nearly matched controls (n = 15).
-· Further validation studies in larger cohorts are warranted to assess their diagnostic utility in the recognition of MA.</a:t>
+              <a:t>· A total of 56 patients diagnosed with AGA, FAPD, or LPP were enrolled.
+· Scalp biopsies were obtained from all participants, and diagnoses were confirmed through histopathological examination.
+· Mast cell distribution and infiltration density were quantified and analyzed using SPSS and Stata software.
+· The study was conducted with full ethical approval.</a:t>
             </a:r>
           </a:p>
         </p:txBody>
@@ -5086,7 +5089,7 @@
                 </a:solidFill>
                 <a:latin typeface="Arial"/>
               </a:rPr>
-              <a:t>◆ 주요 결과 — Results (자동 구분)</a:t>
+              <a:t>◆ 주요 결과 — Result</a:t>
             </a:r>
           </a:p>
         </p:txBody>
@@ -5121,11 +5124,83 @@
                 </a:solidFill>
                 <a:latin typeface="Arial"/>
               </a:rPr>
-              <a:t>· Additional anomalies of the pilosebaceous unit have been observed that may assist in the histopathological detection of MA.
-· Translocation of sebocytes into the follicular canal was seen in both TA and TTM, supporting a shared underlying mechanism.
-· Vectorially warped sebaceous lobules were observed predominately in TA (p = 0.0002), while collapse of the inner root sheath of the lower follicular isthmus and surface lichenification were primarily seen in TTM (p &lt; 0.0002).
-· Lateral impingement of the follicular canal was seen in both TA and TTM (p &lt; 0.0001), although more commonly in TA.
-· These alterations were observed in the absence of other previously described features.</a:t>
+              <a:t>· The majority of participants (91%) were female, with a mean age of 44.3 years.
+· FAPD was the most prevalent diagnosis (42.9%).
+· LPP demonstrated the highest degree of mast cell infiltration, while AGA exhibited the lowest (ANOVA, p &lt; 0.001).
+· Post hoc analysis revealed significant differences between AGA and FAPD (-17.7%, p = 0.001) and between AGA and LPP (-20.1%, p = 0.001).
+· Although mast cell infiltration was higher in patients over 40 years of age, this difference did not reach statistical significance.
+· No significant association was identified between mast cell infiltration and patient sex.</a:t>
+            </a:r>
+          </a:p>
+        </p:txBody>
+      </p:sp>
+      <p:sp>
+        <p:nvSpPr>
+          <p:cNvPr id="5" name="TextBox 4"/>
+          <p:cNvSpPr txBox="1"/>
+          <p:nvPr/>
+        </p:nvSpPr>
+        <p:spPr>
+          <a:xfrm>
+            <a:off x="365760" y="5303520"/>
+            <a:ext cx="4828032" cy="457200"/>
+          </a:xfrm>
+          <a:prstGeom prst="rect">
+            <a:avLst/>
+          </a:prstGeom>
+          <a:noFill/>
+        </p:spPr>
+        <p:txBody>
+          <a:bodyPr wrap="square" anchor="t">
+            <a:spAutoFit/>
+          </a:bodyPr>
+          <a:lstStyle/>
+          <a:p>
+            <a:pPr algn="l"/>
+            <a:r>
+              <a:rPr sz="1300" b="1">
+                <a:solidFill>
+                  <a:srgbClr val="FFFFFF"/>
+                </a:solidFill>
+                <a:latin typeface="Arial"/>
+              </a:rPr>
+              <a:t>◆ 결론 — Conclusion</a:t>
+            </a:r>
+          </a:p>
+        </p:txBody>
+      </p:sp>
+      <p:sp>
+        <p:nvSpPr>
+          <p:cNvPr id="6" name="TextBox 5"/>
+          <p:cNvSpPr txBox="1"/>
+          <p:nvPr/>
+        </p:nvSpPr>
+        <p:spPr>
+          <a:xfrm>
+            <a:off x="457200" y="5806440"/>
+            <a:ext cx="4736592" cy="3566160"/>
+          </a:xfrm>
+          <a:prstGeom prst="rect">
+            <a:avLst/>
+          </a:prstGeom>
+          <a:noFill/>
+        </p:spPr>
+        <p:txBody>
+          <a:bodyPr wrap="square" anchor="t">
+            <a:spAutoFit/>
+          </a:bodyPr>
+          <a:lstStyle/>
+          <a:p>
+            <a:pPr algn="l"/>
+            <a:r>
+              <a:rPr sz="1000" b="0">
+                <a:solidFill>
+                  <a:srgbClr val="D5D8EA"/>
+                </a:solidFill>
+                <a:latin typeface="Arial"/>
+              </a:rPr>
+              <a:t>· Mast cell infiltration is significantly more pronounced in scarring alopecias (LPP and FAPD) compared to non-scarring AGA, suggesting a shared immunopathological mechanism underlying follicular destruction in scarring subtypes.
+· These findings also raise important questions regarding the potential inflammatory contribution of mast cells to AGA pathogenesis.</a:t>
             </a:r>
           </a:p>
         </p:txBody>
@@ -5222,9 +5297,9 @@
                 <a:latin typeface="Arial"/>
               </a:rPr>
               <a:t>[출처]
-논문: Novel Potential Histologic Clues to Mechanical Alopecia: A Comparative Study of Traction Alopecia, Trichotillomania, and Approximately Age/Gender Matched Controls
+논문: Mast Cell Infiltration Helps Distinguish Fibrosing Alopecia in a Pattern Distribution From Androgenetic Alopecia in Scalp Biopsy
 게재: Journal of cutaneous pathology
-원문: https://pubmed.ncbi.nlm.nih.gov/42899449/
+원문: https://pubmed.ncbi.nlm.nih.gov/42902517/
 [이미지 출처]
 - Male pattern baldness.jpg / Originally uploaded by Lkinkade (Transferred by XenonX3) / CC BY-SA 2.5
   https://commons.wikimedia.org/wiki/File:Male_pattern_baldness.jpg

</xml_diff>

<commit_message>
chore: daily content 2026-10-23
</commit_message>
<xml_diff>
--- a/pwa/data/latest/slides.pptx
+++ b/pwa/data/latest/slides.pptx
@@ -13,7 +13,6 @@
     <p:sldId id="261" r:id="rId13"/>
     <p:sldId id="262" r:id="rId14"/>
     <p:sldId id="263" r:id="rId15"/>
-    <p:sldId id="264" r:id="rId16"/>
   </p:sldIdLst>
   <p:sldSz cx="5559552" cy="9875520" type="screen4x3"/>
   <p:notesSz cx="6858000" cy="9144000"/>
@@ -515,7 +514,7 @@
           </a:p>
           <a:p>
             <a:r>
-              <a:t>대본: 91% 이 숫자, 탈모 연구가 새로 내놨습니다</a:t>
+              <a:t>대본: 원형탈모 오늘 나온 최신 연구를 정리했습니다</a:t>
             </a:r>
           </a:p>
           <a:p>
@@ -595,7 +594,7 @@
           </a:p>
           <a:p>
             <a:r>
-              <a:t>대본: 《Journal of cutaneous pathology》 - Mast Cell Infiltration Helps Distinguish Fibrosing Alopecia in a Pattern Distribution From Androgenetic Alopecia in Scalp Biopsy</a:t>
+              <a:t>대본: 《Expert opinion on biological therapy》 - Biologics in alopecia areata: promise, paradox, and the precision medicine frontier</a:t>
             </a:r>
           </a:p>
           <a:p>
@@ -675,7 +674,7 @@
           </a:p>
           <a:p>
             <a:r>
-              <a:t>대본: Method: A total of 56 patients diagnosed with AGA, FAPD, or LPP were enrolled.</a:t>
+              <a:t>대본: Areas covered: This review evaluates the immunopathogenic rationale and available clinical evidence for biologic therapies in AA, including inhibitors of tumor necrosis factor (TNF), interleukin-4 receptor α subunit (IL-4 Rα), IL-17, and IL-23.</a:t>
             </a:r>
           </a:p>
           <a:p>
@@ -755,7 +754,7 @@
           </a:p>
           <a:p>
             <a:r>
-              <a:t>대본: Result: The majority of participants (91%) were female, with a mean age of 44.3 years.</a:t>
+              <a:t>대본: Relevant literature was identified through PubMed and ClinicalTrials.gov (last search: 17 October 2026).</a:t>
             </a:r>
           </a:p>
           <a:p>
@@ -946,81 +945,6 @@
 </file>
 
 <file path=ppt/notesSlides/notesSlide7.xml><?xml version="1.0" encoding="utf-8"?>
-<p:notes xmlns:a="http://schemas.openxmlformats.org/drawingml/2006/main" xmlns:p="http://schemas.openxmlformats.org/presentationml/2006/main" xmlns:r="http://schemas.openxmlformats.org/officeDocument/2006/relationships">
-  <p:cSld>
-    <p:spTree>
-      <p:nvGrpSpPr>
-        <p:cNvPr id="1" name=""/>
-        <p:cNvGrpSpPr/>
-        <p:nvPr/>
-      </p:nvGrpSpPr>
-      <p:grpSpPr>
-        <a:xfrm>
-          <a:off x="0" y="0"/>
-          <a:ext cx="0" cy="0"/>
-          <a:chOff x="0" y="0"/>
-          <a:chExt cx="0" cy="0"/>
-        </a:xfrm>
-      </p:grpSpPr>
-      <p:sp>
-        <p:nvSpPr>
-          <p:cNvPr id="2" name="Slide Image Placeholder 1"/>
-          <p:cNvSpPr>
-            <a:spLocks noGrp="1"/>
-          </p:cNvSpPr>
-          <p:nvPr>
-            <p:ph type="sldImg" idx="2"/>
-          </p:nvPr>
-        </p:nvSpPr>
-        <p:spPr/>
-      </p:sp>
-      <p:sp>
-        <p:nvSpPr>
-          <p:cNvPr id="3" name="Notes Placeholder 2"/>
-          <p:cNvSpPr>
-            <a:spLocks noGrp="1"/>
-          </p:cNvSpPr>
-          <p:nvPr>
-            <p:ph type="body" idx="3" sz="quarter"/>
-          </p:nvPr>
-        </p:nvSpPr>
-        <p:spPr/>
-        <p:txBody>
-          <a:bodyPr/>
-          <a:lstStyle/>
-          <a:p>
-            <a:r>
-              <a:t>편집 참고용 슬라이드입니다. 영상에는 쓰지 않아도 됩니다.</a:t>
-            </a:r>
-          </a:p>
-          <a:p>
-            <a:r>
-              <a:t>원문 영어 문장을 그대로 발췌했으므로 번역·검수 후 사용하세요.</a:t>
-            </a:r>
-          </a:p>
-        </p:txBody>
-      </p:sp>
-      <p:sp>
-        <p:nvSpPr>
-          <p:cNvPr id="4" name="Slide Number Placeholder 3"/>
-          <p:cNvSpPr>
-            <a:spLocks noGrp="1"/>
-          </p:cNvSpPr>
-          <p:nvPr>
-            <p:ph type="sldNum" idx="5" sz="quarter"/>
-          </p:nvPr>
-        </p:nvSpPr>
-        <p:spPr/>
-      </p:sp>
-    </p:spTree>
-  </p:cSld>
-  <p:clrMapOvr>
-    <a:masterClrMapping/>
-  </p:clrMapOvr>
-</p:notes>
-</file>
-
-<file path=ppt/notesSlides/notesSlide8.xml><?xml version="1.0" encoding="utf-8"?>
 <p:notes xmlns:a="http://schemas.openxmlformats.org/drawingml/2006/main" xmlns:p="http://schemas.openxmlformats.org/presentationml/2006/main" xmlns:r="http://schemas.openxmlformats.org/officeDocument/2006/relationships">
   <p:cSld>
     <p:spTree>
@@ -4114,7 +4038,7 @@
                 </a:solidFill>
                 <a:latin typeface="Arial"/>
               </a:rPr>
-              <a:t>JOURNAL OF CUTANEOUS PATHOLOGY</a:t>
+              <a:t>EXPERT OPINION ON BIOLOGICAL THERAPY</a:t>
             </a:r>
           </a:p>
         </p:txBody>
@@ -4149,7 +4073,7 @@
                 </a:solidFill>
                 <a:latin typeface="Arial"/>
               </a:rPr>
-              <a:t>91%</a:t>
+              <a:t>원형탈모</a:t>
             </a:r>
           </a:p>
         </p:txBody>
@@ -4184,7 +4108,7 @@
                 </a:solidFill>
                 <a:latin typeface="Arial"/>
               </a:rPr>
-              <a:t>이 숫자, 탈모 연구가 새로 내놨습니다</a:t>
+              <a:t>오늘 나온 최신 연구를 정리했습니다</a:t>
             </a:r>
           </a:p>
         </p:txBody>
@@ -4219,7 +4143,7 @@
                 </a:solidFill>
                 <a:latin typeface="Arial"/>
               </a:rPr>
-              <a:t>2026 Oct 20  |  매일 아침 탈모 연구 한 편</a:t>
+              <a:t>2026 Oct 21  |  매일 아침 탈모 연구 한 편</a:t>
             </a:r>
           </a:p>
         </p:txBody>
@@ -4304,7 +4228,7 @@
                 </a:solidFill>
                 <a:latin typeface="Arial"/>
               </a:rPr>
-              <a:t>Mast Cell Infiltration Helps Distinguish Fibrosing Alopecia in a Pattern Distribution From Androgenetic Alopecia in Scalp Biopsy</a:t>
+              <a:t>Biologics in alopecia areata: promise, paradox, and the precision medicine frontier</a:t>
             </a:r>
           </a:p>
         </p:txBody>
@@ -4339,7 +4263,7 @@
                 </a:solidFill>
                 <a:latin typeface="Arial"/>
               </a:rPr>
-              <a:t>Journal of cutaneous pathology  ·  2026 Oct 20</a:t>
+              <a:t>Expert opinion on biological therapy  ·  2026 Oct 21</a:t>
             </a:r>
           </a:p>
         </p:txBody>
@@ -4468,7 +4392,7 @@
                 </a:solidFill>
                 <a:latin typeface="Arial"/>
               </a:rPr>
-              <a:t>Method: A total of 56 patients diagnosed with AGA, FAPD, or LPP were enrolled.</a:t>
+              <a:t>Areas covered: This review evaluates the immunopathogenic rationale and available clinical evidence for biologic therapies in AA, including inhibitors of tumor necrosis factor (TNF), interleukin-4 receptor α subunit (IL-4 Rα), IL-17, and IL-23.</a:t>
             </a:r>
           </a:p>
         </p:txBody>
@@ -4597,7 +4521,7 @@
                 </a:solidFill>
                 <a:latin typeface="Arial"/>
               </a:rPr>
-              <a:t>Result: The majority of participants (91%) were female, with a mean age of 44.3 years.</a:t>
+              <a:t>Relevant literature was identified through PubMed and ClinicalTrials.gov (last search: 17 October 2026).</a:t>
             </a:r>
           </a:p>
         </p:txBody>
@@ -4883,7 +4807,7 @@
                 </a:solidFill>
                 <a:latin typeface="Arial"/>
               </a:rPr>
-              <a:t>◆ 배경 — Background</a:t>
+              <a:t>◆ 배경 — Background (자동 구분)</a:t>
             </a:r>
           </a:p>
         </p:txBody>
@@ -4918,9 +4842,9 @@
                 </a:solidFill>
                 <a:latin typeface="Arial"/>
               </a:rPr>
-              <a:t>· Mast cells are key regulators of cutaneous inflammation and are known to accumulate in response to various immunological stimuli.
-· Although their role in several dermatological conditions has been established, their specific contribution to different forms of alopecia-particularly scarring versus nonscarring types-remains incompletely understood.
-· This study aimed to compare the degree of mast cell infiltration across three distinct types of alopecia: androgenetic alopecia (AGA), fibrosing alopecia in a pattern distribution (FAPD), and lichen planopilaris (LPP).</a:t>
+              <a:t>· Introduction: Alopecia areata (AA) is a chronic, immune-mediated non-scarring hair loss affecting approximately 2% of the population.
+· The approval of oral JAK inhibitors has established targeted systemic therapy for moderate-to-severe AA.
+· Incomplete response rates, relapse upon treatment discontinuation, and safety contraindications, however, leave a substantial proportion of patients requiring alternative options.</a:t>
             </a:r>
           </a:p>
         </p:txBody>
@@ -4955,7 +4879,7 @@
                 </a:solidFill>
                 <a:latin typeface="Arial"/>
               </a:rPr>
-              <a:t>◆ 연구 방법 — Method</a:t>
+              <a:t>◆ 주요 결과 — Results (자동 구분)</a:t>
             </a:r>
           </a:p>
         </p:txBody>
@@ -4990,10 +4914,12 @@
                 </a:solidFill>
                 <a:latin typeface="Arial"/>
               </a:rPr>
-              <a:t>· A total of 56 patients diagnosed with AGA, FAPD, or LPP were enrolled.
-· Scalp biopsies were obtained from all participants, and diagnoses were confirmed through histopathological examination.
-· Mast cell distribution and infiltration density were quantified and analyzed using SPSS and Stata software.
-· The study was conducted with full ethical approval.</a:t>
+              <a:t>· Areas covered: This review evaluates the immunopathogenic rationale and available clinical evidence for biologic therapies in AA, including inhibitors of tumor necrosis factor (TNF), interleukin-4 receptor α subunit (IL-4 Rα), IL-17, and IL-23.
+· Relevant literature was identified through PubMed and ClinicalTrials.gov (last search: 17 October 2026).
+· Expert opinion: No biologic has demonstrated efficacy in an adequately powered randomized controlled trial in AA.
+· A phase 2a randomized trial of dupilumab showed modest efficacy, most pronounced in patients with elevated baseline IgE.
+· Paradoxically, TNF, IL-17, and IL-23 inhibitors have been implicated in drug-induced AA, a hypothesis-generating observation that warrants cautious interpretation.
+· Given the higher bar set by JAK inhibitors and the risk of paradoxical disease, currently available cytokine-targeting biologics cannot be recommended for AA outside of clinical trials.</a:t>
             </a:r>
           </a:p>
         </p:txBody>
@@ -5032,213 +4958,6 @@
         </p:nvSpPr>
         <p:spPr>
           <a:xfrm>
-            <a:off x="365760" y="457200"/>
-            <a:ext cx="4828032" cy="457200"/>
-          </a:xfrm>
-          <a:prstGeom prst="rect">
-            <a:avLst/>
-          </a:prstGeom>
-          <a:noFill/>
-        </p:spPr>
-        <p:txBody>
-          <a:bodyPr wrap="square" anchor="ctr">
-            <a:spAutoFit/>
-          </a:bodyPr>
-          <a:lstStyle/>
-          <a:p>
-            <a:pPr algn="l"/>
-            <a:r>
-              <a:rPr sz="1600" b="1">
-                <a:solidFill>
-                  <a:srgbClr val="FF6B6B"/>
-                </a:solidFill>
-                <a:latin typeface="Arial"/>
-              </a:rPr>
-              <a:t>본문 요약 (편집용)</a:t>
-            </a:r>
-          </a:p>
-        </p:txBody>
-      </p:sp>
-      <p:sp>
-        <p:nvSpPr>
-          <p:cNvPr id="3" name="TextBox 2"/>
-          <p:cNvSpPr txBox="1"/>
-          <p:nvPr/>
-        </p:nvSpPr>
-        <p:spPr>
-          <a:xfrm>
-            <a:off x="365760" y="1097280"/>
-            <a:ext cx="4828032" cy="457200"/>
-          </a:xfrm>
-          <a:prstGeom prst="rect">
-            <a:avLst/>
-          </a:prstGeom>
-          <a:noFill/>
-        </p:spPr>
-        <p:txBody>
-          <a:bodyPr wrap="square" anchor="t">
-            <a:spAutoFit/>
-          </a:bodyPr>
-          <a:lstStyle/>
-          <a:p>
-            <a:pPr algn="l"/>
-            <a:r>
-              <a:rPr sz="1300" b="1">
-                <a:solidFill>
-                  <a:srgbClr val="FFFFFF"/>
-                </a:solidFill>
-                <a:latin typeface="Arial"/>
-              </a:rPr>
-              <a:t>◆ 주요 결과 — Result</a:t>
-            </a:r>
-          </a:p>
-        </p:txBody>
-      </p:sp>
-      <p:sp>
-        <p:nvSpPr>
-          <p:cNvPr id="4" name="TextBox 3"/>
-          <p:cNvSpPr txBox="1"/>
-          <p:nvPr/>
-        </p:nvSpPr>
-        <p:spPr>
-          <a:xfrm>
-            <a:off x="457200" y="1600200"/>
-            <a:ext cx="4736592" cy="3566160"/>
-          </a:xfrm>
-          <a:prstGeom prst="rect">
-            <a:avLst/>
-          </a:prstGeom>
-          <a:noFill/>
-        </p:spPr>
-        <p:txBody>
-          <a:bodyPr wrap="square" anchor="t">
-            <a:spAutoFit/>
-          </a:bodyPr>
-          <a:lstStyle/>
-          <a:p>
-            <a:pPr algn="l"/>
-            <a:r>
-              <a:rPr sz="1000" b="0">
-                <a:solidFill>
-                  <a:srgbClr val="D5D8EA"/>
-                </a:solidFill>
-                <a:latin typeface="Arial"/>
-              </a:rPr>
-              <a:t>· The majority of participants (91%) were female, with a mean age of 44.3 years.
-· FAPD was the most prevalent diagnosis (42.9%).
-· LPP demonstrated the highest degree of mast cell infiltration, while AGA exhibited the lowest (ANOVA, p &lt; 0.001).
-· Post hoc analysis revealed significant differences between AGA and FAPD (-17.7%, p = 0.001) and between AGA and LPP (-20.1%, p = 0.001).
-· Although mast cell infiltration was higher in patients over 40 years of age, this difference did not reach statistical significance.
-· No significant association was identified between mast cell infiltration and patient sex.</a:t>
-            </a:r>
-          </a:p>
-        </p:txBody>
-      </p:sp>
-      <p:sp>
-        <p:nvSpPr>
-          <p:cNvPr id="5" name="TextBox 4"/>
-          <p:cNvSpPr txBox="1"/>
-          <p:nvPr/>
-        </p:nvSpPr>
-        <p:spPr>
-          <a:xfrm>
-            <a:off x="365760" y="5303520"/>
-            <a:ext cx="4828032" cy="457200"/>
-          </a:xfrm>
-          <a:prstGeom prst="rect">
-            <a:avLst/>
-          </a:prstGeom>
-          <a:noFill/>
-        </p:spPr>
-        <p:txBody>
-          <a:bodyPr wrap="square" anchor="t">
-            <a:spAutoFit/>
-          </a:bodyPr>
-          <a:lstStyle/>
-          <a:p>
-            <a:pPr algn="l"/>
-            <a:r>
-              <a:rPr sz="1300" b="1">
-                <a:solidFill>
-                  <a:srgbClr val="FFFFFF"/>
-                </a:solidFill>
-                <a:latin typeface="Arial"/>
-              </a:rPr>
-              <a:t>◆ 결론 — Conclusion</a:t>
-            </a:r>
-          </a:p>
-        </p:txBody>
-      </p:sp>
-      <p:sp>
-        <p:nvSpPr>
-          <p:cNvPr id="6" name="TextBox 5"/>
-          <p:cNvSpPr txBox="1"/>
-          <p:nvPr/>
-        </p:nvSpPr>
-        <p:spPr>
-          <a:xfrm>
-            <a:off x="457200" y="5806440"/>
-            <a:ext cx="4736592" cy="3566160"/>
-          </a:xfrm>
-          <a:prstGeom prst="rect">
-            <a:avLst/>
-          </a:prstGeom>
-          <a:noFill/>
-        </p:spPr>
-        <p:txBody>
-          <a:bodyPr wrap="square" anchor="t">
-            <a:spAutoFit/>
-          </a:bodyPr>
-          <a:lstStyle/>
-          <a:p>
-            <a:pPr algn="l"/>
-            <a:r>
-              <a:rPr sz="1000" b="0">
-                <a:solidFill>
-                  <a:srgbClr val="D5D8EA"/>
-                </a:solidFill>
-                <a:latin typeface="Arial"/>
-              </a:rPr>
-              <a:t>· Mast cell infiltration is significantly more pronounced in scarring alopecias (LPP and FAPD) compared to non-scarring AGA, suggesting a shared immunopathological mechanism underlying follicular destruction in scarring subtypes.
-· These findings also raise important questions regarding the potential inflammatory contribution of mast cells to AGA pathogenesis.</a:t>
-            </a:r>
-          </a:p>
-        </p:txBody>
-      </p:sp>
-    </p:spTree>
-  </p:cSld>
-  <p:clrMapOvr>
-    <a:masterClrMapping/>
-  </p:clrMapOvr>
-</p:sld>
-</file>
-
-<file path=ppt/slides/slide9.xml><?xml version="1.0" encoding="utf-8"?>
-<p:sld xmlns:a="http://schemas.openxmlformats.org/drawingml/2006/main" xmlns:p="http://schemas.openxmlformats.org/presentationml/2006/main" xmlns:r="http://schemas.openxmlformats.org/officeDocument/2006/relationships">
-  <p:cSld>
-    <p:bg>
-      <p:bgPr>
-        <a:solidFill>
-          <a:srgbClr val="12142A"/>
-        </a:solidFill>
-        <a:effectLst/>
-      </p:bgPr>
-    </p:bg>
-    <p:spTree>
-      <p:nvGrpSpPr>
-        <p:cNvPr id="1" name=""/>
-        <p:cNvGrpSpPr/>
-        <p:nvPr/>
-      </p:nvGrpSpPr>
-      <p:grpSpPr/>
-      <p:sp>
-        <p:nvSpPr>
-          <p:cNvPr id="2" name="TextBox 1"/>
-          <p:cNvSpPr txBox="1"/>
-          <p:nvPr/>
-        </p:nvSpPr>
-        <p:spPr>
-          <a:xfrm>
             <a:off x="365760" y="731520"/>
             <a:ext cx="4828032" cy="548640"/>
           </a:xfrm>
@@ -5297,9 +5016,9 @@
                 <a:latin typeface="Arial"/>
               </a:rPr>
               <a:t>[출처]
-논문: Mast Cell Infiltration Helps Distinguish Fibrosing Alopecia in a Pattern Distribution From Androgenetic Alopecia in Scalp Biopsy
-게재: Journal of cutaneous pathology
-원문: https://pubmed.ncbi.nlm.nih.gov/42902517/
+논문: Biologics in alopecia areata: promise, paradox, and the precision medicine frontier
+게재: Expert opinion on biological therapy
+원문: https://pubmed.ncbi.nlm.nih.gov/42904500/
 [이미지 출처]
 - Male pattern baldness.jpg / Originally uploaded by Lkinkade (Transferred by XenonX3) / CC BY-SA 2.5
   https://commons.wikimedia.org/wiki/File:Male_pattern_baldness.jpg

</xml_diff>

<commit_message>
chore: daily content 2026-10-24
</commit_message>
<xml_diff>
--- a/pwa/data/latest/slides.pptx
+++ b/pwa/data/latest/slides.pptx
@@ -13,6 +13,7 @@
     <p:sldId id="261" r:id="rId13"/>
     <p:sldId id="262" r:id="rId14"/>
     <p:sldId id="263" r:id="rId15"/>
+    <p:sldId id="264" r:id="rId16"/>
   </p:sldIdLst>
   <p:sldSz cx="5559552" cy="9875520" type="screen4x3"/>
   <p:notesSz cx="6858000" cy="9144000"/>
@@ -514,7 +515,7 @@
           </a:p>
           <a:p>
             <a:r>
-              <a:t>대본: 원형탈모 오늘 나온 최신 연구를 정리했습니다</a:t>
+              <a:t>대본: 9.2% 이 숫자, 탈모 연구가 새로 내놨습니다</a:t>
             </a:r>
           </a:p>
           <a:p>
@@ -594,7 +595,7 @@
           </a:p>
           <a:p>
             <a:r>
-              <a:t>대본: 《Expert opinion on biological therapy》 - Biologics in alopecia areata: promise, paradox, and the precision medicine frontier</a:t>
+              <a:t>대본: 《Lasers in medical science》 - Thulium laser-assisted delivery of growth factors for treating androgenetic alopecia - a randomized, controlled, clinical study</a:t>
             </a:r>
           </a:p>
           <a:p>
@@ -674,7 +675,7 @@
           </a:p>
           <a:p>
             <a:r>
-              <a:t>대본: Areas covered: This review evaluates the immunopathogenic rationale and available clinical evidence for biologic therapies in AA, including inhibitors of tumor necrosis factor (TNF), interleukin-4 receptor α subunit (IL-4 Rα), IL-17, and IL-23.</a:t>
+              <a:t>대본: Androgenetic alopecia (AGA) is the most common form of hair loss and can significantly impact quality of life.</a:t>
             </a:r>
           </a:p>
           <a:p>
@@ -754,7 +755,7 @@
           </a:p>
           <a:p>
             <a:r>
-              <a:t>대본: Relevant literature was identified through PubMed and ClinicalTrials.gov (last search: 17 October 2026).</a:t>
+              <a:t>대본: Emerging non-invasive treatments include laser-assisted delivery of biomimetic growth factor-based serums.</a:t>
             </a:r>
           </a:p>
           <a:p>
@@ -945,6 +946,81 @@
 </file>
 
 <file path=ppt/notesSlides/notesSlide7.xml><?xml version="1.0" encoding="utf-8"?>
+<p:notes xmlns:a="http://schemas.openxmlformats.org/drawingml/2006/main" xmlns:p="http://schemas.openxmlformats.org/presentationml/2006/main" xmlns:r="http://schemas.openxmlformats.org/officeDocument/2006/relationships">
+  <p:cSld>
+    <p:spTree>
+      <p:nvGrpSpPr>
+        <p:cNvPr id="1" name=""/>
+        <p:cNvGrpSpPr/>
+        <p:nvPr/>
+      </p:nvGrpSpPr>
+      <p:grpSpPr>
+        <a:xfrm>
+          <a:off x="0" y="0"/>
+          <a:ext cx="0" cy="0"/>
+          <a:chOff x="0" y="0"/>
+          <a:chExt cx="0" cy="0"/>
+        </a:xfrm>
+      </p:grpSpPr>
+      <p:sp>
+        <p:nvSpPr>
+          <p:cNvPr id="2" name="Slide Image Placeholder 1"/>
+          <p:cNvSpPr>
+            <a:spLocks noGrp="1"/>
+          </p:cNvSpPr>
+          <p:nvPr>
+            <p:ph type="sldImg" idx="2"/>
+          </p:nvPr>
+        </p:nvSpPr>
+        <p:spPr/>
+      </p:sp>
+      <p:sp>
+        <p:nvSpPr>
+          <p:cNvPr id="3" name="Notes Placeholder 2"/>
+          <p:cNvSpPr>
+            <a:spLocks noGrp="1"/>
+          </p:cNvSpPr>
+          <p:nvPr>
+            <p:ph type="body" idx="3" sz="quarter"/>
+          </p:nvPr>
+        </p:nvSpPr>
+        <p:spPr/>
+        <p:txBody>
+          <a:bodyPr/>
+          <a:lstStyle/>
+          <a:p>
+            <a:r>
+              <a:t>편집 참고용 슬라이드입니다. 영상에는 쓰지 않아도 됩니다.</a:t>
+            </a:r>
+          </a:p>
+          <a:p>
+            <a:r>
+              <a:t>원문 영어 문장을 그대로 발췌했으므로 번역·검수 후 사용하세요.</a:t>
+            </a:r>
+          </a:p>
+        </p:txBody>
+      </p:sp>
+      <p:sp>
+        <p:nvSpPr>
+          <p:cNvPr id="4" name="Slide Number Placeholder 3"/>
+          <p:cNvSpPr>
+            <a:spLocks noGrp="1"/>
+          </p:cNvSpPr>
+          <p:nvPr>
+            <p:ph type="sldNum" idx="5" sz="quarter"/>
+          </p:nvPr>
+        </p:nvSpPr>
+        <p:spPr/>
+      </p:sp>
+    </p:spTree>
+  </p:cSld>
+  <p:clrMapOvr>
+    <a:masterClrMapping/>
+  </p:clrMapOvr>
+</p:notes>
+</file>
+
+<file path=ppt/notesSlides/notesSlide8.xml><?xml version="1.0" encoding="utf-8"?>
 <p:notes xmlns:a="http://schemas.openxmlformats.org/drawingml/2006/main" xmlns:p="http://schemas.openxmlformats.org/presentationml/2006/main" xmlns:r="http://schemas.openxmlformats.org/officeDocument/2006/relationships">
   <p:cSld>
     <p:spTree>
@@ -4038,7 +4114,7 @@
                 </a:solidFill>
                 <a:latin typeface="Arial"/>
               </a:rPr>
-              <a:t>EXPERT OPINION ON BIOLOGICAL THERAPY</a:t>
+              <a:t>LASERS IN MEDICAL SCIENCE</a:t>
             </a:r>
           </a:p>
         </p:txBody>
@@ -4073,7 +4149,7 @@
                 </a:solidFill>
                 <a:latin typeface="Arial"/>
               </a:rPr>
-              <a:t>원형탈모</a:t>
+              <a:t>9.2%</a:t>
             </a:r>
           </a:p>
         </p:txBody>
@@ -4108,7 +4184,7 @@
                 </a:solidFill>
                 <a:latin typeface="Arial"/>
               </a:rPr>
-              <a:t>오늘 나온 최신 연구를 정리했습니다</a:t>
+              <a:t>이 숫자, 탈모 연구가 새로 내놨습니다</a:t>
             </a:r>
           </a:p>
         </p:txBody>
@@ -4143,7 +4219,7 @@
                 </a:solidFill>
                 <a:latin typeface="Arial"/>
               </a:rPr>
-              <a:t>2026 Oct 21  |  매일 아침 탈모 연구 한 편</a:t>
+              <a:t>2026 Oct 22  |  매일 아침 탈모 연구 한 편</a:t>
             </a:r>
           </a:p>
         </p:txBody>
@@ -4228,7 +4304,7 @@
                 </a:solidFill>
                 <a:latin typeface="Arial"/>
               </a:rPr>
-              <a:t>Biologics in alopecia areata: promise, paradox, and the precision medicine frontier</a:t>
+              <a:t>Thulium laser-assisted delivery of growth factors for treating androgenetic alopecia - a randomized, controlled, clinical study</a:t>
             </a:r>
           </a:p>
         </p:txBody>
@@ -4263,7 +4339,7 @@
                 </a:solidFill>
                 <a:latin typeface="Arial"/>
               </a:rPr>
-              <a:t>Expert opinion on biological therapy  ·  2026 Oct 21</a:t>
+              <a:t>Lasers in medical science  ·  2026 Oct 22</a:t>
             </a:r>
           </a:p>
         </p:txBody>
@@ -4392,7 +4468,7 @@
                 </a:solidFill>
                 <a:latin typeface="Arial"/>
               </a:rPr>
-              <a:t>Areas covered: This review evaluates the immunopathogenic rationale and available clinical evidence for biologic therapies in AA, including inhibitors of tumor necrosis factor (TNF), interleukin-4 receptor α subunit (IL-4 Rα), IL-17, and IL-23.</a:t>
+              <a:t>Androgenetic alopecia (AGA) is the most common form of hair loss and can significantly impact quality of life.</a:t>
             </a:r>
           </a:p>
         </p:txBody>
@@ -4521,7 +4597,7 @@
                 </a:solidFill>
                 <a:latin typeface="Arial"/>
               </a:rPr>
-              <a:t>Relevant literature was identified through PubMed and ClinicalTrials.gov (last search: 17 October 2026).</a:t>
+              <a:t>Emerging non-invasive treatments include laser-assisted delivery of biomimetic growth factor-based serums.</a:t>
             </a:r>
           </a:p>
         </p:txBody>
@@ -4842,9 +4918,7 @@
                 </a:solidFill>
                 <a:latin typeface="Arial"/>
               </a:rPr>
-              <a:t>· Introduction: Alopecia areata (AA) is a chronic, immune-mediated non-scarring hair loss affecting approximately 2% of the population.
-· The approval of oral JAK inhibitors has established targeted systemic therapy for moderate-to-severe AA.
-· Incomplete response rates, relapse upon treatment discontinuation, and safety contraindications, however, leave a substantial proportion of patients requiring alternative options.</a:t>
+              <a:t>· Emerging non-invasive treatments include laser-assisted delivery of biomimetic growth factor-based serums.</a:t>
             </a:r>
           </a:p>
         </p:txBody>
@@ -4879,7 +4953,7 @@
                 </a:solidFill>
                 <a:latin typeface="Arial"/>
               </a:rPr>
-              <a:t>◆ 주요 결과 — Results (자동 구분)</a:t>
+              <a:t>◆ 연구 방법 — Methods (자동 구분)</a:t>
             </a:r>
           </a:p>
         </p:txBody>
@@ -4914,12 +4988,8 @@
                 </a:solidFill>
                 <a:latin typeface="Arial"/>
               </a:rPr>
-              <a:t>· Areas covered: This review evaluates the immunopathogenic rationale and available clinical evidence for biologic therapies in AA, including inhibitors of tumor necrosis factor (TNF), interleukin-4 receptor α subunit (IL-4 Rα), IL-17, and IL-23.
-· Relevant literature was identified through PubMed and ClinicalTrials.gov (last search: 17 October 2026).
-· Expert opinion: No biologic has demonstrated efficacy in an adequately powered randomized controlled trial in AA.
-· A phase 2a randomized trial of dupilumab showed modest efficacy, most pronounced in patients with elevated baseline IgE.
-· Paradoxically, TNF, IL-17, and IL-23 inhibitors have been implicated in drug-induced AA, a hypothesis-generating observation that warrants cautious interpretation.
-· Given the higher bar set by JAK inhibitors and the risk of paradoxical disease, currently available cytokine-targeting biologics cannot be recommended for AA outside of clinical trials.</a:t>
+              <a:t>· The aim of the study was to evaluate the safety and efficacy of non-ablative fractional laser (NAFL)-assisted delivery, with or without adjunct red light therapy, in patients with AGA.
+· In this pilot study, patients were randomly assigned to: (I) NAFL-assisted serum delivery plus red light therapy (triple), (II) NAFL-assisted serum delivery alone (dual), or (III) NAFL plus red light therapy without serum (EBD-only).</a:t>
             </a:r>
           </a:p>
         </p:txBody>
@@ -4958,6 +5028,142 @@
         </p:nvSpPr>
         <p:spPr>
           <a:xfrm>
+            <a:off x="365760" y="457200"/>
+            <a:ext cx="4828032" cy="457200"/>
+          </a:xfrm>
+          <a:prstGeom prst="rect">
+            <a:avLst/>
+          </a:prstGeom>
+          <a:noFill/>
+        </p:spPr>
+        <p:txBody>
+          <a:bodyPr wrap="square" anchor="ctr">
+            <a:spAutoFit/>
+          </a:bodyPr>
+          <a:lstStyle/>
+          <a:p>
+            <a:pPr algn="l"/>
+            <a:r>
+              <a:rPr sz="1600" b="1">
+                <a:solidFill>
+                  <a:srgbClr val="FF6B6B"/>
+                </a:solidFill>
+                <a:latin typeface="Arial"/>
+              </a:rPr>
+              <a:t>본문 요약 (편집용)</a:t>
+            </a:r>
+          </a:p>
+        </p:txBody>
+      </p:sp>
+      <p:sp>
+        <p:nvSpPr>
+          <p:cNvPr id="3" name="TextBox 2"/>
+          <p:cNvSpPr txBox="1"/>
+          <p:nvPr/>
+        </p:nvSpPr>
+        <p:spPr>
+          <a:xfrm>
+            <a:off x="365760" y="1097280"/>
+            <a:ext cx="4828032" cy="457200"/>
+          </a:xfrm>
+          <a:prstGeom prst="rect">
+            <a:avLst/>
+          </a:prstGeom>
+          <a:noFill/>
+        </p:spPr>
+        <p:txBody>
+          <a:bodyPr wrap="square" anchor="t">
+            <a:spAutoFit/>
+          </a:bodyPr>
+          <a:lstStyle/>
+          <a:p>
+            <a:pPr algn="l"/>
+            <a:r>
+              <a:rPr sz="1300" b="1">
+                <a:solidFill>
+                  <a:srgbClr val="FFFFFF"/>
+                </a:solidFill>
+                <a:latin typeface="Arial"/>
+              </a:rPr>
+              <a:t>◆ 주요 결과 — Results (자동 구분)</a:t>
+            </a:r>
+          </a:p>
+        </p:txBody>
+      </p:sp>
+      <p:sp>
+        <p:nvSpPr>
+          <p:cNvPr id="4" name="TextBox 3"/>
+          <p:cNvSpPr txBox="1"/>
+          <p:nvPr/>
+        </p:nvSpPr>
+        <p:spPr>
+          <a:xfrm>
+            <a:off x="457200" y="1600200"/>
+            <a:ext cx="4736592" cy="3566160"/>
+          </a:xfrm>
+          <a:prstGeom prst="rect">
+            <a:avLst/>
+          </a:prstGeom>
+          <a:noFill/>
+        </p:spPr>
+        <p:txBody>
+          <a:bodyPr wrap="square" anchor="t">
+            <a:spAutoFit/>
+          </a:bodyPr>
+          <a:lstStyle/>
+          <a:p>
+            <a:pPr algn="l"/>
+            <a:r>
+              <a:rPr sz="1000" b="0">
+                <a:solidFill>
+                  <a:srgbClr val="D5D8EA"/>
+                </a:solidFill>
+                <a:latin typeface="Arial"/>
+              </a:rPr>
+              <a:t>· Androgenetic alopecia (AGA) is the most common form of hair loss and can significantly impact quality of life.
+· Primary outcomes were hair density and thickness.
+· Secondary outcomes included patient satisfaction, tolerability, and adverse events.
+· Hair density increased in all groups, with greater improvement in the triple (25.6 ± 7.0 %) and dual (22.7 ± 3.4 %) groups compared to EBD-only (4.9 ± 9.2 %).
+· Hair thickness improved in both serum groups but not in the EBD-only group.
+· Clinical outcomes were similar between triple and dual treatments, though satisfaction was higher with triple therapy.</a:t>
+            </a:r>
+          </a:p>
+        </p:txBody>
+      </p:sp>
+    </p:spTree>
+  </p:cSld>
+  <p:clrMapOvr>
+    <a:masterClrMapping/>
+  </p:clrMapOvr>
+</p:sld>
+</file>
+
+<file path=ppt/slides/slide9.xml><?xml version="1.0" encoding="utf-8"?>
+<p:sld xmlns:a="http://schemas.openxmlformats.org/drawingml/2006/main" xmlns:p="http://schemas.openxmlformats.org/presentationml/2006/main" xmlns:r="http://schemas.openxmlformats.org/officeDocument/2006/relationships">
+  <p:cSld>
+    <p:bg>
+      <p:bgPr>
+        <a:solidFill>
+          <a:srgbClr val="12142A"/>
+        </a:solidFill>
+        <a:effectLst/>
+      </p:bgPr>
+    </p:bg>
+    <p:spTree>
+      <p:nvGrpSpPr>
+        <p:cNvPr id="1" name=""/>
+        <p:cNvGrpSpPr/>
+        <p:nvPr/>
+      </p:nvGrpSpPr>
+      <p:grpSpPr/>
+      <p:sp>
+        <p:nvSpPr>
+          <p:cNvPr id="2" name="TextBox 1"/>
+          <p:cNvSpPr txBox="1"/>
+          <p:nvPr/>
+        </p:nvSpPr>
+        <p:spPr>
+          <a:xfrm>
             <a:off x="365760" y="731520"/>
             <a:ext cx="4828032" cy="548640"/>
           </a:xfrm>
@@ -5016,9 +5222,9 @@
                 <a:latin typeface="Arial"/>
               </a:rPr>
               <a:t>[출처]
-논문: Biologics in alopecia areata: promise, paradox, and the precision medicine frontier
-게재: Expert opinion on biological therapy
-원문: https://pubmed.ncbi.nlm.nih.gov/42904500/
+논문: Thulium laser-assisted delivery of growth factors for treating androgenetic alopecia - a randomized, controlled, clinical study
+게재: Lasers in medical science
+원문: https://pubmed.ncbi.nlm.nih.gov/42911445/
 [이미지 출처]
 - Male pattern baldness.jpg / Originally uploaded by Lkinkade (Transferred by XenonX3) / CC BY-SA 2.5
   https://commons.wikimedia.org/wiki/File:Male_pattern_baldness.jpg

</xml_diff>

<commit_message>
chore: daily content 2026-10-25
</commit_message>
<xml_diff>
--- a/pwa/data/latest/slides.pptx
+++ b/pwa/data/latest/slides.pptx
@@ -14,6 +14,7 @@
     <p:sldId id="262" r:id="rId14"/>
     <p:sldId id="263" r:id="rId15"/>
     <p:sldId id="264" r:id="rId16"/>
+    <p:sldId id="265" r:id="rId17"/>
   </p:sldIdLst>
   <p:sldSz cx="5559552" cy="9875520" type="screen4x3"/>
   <p:notesSz cx="6858000" cy="9144000"/>
@@ -515,7 +516,7 @@
           </a:p>
           <a:p>
             <a:r>
-              <a:t>대본: 9.2% 이 숫자, 탈모 연구가 새로 내놨습니다</a:t>
+              <a:t>대본: 오늘의 논문 Supportive care in cancer에 실린 새 연구입니다</a:t>
             </a:r>
           </a:p>
           <a:p>
@@ -595,7 +596,7 @@
           </a:p>
           <a:p>
             <a:r>
-              <a:t>대본: 《Lasers in medical science》 - Thulium laser-assisted delivery of growth factors for treating androgenetic alopecia - a randomized, controlled, clinical study</a:t>
+              <a:t>대본: 《Supportive care in cancer : official journal of the Multinational Association of Supportive Care in Cancer》 - Evaluating disparities in counseling and resources for chemotherapy-induced hair loss: qualitative analysis of a survey-based approach</a:t>
             </a:r>
           </a:p>
           <a:p>
@@ -675,7 +676,7 @@
           </a:p>
           <a:p>
             <a:r>
-              <a:t>대본: Androgenetic alopecia (AGA) is the most common form of hair loss and can significantly impact quality of life.</a:t>
+              <a:t>대본: Purpose: Chemotherapy-induced alopecia (CIA) is a distressing side effect of cancer treatment that significantly impacts patients' quality of life.</a:t>
             </a:r>
           </a:p>
           <a:p>
@@ -755,7 +756,7 @@
           </a:p>
           <a:p>
             <a:r>
-              <a:t>대본: Emerging non-invasive treatments include laser-assisted delivery of biomimetic growth factor-based serums.</a:t>
+              <a:t>대본: Methods: We conducted a mixed-methods, cross-sectional survey study of 101 adults who had received chemotherapy and experienced hair loss.</a:t>
             </a:r>
           </a:p>
           <a:p>
@@ -1021,6 +1022,81 @@
 </file>
 
 <file path=ppt/notesSlides/notesSlide8.xml><?xml version="1.0" encoding="utf-8"?>
+<p:notes xmlns:a="http://schemas.openxmlformats.org/drawingml/2006/main" xmlns:p="http://schemas.openxmlformats.org/presentationml/2006/main" xmlns:r="http://schemas.openxmlformats.org/officeDocument/2006/relationships">
+  <p:cSld>
+    <p:spTree>
+      <p:nvGrpSpPr>
+        <p:cNvPr id="1" name=""/>
+        <p:cNvGrpSpPr/>
+        <p:nvPr/>
+      </p:nvGrpSpPr>
+      <p:grpSpPr>
+        <a:xfrm>
+          <a:off x="0" y="0"/>
+          <a:ext cx="0" cy="0"/>
+          <a:chOff x="0" y="0"/>
+          <a:chExt cx="0" cy="0"/>
+        </a:xfrm>
+      </p:grpSpPr>
+      <p:sp>
+        <p:nvSpPr>
+          <p:cNvPr id="2" name="Slide Image Placeholder 1"/>
+          <p:cNvSpPr>
+            <a:spLocks noGrp="1"/>
+          </p:cNvSpPr>
+          <p:nvPr>
+            <p:ph type="sldImg" idx="2"/>
+          </p:nvPr>
+        </p:nvSpPr>
+        <p:spPr/>
+      </p:sp>
+      <p:sp>
+        <p:nvSpPr>
+          <p:cNvPr id="3" name="Notes Placeholder 2"/>
+          <p:cNvSpPr>
+            <a:spLocks noGrp="1"/>
+          </p:cNvSpPr>
+          <p:nvPr>
+            <p:ph type="body" idx="3" sz="quarter"/>
+          </p:nvPr>
+        </p:nvSpPr>
+        <p:spPr/>
+        <p:txBody>
+          <a:bodyPr/>
+          <a:lstStyle/>
+          <a:p>
+            <a:r>
+              <a:t>편집 참고용 슬라이드입니다. 영상에는 쓰지 않아도 됩니다.</a:t>
+            </a:r>
+          </a:p>
+          <a:p>
+            <a:r>
+              <a:t>원문 영어 문장을 그대로 발췌했으므로 번역·검수 후 사용하세요.</a:t>
+            </a:r>
+          </a:p>
+        </p:txBody>
+      </p:sp>
+      <p:sp>
+        <p:nvSpPr>
+          <p:cNvPr id="4" name="Slide Number Placeholder 3"/>
+          <p:cNvSpPr>
+            <a:spLocks noGrp="1"/>
+          </p:cNvSpPr>
+          <p:nvPr>
+            <p:ph type="sldNum" idx="5" sz="quarter"/>
+          </p:nvPr>
+        </p:nvSpPr>
+        <p:spPr/>
+      </p:sp>
+    </p:spTree>
+  </p:cSld>
+  <p:clrMapOvr>
+    <a:masterClrMapping/>
+  </p:clrMapOvr>
+</p:notes>
+</file>
+
+<file path=ppt/notesSlides/notesSlide9.xml><?xml version="1.0" encoding="utf-8"?>
 <p:notes xmlns:a="http://schemas.openxmlformats.org/drawingml/2006/main" xmlns:p="http://schemas.openxmlformats.org/presentationml/2006/main" xmlns:r="http://schemas.openxmlformats.org/officeDocument/2006/relationships">
   <p:cSld>
     <p:spTree>
@@ -4114,7 +4190,7 @@
                 </a:solidFill>
                 <a:latin typeface="Arial"/>
               </a:rPr>
-              <a:t>LASERS IN MEDICAL SCIENCE</a:t>
+              <a:t>SUPPORTIVE CARE IN CANCER : OFFICIAL JOU</a:t>
             </a:r>
           </a:p>
         </p:txBody>
@@ -4149,7 +4225,7 @@
                 </a:solidFill>
                 <a:latin typeface="Arial"/>
               </a:rPr>
-              <a:t>9.2%</a:t>
+              <a:t>오늘의 논문</a:t>
             </a:r>
           </a:p>
         </p:txBody>
@@ -4184,7 +4260,7 @@
                 </a:solidFill>
                 <a:latin typeface="Arial"/>
               </a:rPr>
-              <a:t>이 숫자, 탈모 연구가 새로 내놨습니다</a:t>
+              <a:t>Supportive care in cancer에 실린 새 연구입니다</a:t>
             </a:r>
           </a:p>
         </p:txBody>
@@ -4220,6 +4296,118 @@
                 <a:latin typeface="Arial"/>
               </a:rPr>
               <a:t>2026 Oct 22  |  매일 아침 탈모 연구 한 편</a:t>
+            </a:r>
+          </a:p>
+        </p:txBody>
+      </p:sp>
+    </p:spTree>
+  </p:cSld>
+  <p:clrMapOvr>
+    <a:masterClrMapping/>
+  </p:clrMapOvr>
+</p:sld>
+</file>
+
+<file path=ppt/slides/slide10.xml><?xml version="1.0" encoding="utf-8"?>
+<p:sld xmlns:a="http://schemas.openxmlformats.org/drawingml/2006/main" xmlns:p="http://schemas.openxmlformats.org/presentationml/2006/main" xmlns:r="http://schemas.openxmlformats.org/officeDocument/2006/relationships">
+  <p:cSld>
+    <p:bg>
+      <p:bgPr>
+        <a:solidFill>
+          <a:srgbClr val="12142A"/>
+        </a:solidFill>
+        <a:effectLst/>
+      </p:bgPr>
+    </p:bg>
+    <p:spTree>
+      <p:nvGrpSpPr>
+        <p:cNvPr id="1" name=""/>
+        <p:cNvGrpSpPr/>
+        <p:nvPr/>
+      </p:nvGrpSpPr>
+      <p:grpSpPr/>
+      <p:sp>
+        <p:nvSpPr>
+          <p:cNvPr id="2" name="TextBox 1"/>
+          <p:cNvSpPr txBox="1"/>
+          <p:nvPr/>
+        </p:nvSpPr>
+        <p:spPr>
+          <a:xfrm>
+            <a:off x="365760" y="731520"/>
+            <a:ext cx="4828032" cy="548640"/>
+          </a:xfrm>
+          <a:prstGeom prst="rect">
+            <a:avLst/>
+          </a:prstGeom>
+          <a:noFill/>
+        </p:spPr>
+        <p:txBody>
+          <a:bodyPr wrap="square" anchor="ctr">
+            <a:spAutoFit/>
+          </a:bodyPr>
+          <a:lstStyle/>
+          <a:p>
+            <a:pPr algn="ctr"/>
+            <a:r>
+              <a:rPr sz="2200" b="1">
+                <a:solidFill>
+                  <a:srgbClr val="FF6B6B"/>
+                </a:solidFill>
+                <a:latin typeface="Arial"/>
+              </a:rPr>
+              <a:t>출처</a:t>
+            </a:r>
+          </a:p>
+        </p:txBody>
+      </p:sp>
+      <p:sp>
+        <p:nvSpPr>
+          <p:cNvPr id="3" name="TextBox 2"/>
+          <p:cNvSpPr txBox="1"/>
+          <p:nvPr/>
+        </p:nvSpPr>
+        <p:spPr>
+          <a:xfrm>
+            <a:off x="365760" y="1463040"/>
+            <a:ext cx="4828032" cy="7680960"/>
+          </a:xfrm>
+          <a:prstGeom prst="rect">
+            <a:avLst/>
+          </a:prstGeom>
+          <a:noFill/>
+        </p:spPr>
+        <p:txBody>
+          <a:bodyPr wrap="square" anchor="t">
+            <a:spAutoFit/>
+          </a:bodyPr>
+          <a:lstStyle/>
+          <a:p>
+            <a:pPr algn="l"/>
+            <a:r>
+              <a:rPr sz="1000" b="0">
+                <a:solidFill>
+                  <a:srgbClr val="D5D8EA"/>
+                </a:solidFill>
+                <a:latin typeface="Arial"/>
+              </a:rPr>
+              <a:t>[출처]
+논문: Evaluating disparities in counseling and resources for chemotherapy-induced hair loss: qualitative analysis of a survey-based approach
+게재: Supportive care in cancer : official journal of the Multinational Association of Supportive Care in Cancer
+원문: https://pubmed.ncbi.nlm.nih.gov/42911279/
+[이미지 출처]
+- Male pattern baldness.jpg / Originally uploaded by Lkinkade (Transferred by XenonX3) / CC BY-SA 2.5
+  https://commons.wikimedia.org/wiki/File:Male_pattern_baldness.jpg
+- Male-pattern hair loss.jpg / BlaiserPascal / CC BY-SA 4.0
+  https://commons.wikimedia.org/wiki/File:Male-pattern_hair_loss.jpg
+※ CC BY-SA 이미지가 포함되어 있습니다. 저작자 표시가 필수이며,
+  동일조건변경허락(ShareAlike) 조항이 영상 전체에 적용될 수 있으니
+  상업적 이용 시 해당 이미지를 교체하는 편이 안전합니다.
+[논문 본문 그림·표]
+- PubMed Central PMC13690825 (재사용 가능 라이선스)
+  https://www.ncbi.nlm.nih.gov/pmc/articles/PMC13690825/
+  ※ 오픈액세스 논문의 그림·표이며, 위 원문 출처를 함께 표기하세요.
+</a:t>
             </a:r>
           </a:p>
         </p:txBody>
@@ -4304,7 +4492,7 @@
                 </a:solidFill>
                 <a:latin typeface="Arial"/>
               </a:rPr>
-              <a:t>Thulium laser-assisted delivery of growth factors for treating androgenetic alopecia - a randomized, controlled, clinical study</a:t>
+              <a:t>Evaluating disparities in counseling and resources for chemotherapy-induced hair loss: qualitative analysis of a survey-based approach</a:t>
             </a:r>
           </a:p>
         </p:txBody>
@@ -4339,7 +4527,7 @@
                 </a:solidFill>
                 <a:latin typeface="Arial"/>
               </a:rPr>
-              <a:t>Lasers in medical science  ·  2026 Oct 22</a:t>
+              <a:t>Supportive care in cancer : official journal of the Multinational Association of Supportive Care in Cancer  ·  2026 Oct 22</a:t>
             </a:r>
           </a:p>
         </p:txBody>
@@ -4468,7 +4656,7 @@
                 </a:solidFill>
                 <a:latin typeface="Arial"/>
               </a:rPr>
-              <a:t>Androgenetic alopecia (AGA) is the most common form of hair loss and can significantly impact quality of life.</a:t>
+              <a:t>Purpose: Chemotherapy-induced alopecia (CIA) is a distressing side effect of cancer treatment that significantly impacts patients' quality of life.</a:t>
             </a:r>
           </a:p>
         </p:txBody>
@@ -4597,7 +4785,7 @@
                 </a:solidFill>
                 <a:latin typeface="Arial"/>
               </a:rPr>
-              <a:t>Emerging non-invasive treatments include laser-assisted delivery of biomimetic growth factor-based serums.</a:t>
+              <a:t>Methods: We conducted a mixed-methods, cross-sectional survey study of 101 adults who had received chemotherapy and experienced hair loss.</a:t>
             </a:r>
           </a:p>
         </p:txBody>
@@ -4883,7 +5071,7 @@
                 </a:solidFill>
                 <a:latin typeface="Arial"/>
               </a:rPr>
-              <a:t>◆ 배경 — Background (자동 구분)</a:t>
+              <a:t>◆ 배경 — Introduction and background</a:t>
             </a:r>
           </a:p>
         </p:txBody>
@@ -4918,7 +5106,9 @@
                 </a:solidFill>
                 <a:latin typeface="Arial"/>
               </a:rPr>
-              <a:t>· Emerging non-invasive treatments include laser-assisted delivery of biomimetic growth factor-based serums.</a:t>
+              <a:t>· Chemotherapy-induced hair loss, also referred to as chemotherapy-induced alopecia (CIA), is one of the most visible and emotionally distressing side effects of cancer treatment.
+· Prior research has documented associations between hair loss and reduced quality of life, body image concerns, and psychosocial distress, underscoring the clinical importance of addressing CIA as part of comprehensive cancer care.
+· Beyond physical appearance, hair loss can disrupt patients’ sense of privacy and social identity, serving as a visible marker of illness that persists throughout treatment and recovery.</a:t>
             </a:r>
           </a:p>
         </p:txBody>
@@ -4953,7 +5143,7 @@
                 </a:solidFill>
                 <a:latin typeface="Arial"/>
               </a:rPr>
-              <a:t>◆ 연구 방법 — Methods (자동 구분)</a:t>
+              <a:t>◆ 연구 방법 — Methods</a:t>
             </a:r>
           </a:p>
         </p:txBody>
@@ -4988,8 +5178,9 @@
                 </a:solidFill>
                 <a:latin typeface="Arial"/>
               </a:rPr>
-              <a:t>· The aim of the study was to evaluate the safety and efficacy of non-ablative fractional laser (NAFL)-assisted delivery, with or without adjunct red light therapy, in patients with AGA.
-· In this pilot study, patients were randomly assigned to: (I) NAFL-assisted serum delivery plus red light therapy (triple), (II) NAFL-assisted serum delivery alone (dual), or (III) NAFL plus red light therapy without serum (EBD-only).</a:t>
+              <a:t>· Eligible participants included adult individuals (at least 18 years old) who had received chemotherapy and experienced hair loss.
+· A total of 101 individuals participated in the survey study.
+· The survey was open from January to May 2025.</a:t>
             </a:r>
           </a:p>
         </p:txBody>
@@ -5085,7 +5276,7 @@
                 </a:solidFill>
                 <a:latin typeface="Arial"/>
               </a:rPr>
-              <a:t>◆ 주요 결과 — Results (자동 구분)</a:t>
+              <a:t>◆ 주요 결과 — Results</a:t>
             </a:r>
           </a:p>
         </p:txBody>
@@ -5120,12 +5311,86 @@
                 </a:solidFill>
                 <a:latin typeface="Arial"/>
               </a:rPr>
-              <a:t>· Androgenetic alopecia (AGA) is the most common form of hair loss and can significantly impact quality of life.
-· Primary outcomes were hair density and thickness.
-· Secondary outcomes included patient satisfaction, tolerability, and adverse events.
-· Hair density increased in all groups, with greater improvement in the triple (25.6 ± 7.0 %) and dual (22.7 ± 3.4 %) groups compared to EBD-only (4.9 ± 9.2 %).
-· Hair thickness improved in both serum groups but not in the EBD-only group.
-· Clinical outcomes were similar between triple and dual treatments, though satisfaction was higher with triple therapy.</a:t>
+              <a:t>· A total of 101 participants completed the survey.
+· Most participants had completed at least a bachelor’s degree (74.3%), and 56.4% were employed either full time or part time.
+· Among participants who reported household income (n = 99), 57.6% reported an annual household income of $100,000 or greater.
+· Open-ended survey responses revealed 11 distinct themes reflecting patients’ experiences with chemotherapy-induced hair loss, counseling, and access to supportive resources.
+· If I had had to pay for it, I don’t know if I could’ve afforded it.”“I wish it had been covered by insurance.”“I was Medicaid pending when I started treatment.”“My insurance requires preauthorization for a wig, which I didn’t know before purchasing one.”Logistical burdens and institutional limitations.Scalp cooling often required extensive coordination—dry ice, caregiver help, and long infusion times—and many centers lacked equipment, training, or support staff, making it difficult to implement effectively.“Professional systems are not available at my treatment center… then I’d still have to trudge in 60 pounds or so of dry ice each time.”“I wish my facility had capping machines so we didn’t have to take the machine back and forth.”“The process was exhausting, especially the post-infusion cooling.”“Nurses didn’t really know how to use the machine and seemed to be burdened.”“The self caps don’t stay cold long enough.”Scalp cooling effectiveness and treatment experience.Patients reported mixed outcomes with scalp cooling, ranging from successful partial retention to complete failure.
+· Scalp cooling often required extensive coordination—dry ice, caregiver help, and long infusion times—and many centers lacked equipment, training, or support staff, making it difficult to implement effectively.“Professional systems are not available at my treatment center… then I’d still have to trudge in 60 pounds or so of dry ice each time.”“I wish my facility had capping machines so we didn’t have to take the machine back and forth.”“The process was exhausting, especially the post-infusion cooling.”“Nurses didn’t really know how to use the machine and seemed to be burdened.”“The self caps don’t stay cold long enough.”
+· “Professional systems are not available at my treatment center… then I’d still have to trudge in 60 pounds or so of dry ice each time.”</a:t>
+            </a:r>
+          </a:p>
+        </p:txBody>
+      </p:sp>
+      <p:sp>
+        <p:nvSpPr>
+          <p:cNvPr id="5" name="TextBox 4"/>
+          <p:cNvSpPr txBox="1"/>
+          <p:nvPr/>
+        </p:nvSpPr>
+        <p:spPr>
+          <a:xfrm>
+            <a:off x="365760" y="5303520"/>
+            <a:ext cx="4828032" cy="457200"/>
+          </a:xfrm>
+          <a:prstGeom prst="rect">
+            <a:avLst/>
+          </a:prstGeom>
+          <a:noFill/>
+        </p:spPr>
+        <p:txBody>
+          <a:bodyPr wrap="square" anchor="t">
+            <a:spAutoFit/>
+          </a:bodyPr>
+          <a:lstStyle/>
+          <a:p>
+            <a:pPr algn="l"/>
+            <a:r>
+              <a:rPr sz="1300" b="1">
+                <a:solidFill>
+                  <a:srgbClr val="FFFFFF"/>
+                </a:solidFill>
+                <a:latin typeface="Arial"/>
+              </a:rPr>
+              <a:t>◆ 고찰 — Discussion</a:t>
+            </a:r>
+          </a:p>
+        </p:txBody>
+      </p:sp>
+      <p:sp>
+        <p:nvSpPr>
+          <p:cNvPr id="6" name="TextBox 5"/>
+          <p:cNvSpPr txBox="1"/>
+          <p:nvPr/>
+        </p:nvSpPr>
+        <p:spPr>
+          <a:xfrm>
+            <a:off x="457200" y="5806440"/>
+            <a:ext cx="4736592" cy="3566160"/>
+          </a:xfrm>
+          <a:prstGeom prst="rect">
+            <a:avLst/>
+          </a:prstGeom>
+          <a:noFill/>
+        </p:spPr>
+        <p:txBody>
+          <a:bodyPr wrap="square" anchor="t">
+            <a:spAutoFit/>
+          </a:bodyPr>
+          <a:lstStyle/>
+          <a:p>
+            <a:pPr algn="l"/>
+            <a:r>
+              <a:rPr sz="1000" b="0">
+                <a:solidFill>
+                  <a:srgbClr val="D5D8EA"/>
+                </a:solidFill>
+                <a:latin typeface="Arial"/>
+              </a:rPr>
+              <a:t>· A survey study of oncologists and dermatologists (n = 103) found significant differences in how CIA was viewed.
+· Another study of oncologists (n = 155) found that 67.1% of providers felt that all patients should be offered scalp cooling therapy, but only 26.3% report regularly initiating conversations about scalp cooling therapy and only 36% felt that scalp cooling benefits were worth the effort and cost involved.
+· A survey study of women in Facebook groups created for scalp cooling therapy users (n = 219) found that key motivations for utilizing social media in scalp cooling therapy included to gain support from others going through a similar experience (88.1% of participants), to receive scalp cooling instructions (82.2%), and to learn about the scalp cooling therapy outcomes of other patients (69.9%).
+· In a study of 179 patients undergoing chemotherapy, 56.4% reported that hair loss was the worst side effect, with 11.7% finding it worse than the disease itself and 16.2% reporting that hair loss would have made them stop chemotherapy if it was not a life-saving treatment.</a:t>
             </a:r>
           </a:p>
         </p:txBody>
@@ -5164,8 +5429,8 @@
         </p:nvSpPr>
         <p:spPr>
           <a:xfrm>
-            <a:off x="365760" y="731520"/>
-            <a:ext cx="4828032" cy="548640"/>
+            <a:off x="365760" y="457200"/>
+            <a:ext cx="4828032" cy="457200"/>
           </a:xfrm>
           <a:prstGeom prst="rect">
             <a:avLst/>
@@ -5178,15 +5443,15 @@
           </a:bodyPr>
           <a:lstStyle/>
           <a:p>
-            <a:pPr algn="ctr"/>
-            <a:r>
-              <a:rPr sz="2200" b="1">
+            <a:pPr algn="l"/>
+            <a:r>
+              <a:rPr sz="1600" b="1">
                 <a:solidFill>
                   <a:srgbClr val="FF6B6B"/>
                 </a:solidFill>
                 <a:latin typeface="Arial"/>
               </a:rPr>
-              <a:t>출처</a:t>
+              <a:t>본문 요약 (편집용)</a:t>
             </a:r>
           </a:p>
         </p:txBody>
@@ -5199,8 +5464,8 @@
         </p:nvSpPr>
         <p:spPr>
           <a:xfrm>
-            <a:off x="365760" y="1463040"/>
-            <a:ext cx="4828032" cy="7680960"/>
+            <a:off x="365760" y="1097280"/>
+            <a:ext cx="4828032" cy="457200"/>
           </a:xfrm>
           <a:prstGeom prst="rect">
             <a:avLst/>
@@ -5215,25 +5480,50 @@
           <a:p>
             <a:pPr algn="l"/>
             <a:r>
+              <a:rPr sz="1300" b="1">
+                <a:solidFill>
+                  <a:srgbClr val="FFFFFF"/>
+                </a:solidFill>
+                <a:latin typeface="Arial"/>
+              </a:rPr>
+              <a:t>◆ 결론 — Conclusion</a:t>
+            </a:r>
+          </a:p>
+        </p:txBody>
+      </p:sp>
+      <p:sp>
+        <p:nvSpPr>
+          <p:cNvPr id="4" name="TextBox 3"/>
+          <p:cNvSpPr txBox="1"/>
+          <p:nvPr/>
+        </p:nvSpPr>
+        <p:spPr>
+          <a:xfrm>
+            <a:off x="457200" y="1600200"/>
+            <a:ext cx="4736592" cy="3566160"/>
+          </a:xfrm>
+          <a:prstGeom prst="rect">
+            <a:avLst/>
+          </a:prstGeom>
+          <a:noFill/>
+        </p:spPr>
+        <p:txBody>
+          <a:bodyPr wrap="square" anchor="t">
+            <a:spAutoFit/>
+          </a:bodyPr>
+          <a:lstStyle/>
+          <a:p>
+            <a:pPr algn="l"/>
+            <a:r>
               <a:rPr sz="1000" b="0">
                 <a:solidFill>
                   <a:srgbClr val="D5D8EA"/>
                 </a:solidFill>
                 <a:latin typeface="Arial"/>
               </a:rPr>
-              <a:t>[출처]
-논문: Thulium laser-assisted delivery of growth factors for treating androgenetic alopecia - a randomized, controlled, clinical study
-게재: Lasers in medical science
-원문: https://pubmed.ncbi.nlm.nih.gov/42911445/
-[이미지 출처]
-- Male pattern baldness.jpg / Originally uploaded by Lkinkade (Transferred by XenonX3) / CC BY-SA 2.5
-  https://commons.wikimedia.org/wiki/File:Male_pattern_baldness.jpg
-- Male-pattern hair loss.jpg / BlaiserPascal / CC BY-SA 4.0
-  https://commons.wikimedia.org/wiki/File:Male-pattern_hair_loss.jpg
-※ CC BY-SA 이미지가 포함되어 있습니다. 저작자 표시가 필수이며,
-  동일조건변경허락(ShareAlike) 조항이 영상 전체에 적용될 수 있으니
-  상업적 이용 시 해당 이미지를 교체하는 편이 안전합니다.
-</a:t>
+              <a:t>· CIA remains a significant and often inadequately addressed aspect of cancer care.
+· Participants described gaps in counseling, variable access to preventive and management strategies, financial and logistical barriers, and unmet needs related to hair regrowth and psychosocial support.
+· Standardized, evidence-based CIA education incorporated into routine pre-chemotherapy counseling represents an important starting point for improving care by ensuring that patients receive consistent information about anticipated hair loss and available prevention and management options.</a:t>
             </a:r>
           </a:p>
         </p:txBody>

</xml_diff>

<commit_message>
chore: daily content 2026-10-26
</commit_message>
<xml_diff>
--- a/pwa/data/latest/slides.pptx
+++ b/pwa/data/latest/slides.pptx
@@ -15,6 +15,7 @@
     <p:sldId id="263" r:id="rId15"/>
     <p:sldId id="264" r:id="rId16"/>
     <p:sldId id="265" r:id="rId17"/>
+    <p:sldId id="266" r:id="rId18"/>
   </p:sldIdLst>
   <p:sldSz cx="5559552" cy="9875520" type="screen4x3"/>
   <p:notesSz cx="6858000" cy="9144000"/>
@@ -516,12 +517,87 @@
           </a:p>
           <a:p>
             <a:r>
-              <a:t>대본: 오늘의 논문 Supportive care in cancer에 실린 새 연구입니다</a:t>
+              <a:t>대본: 오늘의 논문 Clinical, cosmetic and investigational dermatology에 실린 새 연구입니다</a:t>
             </a:r>
           </a:p>
           <a:p>
             <a:r>
               <a:t>연출 노트: 0.5초 안에 스크롤을 멈추게 하는 구간. 숫자를 크게 읽어준다.</a:t>
+            </a:r>
+          </a:p>
+        </p:txBody>
+      </p:sp>
+      <p:sp>
+        <p:nvSpPr>
+          <p:cNvPr id="4" name="Slide Number Placeholder 3"/>
+          <p:cNvSpPr>
+            <a:spLocks noGrp="1"/>
+          </p:cNvSpPr>
+          <p:nvPr>
+            <p:ph type="sldNum" idx="5" sz="quarter"/>
+          </p:nvPr>
+        </p:nvSpPr>
+        <p:spPr/>
+      </p:sp>
+    </p:spTree>
+  </p:cSld>
+  <p:clrMapOvr>
+    <a:masterClrMapping/>
+  </p:clrMapOvr>
+</p:notes>
+</file>
+
+<file path=ppt/notesSlides/notesSlide10.xml><?xml version="1.0" encoding="utf-8"?>
+<p:notes xmlns:a="http://schemas.openxmlformats.org/drawingml/2006/main" xmlns:p="http://schemas.openxmlformats.org/presentationml/2006/main" xmlns:r="http://schemas.openxmlformats.org/officeDocument/2006/relationships">
+  <p:cSld>
+    <p:spTree>
+      <p:nvGrpSpPr>
+        <p:cNvPr id="1" name=""/>
+        <p:cNvGrpSpPr/>
+        <p:nvPr/>
+      </p:nvGrpSpPr>
+      <p:grpSpPr>
+        <a:xfrm>
+          <a:off x="0" y="0"/>
+          <a:ext cx="0" cy="0"/>
+          <a:chOff x="0" y="0"/>
+          <a:chExt cx="0" cy="0"/>
+        </a:xfrm>
+      </p:grpSpPr>
+      <p:sp>
+        <p:nvSpPr>
+          <p:cNvPr id="2" name="Slide Image Placeholder 1"/>
+          <p:cNvSpPr>
+            <a:spLocks noGrp="1"/>
+          </p:cNvSpPr>
+          <p:nvPr>
+            <p:ph type="sldImg" idx="2"/>
+          </p:nvPr>
+        </p:nvSpPr>
+        <p:spPr/>
+      </p:sp>
+      <p:sp>
+        <p:nvSpPr>
+          <p:cNvPr id="3" name="Notes Placeholder 2"/>
+          <p:cNvSpPr>
+            <a:spLocks noGrp="1"/>
+          </p:cNvSpPr>
+          <p:nvPr>
+            <p:ph type="body" idx="3" sz="quarter"/>
+          </p:nvPr>
+        </p:nvSpPr>
+        <p:spPr/>
+        <p:txBody>
+          <a:bodyPr/>
+          <a:lstStyle/>
+          <a:p>
+            <a:r>
+              <a:t>편집 참고용 슬라이드입니다. 영상에는 쓰지 않아도 됩니다.</a:t>
+            </a:r>
+          </a:p>
+          <a:p>
+            <a:r>
+              <a:t>원문 영어 문장을 그대로 발췌했으므로 번역·검수 후 사용하세요.</a:t>
             </a:r>
           </a:p>
         </p:txBody>
@@ -596,7 +672,7 @@
           </a:p>
           <a:p>
             <a:r>
-              <a:t>대본: 《Supportive care in cancer : official journal of the Multinational Association of Supportive Care in Cancer》 - Evaluating disparities in counseling and resources for chemotherapy-induced hair loss: qualitative analysis of a survey-based approach</a:t>
+              <a:t>대본: 《Clinical, cosmetic and investigational dermatology》 - Immune Cells in Hair Follicle Physiology and Pathology</a:t>
             </a:r>
           </a:p>
           <a:p>
@@ -676,7 +752,7 @@
           </a:p>
           <a:p>
             <a:r>
-              <a:t>대본: Purpose: Chemotherapy-induced alopecia (CIA) is a distressing side effect of cancer treatment that significantly impacts patients' quality of life.</a:t>
+              <a:t>대본: The hair follicle (HF) is a sophisticated mini-organ with intrinsic cyclic activity that generates hair shafts.</a:t>
             </a:r>
           </a:p>
           <a:p>
@@ -751,17 +827,17 @@
           <a:lstStyle/>
           <a:p>
             <a:r>
-              <a:t>[key_finding_2] 약 10초</a:t>
-            </a:r>
-          </a:p>
-          <a:p>
-            <a:r>
-              <a:t>대본: Methods: We conducted a mixed-methods, cross-sectional survey study of 101 adults who had received chemotherapy and experienced hair loss.</a:t>
-            </a:r>
-          </a:p>
-          <a:p>
-            <a:r>
-              <a:t>연출 노트: 핵심 포인트 2.</a:t>
+              <a:t>[paper_table] 약 8초</a:t>
+            </a:r>
+          </a:p>
+          <a:p>
+            <a:r>
+              <a:t>대본: 표로 보면 이렇습니다. Hair Follicle-Related Immune Cell Functions and Mechanisms</a:t>
+            </a:r>
+          </a:p>
+          <a:p>
+            <a:r>
+              <a:t>연출 노트: 핵심 숫자 한 칸만 짚어준다. 표는 셀을 직접 수정할 수 있다.</a:t>
             </a:r>
           </a:p>
         </p:txBody>
@@ -831,17 +907,17 @@
           <a:lstStyle/>
           <a:p>
             <a:r>
-              <a:t>[my_take] 약 10초</a:t>
-            </a:r>
-          </a:p>
-          <a:p>
-            <a:r>
-              <a:t>대본: 탈모 연구, 매일 쉽게 정리해드립니다 🙂</a:t>
-            </a:r>
-          </a:p>
-          <a:p>
-            <a:r>
-              <a:t>연출 노트: 본인 사진 + 코멘트. 문구를 직접 바꿔 쓰세요.</a:t>
+              <a:t>[key_finding_2] 약 10초</a:t>
+            </a:r>
+          </a:p>
+          <a:p>
+            <a:r>
+              <a:t>대본: A variety of immune cells, including macrophages, mast cells, T cells, and Langerhans cells, reside around HFs, collectively forming a delicate and intricate immune microenvironment.</a:t>
+            </a:r>
+          </a:p>
+          <a:p>
+            <a:r>
+              <a:t>연출 노트: 핵심 포인트 2.</a:t>
             </a:r>
           </a:p>
         </p:txBody>
@@ -911,17 +987,17 @@
           <a:lstStyle/>
           <a:p>
             <a:r>
-              <a:t>[cta] 약 8초</a:t>
-            </a:r>
-          </a:p>
-          <a:p>
-            <a:r>
-              <a:t>대본: 더 자세한 내용은 원문 링크에서 확인하세요. 매일 새로운 탈모 연구, 팔로우하고 놓치지 마세요!</a:t>
-            </a:r>
-          </a:p>
-          <a:p>
-            <a:r>
-              <a:t>연출 노트: 원문 링크는 고정 댓글로 안내.</a:t>
+              <a:t>[my_take] 약 10초</a:t>
+            </a:r>
+          </a:p>
+          <a:p>
+            <a:r>
+              <a:t>대본: 탈모 연구, 매일 쉽게 정리해드립니다 🙂</a:t>
+            </a:r>
+          </a:p>
+          <a:p>
+            <a:r>
+              <a:t>연출 노트: 본인 사진 + 코멘트. 문구를 직접 바꿔 쓰세요.</a:t>
             </a:r>
           </a:p>
         </p:txBody>
@@ -991,12 +1067,17 @@
           <a:lstStyle/>
           <a:p>
             <a:r>
-              <a:t>편집 참고용 슬라이드입니다. 영상에는 쓰지 않아도 됩니다.</a:t>
-            </a:r>
-          </a:p>
-          <a:p>
-            <a:r>
-              <a:t>원문 영어 문장을 그대로 발췌했으므로 번역·검수 후 사용하세요.</a:t>
+              <a:t>[cta] 약 8초</a:t>
+            </a:r>
+          </a:p>
+          <a:p>
+            <a:r>
+              <a:t>대본: 더 자세한 내용은 원문 링크에서 확인하세요. 매일 새로운 탈모 연구, 팔로우하고 놓치지 마세요!</a:t>
+            </a:r>
+          </a:p>
+          <a:p>
+            <a:r>
+              <a:t>연출 노트: 원문 링크는 고정 댓글로 안내.</a:t>
             </a:r>
           </a:p>
         </p:txBody>
@@ -4190,7 +4271,7 @@
                 </a:solidFill>
                 <a:latin typeface="Arial"/>
               </a:rPr>
-              <a:t>SUPPORTIVE CARE IN CANCER : OFFICIAL JOU</a:t>
+              <a:t>CLINICAL, COSMETIC AND INVESTIGATIONAL D</a:t>
             </a:r>
           </a:p>
         </p:txBody>
@@ -4260,7 +4341,7 @@
                 </a:solidFill>
                 <a:latin typeface="Arial"/>
               </a:rPr>
-              <a:t>Supportive care in cancer에 실린 새 연구입니다</a:t>
+              <a:t>Clinical, cosmetic and investigational dermatology에 실린 새 연구입니다</a:t>
             </a:r>
           </a:p>
         </p:txBody>
@@ -4295,7 +4376,7 @@
                 </a:solidFill>
                 <a:latin typeface="Arial"/>
               </a:rPr>
-              <a:t>2026 Oct 22  |  매일 아침 탈모 연구 한 편</a:t>
+              <a:t>2026  |  매일 아침 탈모 연구 한 편</a:t>
             </a:r>
           </a:p>
         </p:txBody>
@@ -4334,6 +4415,139 @@
         </p:nvSpPr>
         <p:spPr>
           <a:xfrm>
+            <a:off x="365760" y="457200"/>
+            <a:ext cx="4828032" cy="457200"/>
+          </a:xfrm>
+          <a:prstGeom prst="rect">
+            <a:avLst/>
+          </a:prstGeom>
+          <a:noFill/>
+        </p:spPr>
+        <p:txBody>
+          <a:bodyPr wrap="square" anchor="ctr">
+            <a:spAutoFit/>
+          </a:bodyPr>
+          <a:lstStyle/>
+          <a:p>
+            <a:pPr algn="l"/>
+            <a:r>
+              <a:rPr sz="1600" b="1">
+                <a:solidFill>
+                  <a:srgbClr val="FF6B6B"/>
+                </a:solidFill>
+                <a:latin typeface="Arial"/>
+              </a:rPr>
+              <a:t>본문 요약 (편집용)</a:t>
+            </a:r>
+          </a:p>
+        </p:txBody>
+      </p:sp>
+      <p:sp>
+        <p:nvSpPr>
+          <p:cNvPr id="3" name="TextBox 2"/>
+          <p:cNvSpPr txBox="1"/>
+          <p:nvPr/>
+        </p:nvSpPr>
+        <p:spPr>
+          <a:xfrm>
+            <a:off x="365760" y="1097280"/>
+            <a:ext cx="4828032" cy="457200"/>
+          </a:xfrm>
+          <a:prstGeom prst="rect">
+            <a:avLst/>
+          </a:prstGeom>
+          <a:noFill/>
+        </p:spPr>
+        <p:txBody>
+          <a:bodyPr wrap="square" anchor="t">
+            <a:spAutoFit/>
+          </a:bodyPr>
+          <a:lstStyle/>
+          <a:p>
+            <a:pPr algn="l"/>
+            <a:r>
+              <a:rPr sz="1300" b="1">
+                <a:solidFill>
+                  <a:srgbClr val="FFFFFF"/>
+                </a:solidFill>
+                <a:latin typeface="Arial"/>
+              </a:rPr>
+              <a:t>◆ 결론 — Conclusion</a:t>
+            </a:r>
+          </a:p>
+        </p:txBody>
+      </p:sp>
+      <p:sp>
+        <p:nvSpPr>
+          <p:cNvPr id="4" name="TextBox 3"/>
+          <p:cNvSpPr txBox="1"/>
+          <p:nvPr/>
+        </p:nvSpPr>
+        <p:spPr>
+          <a:xfrm>
+            <a:off x="457200" y="1600200"/>
+            <a:ext cx="4736592" cy="3566160"/>
+          </a:xfrm>
+          <a:prstGeom prst="rect">
+            <a:avLst/>
+          </a:prstGeom>
+          <a:noFill/>
+        </p:spPr>
+        <p:txBody>
+          <a:bodyPr wrap="square" anchor="t">
+            <a:spAutoFit/>
+          </a:bodyPr>
+          <a:lstStyle/>
+          <a:p>
+            <a:pPr algn="l"/>
+            <a:r>
+              <a:rPr sz="1000" b="0">
+                <a:solidFill>
+                  <a:srgbClr val="D5D8EA"/>
+                </a:solidFill>
+                <a:latin typeface="Arial"/>
+              </a:rPr>
+              <a:t>· The HF immune system exhibits distinct characteristics different from that of interfollicular skin.
+· The unique perifollicular immune microenvironment is indispensable for maintaining HF physiological homeostasis and normal biological functions.
+· Under physiological conditions, specialized perifollicular immune cells precisely modulate HFSC proliferation and differentiation to ensure orderly hair cycle progression.</a:t>
+            </a:r>
+          </a:p>
+        </p:txBody>
+      </p:sp>
+    </p:spTree>
+  </p:cSld>
+  <p:clrMapOvr>
+    <a:masterClrMapping/>
+  </p:clrMapOvr>
+</p:sld>
+</file>
+
+<file path=ppt/slides/slide11.xml><?xml version="1.0" encoding="utf-8"?>
+<p:sld xmlns:a="http://schemas.openxmlformats.org/drawingml/2006/main" xmlns:p="http://schemas.openxmlformats.org/presentationml/2006/main" xmlns:r="http://schemas.openxmlformats.org/officeDocument/2006/relationships">
+  <p:cSld>
+    <p:bg>
+      <p:bgPr>
+        <a:solidFill>
+          <a:srgbClr val="12142A"/>
+        </a:solidFill>
+        <a:effectLst/>
+      </p:bgPr>
+    </p:bg>
+    <p:spTree>
+      <p:nvGrpSpPr>
+        <p:cNvPr id="1" name=""/>
+        <p:cNvGrpSpPr/>
+        <p:nvPr/>
+      </p:nvGrpSpPr>
+      <p:grpSpPr/>
+      <p:sp>
+        <p:nvSpPr>
+          <p:cNvPr id="2" name="TextBox 1"/>
+          <p:cNvSpPr txBox="1"/>
+          <p:nvPr/>
+        </p:nvSpPr>
+        <p:spPr>
+          <a:xfrm>
             <a:off x="365760" y="731520"/>
             <a:ext cx="4828032" cy="548640"/>
           </a:xfrm>
@@ -4392,9 +4606,9 @@
                 <a:latin typeface="Arial"/>
               </a:rPr>
               <a:t>[출처]
-논문: Evaluating disparities in counseling and resources for chemotherapy-induced hair loss: qualitative analysis of a survey-based approach
-게재: Supportive care in cancer : official journal of the Multinational Association of Supportive Care in Cancer
-원문: https://pubmed.ncbi.nlm.nih.gov/42911279/
+논문: Immune Cells in Hair Follicle Physiology and Pathology
+게재: Clinical, cosmetic and investigational dermatology
+원문: https://pubmed.ncbi.nlm.nih.gov/42927355/
 [이미지 출처]
 - Male pattern baldness.jpg / Originally uploaded by Lkinkade (Transferred by XenonX3) / CC BY-SA 2.5
   https://commons.wikimedia.org/wiki/File:Male_pattern_baldness.jpg
@@ -4404,8 +4618,9 @@
   동일조건변경허락(ShareAlike) 조항이 영상 전체에 적용될 수 있으니
   상업적 이용 시 해당 이미지를 교체하는 편이 안전합니다.
 [논문 본문 그림·표]
-- PubMed Central PMC13690825 (재사용 가능 라이선스)
-  https://www.ncbi.nlm.nih.gov/pmc/articles/PMC13690825/
+- PubMed Central PMC13695359 (CC BY-NC(비상업 한정) - 수익화 채널에서는 사용 주의)
+  https://www.ncbi.nlm.nih.gov/pmc/articles/PMC13695359/
+  · Table 1
   ※ 오픈액세스 논문의 그림·표이며, 위 원문 출처를 함께 표기하세요.
 </a:t>
             </a:r>
@@ -4492,7 +4707,7 @@
                 </a:solidFill>
                 <a:latin typeface="Arial"/>
               </a:rPr>
-              <a:t>Evaluating disparities in counseling and resources for chemotherapy-induced hair loss: qualitative analysis of a survey-based approach</a:t>
+              <a:t>Immune Cells in Hair Follicle Physiology and Pathology</a:t>
             </a:r>
           </a:p>
         </p:txBody>
@@ -4527,7 +4742,7 @@
                 </a:solidFill>
                 <a:latin typeface="Arial"/>
               </a:rPr>
-              <a:t>Supportive care in cancer : official journal of the Multinational Association of Supportive Care in Cancer  ·  2026 Oct 22</a:t>
+              <a:t>Clinical, cosmetic and investigational dermatology  ·  2026</a:t>
             </a:r>
           </a:p>
         </p:txBody>
@@ -4656,7 +4871,7 @@
                 </a:solidFill>
                 <a:latin typeface="Arial"/>
               </a:rPr>
-              <a:t>Purpose: Chemotherapy-induced alopecia (CIA) is a distressing side effect of cancer treatment that significantly impacts patients' quality of life.</a:t>
+              <a:t>The hair follicle (HF) is a sophisticated mini-organ with intrinsic cyclic activity that generates hair shafts.</a:t>
             </a:r>
           </a:p>
         </p:txBody>
@@ -4670,6 +4885,620 @@
 </file>
 
 <file path=ppt/slides/slide4.xml><?xml version="1.0" encoding="utf-8"?>
+<p:sld xmlns:a="http://schemas.openxmlformats.org/drawingml/2006/main" xmlns:p="http://schemas.openxmlformats.org/presentationml/2006/main" xmlns:r="http://schemas.openxmlformats.org/officeDocument/2006/relationships">
+  <p:cSld>
+    <p:bg>
+      <p:bgPr>
+        <a:solidFill>
+          <a:srgbClr val="12142A"/>
+        </a:solidFill>
+        <a:effectLst/>
+      </p:bgPr>
+    </p:bg>
+    <p:spTree>
+      <p:nvGrpSpPr>
+        <p:cNvPr id="1" name=""/>
+        <p:cNvGrpSpPr/>
+        <p:nvPr/>
+      </p:nvGrpSpPr>
+      <p:grpSpPr/>
+      <p:sp>
+        <p:nvSpPr>
+          <p:cNvPr id="2" name="TextBox 1"/>
+          <p:cNvSpPr txBox="1"/>
+          <p:nvPr/>
+        </p:nvSpPr>
+        <p:spPr>
+          <a:xfrm>
+            <a:off x="365760" y="1097280"/>
+            <a:ext cx="4828032" cy="548640"/>
+          </a:xfrm>
+          <a:prstGeom prst="rect">
+            <a:avLst/>
+          </a:prstGeom>
+          <a:noFill/>
+        </p:spPr>
+        <p:txBody>
+          <a:bodyPr wrap="square" anchor="ctr">
+            <a:spAutoFit/>
+          </a:bodyPr>
+          <a:lstStyle/>
+          <a:p>
+            <a:pPr algn="ctr"/>
+            <a:r>
+              <a:rPr sz="2000" b="1">
+                <a:solidFill>
+                  <a:srgbClr val="FF6B6B"/>
+                </a:solidFill>
+                <a:latin typeface="Arial"/>
+              </a:rPr>
+              <a:t>논문 Table 1</a:t>
+            </a:r>
+          </a:p>
+        </p:txBody>
+      </p:sp>
+      <p:sp>
+        <p:nvSpPr>
+          <p:cNvPr id="3" name="TextBox 2"/>
+          <p:cNvSpPr txBox="1"/>
+          <p:nvPr/>
+        </p:nvSpPr>
+        <p:spPr>
+          <a:xfrm>
+            <a:off x="365760" y="1737360"/>
+            <a:ext cx="4828032" cy="914400"/>
+          </a:xfrm>
+          <a:prstGeom prst="rect">
+            <a:avLst/>
+          </a:prstGeom>
+          <a:noFill/>
+        </p:spPr>
+        <p:txBody>
+          <a:bodyPr wrap="square" anchor="ctr">
+            <a:spAutoFit/>
+          </a:bodyPr>
+          <a:lstStyle/>
+          <a:p>
+            <a:pPr algn="ctr"/>
+            <a:r>
+              <a:rPr sz="1300" b="0">
+                <a:solidFill>
+                  <a:srgbClr val="AAAFCD"/>
+                </a:solidFill>
+                <a:latin typeface="Arial"/>
+              </a:rPr>
+              <a:t>Hair Follicle-Related Immune Cell Functions and Mechanisms</a:t>
+            </a:r>
+          </a:p>
+        </p:txBody>
+      </p:sp>
+      <p:graphicFrame>
+        <p:nvGraphicFramePr>
+          <p:cNvPr id="4" name="Table 3"/>
+          <p:cNvGraphicFramePr>
+            <a:graphicFrameLocks noGrp="1"/>
+          </p:cNvGraphicFramePr>
+          <p:nvPr/>
+        </p:nvGraphicFramePr>
+        <p:xfrm>
+          <a:off x="320040" y="2926080"/>
+          <a:ext cx="4919472" cy="3520440"/>
+        </p:xfrm>
+        <a:graphic>
+          <a:graphicData uri="http://schemas.openxmlformats.org/drawingml/2006/table">
+            <a:tbl>
+              <a:tblPr firstRow="1" bandRow="1">
+                <a:tableStyleId>{5C22544A-7EE6-4342-B048-85BDC9FD1C3A}</a:tableStyleId>
+              </a:tblPr>
+              <a:tblGrid>
+                <a:gridCol w="1229868"/>
+                <a:gridCol w="1229868"/>
+                <a:gridCol w="1229868"/>
+                <a:gridCol w="1229868"/>
+              </a:tblGrid>
+              <a:tr h="502920">
+                <a:tc>
+                  <a:txBody>
+                    <a:bodyPr/>
+                    <a:lstStyle/>
+                    <a:p>
+                      <a:pPr>
+                        <a:defRPr sz="1200" b="1">
+                          <a:latin typeface="Arial"/>
+                        </a:defRPr>
+                      </a:pPr>
+                      <a:r>
+                        <a:t>Type of Action</a:t>
+                      </a:r>
+                    </a:p>
+                  </a:txBody>
+                  <a:tcPr/>
+                </a:tc>
+                <a:tc>
+                  <a:txBody>
+                    <a:bodyPr/>
+                    <a:lstStyle/>
+                    <a:p>
+                      <a:pPr>
+                        <a:defRPr sz="1200" b="1">
+                          <a:latin typeface="Arial"/>
+                        </a:defRPr>
+                      </a:pPr>
+                      <a:r>
+                        <a:t>Immune Cell</a:t>
+                      </a:r>
+                    </a:p>
+                  </a:txBody>
+                  <a:tcPr/>
+                </a:tc>
+                <a:tc>
+                  <a:txBody>
+                    <a:bodyPr/>
+                    <a:lstStyle/>
+                    <a:p>
+                      <a:pPr>
+                        <a:defRPr sz="1200" b="1">
+                          <a:latin typeface="Arial"/>
+                        </a:defRPr>
+                      </a:pPr>
+                      <a:r>
+                        <a:t>Specific Functions and Mechanisms</a:t>
+                      </a:r>
+                    </a:p>
+                  </a:txBody>
+                  <a:tcPr/>
+                </a:tc>
+                <a:tc>
+                  <a:txBody>
+                    <a:bodyPr/>
+                    <a:lstStyle/>
+                    <a:p>
+                      <a:pPr>
+                        <a:defRPr sz="1200" b="1">
+                          <a:latin typeface="Arial"/>
+                        </a:defRPr>
+                      </a:pPr>
+                      <a:r>
+                        <a:t>Sample Source</a:t>
+                      </a:r>
+                    </a:p>
+                  </a:txBody>
+                  <a:tcPr/>
+                </a:tc>
+              </a:tr>
+              <a:tr h="502920">
+                <a:tc>
+                  <a:txBody>
+                    <a:bodyPr/>
+                    <a:lstStyle/>
+                    <a:p>
+                      <a:pPr>
+                        <a:defRPr sz="1100" b="0">
+                          <a:latin typeface="Arial"/>
+                        </a:defRPr>
+                      </a:pPr>
+                      <a:r>
+                        <a:t>Regulate hair follicle cycle</a:t>
+                      </a:r>
+                    </a:p>
+                  </a:txBody>
+                  <a:tcPr/>
+                </a:tc>
+                <a:tc>
+                  <a:txBody>
+                    <a:bodyPr/>
+                    <a:lstStyle/>
+                    <a:p>
+                      <a:pPr>
+                        <a:defRPr sz="1100" b="0">
+                          <a:latin typeface="Arial"/>
+                        </a:defRPr>
+                      </a:pPr>
+                      <a:r>
+                        <a:t>Macrophages</a:t>
+                      </a:r>
+                    </a:p>
+                  </a:txBody>
+                  <a:tcPr/>
+                </a:tc>
+                <a:tc>
+                  <a:txBody>
+                    <a:bodyPr/>
+                    <a:lstStyle/>
+                    <a:p>
+                      <a:pPr>
+                        <a:defRPr sz="1100" b="0">
+                          <a:latin typeface="Arial"/>
+                        </a:defRPr>
+                      </a:pPr>
+                      <a:r>
+                        <a:t>Castellana D et al demonstrated that apo</a:t>
+                      </a:r>
+                    </a:p>
+                  </a:txBody>
+                  <a:tcPr/>
+                </a:tc>
+                <a:tc>
+                  <a:txBody>
+                    <a:bodyPr/>
+                    <a:lstStyle/>
+                    <a:p>
+                      <a:pPr>
+                        <a:defRPr sz="1100" b="0">
+                          <a:latin typeface="Arial"/>
+                        </a:defRPr>
+                      </a:pPr>
+                      <a:r>
+                        <a:t>Mouse</a:t>
+                      </a:r>
+                    </a:p>
+                  </a:txBody>
+                  <a:tcPr/>
+                </a:tc>
+              </a:tr>
+              <a:tr h="502920">
+                <a:tc>
+                  <a:txBody>
+                    <a:bodyPr/>
+                    <a:lstStyle/>
+                    <a:p>
+                      <a:pPr>
+                        <a:defRPr sz="1100" b="0">
+                          <a:latin typeface="Arial"/>
+                        </a:defRPr>
+                      </a:pPr>
+                      <a:r>
+                        <a:t>Perifollicular macrophages act as the co</a:t>
+                      </a:r>
+                    </a:p>
+                  </a:txBody>
+                  <a:tcPr/>
+                </a:tc>
+                <a:tc>
+                  <a:txBody>
+                    <a:bodyPr/>
+                    <a:lstStyle/>
+                    <a:p>
+                      <a:pPr>
+                        <a:defRPr sz="1100" b="0">
+                          <a:latin typeface="Arial"/>
+                        </a:defRPr>
+                      </a:pPr>
+                      <a:r>
+                        <a:t>Mouse</a:t>
+                      </a:r>
+                    </a:p>
+                  </a:txBody>
+                  <a:tcPr/>
+                </a:tc>
+                <a:tc>
+                  <a:txBody>
+                    <a:bodyPr/>
+                    <a:lstStyle/>
+                    <a:p>
+                      <a:pPr>
+                        <a:defRPr sz="1100" b="0">
+                          <a:latin typeface="Arial"/>
+                        </a:defRPr>
+                      </a:pPr>
+                      <a:r>
+                        <a:t>Castellana D et al demonstrated that apo</a:t>
+                      </a:r>
+                    </a:p>
+                  </a:txBody>
+                  <a:tcPr/>
+                </a:tc>
+                <a:tc>
+                  <a:txBody>
+                    <a:bodyPr/>
+                    <a:lstStyle/>
+                    <a:p>
+                      <a:pPr>
+                        <a:defRPr sz="1100" b="0">
+                          <a:latin typeface="Arial"/>
+                        </a:defRPr>
+                      </a:pPr>
+                      <a:r>
+                        <a:t>Mouse</a:t>
+                      </a:r>
+                    </a:p>
+                  </a:txBody>
+                  <a:tcPr/>
+                </a:tc>
+              </a:tr>
+              <a:tr h="502920">
+                <a:tc>
+                  <a:txBody>
+                    <a:bodyPr/>
+                    <a:lstStyle/>
+                    <a:p>
+                      <a:pPr>
+                        <a:defRPr sz="1100" b="0">
+                          <a:latin typeface="Arial"/>
+                        </a:defRPr>
+                      </a:pPr>
+                      <a:r>
+                        <a:t>Hardman et al reported that during the t</a:t>
+                      </a:r>
+                    </a:p>
+                  </a:txBody>
+                  <a:tcPr/>
+                </a:tc>
+                <a:tc>
+                  <a:txBody>
+                    <a:bodyPr/>
+                    <a:lstStyle/>
+                    <a:p>
+                      <a:pPr>
+                        <a:defRPr sz="1100" b="0">
+                          <a:latin typeface="Arial"/>
+                        </a:defRPr>
+                      </a:pPr>
+                      <a:r>
+                        <a:t>Human</a:t>
+                      </a:r>
+                    </a:p>
+                  </a:txBody>
+                  <a:tcPr/>
+                </a:tc>
+                <a:tc>
+                  <a:txBody>
+                    <a:bodyPr/>
+                    <a:lstStyle/>
+                    <a:p>
+                      <a:pPr>
+                        <a:defRPr sz="1100" b="0">
+                          <a:latin typeface="Arial"/>
+                        </a:defRPr>
+                      </a:pPr>
+                      <a:r>
+                        <a:t>Castellana D et al demonstrated that apo</a:t>
+                      </a:r>
+                    </a:p>
+                  </a:txBody>
+                  <a:tcPr/>
+                </a:tc>
+                <a:tc>
+                  <a:txBody>
+                    <a:bodyPr/>
+                    <a:lstStyle/>
+                    <a:p>
+                      <a:pPr>
+                        <a:defRPr sz="1100" b="0">
+                          <a:latin typeface="Arial"/>
+                        </a:defRPr>
+                      </a:pPr>
+                      <a:r>
+                        <a:t>Mouse</a:t>
+                      </a:r>
+                    </a:p>
+                  </a:txBody>
+                  <a:tcPr/>
+                </a:tc>
+              </a:tr>
+              <a:tr h="502920">
+                <a:tc>
+                  <a:txBody>
+                    <a:bodyPr/>
+                    <a:lstStyle/>
+                    <a:p>
+                      <a:pPr>
+                        <a:defRPr sz="1100" b="0">
+                          <a:latin typeface="Arial"/>
+                        </a:defRPr>
+                      </a:pPr>
+                      <a:r>
+                        <a:t>Wang E et al found that TREM2⁺ dermal ma</a:t>
+                      </a:r>
+                    </a:p>
+                  </a:txBody>
+                  <a:tcPr/>
+                </a:tc>
+                <a:tc>
+                  <a:txBody>
+                    <a:bodyPr/>
+                    <a:lstStyle/>
+                    <a:p>
+                      <a:pPr>
+                        <a:defRPr sz="1100" b="0">
+                          <a:latin typeface="Arial"/>
+                        </a:defRPr>
+                      </a:pPr>
+                      <a:r>
+                        <a:t>Mouse</a:t>
+                      </a:r>
+                    </a:p>
+                  </a:txBody>
+                  <a:tcPr/>
+                </a:tc>
+                <a:tc>
+                  <a:txBody>
+                    <a:bodyPr/>
+                    <a:lstStyle/>
+                    <a:p>
+                      <a:pPr>
+                        <a:defRPr sz="1100" b="0">
+                          <a:latin typeface="Arial"/>
+                        </a:defRPr>
+                      </a:pPr>
+                      <a:r>
+                        <a:t>Castellana D et al demonstrated that apo</a:t>
+                      </a:r>
+                    </a:p>
+                  </a:txBody>
+                  <a:tcPr/>
+                </a:tc>
+                <a:tc>
+                  <a:txBody>
+                    <a:bodyPr/>
+                    <a:lstStyle/>
+                    <a:p>
+                      <a:pPr>
+                        <a:defRPr sz="1100" b="0">
+                          <a:latin typeface="Arial"/>
+                        </a:defRPr>
+                      </a:pPr>
+                      <a:r>
+                        <a:t>Mouse</a:t>
+                      </a:r>
+                    </a:p>
+                  </a:txBody>
+                  <a:tcPr/>
+                </a:tc>
+              </a:tr>
+              <a:tr h="502920">
+                <a:tc>
+                  <a:txBody>
+                    <a:bodyPr/>
+                    <a:lstStyle/>
+                    <a:p>
+                      <a:pPr>
+                        <a:defRPr sz="1100" b="0">
+                          <a:latin typeface="Arial"/>
+                        </a:defRPr>
+                      </a:pPr>
+                      <a:r>
+                        <a:t>Liu M et al proposed that endogenous rea</a:t>
+                      </a:r>
+                    </a:p>
+                  </a:txBody>
+                  <a:tcPr/>
+                </a:tc>
+                <a:tc>
+                  <a:txBody>
+                    <a:bodyPr/>
+                    <a:lstStyle/>
+                    <a:p>
+                      <a:pPr>
+                        <a:defRPr sz="1100" b="0">
+                          <a:latin typeface="Arial"/>
+                        </a:defRPr>
+                      </a:pPr>
+                      <a:r>
+                        <a:t>Mouse</a:t>
+                      </a:r>
+                    </a:p>
+                  </a:txBody>
+                  <a:tcPr/>
+                </a:tc>
+                <a:tc>
+                  <a:txBody>
+                    <a:bodyPr/>
+                    <a:lstStyle/>
+                    <a:p>
+                      <a:pPr>
+                        <a:defRPr sz="1100" b="0">
+                          <a:latin typeface="Arial"/>
+                        </a:defRPr>
+                      </a:pPr>
+                      <a:r>
+                        <a:t>Castellana D et al demonstrated that apo</a:t>
+                      </a:r>
+                    </a:p>
+                  </a:txBody>
+                  <a:tcPr/>
+                </a:tc>
+                <a:tc>
+                  <a:txBody>
+                    <a:bodyPr/>
+                    <a:lstStyle/>
+                    <a:p>
+                      <a:pPr>
+                        <a:defRPr sz="1100" b="0">
+                          <a:latin typeface="Arial"/>
+                        </a:defRPr>
+                      </a:pPr>
+                      <a:r>
+                        <a:t>Mouse</a:t>
+                      </a:r>
+                    </a:p>
+                  </a:txBody>
+                  <a:tcPr/>
+                </a:tc>
+              </a:tr>
+              <a:tr h="502920">
+                <a:tc>
+                  <a:txBody>
+                    <a:bodyPr/>
+                    <a:lstStyle/>
+                    <a:p>
+                      <a:pPr>
+                        <a:defRPr sz="1100" b="0">
+                          <a:latin typeface="Arial"/>
+                        </a:defRPr>
+                      </a:pPr>
+                      <a:r>
+                        <a:t>Mast cells</a:t>
+                      </a:r>
+                    </a:p>
+                  </a:txBody>
+                  <a:tcPr/>
+                </a:tc>
+                <a:tc>
+                  <a:txBody>
+                    <a:bodyPr/>
+                    <a:lstStyle/>
+                    <a:p>
+                      <a:pPr>
+                        <a:defRPr sz="1100" b="0">
+                          <a:latin typeface="Arial"/>
+                        </a:defRPr>
+                      </a:pPr>
+                      <a:r>
+                        <a:t>Paus R et al firstly confirmed that mast</a:t>
+                      </a:r>
+                    </a:p>
+                  </a:txBody>
+                  <a:tcPr/>
+                </a:tc>
+                <a:tc>
+                  <a:txBody>
+                    <a:bodyPr/>
+                    <a:lstStyle/>
+                    <a:p>
+                      <a:pPr>
+                        <a:defRPr sz="1100" b="0">
+                          <a:latin typeface="Arial"/>
+                        </a:defRPr>
+                      </a:pPr>
+                      <a:r>
+                        <a:t>Mouse</a:t>
+                      </a:r>
+                    </a:p>
+                  </a:txBody>
+                  <a:tcPr/>
+                </a:tc>
+                <a:tc>
+                  <a:txBody>
+                    <a:bodyPr/>
+                    <a:lstStyle/>
+                    <a:p>
+                      <a:pPr>
+                        <a:defRPr sz="1100" b="0">
+                          <a:latin typeface="Arial"/>
+                        </a:defRPr>
+                      </a:pPr>
+                      <a:r>
+                        <a:t>Mouse</a:t>
+                      </a:r>
+                    </a:p>
+                  </a:txBody>
+                  <a:tcPr/>
+                </a:tc>
+              </a:tr>
+            </a:tbl>
+          </a:graphicData>
+        </a:graphic>
+      </p:graphicFrame>
+    </p:spTree>
+  </p:cSld>
+  <p:clrMapOvr>
+    <a:masterClrMapping/>
+  </p:clrMapOvr>
+</p:sld>
+</file>
+
+<file path=ppt/slides/slide5.xml><?xml version="1.0" encoding="utf-8"?>
 <p:sld xmlns:a="http://schemas.openxmlformats.org/drawingml/2006/main" xmlns:p="http://schemas.openxmlformats.org/presentationml/2006/main" xmlns:r="http://schemas.openxmlformats.org/officeDocument/2006/relationships">
   <p:cSld>
     <p:bg>
@@ -4785,7 +5614,7 @@
                 </a:solidFill>
                 <a:latin typeface="Arial"/>
               </a:rPr>
-              <a:t>Methods: We conducted a mixed-methods, cross-sectional survey study of 101 adults who had received chemotherapy and experienced hair loss.</a:t>
+              <a:t>A variety of immune cells, including macrophages, mast cells, T cells, and Langerhans cells, reside around HFs, collectively forming a delicate and intricate immune microenvironment.</a:t>
             </a:r>
           </a:p>
         </p:txBody>
@@ -4798,7 +5627,7 @@
 </p:sld>
 </file>
 
-<file path=ppt/slides/slide5.xml><?xml version="1.0" encoding="utf-8"?>
+<file path=ppt/slides/slide6.xml><?xml version="1.0" encoding="utf-8"?>
 <p:sld xmlns:a="http://schemas.openxmlformats.org/drawingml/2006/main" xmlns:p="http://schemas.openxmlformats.org/presentationml/2006/main" xmlns:r="http://schemas.openxmlformats.org/officeDocument/2006/relationships">
   <p:cSld>
     <p:bg>
@@ -4927,7 +5756,7 @@
 </p:sld>
 </file>
 
-<file path=ppt/slides/slide6.xml><?xml version="1.0" encoding="utf-8"?>
+<file path=ppt/slides/slide7.xml><?xml version="1.0" encoding="utf-8"?>
 <p:sld xmlns:a="http://schemas.openxmlformats.org/drawingml/2006/main" xmlns:p="http://schemas.openxmlformats.org/presentationml/2006/main" xmlns:r="http://schemas.openxmlformats.org/officeDocument/2006/relationships">
   <p:cSld>
     <p:bg>
@@ -4976,211 +5805,6 @@
                 <a:latin typeface="Arial"/>
               </a:rPr>
               <a:t>더 자세한 내용은 원문 링크에서 확인하세요. 매일 새로운 탈모 연구, 팔로우하고 놓치지 마세요!</a:t>
-            </a:r>
-          </a:p>
-        </p:txBody>
-      </p:sp>
-    </p:spTree>
-  </p:cSld>
-  <p:clrMapOvr>
-    <a:masterClrMapping/>
-  </p:clrMapOvr>
-</p:sld>
-</file>
-
-<file path=ppt/slides/slide7.xml><?xml version="1.0" encoding="utf-8"?>
-<p:sld xmlns:a="http://schemas.openxmlformats.org/drawingml/2006/main" xmlns:p="http://schemas.openxmlformats.org/presentationml/2006/main" xmlns:r="http://schemas.openxmlformats.org/officeDocument/2006/relationships">
-  <p:cSld>
-    <p:bg>
-      <p:bgPr>
-        <a:solidFill>
-          <a:srgbClr val="12142A"/>
-        </a:solidFill>
-        <a:effectLst/>
-      </p:bgPr>
-    </p:bg>
-    <p:spTree>
-      <p:nvGrpSpPr>
-        <p:cNvPr id="1" name=""/>
-        <p:cNvGrpSpPr/>
-        <p:nvPr/>
-      </p:nvGrpSpPr>
-      <p:grpSpPr/>
-      <p:sp>
-        <p:nvSpPr>
-          <p:cNvPr id="2" name="TextBox 1"/>
-          <p:cNvSpPr txBox="1"/>
-          <p:nvPr/>
-        </p:nvSpPr>
-        <p:spPr>
-          <a:xfrm>
-            <a:off x="365760" y="457200"/>
-            <a:ext cx="4828032" cy="457200"/>
-          </a:xfrm>
-          <a:prstGeom prst="rect">
-            <a:avLst/>
-          </a:prstGeom>
-          <a:noFill/>
-        </p:spPr>
-        <p:txBody>
-          <a:bodyPr wrap="square" anchor="ctr">
-            <a:spAutoFit/>
-          </a:bodyPr>
-          <a:lstStyle/>
-          <a:p>
-            <a:pPr algn="l"/>
-            <a:r>
-              <a:rPr sz="1600" b="1">
-                <a:solidFill>
-                  <a:srgbClr val="FF6B6B"/>
-                </a:solidFill>
-                <a:latin typeface="Arial"/>
-              </a:rPr>
-              <a:t>본문 요약 (편집용)</a:t>
-            </a:r>
-          </a:p>
-        </p:txBody>
-      </p:sp>
-      <p:sp>
-        <p:nvSpPr>
-          <p:cNvPr id="3" name="TextBox 2"/>
-          <p:cNvSpPr txBox="1"/>
-          <p:nvPr/>
-        </p:nvSpPr>
-        <p:spPr>
-          <a:xfrm>
-            <a:off x="365760" y="1097280"/>
-            <a:ext cx="4828032" cy="457200"/>
-          </a:xfrm>
-          <a:prstGeom prst="rect">
-            <a:avLst/>
-          </a:prstGeom>
-          <a:noFill/>
-        </p:spPr>
-        <p:txBody>
-          <a:bodyPr wrap="square" anchor="t">
-            <a:spAutoFit/>
-          </a:bodyPr>
-          <a:lstStyle/>
-          <a:p>
-            <a:pPr algn="l"/>
-            <a:r>
-              <a:rPr sz="1300" b="1">
-                <a:solidFill>
-                  <a:srgbClr val="FFFFFF"/>
-                </a:solidFill>
-                <a:latin typeface="Arial"/>
-              </a:rPr>
-              <a:t>◆ 배경 — Introduction and background</a:t>
-            </a:r>
-          </a:p>
-        </p:txBody>
-      </p:sp>
-      <p:sp>
-        <p:nvSpPr>
-          <p:cNvPr id="4" name="TextBox 3"/>
-          <p:cNvSpPr txBox="1"/>
-          <p:nvPr/>
-        </p:nvSpPr>
-        <p:spPr>
-          <a:xfrm>
-            <a:off x="457200" y="1600200"/>
-            <a:ext cx="4736592" cy="3566160"/>
-          </a:xfrm>
-          <a:prstGeom prst="rect">
-            <a:avLst/>
-          </a:prstGeom>
-          <a:noFill/>
-        </p:spPr>
-        <p:txBody>
-          <a:bodyPr wrap="square" anchor="t">
-            <a:spAutoFit/>
-          </a:bodyPr>
-          <a:lstStyle/>
-          <a:p>
-            <a:pPr algn="l"/>
-            <a:r>
-              <a:rPr sz="1000" b="0">
-                <a:solidFill>
-                  <a:srgbClr val="D5D8EA"/>
-                </a:solidFill>
-                <a:latin typeface="Arial"/>
-              </a:rPr>
-              <a:t>· Chemotherapy-induced hair loss, also referred to as chemotherapy-induced alopecia (CIA), is one of the most visible and emotionally distressing side effects of cancer treatment.
-· Prior research has documented associations between hair loss and reduced quality of life, body image concerns, and psychosocial distress, underscoring the clinical importance of addressing CIA as part of comprehensive cancer care.
-· Beyond physical appearance, hair loss can disrupt patients’ sense of privacy and social identity, serving as a visible marker of illness that persists throughout treatment and recovery.</a:t>
-            </a:r>
-          </a:p>
-        </p:txBody>
-      </p:sp>
-      <p:sp>
-        <p:nvSpPr>
-          <p:cNvPr id="5" name="TextBox 4"/>
-          <p:cNvSpPr txBox="1"/>
-          <p:nvPr/>
-        </p:nvSpPr>
-        <p:spPr>
-          <a:xfrm>
-            <a:off x="365760" y="5303520"/>
-            <a:ext cx="4828032" cy="457200"/>
-          </a:xfrm>
-          <a:prstGeom prst="rect">
-            <a:avLst/>
-          </a:prstGeom>
-          <a:noFill/>
-        </p:spPr>
-        <p:txBody>
-          <a:bodyPr wrap="square" anchor="t">
-            <a:spAutoFit/>
-          </a:bodyPr>
-          <a:lstStyle/>
-          <a:p>
-            <a:pPr algn="l"/>
-            <a:r>
-              <a:rPr sz="1300" b="1">
-                <a:solidFill>
-                  <a:srgbClr val="FFFFFF"/>
-                </a:solidFill>
-                <a:latin typeface="Arial"/>
-              </a:rPr>
-              <a:t>◆ 연구 방법 — Methods</a:t>
-            </a:r>
-          </a:p>
-        </p:txBody>
-      </p:sp>
-      <p:sp>
-        <p:nvSpPr>
-          <p:cNvPr id="6" name="TextBox 5"/>
-          <p:cNvSpPr txBox="1"/>
-          <p:nvPr/>
-        </p:nvSpPr>
-        <p:spPr>
-          <a:xfrm>
-            <a:off x="457200" y="5806440"/>
-            <a:ext cx="4736592" cy="3566160"/>
-          </a:xfrm>
-          <a:prstGeom prst="rect">
-            <a:avLst/>
-          </a:prstGeom>
-          <a:noFill/>
-        </p:spPr>
-        <p:txBody>
-          <a:bodyPr wrap="square" anchor="t">
-            <a:spAutoFit/>
-          </a:bodyPr>
-          <a:lstStyle/>
-          <a:p>
-            <a:pPr algn="l"/>
-            <a:r>
-              <a:rPr sz="1000" b="0">
-                <a:solidFill>
-                  <a:srgbClr val="D5D8EA"/>
-                </a:solidFill>
-                <a:latin typeface="Arial"/>
-              </a:rPr>
-              <a:t>· Eligible participants included adult individuals (at least 18 years old) who had received chemotherapy and experienced hair loss.
-· A total of 101 individuals participated in the survey study.
-· The survey was open from January to May 2025.</a:t>
             </a:r>
           </a:p>
         </p:txBody>
@@ -5276,7 +5900,7 @@
                 </a:solidFill>
                 <a:latin typeface="Arial"/>
               </a:rPr>
-              <a:t>◆ 주요 결과 — Results</a:t>
+              <a:t>◆ 배경 — Introduction</a:t>
             </a:r>
           </a:p>
         </p:txBody>
@@ -5311,13 +5935,9 @@
                 </a:solidFill>
                 <a:latin typeface="Arial"/>
               </a:rPr>
-              <a:t>· A total of 101 participants completed the survey.
-· Most participants had completed at least a bachelor’s degree (74.3%), and 56.4% were employed either full time or part time.
-· Among participants who reported household income (n = 99), 57.6% reported an annual household income of $100,000 or greater.
-· Open-ended survey responses revealed 11 distinct themes reflecting patients’ experiences with chemotherapy-induced hair loss, counseling, and access to supportive resources.
-· If I had had to pay for it, I don’t know if I could’ve afforded it.”“I wish it had been covered by insurance.”“I was Medicaid pending when I started treatment.”“My insurance requires preauthorization for a wig, which I didn’t know before purchasing one.”Logistical burdens and institutional limitations.Scalp cooling often required extensive coordination—dry ice, caregiver help, and long infusion times—and many centers lacked equipment, training, or support staff, making it difficult to implement effectively.“Professional systems are not available at my treatment center… then I’d still have to trudge in 60 pounds or so of dry ice each time.”“I wish my facility had capping machines so we didn’t have to take the machine back and forth.”“The process was exhausting, especially the post-infusion cooling.”“Nurses didn’t really know how to use the machine and seemed to be burdened.”“The self caps don’t stay cold long enough.”Scalp cooling effectiveness and treatment experience.Patients reported mixed outcomes with scalp cooling, ranging from successful partial retention to complete failure.
-· Scalp cooling often required extensive coordination—dry ice, caregiver help, and long infusion times—and many centers lacked equipment, training, or support staff, making it difficult to implement effectively.“Professional systems are not available at my treatment center… then I’d still have to trudge in 60 pounds or so of dry ice each time.”“I wish my facility had capping machines so we didn’t have to take the machine back and forth.”“The process was exhausting, especially the post-infusion cooling.”“Nurses didn’t really know how to use the machine and seemed to be burdened.”“The self caps don’t stay cold long enough.”
-· “Professional systems are not available at my treatment center… then I’d still have to trudge in 60 pounds or so of dry ice each time.”</a:t>
+              <a:t>· As a crucial cutaneous appendage, the hair follicle (HF) executes multiple physiological functions, including sebum and sweat secretion, hair shaft production, cutaneous barrier protection, and thermoregulation.
+· Anatomically, the HF is divided into four distinct regions from superficial to deep: the infundibulum, the isthmus, the suprabulbar region, and the hair bulb.1 The infundibulum is located above the sebaceous gland duct opening and communicates directly with the follicular orifice.
+· The isthmus is demarcated superiorly by the sebaceous gland duct opening and inferiorly by the arrector pili muscle insertion site, which is adjacent to the bulge region where HFSCs reside.</a:t>
             </a:r>
           </a:p>
         </p:txBody>
@@ -5352,7 +5972,7 @@
                 </a:solidFill>
                 <a:latin typeface="Arial"/>
               </a:rPr>
-              <a:t>◆ 고찰 — Discussion</a:t>
+              <a:t>◆ 그 밖의 내용 — Composition of Immune Cells Surrounding Hair Follicles</a:t>
             </a:r>
           </a:p>
         </p:txBody>
@@ -5387,10 +6007,8 @@
                 </a:solidFill>
                 <a:latin typeface="Arial"/>
               </a:rPr>
-              <a:t>· A survey study of oncologists and dermatologists (n = 103) found significant differences in how CIA was viewed.
-· Another study of oncologists (n = 155) found that 67.1% of providers felt that all patients should be offered scalp cooling therapy, but only 26.3% report regularly initiating conversations about scalp cooling therapy and only 36% felt that scalp cooling benefits were worth the effort and cost involved.
-· A survey study of women in Facebook groups created for scalp cooling therapy users (n = 219) found that key motivations for utilizing social media in scalp cooling therapy included to gain support from others going through a similar experience (88.1% of participants), to receive scalp cooling instructions (82.2%), and to learn about the scalp cooling therapy outcomes of other patients (69.9%).
-· In a study of 179 patients undergoing chemotherapy, 56.4% reported that hair loss was the worst side effect, with 11.7% finding it worse than the disease itself and 16.2% reporting that hair loss would have made them stop chemotherapy if it was not a life-saving treatment.</a:t>
+              <a:t>· The distribution pattern of immune cells differs significantly between the epidermis and HFs, with each immune cell type exhibiting unique localization characteristics in the perifollicular region.
+· Approximately 10% of cutaneous CD4⁺ T cells in human skin are FoxP3⁺ regulatory T cells (Treg cells) with potent immunosuppressive properties, which are enriched in HF-rich skin regions.6,7 Accumulating evidence indicates that cutaneous FoxP3⁺ Treg cells preferentially colonize the HF bulge region.8,9 In healthy human scalp skin, a small number of tissue-resident γδ T cells (primarily the Vδ1⁺ subset) are predominantly confined to the HF infundibulum.10,11</a:t>
             </a:r>
           </a:p>
         </p:txBody>
@@ -5486,7 +6104,7 @@
                 </a:solidFill>
                 <a:latin typeface="Arial"/>
               </a:rPr>
-              <a:t>◆ 결론 — Conclusion</a:t>
+              <a:t>◆ 그 밖의 내용 — Functions of Perifollicular Immune Cells</a:t>
             </a:r>
           </a:p>
         </p:txBody>
@@ -5521,9 +6139,77 @@
                 </a:solidFill>
                 <a:latin typeface="Arial"/>
               </a:rPr>
-              <a:t>· CIA remains a significant and often inadequately addressed aspect of cancer care.
-· Participants described gaps in counseling, variable access to preventive and management strategies, financial and logistical barriers, and unmet needs related to hair regrowth and psychosocial support.
-· Standardized, evidence-based CIA education incorporated into routine pre-chemotherapy counseling represents an important starting point for improving care by ensuring that patients receive consistent information about anticipated hair loss and available prevention and management options.</a:t>
+              <a:t>· Type 2 ILCs upregulate IL‑13 expression to restrict mite colonization and invasion within HFs and maintain follicular structural integrity.33 During Staphylococcus aureus infection of HFs, neutrophils migrate to perifollicular regions to phagocytose bacteria and trigger localized chronic inflammation.34 CCR6⁺ Treg cells abundantly migrate into neonatal skin and colonize HFs under the chemotactic induction of CCL20, mediating host immune tolerance to skin commensal microbes.35 Microbial colonization in HFs drives physiological Treg accumulation in neonatal skin.</a:t>
+            </a:r>
+          </a:p>
+        </p:txBody>
+      </p:sp>
+      <p:sp>
+        <p:nvSpPr>
+          <p:cNvPr id="5" name="TextBox 4"/>
+          <p:cNvSpPr txBox="1"/>
+          <p:nvPr/>
+        </p:nvSpPr>
+        <p:spPr>
+          <a:xfrm>
+            <a:off x="365760" y="5303520"/>
+            <a:ext cx="4828032" cy="457200"/>
+          </a:xfrm>
+          <a:prstGeom prst="rect">
+            <a:avLst/>
+          </a:prstGeom>
+          <a:noFill/>
+        </p:spPr>
+        <p:txBody>
+          <a:bodyPr wrap="square" anchor="t">
+            <a:spAutoFit/>
+          </a:bodyPr>
+          <a:lstStyle/>
+          <a:p>
+            <a:pPr algn="l"/>
+            <a:r>
+              <a:rPr sz="1300" b="1">
+                <a:solidFill>
+                  <a:srgbClr val="FFFFFF"/>
+                </a:solidFill>
+                <a:latin typeface="Arial"/>
+              </a:rPr>
+              <a:t>◆ 그 밖의 내용 — Immunopathogenesis of Hair Follicle-Associated Diseases</a:t>
+            </a:r>
+          </a:p>
+        </p:txBody>
+      </p:sp>
+      <p:sp>
+        <p:nvSpPr>
+          <p:cNvPr id="6" name="TextBox 5"/>
+          <p:cNvSpPr txBox="1"/>
+          <p:nvPr/>
+        </p:nvSpPr>
+        <p:spPr>
+          <a:xfrm>
+            <a:off x="457200" y="5806440"/>
+            <a:ext cx="4736592" cy="3566160"/>
+          </a:xfrm>
+          <a:prstGeom prst="rect">
+            <a:avLst/>
+          </a:prstGeom>
+          <a:noFill/>
+        </p:spPr>
+        <p:txBody>
+          <a:bodyPr wrap="square" anchor="t">
+            <a:spAutoFit/>
+          </a:bodyPr>
+          <a:lstStyle/>
+          <a:p>
+            <a:pPr algn="l"/>
+            <a:r>
+              <a:rPr sz="1000" b="0">
+                <a:solidFill>
+                  <a:srgbClr val="D5D8EA"/>
+                </a:solidFill>
+                <a:latin typeface="Arial"/>
+              </a:rPr>
+              <a:t>· AA is a representative autoimmune alopecia driven by dysregulated immune responses that specifically target autologous HFs, leading to premature anagen termination, arrested hair shaft growth, and localized hair loss.60–62 Accumulating studies have confirmed that massive expansion and aberrant activation of cytotoxic CD8⁺ T cells, which specifically infiltrate and damage HF epithelia, are the core initiating events of AA pathogenesis.49,63–66 Specific depletion of CD8⁺ T cells, rather than CD4⁺ T cells, NK cells, B cells, or γδ T cells, can effectively prevent and reverse AA pathological lesions.46 Clearance of infiltrating CD8⁺ T cells from affected HFs restores follicular structural integrity and promotes hair regrowth.47 Cytotoxic CD8⁺NKG2D⁺ T lymphocytes have been identified as the pivotal drivers of AA immunopathogenesis.48 A clinical study of 331 patients with chronic AA demonstrated compartmentalized infiltration of CD4⁺ Th17 cells and CD8⁺ cytotoxic T lymphocytes (CTLs) in the hair bulb and bulge region, which synergistically promote disease progression.45 CCR6⁺ Th17 cells predominantly accumulate around the hair bulb, disrupt HF immune privilege, and facilitate CTL recruitment and activation via secretion of IL‑17 and IFN‑γ.</a:t>
             </a:r>
           </a:p>
         </p:txBody>

</xml_diff>

<commit_message>
chore: daily content 2026-10-27
</commit_message>
<xml_diff>
--- a/pwa/data/latest/slides.pptx
+++ b/pwa/data/latest/slides.pptx
@@ -14,8 +14,6 @@
     <p:sldId id="262" r:id="rId14"/>
     <p:sldId id="263" r:id="rId15"/>
     <p:sldId id="264" r:id="rId16"/>
-    <p:sldId id="265" r:id="rId17"/>
-    <p:sldId id="266" r:id="rId18"/>
   </p:sldIdLst>
   <p:sldSz cx="5559552" cy="9875520" type="screen4x3"/>
   <p:notesSz cx="6858000" cy="9144000"/>
@@ -517,87 +515,12 @@
           </a:p>
           <a:p>
             <a:r>
-              <a:t>대본: 오늘의 논문 Clinical, cosmetic and investigational dermatology에 실린 새 연구입니다</a:t>
+              <a:t>대본: 오늘의 논문 Clinics and practice에 실린 새 연구입니다</a:t>
             </a:r>
           </a:p>
           <a:p>
             <a:r>
               <a:t>연출 노트: 0.5초 안에 스크롤을 멈추게 하는 구간. 숫자를 크게 읽어준다.</a:t>
-            </a:r>
-          </a:p>
-        </p:txBody>
-      </p:sp>
-      <p:sp>
-        <p:nvSpPr>
-          <p:cNvPr id="4" name="Slide Number Placeholder 3"/>
-          <p:cNvSpPr>
-            <a:spLocks noGrp="1"/>
-          </p:cNvSpPr>
-          <p:nvPr>
-            <p:ph type="sldNum" idx="5" sz="quarter"/>
-          </p:nvPr>
-        </p:nvSpPr>
-        <p:spPr/>
-      </p:sp>
-    </p:spTree>
-  </p:cSld>
-  <p:clrMapOvr>
-    <a:masterClrMapping/>
-  </p:clrMapOvr>
-</p:notes>
-</file>
-
-<file path=ppt/notesSlides/notesSlide10.xml><?xml version="1.0" encoding="utf-8"?>
-<p:notes xmlns:a="http://schemas.openxmlformats.org/drawingml/2006/main" xmlns:p="http://schemas.openxmlformats.org/presentationml/2006/main" xmlns:r="http://schemas.openxmlformats.org/officeDocument/2006/relationships">
-  <p:cSld>
-    <p:spTree>
-      <p:nvGrpSpPr>
-        <p:cNvPr id="1" name=""/>
-        <p:cNvGrpSpPr/>
-        <p:nvPr/>
-      </p:nvGrpSpPr>
-      <p:grpSpPr>
-        <a:xfrm>
-          <a:off x="0" y="0"/>
-          <a:ext cx="0" cy="0"/>
-          <a:chOff x="0" y="0"/>
-          <a:chExt cx="0" cy="0"/>
-        </a:xfrm>
-      </p:grpSpPr>
-      <p:sp>
-        <p:nvSpPr>
-          <p:cNvPr id="2" name="Slide Image Placeholder 1"/>
-          <p:cNvSpPr>
-            <a:spLocks noGrp="1"/>
-          </p:cNvSpPr>
-          <p:nvPr>
-            <p:ph type="sldImg" idx="2"/>
-          </p:nvPr>
-        </p:nvSpPr>
-        <p:spPr/>
-      </p:sp>
-      <p:sp>
-        <p:nvSpPr>
-          <p:cNvPr id="3" name="Notes Placeholder 2"/>
-          <p:cNvSpPr>
-            <a:spLocks noGrp="1"/>
-          </p:cNvSpPr>
-          <p:nvPr>
-            <p:ph type="body" idx="3" sz="quarter"/>
-          </p:nvPr>
-        </p:nvSpPr>
-        <p:spPr/>
-        <p:txBody>
-          <a:bodyPr/>
-          <a:lstStyle/>
-          <a:p>
-            <a:r>
-              <a:t>편집 참고용 슬라이드입니다. 영상에는 쓰지 않아도 됩니다.</a:t>
-            </a:r>
-          </a:p>
-          <a:p>
-            <a:r>
-              <a:t>원문 영어 문장을 그대로 발췌했으므로 번역·검수 후 사용하세요.</a:t>
             </a:r>
           </a:p>
         </p:txBody>
@@ -672,7 +595,7 @@
           </a:p>
           <a:p>
             <a:r>
-              <a:t>대본: 《Clinical, cosmetic and investigational dermatology》 - Immune Cells in Hair Follicle Physiology and Pathology</a:t>
+              <a:t>대본: 《Clinics and practice》 - Destroyed Melanocytes Manifested with Poliosis and Halo Nevi in Children: Proposed Immunopathophysiological Mechanisms with Emphasis on Hair Follicle Immune Privilege</a:t>
             </a:r>
           </a:p>
           <a:p>
@@ -752,7 +675,7 @@
           </a:p>
           <a:p>
             <a:r>
-              <a:t>대본: The hair follicle (HF) is a sophisticated mini-organ with intrinsic cyclic activity that generates hair shafts.</a:t>
+              <a:t>대본: Both poliosis (circumscribed depigmentation of the hair in any area of the body) and halo nevi (a melanocytic nevus which acquires a surrounding depigmented rim) are characterized by depigmentation driven by a T-cell-mediated loss of functional melanocytes within the epidermis and hair bulbs.</a:t>
             </a:r>
           </a:p>
           <a:p>
@@ -827,17 +750,17 @@
           <a:lstStyle/>
           <a:p>
             <a:r>
-              <a:t>[paper_table] 약 8초</a:t>
-            </a:r>
-          </a:p>
-          <a:p>
-            <a:r>
-              <a:t>대본: 표로 보면 이렇습니다. Hair Follicle-Related Immune Cell Functions and Mechanisms</a:t>
-            </a:r>
-          </a:p>
-          <a:p>
-            <a:r>
-              <a:t>연출 노트: 핵심 숫자 한 칸만 짚어준다. 표는 셀을 직접 수정할 수 있다.</a:t>
+              <a:t>[key_finding_2] 약 10초</a:t>
+            </a:r>
+          </a:p>
+          <a:p>
+            <a:r>
+              <a:t>대본: Halo nevi and poliosis are a relatively frequent phenomenon occurring in 1% of the children and adolescents with an average age of onset of 15 years and has no gender predisposition.</a:t>
+            </a:r>
+          </a:p>
+          <a:p>
+            <a:r>
+              <a:t>연출 노트: 핵심 포인트 2.</a:t>
             </a:r>
           </a:p>
         </p:txBody>
@@ -907,17 +830,17 @@
           <a:lstStyle/>
           <a:p>
             <a:r>
-              <a:t>[key_finding_2] 약 10초</a:t>
-            </a:r>
-          </a:p>
-          <a:p>
-            <a:r>
-              <a:t>대본: A variety of immune cells, including macrophages, mast cells, T cells, and Langerhans cells, reside around HFs, collectively forming a delicate and intricate immune microenvironment.</a:t>
-            </a:r>
-          </a:p>
-          <a:p>
-            <a:r>
-              <a:t>연출 노트: 핵심 포인트 2.</a:t>
+              <a:t>[my_take] 약 10초</a:t>
+            </a:r>
+          </a:p>
+          <a:p>
+            <a:r>
+              <a:t>대본: 탈모 연구, 매일 쉽게 정리해드립니다 🙂</a:t>
+            </a:r>
+          </a:p>
+          <a:p>
+            <a:r>
+              <a:t>연출 노트: 본인 사진 + 코멘트. 문구를 직접 바꿔 쓰세요.</a:t>
             </a:r>
           </a:p>
         </p:txBody>
@@ -987,17 +910,17 @@
           <a:lstStyle/>
           <a:p>
             <a:r>
-              <a:t>[my_take] 약 10초</a:t>
-            </a:r>
-          </a:p>
-          <a:p>
-            <a:r>
-              <a:t>대본: 탈모 연구, 매일 쉽게 정리해드립니다 🙂</a:t>
-            </a:r>
-          </a:p>
-          <a:p>
-            <a:r>
-              <a:t>연출 노트: 본인 사진 + 코멘트. 문구를 직접 바꿔 쓰세요.</a:t>
+              <a:t>[cta] 약 8초</a:t>
+            </a:r>
+          </a:p>
+          <a:p>
+            <a:r>
+              <a:t>대본: 더 자세한 내용은 원문 링크에서 확인하세요. 매일 새로운 탈모 연구, 팔로우하고 놓치지 마세요!</a:t>
+            </a:r>
+          </a:p>
+          <a:p>
+            <a:r>
+              <a:t>연출 노트: 원문 링크는 고정 댓글로 안내.</a:t>
             </a:r>
           </a:p>
         </p:txBody>
@@ -1067,17 +990,12 @@
           <a:lstStyle/>
           <a:p>
             <a:r>
-              <a:t>[cta] 약 8초</a:t>
-            </a:r>
-          </a:p>
-          <a:p>
-            <a:r>
-              <a:t>대본: 더 자세한 내용은 원문 링크에서 확인하세요. 매일 새로운 탈모 연구, 팔로우하고 놓치지 마세요!</a:t>
-            </a:r>
-          </a:p>
-          <a:p>
-            <a:r>
-              <a:t>연출 노트: 원문 링크는 고정 댓글로 안내.</a:t>
+              <a:t>편집 참고용 슬라이드입니다. 영상에는 쓰지 않아도 됩니다.</a:t>
+            </a:r>
+          </a:p>
+          <a:p>
+            <a:r>
+              <a:t>원문 영어 문장을 그대로 발췌했으므로 번역·검수 후 사용하세요.</a:t>
             </a:r>
           </a:p>
         </p:txBody>
@@ -1103,81 +1021,6 @@
 </file>
 
 <file path=ppt/notesSlides/notesSlide8.xml><?xml version="1.0" encoding="utf-8"?>
-<p:notes xmlns:a="http://schemas.openxmlformats.org/drawingml/2006/main" xmlns:p="http://schemas.openxmlformats.org/presentationml/2006/main" xmlns:r="http://schemas.openxmlformats.org/officeDocument/2006/relationships">
-  <p:cSld>
-    <p:spTree>
-      <p:nvGrpSpPr>
-        <p:cNvPr id="1" name=""/>
-        <p:cNvGrpSpPr/>
-        <p:nvPr/>
-      </p:nvGrpSpPr>
-      <p:grpSpPr>
-        <a:xfrm>
-          <a:off x="0" y="0"/>
-          <a:ext cx="0" cy="0"/>
-          <a:chOff x="0" y="0"/>
-          <a:chExt cx="0" cy="0"/>
-        </a:xfrm>
-      </p:grpSpPr>
-      <p:sp>
-        <p:nvSpPr>
-          <p:cNvPr id="2" name="Slide Image Placeholder 1"/>
-          <p:cNvSpPr>
-            <a:spLocks noGrp="1"/>
-          </p:cNvSpPr>
-          <p:nvPr>
-            <p:ph type="sldImg" idx="2"/>
-          </p:nvPr>
-        </p:nvSpPr>
-        <p:spPr/>
-      </p:sp>
-      <p:sp>
-        <p:nvSpPr>
-          <p:cNvPr id="3" name="Notes Placeholder 2"/>
-          <p:cNvSpPr>
-            <a:spLocks noGrp="1"/>
-          </p:cNvSpPr>
-          <p:nvPr>
-            <p:ph type="body" idx="3" sz="quarter"/>
-          </p:nvPr>
-        </p:nvSpPr>
-        <p:spPr/>
-        <p:txBody>
-          <a:bodyPr/>
-          <a:lstStyle/>
-          <a:p>
-            <a:r>
-              <a:t>편집 참고용 슬라이드입니다. 영상에는 쓰지 않아도 됩니다.</a:t>
-            </a:r>
-          </a:p>
-          <a:p>
-            <a:r>
-              <a:t>원문 영어 문장을 그대로 발췌했으므로 번역·검수 후 사용하세요.</a:t>
-            </a:r>
-          </a:p>
-        </p:txBody>
-      </p:sp>
-      <p:sp>
-        <p:nvSpPr>
-          <p:cNvPr id="4" name="Slide Number Placeholder 3"/>
-          <p:cNvSpPr>
-            <a:spLocks noGrp="1"/>
-          </p:cNvSpPr>
-          <p:nvPr>
-            <p:ph type="sldNum" idx="5" sz="quarter"/>
-          </p:nvPr>
-        </p:nvSpPr>
-        <p:spPr/>
-      </p:sp>
-    </p:spTree>
-  </p:cSld>
-  <p:clrMapOvr>
-    <a:masterClrMapping/>
-  </p:clrMapOvr>
-</p:notes>
-</file>
-
-<file path=ppt/notesSlides/notesSlide9.xml><?xml version="1.0" encoding="utf-8"?>
 <p:notes xmlns:a="http://schemas.openxmlformats.org/drawingml/2006/main" xmlns:p="http://schemas.openxmlformats.org/presentationml/2006/main" xmlns:r="http://schemas.openxmlformats.org/officeDocument/2006/relationships">
   <p:cSld>
     <p:spTree>
@@ -4271,7 +4114,7 @@
                 </a:solidFill>
                 <a:latin typeface="Arial"/>
               </a:rPr>
-              <a:t>CLINICAL, COSMETIC AND INVESTIGATIONAL D</a:t>
+              <a:t>CLINICS AND PRACTICE</a:t>
             </a:r>
           </a:p>
         </p:txBody>
@@ -4341,7 +4184,7 @@
                 </a:solidFill>
                 <a:latin typeface="Arial"/>
               </a:rPr>
-              <a:t>Clinical, cosmetic and investigational dermatology에 실린 새 연구입니다</a:t>
+              <a:t>Clinics and practice에 실린 새 연구입니다</a:t>
             </a:r>
           </a:p>
         </p:txBody>
@@ -4376,253 +4219,7 @@
                 </a:solidFill>
                 <a:latin typeface="Arial"/>
               </a:rPr>
-              <a:t>2026  |  매일 아침 탈모 연구 한 편</a:t>
-            </a:r>
-          </a:p>
-        </p:txBody>
-      </p:sp>
-    </p:spTree>
-  </p:cSld>
-  <p:clrMapOvr>
-    <a:masterClrMapping/>
-  </p:clrMapOvr>
-</p:sld>
-</file>
-
-<file path=ppt/slides/slide10.xml><?xml version="1.0" encoding="utf-8"?>
-<p:sld xmlns:a="http://schemas.openxmlformats.org/drawingml/2006/main" xmlns:p="http://schemas.openxmlformats.org/presentationml/2006/main" xmlns:r="http://schemas.openxmlformats.org/officeDocument/2006/relationships">
-  <p:cSld>
-    <p:bg>
-      <p:bgPr>
-        <a:solidFill>
-          <a:srgbClr val="12142A"/>
-        </a:solidFill>
-        <a:effectLst/>
-      </p:bgPr>
-    </p:bg>
-    <p:spTree>
-      <p:nvGrpSpPr>
-        <p:cNvPr id="1" name=""/>
-        <p:cNvGrpSpPr/>
-        <p:nvPr/>
-      </p:nvGrpSpPr>
-      <p:grpSpPr/>
-      <p:sp>
-        <p:nvSpPr>
-          <p:cNvPr id="2" name="TextBox 1"/>
-          <p:cNvSpPr txBox="1"/>
-          <p:nvPr/>
-        </p:nvSpPr>
-        <p:spPr>
-          <a:xfrm>
-            <a:off x="365760" y="457200"/>
-            <a:ext cx="4828032" cy="457200"/>
-          </a:xfrm>
-          <a:prstGeom prst="rect">
-            <a:avLst/>
-          </a:prstGeom>
-          <a:noFill/>
-        </p:spPr>
-        <p:txBody>
-          <a:bodyPr wrap="square" anchor="ctr">
-            <a:spAutoFit/>
-          </a:bodyPr>
-          <a:lstStyle/>
-          <a:p>
-            <a:pPr algn="l"/>
-            <a:r>
-              <a:rPr sz="1600" b="1">
-                <a:solidFill>
-                  <a:srgbClr val="FF6B6B"/>
-                </a:solidFill>
-                <a:latin typeface="Arial"/>
-              </a:rPr>
-              <a:t>본문 요약 (편집용)</a:t>
-            </a:r>
-          </a:p>
-        </p:txBody>
-      </p:sp>
-      <p:sp>
-        <p:nvSpPr>
-          <p:cNvPr id="3" name="TextBox 2"/>
-          <p:cNvSpPr txBox="1"/>
-          <p:nvPr/>
-        </p:nvSpPr>
-        <p:spPr>
-          <a:xfrm>
-            <a:off x="365760" y="1097280"/>
-            <a:ext cx="4828032" cy="457200"/>
-          </a:xfrm>
-          <a:prstGeom prst="rect">
-            <a:avLst/>
-          </a:prstGeom>
-          <a:noFill/>
-        </p:spPr>
-        <p:txBody>
-          <a:bodyPr wrap="square" anchor="t">
-            <a:spAutoFit/>
-          </a:bodyPr>
-          <a:lstStyle/>
-          <a:p>
-            <a:pPr algn="l"/>
-            <a:r>
-              <a:rPr sz="1300" b="1">
-                <a:solidFill>
-                  <a:srgbClr val="FFFFFF"/>
-                </a:solidFill>
-                <a:latin typeface="Arial"/>
-              </a:rPr>
-              <a:t>◆ 결론 — Conclusion</a:t>
-            </a:r>
-          </a:p>
-        </p:txBody>
-      </p:sp>
-      <p:sp>
-        <p:nvSpPr>
-          <p:cNvPr id="4" name="TextBox 3"/>
-          <p:cNvSpPr txBox="1"/>
-          <p:nvPr/>
-        </p:nvSpPr>
-        <p:spPr>
-          <a:xfrm>
-            <a:off x="457200" y="1600200"/>
-            <a:ext cx="4736592" cy="3566160"/>
-          </a:xfrm>
-          <a:prstGeom prst="rect">
-            <a:avLst/>
-          </a:prstGeom>
-          <a:noFill/>
-        </p:spPr>
-        <p:txBody>
-          <a:bodyPr wrap="square" anchor="t">
-            <a:spAutoFit/>
-          </a:bodyPr>
-          <a:lstStyle/>
-          <a:p>
-            <a:pPr algn="l"/>
-            <a:r>
-              <a:rPr sz="1000" b="0">
-                <a:solidFill>
-                  <a:srgbClr val="D5D8EA"/>
-                </a:solidFill>
-                <a:latin typeface="Arial"/>
-              </a:rPr>
-              <a:t>· The HF immune system exhibits distinct characteristics different from that of interfollicular skin.
-· The unique perifollicular immune microenvironment is indispensable for maintaining HF physiological homeostasis and normal biological functions.
-· Under physiological conditions, specialized perifollicular immune cells precisely modulate HFSC proliferation and differentiation to ensure orderly hair cycle progression.</a:t>
-            </a:r>
-          </a:p>
-        </p:txBody>
-      </p:sp>
-    </p:spTree>
-  </p:cSld>
-  <p:clrMapOvr>
-    <a:masterClrMapping/>
-  </p:clrMapOvr>
-</p:sld>
-</file>
-
-<file path=ppt/slides/slide11.xml><?xml version="1.0" encoding="utf-8"?>
-<p:sld xmlns:a="http://schemas.openxmlformats.org/drawingml/2006/main" xmlns:p="http://schemas.openxmlformats.org/presentationml/2006/main" xmlns:r="http://schemas.openxmlformats.org/officeDocument/2006/relationships">
-  <p:cSld>
-    <p:bg>
-      <p:bgPr>
-        <a:solidFill>
-          <a:srgbClr val="12142A"/>
-        </a:solidFill>
-        <a:effectLst/>
-      </p:bgPr>
-    </p:bg>
-    <p:spTree>
-      <p:nvGrpSpPr>
-        <p:cNvPr id="1" name=""/>
-        <p:cNvGrpSpPr/>
-        <p:nvPr/>
-      </p:nvGrpSpPr>
-      <p:grpSpPr/>
-      <p:sp>
-        <p:nvSpPr>
-          <p:cNvPr id="2" name="TextBox 1"/>
-          <p:cNvSpPr txBox="1"/>
-          <p:nvPr/>
-        </p:nvSpPr>
-        <p:spPr>
-          <a:xfrm>
-            <a:off x="365760" y="731520"/>
-            <a:ext cx="4828032" cy="548640"/>
-          </a:xfrm>
-          <a:prstGeom prst="rect">
-            <a:avLst/>
-          </a:prstGeom>
-          <a:noFill/>
-        </p:spPr>
-        <p:txBody>
-          <a:bodyPr wrap="square" anchor="ctr">
-            <a:spAutoFit/>
-          </a:bodyPr>
-          <a:lstStyle/>
-          <a:p>
-            <a:pPr algn="ctr"/>
-            <a:r>
-              <a:rPr sz="2200" b="1">
-                <a:solidFill>
-                  <a:srgbClr val="FF6B6B"/>
-                </a:solidFill>
-                <a:latin typeface="Arial"/>
-              </a:rPr>
-              <a:t>출처</a:t>
-            </a:r>
-          </a:p>
-        </p:txBody>
-      </p:sp>
-      <p:sp>
-        <p:nvSpPr>
-          <p:cNvPr id="3" name="TextBox 2"/>
-          <p:cNvSpPr txBox="1"/>
-          <p:nvPr/>
-        </p:nvSpPr>
-        <p:spPr>
-          <a:xfrm>
-            <a:off x="365760" y="1463040"/>
-            <a:ext cx="4828032" cy="7680960"/>
-          </a:xfrm>
-          <a:prstGeom prst="rect">
-            <a:avLst/>
-          </a:prstGeom>
-          <a:noFill/>
-        </p:spPr>
-        <p:txBody>
-          <a:bodyPr wrap="square" anchor="t">
-            <a:spAutoFit/>
-          </a:bodyPr>
-          <a:lstStyle/>
-          <a:p>
-            <a:pPr algn="l"/>
-            <a:r>
-              <a:rPr sz="1000" b="0">
-                <a:solidFill>
-                  <a:srgbClr val="D5D8EA"/>
-                </a:solidFill>
-                <a:latin typeface="Arial"/>
-              </a:rPr>
-              <a:t>[출처]
-논문: Immune Cells in Hair Follicle Physiology and Pathology
-게재: Clinical, cosmetic and investigational dermatology
-원문: https://pubmed.ncbi.nlm.nih.gov/42927355/
-[이미지 출처]
-- Male pattern baldness.jpg / Originally uploaded by Lkinkade (Transferred by XenonX3) / CC BY-SA 2.5
-  https://commons.wikimedia.org/wiki/File:Male_pattern_baldness.jpg
-- Male-pattern hair loss.jpg / BlaiserPascal / CC BY-SA 4.0
-  https://commons.wikimedia.org/wiki/File:Male-pattern_hair_loss.jpg
-※ CC BY-SA 이미지가 포함되어 있습니다. 저작자 표시가 필수이며,
-  동일조건변경허락(ShareAlike) 조항이 영상 전체에 적용될 수 있으니
-  상업적 이용 시 해당 이미지를 교체하는 편이 안전합니다.
-[논문 본문 그림·표]
-- PubMed Central PMC13695359 (CC BY-NC(비상업 한정) - 수익화 채널에서는 사용 주의)
-  https://www.ncbi.nlm.nih.gov/pmc/articles/PMC13695359/
-  · Table 1
-  ※ 오픈액세스 논문의 그림·표이며, 위 원문 출처를 함께 표기하세요.
-</a:t>
+              <a:t>2026 Oct 7  |  매일 아침 탈모 연구 한 편</a:t>
             </a:r>
           </a:p>
         </p:txBody>
@@ -4707,7 +4304,7 @@
                 </a:solidFill>
                 <a:latin typeface="Arial"/>
               </a:rPr>
-              <a:t>Immune Cells in Hair Follicle Physiology and Pathology</a:t>
+              <a:t>Destroyed Melanocytes Manifested with Poliosis and Halo Nevi in Children: Proposed Immunopathophysiological Mechanisms with Emphasis on Hair Follicle Immune Privilege</a:t>
             </a:r>
           </a:p>
         </p:txBody>
@@ -4742,7 +4339,7 @@
                 </a:solidFill>
                 <a:latin typeface="Arial"/>
               </a:rPr>
-              <a:t>Clinical, cosmetic and investigational dermatology  ·  2026</a:t>
+              <a:t>Clinics and practice  ·  2026 Oct 7</a:t>
             </a:r>
           </a:p>
         </p:txBody>
@@ -4871,7 +4468,7 @@
                 </a:solidFill>
                 <a:latin typeface="Arial"/>
               </a:rPr>
-              <a:t>The hair follicle (HF) is a sophisticated mini-organ with intrinsic cyclic activity that generates hair shafts.</a:t>
+              <a:t>Both poliosis (circumscribed depigmentation of the hair in any area of the body) and halo nevi (a melanocytic nevus which acquires a surrounding depigmented rim) are characterized by depigmentation driven by a T-cell-mediated loss of functional melanocytes within the epidermis and hair bulbs.</a:t>
             </a:r>
           </a:p>
         </p:txBody>
@@ -4885,620 +4482,6 @@
 </file>
 
 <file path=ppt/slides/slide4.xml><?xml version="1.0" encoding="utf-8"?>
-<p:sld xmlns:a="http://schemas.openxmlformats.org/drawingml/2006/main" xmlns:p="http://schemas.openxmlformats.org/presentationml/2006/main" xmlns:r="http://schemas.openxmlformats.org/officeDocument/2006/relationships">
-  <p:cSld>
-    <p:bg>
-      <p:bgPr>
-        <a:solidFill>
-          <a:srgbClr val="12142A"/>
-        </a:solidFill>
-        <a:effectLst/>
-      </p:bgPr>
-    </p:bg>
-    <p:spTree>
-      <p:nvGrpSpPr>
-        <p:cNvPr id="1" name=""/>
-        <p:cNvGrpSpPr/>
-        <p:nvPr/>
-      </p:nvGrpSpPr>
-      <p:grpSpPr/>
-      <p:sp>
-        <p:nvSpPr>
-          <p:cNvPr id="2" name="TextBox 1"/>
-          <p:cNvSpPr txBox="1"/>
-          <p:nvPr/>
-        </p:nvSpPr>
-        <p:spPr>
-          <a:xfrm>
-            <a:off x="365760" y="1097280"/>
-            <a:ext cx="4828032" cy="548640"/>
-          </a:xfrm>
-          <a:prstGeom prst="rect">
-            <a:avLst/>
-          </a:prstGeom>
-          <a:noFill/>
-        </p:spPr>
-        <p:txBody>
-          <a:bodyPr wrap="square" anchor="ctr">
-            <a:spAutoFit/>
-          </a:bodyPr>
-          <a:lstStyle/>
-          <a:p>
-            <a:pPr algn="ctr"/>
-            <a:r>
-              <a:rPr sz="2000" b="1">
-                <a:solidFill>
-                  <a:srgbClr val="FF6B6B"/>
-                </a:solidFill>
-                <a:latin typeface="Arial"/>
-              </a:rPr>
-              <a:t>논문 Table 1</a:t>
-            </a:r>
-          </a:p>
-        </p:txBody>
-      </p:sp>
-      <p:sp>
-        <p:nvSpPr>
-          <p:cNvPr id="3" name="TextBox 2"/>
-          <p:cNvSpPr txBox="1"/>
-          <p:nvPr/>
-        </p:nvSpPr>
-        <p:spPr>
-          <a:xfrm>
-            <a:off x="365760" y="1737360"/>
-            <a:ext cx="4828032" cy="914400"/>
-          </a:xfrm>
-          <a:prstGeom prst="rect">
-            <a:avLst/>
-          </a:prstGeom>
-          <a:noFill/>
-        </p:spPr>
-        <p:txBody>
-          <a:bodyPr wrap="square" anchor="ctr">
-            <a:spAutoFit/>
-          </a:bodyPr>
-          <a:lstStyle/>
-          <a:p>
-            <a:pPr algn="ctr"/>
-            <a:r>
-              <a:rPr sz="1300" b="0">
-                <a:solidFill>
-                  <a:srgbClr val="AAAFCD"/>
-                </a:solidFill>
-                <a:latin typeface="Arial"/>
-              </a:rPr>
-              <a:t>Hair Follicle-Related Immune Cell Functions and Mechanisms</a:t>
-            </a:r>
-          </a:p>
-        </p:txBody>
-      </p:sp>
-      <p:graphicFrame>
-        <p:nvGraphicFramePr>
-          <p:cNvPr id="4" name="Table 3"/>
-          <p:cNvGraphicFramePr>
-            <a:graphicFrameLocks noGrp="1"/>
-          </p:cNvGraphicFramePr>
-          <p:nvPr/>
-        </p:nvGraphicFramePr>
-        <p:xfrm>
-          <a:off x="320040" y="2926080"/>
-          <a:ext cx="4919472" cy="3520440"/>
-        </p:xfrm>
-        <a:graphic>
-          <a:graphicData uri="http://schemas.openxmlformats.org/drawingml/2006/table">
-            <a:tbl>
-              <a:tblPr firstRow="1" bandRow="1">
-                <a:tableStyleId>{5C22544A-7EE6-4342-B048-85BDC9FD1C3A}</a:tableStyleId>
-              </a:tblPr>
-              <a:tblGrid>
-                <a:gridCol w="1229868"/>
-                <a:gridCol w="1229868"/>
-                <a:gridCol w="1229868"/>
-                <a:gridCol w="1229868"/>
-              </a:tblGrid>
-              <a:tr h="502920">
-                <a:tc>
-                  <a:txBody>
-                    <a:bodyPr/>
-                    <a:lstStyle/>
-                    <a:p>
-                      <a:pPr>
-                        <a:defRPr sz="1200" b="1">
-                          <a:latin typeface="Arial"/>
-                        </a:defRPr>
-                      </a:pPr>
-                      <a:r>
-                        <a:t>Type of Action</a:t>
-                      </a:r>
-                    </a:p>
-                  </a:txBody>
-                  <a:tcPr/>
-                </a:tc>
-                <a:tc>
-                  <a:txBody>
-                    <a:bodyPr/>
-                    <a:lstStyle/>
-                    <a:p>
-                      <a:pPr>
-                        <a:defRPr sz="1200" b="1">
-                          <a:latin typeface="Arial"/>
-                        </a:defRPr>
-                      </a:pPr>
-                      <a:r>
-                        <a:t>Immune Cell</a:t>
-                      </a:r>
-                    </a:p>
-                  </a:txBody>
-                  <a:tcPr/>
-                </a:tc>
-                <a:tc>
-                  <a:txBody>
-                    <a:bodyPr/>
-                    <a:lstStyle/>
-                    <a:p>
-                      <a:pPr>
-                        <a:defRPr sz="1200" b="1">
-                          <a:latin typeface="Arial"/>
-                        </a:defRPr>
-                      </a:pPr>
-                      <a:r>
-                        <a:t>Specific Functions and Mechanisms</a:t>
-                      </a:r>
-                    </a:p>
-                  </a:txBody>
-                  <a:tcPr/>
-                </a:tc>
-                <a:tc>
-                  <a:txBody>
-                    <a:bodyPr/>
-                    <a:lstStyle/>
-                    <a:p>
-                      <a:pPr>
-                        <a:defRPr sz="1200" b="1">
-                          <a:latin typeface="Arial"/>
-                        </a:defRPr>
-                      </a:pPr>
-                      <a:r>
-                        <a:t>Sample Source</a:t>
-                      </a:r>
-                    </a:p>
-                  </a:txBody>
-                  <a:tcPr/>
-                </a:tc>
-              </a:tr>
-              <a:tr h="502920">
-                <a:tc>
-                  <a:txBody>
-                    <a:bodyPr/>
-                    <a:lstStyle/>
-                    <a:p>
-                      <a:pPr>
-                        <a:defRPr sz="1100" b="0">
-                          <a:latin typeface="Arial"/>
-                        </a:defRPr>
-                      </a:pPr>
-                      <a:r>
-                        <a:t>Regulate hair follicle cycle</a:t>
-                      </a:r>
-                    </a:p>
-                  </a:txBody>
-                  <a:tcPr/>
-                </a:tc>
-                <a:tc>
-                  <a:txBody>
-                    <a:bodyPr/>
-                    <a:lstStyle/>
-                    <a:p>
-                      <a:pPr>
-                        <a:defRPr sz="1100" b="0">
-                          <a:latin typeface="Arial"/>
-                        </a:defRPr>
-                      </a:pPr>
-                      <a:r>
-                        <a:t>Macrophages</a:t>
-                      </a:r>
-                    </a:p>
-                  </a:txBody>
-                  <a:tcPr/>
-                </a:tc>
-                <a:tc>
-                  <a:txBody>
-                    <a:bodyPr/>
-                    <a:lstStyle/>
-                    <a:p>
-                      <a:pPr>
-                        <a:defRPr sz="1100" b="0">
-                          <a:latin typeface="Arial"/>
-                        </a:defRPr>
-                      </a:pPr>
-                      <a:r>
-                        <a:t>Castellana D et al demonstrated that apo</a:t>
-                      </a:r>
-                    </a:p>
-                  </a:txBody>
-                  <a:tcPr/>
-                </a:tc>
-                <a:tc>
-                  <a:txBody>
-                    <a:bodyPr/>
-                    <a:lstStyle/>
-                    <a:p>
-                      <a:pPr>
-                        <a:defRPr sz="1100" b="0">
-                          <a:latin typeface="Arial"/>
-                        </a:defRPr>
-                      </a:pPr>
-                      <a:r>
-                        <a:t>Mouse</a:t>
-                      </a:r>
-                    </a:p>
-                  </a:txBody>
-                  <a:tcPr/>
-                </a:tc>
-              </a:tr>
-              <a:tr h="502920">
-                <a:tc>
-                  <a:txBody>
-                    <a:bodyPr/>
-                    <a:lstStyle/>
-                    <a:p>
-                      <a:pPr>
-                        <a:defRPr sz="1100" b="0">
-                          <a:latin typeface="Arial"/>
-                        </a:defRPr>
-                      </a:pPr>
-                      <a:r>
-                        <a:t>Perifollicular macrophages act as the co</a:t>
-                      </a:r>
-                    </a:p>
-                  </a:txBody>
-                  <a:tcPr/>
-                </a:tc>
-                <a:tc>
-                  <a:txBody>
-                    <a:bodyPr/>
-                    <a:lstStyle/>
-                    <a:p>
-                      <a:pPr>
-                        <a:defRPr sz="1100" b="0">
-                          <a:latin typeface="Arial"/>
-                        </a:defRPr>
-                      </a:pPr>
-                      <a:r>
-                        <a:t>Mouse</a:t>
-                      </a:r>
-                    </a:p>
-                  </a:txBody>
-                  <a:tcPr/>
-                </a:tc>
-                <a:tc>
-                  <a:txBody>
-                    <a:bodyPr/>
-                    <a:lstStyle/>
-                    <a:p>
-                      <a:pPr>
-                        <a:defRPr sz="1100" b="0">
-                          <a:latin typeface="Arial"/>
-                        </a:defRPr>
-                      </a:pPr>
-                      <a:r>
-                        <a:t>Castellana D et al demonstrated that apo</a:t>
-                      </a:r>
-                    </a:p>
-                  </a:txBody>
-                  <a:tcPr/>
-                </a:tc>
-                <a:tc>
-                  <a:txBody>
-                    <a:bodyPr/>
-                    <a:lstStyle/>
-                    <a:p>
-                      <a:pPr>
-                        <a:defRPr sz="1100" b="0">
-                          <a:latin typeface="Arial"/>
-                        </a:defRPr>
-                      </a:pPr>
-                      <a:r>
-                        <a:t>Mouse</a:t>
-                      </a:r>
-                    </a:p>
-                  </a:txBody>
-                  <a:tcPr/>
-                </a:tc>
-              </a:tr>
-              <a:tr h="502920">
-                <a:tc>
-                  <a:txBody>
-                    <a:bodyPr/>
-                    <a:lstStyle/>
-                    <a:p>
-                      <a:pPr>
-                        <a:defRPr sz="1100" b="0">
-                          <a:latin typeface="Arial"/>
-                        </a:defRPr>
-                      </a:pPr>
-                      <a:r>
-                        <a:t>Hardman et al reported that during the t</a:t>
-                      </a:r>
-                    </a:p>
-                  </a:txBody>
-                  <a:tcPr/>
-                </a:tc>
-                <a:tc>
-                  <a:txBody>
-                    <a:bodyPr/>
-                    <a:lstStyle/>
-                    <a:p>
-                      <a:pPr>
-                        <a:defRPr sz="1100" b="0">
-                          <a:latin typeface="Arial"/>
-                        </a:defRPr>
-                      </a:pPr>
-                      <a:r>
-                        <a:t>Human</a:t>
-                      </a:r>
-                    </a:p>
-                  </a:txBody>
-                  <a:tcPr/>
-                </a:tc>
-                <a:tc>
-                  <a:txBody>
-                    <a:bodyPr/>
-                    <a:lstStyle/>
-                    <a:p>
-                      <a:pPr>
-                        <a:defRPr sz="1100" b="0">
-                          <a:latin typeface="Arial"/>
-                        </a:defRPr>
-                      </a:pPr>
-                      <a:r>
-                        <a:t>Castellana D et al demonstrated that apo</a:t>
-                      </a:r>
-                    </a:p>
-                  </a:txBody>
-                  <a:tcPr/>
-                </a:tc>
-                <a:tc>
-                  <a:txBody>
-                    <a:bodyPr/>
-                    <a:lstStyle/>
-                    <a:p>
-                      <a:pPr>
-                        <a:defRPr sz="1100" b="0">
-                          <a:latin typeface="Arial"/>
-                        </a:defRPr>
-                      </a:pPr>
-                      <a:r>
-                        <a:t>Mouse</a:t>
-                      </a:r>
-                    </a:p>
-                  </a:txBody>
-                  <a:tcPr/>
-                </a:tc>
-              </a:tr>
-              <a:tr h="502920">
-                <a:tc>
-                  <a:txBody>
-                    <a:bodyPr/>
-                    <a:lstStyle/>
-                    <a:p>
-                      <a:pPr>
-                        <a:defRPr sz="1100" b="0">
-                          <a:latin typeface="Arial"/>
-                        </a:defRPr>
-                      </a:pPr>
-                      <a:r>
-                        <a:t>Wang E et al found that TREM2⁺ dermal ma</a:t>
-                      </a:r>
-                    </a:p>
-                  </a:txBody>
-                  <a:tcPr/>
-                </a:tc>
-                <a:tc>
-                  <a:txBody>
-                    <a:bodyPr/>
-                    <a:lstStyle/>
-                    <a:p>
-                      <a:pPr>
-                        <a:defRPr sz="1100" b="0">
-                          <a:latin typeface="Arial"/>
-                        </a:defRPr>
-                      </a:pPr>
-                      <a:r>
-                        <a:t>Mouse</a:t>
-                      </a:r>
-                    </a:p>
-                  </a:txBody>
-                  <a:tcPr/>
-                </a:tc>
-                <a:tc>
-                  <a:txBody>
-                    <a:bodyPr/>
-                    <a:lstStyle/>
-                    <a:p>
-                      <a:pPr>
-                        <a:defRPr sz="1100" b="0">
-                          <a:latin typeface="Arial"/>
-                        </a:defRPr>
-                      </a:pPr>
-                      <a:r>
-                        <a:t>Castellana D et al demonstrated that apo</a:t>
-                      </a:r>
-                    </a:p>
-                  </a:txBody>
-                  <a:tcPr/>
-                </a:tc>
-                <a:tc>
-                  <a:txBody>
-                    <a:bodyPr/>
-                    <a:lstStyle/>
-                    <a:p>
-                      <a:pPr>
-                        <a:defRPr sz="1100" b="0">
-                          <a:latin typeface="Arial"/>
-                        </a:defRPr>
-                      </a:pPr>
-                      <a:r>
-                        <a:t>Mouse</a:t>
-                      </a:r>
-                    </a:p>
-                  </a:txBody>
-                  <a:tcPr/>
-                </a:tc>
-              </a:tr>
-              <a:tr h="502920">
-                <a:tc>
-                  <a:txBody>
-                    <a:bodyPr/>
-                    <a:lstStyle/>
-                    <a:p>
-                      <a:pPr>
-                        <a:defRPr sz="1100" b="0">
-                          <a:latin typeface="Arial"/>
-                        </a:defRPr>
-                      </a:pPr>
-                      <a:r>
-                        <a:t>Liu M et al proposed that endogenous rea</a:t>
-                      </a:r>
-                    </a:p>
-                  </a:txBody>
-                  <a:tcPr/>
-                </a:tc>
-                <a:tc>
-                  <a:txBody>
-                    <a:bodyPr/>
-                    <a:lstStyle/>
-                    <a:p>
-                      <a:pPr>
-                        <a:defRPr sz="1100" b="0">
-                          <a:latin typeface="Arial"/>
-                        </a:defRPr>
-                      </a:pPr>
-                      <a:r>
-                        <a:t>Mouse</a:t>
-                      </a:r>
-                    </a:p>
-                  </a:txBody>
-                  <a:tcPr/>
-                </a:tc>
-                <a:tc>
-                  <a:txBody>
-                    <a:bodyPr/>
-                    <a:lstStyle/>
-                    <a:p>
-                      <a:pPr>
-                        <a:defRPr sz="1100" b="0">
-                          <a:latin typeface="Arial"/>
-                        </a:defRPr>
-                      </a:pPr>
-                      <a:r>
-                        <a:t>Castellana D et al demonstrated that apo</a:t>
-                      </a:r>
-                    </a:p>
-                  </a:txBody>
-                  <a:tcPr/>
-                </a:tc>
-                <a:tc>
-                  <a:txBody>
-                    <a:bodyPr/>
-                    <a:lstStyle/>
-                    <a:p>
-                      <a:pPr>
-                        <a:defRPr sz="1100" b="0">
-                          <a:latin typeface="Arial"/>
-                        </a:defRPr>
-                      </a:pPr>
-                      <a:r>
-                        <a:t>Mouse</a:t>
-                      </a:r>
-                    </a:p>
-                  </a:txBody>
-                  <a:tcPr/>
-                </a:tc>
-              </a:tr>
-              <a:tr h="502920">
-                <a:tc>
-                  <a:txBody>
-                    <a:bodyPr/>
-                    <a:lstStyle/>
-                    <a:p>
-                      <a:pPr>
-                        <a:defRPr sz="1100" b="0">
-                          <a:latin typeface="Arial"/>
-                        </a:defRPr>
-                      </a:pPr>
-                      <a:r>
-                        <a:t>Mast cells</a:t>
-                      </a:r>
-                    </a:p>
-                  </a:txBody>
-                  <a:tcPr/>
-                </a:tc>
-                <a:tc>
-                  <a:txBody>
-                    <a:bodyPr/>
-                    <a:lstStyle/>
-                    <a:p>
-                      <a:pPr>
-                        <a:defRPr sz="1100" b="0">
-                          <a:latin typeface="Arial"/>
-                        </a:defRPr>
-                      </a:pPr>
-                      <a:r>
-                        <a:t>Paus R et al firstly confirmed that mast</a:t>
-                      </a:r>
-                    </a:p>
-                  </a:txBody>
-                  <a:tcPr/>
-                </a:tc>
-                <a:tc>
-                  <a:txBody>
-                    <a:bodyPr/>
-                    <a:lstStyle/>
-                    <a:p>
-                      <a:pPr>
-                        <a:defRPr sz="1100" b="0">
-                          <a:latin typeface="Arial"/>
-                        </a:defRPr>
-                      </a:pPr>
-                      <a:r>
-                        <a:t>Mouse</a:t>
-                      </a:r>
-                    </a:p>
-                  </a:txBody>
-                  <a:tcPr/>
-                </a:tc>
-                <a:tc>
-                  <a:txBody>
-                    <a:bodyPr/>
-                    <a:lstStyle/>
-                    <a:p>
-                      <a:pPr>
-                        <a:defRPr sz="1100" b="0">
-                          <a:latin typeface="Arial"/>
-                        </a:defRPr>
-                      </a:pPr>
-                      <a:r>
-                        <a:t>Mouse</a:t>
-                      </a:r>
-                    </a:p>
-                  </a:txBody>
-                  <a:tcPr/>
-                </a:tc>
-              </a:tr>
-            </a:tbl>
-          </a:graphicData>
-        </a:graphic>
-      </p:graphicFrame>
-    </p:spTree>
-  </p:cSld>
-  <p:clrMapOvr>
-    <a:masterClrMapping/>
-  </p:clrMapOvr>
-</p:sld>
-</file>
-
-<file path=ppt/slides/slide5.xml><?xml version="1.0" encoding="utf-8"?>
 <p:sld xmlns:a="http://schemas.openxmlformats.org/drawingml/2006/main" xmlns:p="http://schemas.openxmlformats.org/presentationml/2006/main" xmlns:r="http://schemas.openxmlformats.org/officeDocument/2006/relationships">
   <p:cSld>
     <p:bg>
@@ -5614,7 +4597,7 @@
                 </a:solidFill>
                 <a:latin typeface="Arial"/>
               </a:rPr>
-              <a:t>A variety of immune cells, including macrophages, mast cells, T cells, and Langerhans cells, reside around HFs, collectively forming a delicate and intricate immune microenvironment.</a:t>
+              <a:t>Halo nevi and poliosis are a relatively frequent phenomenon occurring in 1% of the children and adolescents with an average age of onset of 15 years and has no gender predisposition.</a:t>
             </a:r>
           </a:p>
         </p:txBody>
@@ -5627,7 +4610,7 @@
 </p:sld>
 </file>
 
-<file path=ppt/slides/slide6.xml><?xml version="1.0" encoding="utf-8"?>
+<file path=ppt/slides/slide5.xml><?xml version="1.0" encoding="utf-8"?>
 <p:sld xmlns:a="http://schemas.openxmlformats.org/drawingml/2006/main" xmlns:p="http://schemas.openxmlformats.org/presentationml/2006/main" xmlns:r="http://schemas.openxmlformats.org/officeDocument/2006/relationships">
   <p:cSld>
     <p:bg>
@@ -5756,7 +4739,7 @@
 </p:sld>
 </file>
 
-<file path=ppt/slides/slide7.xml><?xml version="1.0" encoding="utf-8"?>
+<file path=ppt/slides/slide6.xml><?xml version="1.0" encoding="utf-8"?>
 <p:sld xmlns:a="http://schemas.openxmlformats.org/drawingml/2006/main" xmlns:p="http://schemas.openxmlformats.org/presentationml/2006/main" xmlns:r="http://schemas.openxmlformats.org/officeDocument/2006/relationships">
   <p:cSld>
     <p:bg>
@@ -5805,6 +4788,208 @@
                 <a:latin typeface="Arial"/>
               </a:rPr>
               <a:t>더 자세한 내용은 원문 링크에서 확인하세요. 매일 새로운 탈모 연구, 팔로우하고 놓치지 마세요!</a:t>
+            </a:r>
+          </a:p>
+        </p:txBody>
+      </p:sp>
+    </p:spTree>
+  </p:cSld>
+  <p:clrMapOvr>
+    <a:masterClrMapping/>
+  </p:clrMapOvr>
+</p:sld>
+</file>
+
+<file path=ppt/slides/slide7.xml><?xml version="1.0" encoding="utf-8"?>
+<p:sld xmlns:a="http://schemas.openxmlformats.org/drawingml/2006/main" xmlns:p="http://schemas.openxmlformats.org/presentationml/2006/main" xmlns:r="http://schemas.openxmlformats.org/officeDocument/2006/relationships">
+  <p:cSld>
+    <p:bg>
+      <p:bgPr>
+        <a:solidFill>
+          <a:srgbClr val="12142A"/>
+        </a:solidFill>
+        <a:effectLst/>
+      </p:bgPr>
+    </p:bg>
+    <p:spTree>
+      <p:nvGrpSpPr>
+        <p:cNvPr id="1" name=""/>
+        <p:cNvGrpSpPr/>
+        <p:nvPr/>
+      </p:nvGrpSpPr>
+      <p:grpSpPr/>
+      <p:sp>
+        <p:nvSpPr>
+          <p:cNvPr id="2" name="TextBox 1"/>
+          <p:cNvSpPr txBox="1"/>
+          <p:nvPr/>
+        </p:nvSpPr>
+        <p:spPr>
+          <a:xfrm>
+            <a:off x="365760" y="457200"/>
+            <a:ext cx="4828032" cy="457200"/>
+          </a:xfrm>
+          <a:prstGeom prst="rect">
+            <a:avLst/>
+          </a:prstGeom>
+          <a:noFill/>
+        </p:spPr>
+        <p:txBody>
+          <a:bodyPr wrap="square" anchor="ctr">
+            <a:spAutoFit/>
+          </a:bodyPr>
+          <a:lstStyle/>
+          <a:p>
+            <a:pPr algn="l"/>
+            <a:r>
+              <a:rPr sz="1600" b="1">
+                <a:solidFill>
+                  <a:srgbClr val="FF6B6B"/>
+                </a:solidFill>
+                <a:latin typeface="Arial"/>
+              </a:rPr>
+              <a:t>본문 요약 (편집용)</a:t>
+            </a:r>
+          </a:p>
+        </p:txBody>
+      </p:sp>
+      <p:sp>
+        <p:nvSpPr>
+          <p:cNvPr id="3" name="TextBox 2"/>
+          <p:cNvSpPr txBox="1"/>
+          <p:nvPr/>
+        </p:nvSpPr>
+        <p:spPr>
+          <a:xfrm>
+            <a:off x="365760" y="1097280"/>
+            <a:ext cx="4828032" cy="457200"/>
+          </a:xfrm>
+          <a:prstGeom prst="rect">
+            <a:avLst/>
+          </a:prstGeom>
+          <a:noFill/>
+        </p:spPr>
+        <p:txBody>
+          <a:bodyPr wrap="square" anchor="t">
+            <a:spAutoFit/>
+          </a:bodyPr>
+          <a:lstStyle/>
+          <a:p>
+            <a:pPr algn="l"/>
+            <a:r>
+              <a:rPr sz="1300" b="1">
+                <a:solidFill>
+                  <a:srgbClr val="FFFFFF"/>
+                </a:solidFill>
+                <a:latin typeface="Arial"/>
+              </a:rPr>
+              <a:t>◆ 배경 — Background (자동 구분)</a:t>
+            </a:r>
+          </a:p>
+        </p:txBody>
+      </p:sp>
+      <p:sp>
+        <p:nvSpPr>
+          <p:cNvPr id="4" name="TextBox 3"/>
+          <p:cNvSpPr txBox="1"/>
+          <p:nvPr/>
+        </p:nvSpPr>
+        <p:spPr>
+          <a:xfrm>
+            <a:off x="457200" y="1600200"/>
+            <a:ext cx="4736592" cy="3566160"/>
+          </a:xfrm>
+          <a:prstGeom prst="rect">
+            <a:avLst/>
+          </a:prstGeom>
+          <a:noFill/>
+        </p:spPr>
+        <p:txBody>
+          <a:bodyPr wrap="square" anchor="t">
+            <a:spAutoFit/>
+          </a:bodyPr>
+          <a:lstStyle/>
+          <a:p>
+            <a:pPr algn="l"/>
+            <a:r>
+              <a:rPr sz="1000" b="0">
+                <a:solidFill>
+                  <a:srgbClr val="D5D8EA"/>
+                </a:solidFill>
+                <a:latin typeface="Arial"/>
+              </a:rPr>
+              <a:t>· Both poliosis (circumscribed depigmentation of the hair in any area of the body) and halo nevi (a melanocytic nevus which acquires a surrounding depigmented rim) are characterized by depigmentation driven by a T-cell-mediated loss of functional melanocytes within the epidermis and hair bulbs.
+· Halo nevi and poliosis are a relatively frequent phenomenon occurring in 1% of the children and adolescents with an average age of onset of 15 years and has no gender predisposition.</a:t>
+            </a:r>
+          </a:p>
+        </p:txBody>
+      </p:sp>
+      <p:sp>
+        <p:nvSpPr>
+          <p:cNvPr id="5" name="TextBox 4"/>
+          <p:cNvSpPr txBox="1"/>
+          <p:nvPr/>
+        </p:nvSpPr>
+        <p:spPr>
+          <a:xfrm>
+            <a:off x="365760" y="5303520"/>
+            <a:ext cx="4828032" cy="457200"/>
+          </a:xfrm>
+          <a:prstGeom prst="rect">
+            <a:avLst/>
+          </a:prstGeom>
+          <a:noFill/>
+        </p:spPr>
+        <p:txBody>
+          <a:bodyPr wrap="square" anchor="t">
+            <a:spAutoFit/>
+          </a:bodyPr>
+          <a:lstStyle/>
+          <a:p>
+            <a:pPr algn="l"/>
+            <a:r>
+              <a:rPr sz="1300" b="1">
+                <a:solidFill>
+                  <a:srgbClr val="FFFFFF"/>
+                </a:solidFill>
+                <a:latin typeface="Arial"/>
+              </a:rPr>
+              <a:t>◆ 연구 방법 — Methods (자동 구분)</a:t>
+            </a:r>
+          </a:p>
+        </p:txBody>
+      </p:sp>
+      <p:sp>
+        <p:nvSpPr>
+          <p:cNvPr id="6" name="TextBox 5"/>
+          <p:cNvSpPr txBox="1"/>
+          <p:nvPr/>
+        </p:nvSpPr>
+        <p:spPr>
+          <a:xfrm>
+            <a:off x="457200" y="5806440"/>
+            <a:ext cx="4736592" cy="3566160"/>
+          </a:xfrm>
+          <a:prstGeom prst="rect">
+            <a:avLst/>
+          </a:prstGeom>
+          <a:noFill/>
+        </p:spPr>
+        <p:txBody>
+          <a:bodyPr wrap="square" anchor="t">
+            <a:spAutoFit/>
+          </a:bodyPr>
+          <a:lstStyle/>
+          <a:p>
+            <a:pPr algn="l"/>
+            <a:r>
+              <a:rPr sz="1000" b="0">
+                <a:solidFill>
+                  <a:srgbClr val="D5D8EA"/>
+                </a:solidFill>
+                <a:latin typeface="Arial"/>
+              </a:rPr>
+              <a:t>· This may indicate that the halo nevi on the trunk induced a temporary systemic autoimmune reaction during the halo phenomenon, collaterally destroying melanocytes at distance on the scalp causing poliosis.</a:t>
             </a:r>
           </a:p>
         </p:txBody>
@@ -5900,7 +5085,7 @@
                 </a:solidFill>
                 <a:latin typeface="Arial"/>
               </a:rPr>
-              <a:t>◆ 배경 — Introduction</a:t>
+              <a:t>◆ 주요 결과 — Results (자동 구분)</a:t>
             </a:r>
           </a:p>
         </p:txBody>
@@ -5935,80 +5120,9 @@
                 </a:solidFill>
                 <a:latin typeface="Arial"/>
               </a:rPr>
-              <a:t>· As a crucial cutaneous appendage, the hair follicle (HF) executes multiple physiological functions, including sebum and sweat secretion, hair shaft production, cutaneous barrier protection, and thermoregulation.
-· Anatomically, the HF is divided into four distinct regions from superficial to deep: the infundibulum, the isthmus, the suprabulbar region, and the hair bulb.1 The infundibulum is located above the sebaceous gland duct opening and communicates directly with the follicular orifice.
-· The isthmus is demarcated superiorly by the sebaceous gland duct opening and inferiorly by the arrector pili muscle insertion site, which is adjacent to the bulge region where HFSCs reside.</a:t>
-            </a:r>
-          </a:p>
-        </p:txBody>
-      </p:sp>
-      <p:sp>
-        <p:nvSpPr>
-          <p:cNvPr id="5" name="TextBox 4"/>
-          <p:cNvSpPr txBox="1"/>
-          <p:nvPr/>
-        </p:nvSpPr>
-        <p:spPr>
-          <a:xfrm>
-            <a:off x="365760" y="5303520"/>
-            <a:ext cx="4828032" cy="457200"/>
-          </a:xfrm>
-          <a:prstGeom prst="rect">
-            <a:avLst/>
-          </a:prstGeom>
-          <a:noFill/>
-        </p:spPr>
-        <p:txBody>
-          <a:bodyPr wrap="square" anchor="t">
-            <a:spAutoFit/>
-          </a:bodyPr>
-          <a:lstStyle/>
-          <a:p>
-            <a:pPr algn="l"/>
-            <a:r>
-              <a:rPr sz="1300" b="1">
-                <a:solidFill>
-                  <a:srgbClr val="FFFFFF"/>
-                </a:solidFill>
-                <a:latin typeface="Arial"/>
-              </a:rPr>
-              <a:t>◆ 그 밖의 내용 — Composition of Immune Cells Surrounding Hair Follicles</a:t>
-            </a:r>
-          </a:p>
-        </p:txBody>
-      </p:sp>
-      <p:sp>
-        <p:nvSpPr>
-          <p:cNvPr id="6" name="TextBox 5"/>
-          <p:cNvSpPr txBox="1"/>
-          <p:nvPr/>
-        </p:nvSpPr>
-        <p:spPr>
-          <a:xfrm>
-            <a:off x="457200" y="5806440"/>
-            <a:ext cx="4736592" cy="3566160"/>
-          </a:xfrm>
-          <a:prstGeom prst="rect">
-            <a:avLst/>
-          </a:prstGeom>
-          <a:noFill/>
-        </p:spPr>
-        <p:txBody>
-          <a:bodyPr wrap="square" anchor="t">
-            <a:spAutoFit/>
-          </a:bodyPr>
-          <a:lstStyle/>
-          <a:p>
-            <a:pPr algn="l"/>
-            <a:r>
-              <a:rPr sz="1000" b="0">
-                <a:solidFill>
-                  <a:srgbClr val="D5D8EA"/>
-                </a:solidFill>
-                <a:latin typeface="Arial"/>
-              </a:rPr>
-              <a:t>· The distribution pattern of immune cells differs significantly between the epidermis and HFs, with each immune cell type exhibiting unique localization characteristics in the perifollicular region.
-· Approximately 10% of cutaneous CD4⁺ T cells in human skin are FoxP3⁺ regulatory T cells (Treg cells) with potent immunosuppressive properties, which are enriched in HF-rich skin regions.6,7 Accumulating evidence indicates that cutaneous FoxP3⁺ Treg cells preferentially colonize the HF bulge region.8,9 In healthy human scalp skin, a small number of tissue-resident γδ T cells (primarily the Vδ1⁺ subset) are predominantly confined to the HF infundibulum.10,11</a:t>
+              <a:t>· Both can be associated with vitiligo and are occasionally seen together as the same cytotoxic immune response (specifically CD8+ T cells) that destroys nevus melanocytes which can attack the same melanocyte-specific targets surrounding epidermal and follicular melanocytes.
+· While poliosis is frequently seen on the scalp, halo nevi on the scalp have been scarcely reported in the literature.
+· The timing of occurrence of the destruction of both epidermal and follicular melanocytes may be supported by a case of a 13-year-old Caucasian male with three halo nevi on the trunk which preceded the development of four scalp patches of poliosis.</a:t>
             </a:r>
           </a:p>
         </p:txBody>
@@ -6047,8 +5161,8 @@
         </p:nvSpPr>
         <p:spPr>
           <a:xfrm>
-            <a:off x="365760" y="457200"/>
-            <a:ext cx="4828032" cy="457200"/>
+            <a:off x="365760" y="731520"/>
+            <a:ext cx="4828032" cy="548640"/>
           </a:xfrm>
           <a:prstGeom prst="rect">
             <a:avLst/>
@@ -6061,15 +5175,15 @@
           </a:bodyPr>
           <a:lstStyle/>
           <a:p>
-            <a:pPr algn="l"/>
-            <a:r>
-              <a:rPr sz="1600" b="1">
+            <a:pPr algn="ctr"/>
+            <a:r>
+              <a:rPr sz="2200" b="1">
                 <a:solidFill>
                   <a:srgbClr val="FF6B6B"/>
                 </a:solidFill>
                 <a:latin typeface="Arial"/>
               </a:rPr>
-              <a:t>본문 요약 (편집용)</a:t>
+              <a:t>출처</a:t>
             </a:r>
           </a:p>
         </p:txBody>
@@ -6082,8 +5196,8 @@
         </p:nvSpPr>
         <p:spPr>
           <a:xfrm>
-            <a:off x="365760" y="1097280"/>
-            <a:ext cx="4828032" cy="457200"/>
+            <a:off x="365760" y="1463040"/>
+            <a:ext cx="4828032" cy="7680960"/>
           </a:xfrm>
           <a:prstGeom prst="rect">
             <a:avLst/>
@@ -6098,118 +5212,25 @@
           <a:p>
             <a:pPr algn="l"/>
             <a:r>
-              <a:rPr sz="1300" b="1">
-                <a:solidFill>
-                  <a:srgbClr val="FFFFFF"/>
-                </a:solidFill>
-                <a:latin typeface="Arial"/>
-              </a:rPr>
-              <a:t>◆ 그 밖의 내용 — Functions of Perifollicular Immune Cells</a:t>
-            </a:r>
-          </a:p>
-        </p:txBody>
-      </p:sp>
-      <p:sp>
-        <p:nvSpPr>
-          <p:cNvPr id="4" name="TextBox 3"/>
-          <p:cNvSpPr txBox="1"/>
-          <p:nvPr/>
-        </p:nvSpPr>
-        <p:spPr>
-          <a:xfrm>
-            <a:off x="457200" y="1600200"/>
-            <a:ext cx="4736592" cy="3566160"/>
-          </a:xfrm>
-          <a:prstGeom prst="rect">
-            <a:avLst/>
-          </a:prstGeom>
-          <a:noFill/>
-        </p:spPr>
-        <p:txBody>
-          <a:bodyPr wrap="square" anchor="t">
-            <a:spAutoFit/>
-          </a:bodyPr>
-          <a:lstStyle/>
-          <a:p>
-            <a:pPr algn="l"/>
-            <a:r>
               <a:rPr sz="1000" b="0">
                 <a:solidFill>
                   <a:srgbClr val="D5D8EA"/>
                 </a:solidFill>
                 <a:latin typeface="Arial"/>
               </a:rPr>
-              <a:t>· Type 2 ILCs upregulate IL‑13 expression to restrict mite colonization and invasion within HFs and maintain follicular structural integrity.33 During Staphylococcus aureus infection of HFs, neutrophils migrate to perifollicular regions to phagocytose bacteria and trigger localized chronic inflammation.34 CCR6⁺ Treg cells abundantly migrate into neonatal skin and colonize HFs under the chemotactic induction of CCL20, mediating host immune tolerance to skin commensal microbes.35 Microbial colonization in HFs drives physiological Treg accumulation in neonatal skin.</a:t>
-            </a:r>
-          </a:p>
-        </p:txBody>
-      </p:sp>
-      <p:sp>
-        <p:nvSpPr>
-          <p:cNvPr id="5" name="TextBox 4"/>
-          <p:cNvSpPr txBox="1"/>
-          <p:nvPr/>
-        </p:nvSpPr>
-        <p:spPr>
-          <a:xfrm>
-            <a:off x="365760" y="5303520"/>
-            <a:ext cx="4828032" cy="457200"/>
-          </a:xfrm>
-          <a:prstGeom prst="rect">
-            <a:avLst/>
-          </a:prstGeom>
-          <a:noFill/>
-        </p:spPr>
-        <p:txBody>
-          <a:bodyPr wrap="square" anchor="t">
-            <a:spAutoFit/>
-          </a:bodyPr>
-          <a:lstStyle/>
-          <a:p>
-            <a:pPr algn="l"/>
-            <a:r>
-              <a:rPr sz="1300" b="1">
-                <a:solidFill>
-                  <a:srgbClr val="FFFFFF"/>
-                </a:solidFill>
-                <a:latin typeface="Arial"/>
-              </a:rPr>
-              <a:t>◆ 그 밖의 내용 — Immunopathogenesis of Hair Follicle-Associated Diseases</a:t>
-            </a:r>
-          </a:p>
-        </p:txBody>
-      </p:sp>
-      <p:sp>
-        <p:nvSpPr>
-          <p:cNvPr id="6" name="TextBox 5"/>
-          <p:cNvSpPr txBox="1"/>
-          <p:nvPr/>
-        </p:nvSpPr>
-        <p:spPr>
-          <a:xfrm>
-            <a:off x="457200" y="5806440"/>
-            <a:ext cx="4736592" cy="3566160"/>
-          </a:xfrm>
-          <a:prstGeom prst="rect">
-            <a:avLst/>
-          </a:prstGeom>
-          <a:noFill/>
-        </p:spPr>
-        <p:txBody>
-          <a:bodyPr wrap="square" anchor="t">
-            <a:spAutoFit/>
-          </a:bodyPr>
-          <a:lstStyle/>
-          <a:p>
-            <a:pPr algn="l"/>
-            <a:r>
-              <a:rPr sz="1000" b="0">
-                <a:solidFill>
-                  <a:srgbClr val="D5D8EA"/>
-                </a:solidFill>
-                <a:latin typeface="Arial"/>
-              </a:rPr>
-              <a:t>· AA is a representative autoimmune alopecia driven by dysregulated immune responses that specifically target autologous HFs, leading to premature anagen termination, arrested hair shaft growth, and localized hair loss.60–62 Accumulating studies have confirmed that massive expansion and aberrant activation of cytotoxic CD8⁺ T cells, which specifically infiltrate and damage HF epithelia, are the core initiating events of AA pathogenesis.49,63–66 Specific depletion of CD8⁺ T cells, rather than CD4⁺ T cells, NK cells, B cells, or γδ T cells, can effectively prevent and reverse AA pathological lesions.46 Clearance of infiltrating CD8⁺ T cells from affected HFs restores follicular structural integrity and promotes hair regrowth.47 Cytotoxic CD8⁺NKG2D⁺ T lymphocytes have been identified as the pivotal drivers of AA immunopathogenesis.48 A clinical study of 331 patients with chronic AA demonstrated compartmentalized infiltration of CD4⁺ Th17 cells and CD8⁺ cytotoxic T lymphocytes (CTLs) in the hair bulb and bulge region, which synergistically promote disease progression.45 CCR6⁺ Th17 cells predominantly accumulate around the hair bulb, disrupt HF immune privilege, and facilitate CTL recruitment and activation via secretion of IL‑17 and IFN‑γ.</a:t>
+              <a:t>[출처]
+논문: Destroyed Melanocytes Manifested with Poliosis and Halo Nevi in Children: Proposed Immunopathophysiological Mechanisms with Emphasis on Hair Follicle Immune Privilege
+게재: Clinics and practice
+원문: https://pubmed.ncbi.nlm.nih.gov/42930370/
+[이미지 출처]
+- Male pattern baldness.jpg / Originally uploaded by Lkinkade (Transferred by XenonX3) / CC BY-SA 2.5
+  https://commons.wikimedia.org/wiki/File:Male_pattern_baldness.jpg
+- Male-pattern hair loss.jpg / BlaiserPascal / CC BY-SA 4.0
+  https://commons.wikimedia.org/wiki/File:Male-pattern_hair_loss.jpg
+※ CC BY-SA 이미지가 포함되어 있습니다. 저작자 표시가 필수이며,
+  동일조건변경허락(ShareAlike) 조항이 영상 전체에 적용될 수 있으니
+  상업적 이용 시 해당 이미지를 교체하는 편이 안전합니다.
+</a:t>
             </a:r>
           </a:p>
         </p:txBody>

</xml_diff>

<commit_message>
chore: daily content 2026-10-28
</commit_message>
<xml_diff>
--- a/pwa/data/latest/slides.pptx
+++ b/pwa/data/latest/slides.pptx
@@ -14,6 +14,8 @@
     <p:sldId id="262" r:id="rId14"/>
     <p:sldId id="263" r:id="rId15"/>
     <p:sldId id="264" r:id="rId16"/>
+    <p:sldId id="265" r:id="rId17"/>
+    <p:sldId id="266" r:id="rId18"/>
   </p:sldIdLst>
   <p:sldSz cx="5559552" cy="9875520" type="screen4x3"/>
   <p:notesSz cx="6858000" cy="9144000"/>
@@ -515,12 +517,87 @@
           </a:p>
           <a:p>
             <a:r>
-              <a:t>대본: 오늘의 논문 Clinics and practice에 실린 새 연구입니다</a:t>
+              <a:t>대본: 미녹시딜 오늘 나온 최신 연구를 정리했습니다</a:t>
             </a:r>
           </a:p>
           <a:p>
             <a:r>
               <a:t>연출 노트: 0.5초 안에 스크롤을 멈추게 하는 구간. 숫자를 크게 읽어준다.</a:t>
+            </a:r>
+          </a:p>
+        </p:txBody>
+      </p:sp>
+      <p:sp>
+        <p:nvSpPr>
+          <p:cNvPr id="4" name="Slide Number Placeholder 3"/>
+          <p:cNvSpPr>
+            <a:spLocks noGrp="1"/>
+          </p:cNvSpPr>
+          <p:nvPr>
+            <p:ph type="sldNum" idx="5" sz="quarter"/>
+          </p:nvPr>
+        </p:nvSpPr>
+        <p:spPr/>
+      </p:sp>
+    </p:spTree>
+  </p:cSld>
+  <p:clrMapOvr>
+    <a:masterClrMapping/>
+  </p:clrMapOvr>
+</p:notes>
+</file>
+
+<file path=ppt/notesSlides/notesSlide10.xml><?xml version="1.0" encoding="utf-8"?>
+<p:notes xmlns:a="http://schemas.openxmlformats.org/drawingml/2006/main" xmlns:p="http://schemas.openxmlformats.org/presentationml/2006/main" xmlns:r="http://schemas.openxmlformats.org/officeDocument/2006/relationships">
+  <p:cSld>
+    <p:spTree>
+      <p:nvGrpSpPr>
+        <p:cNvPr id="1" name=""/>
+        <p:cNvGrpSpPr/>
+        <p:nvPr/>
+      </p:nvGrpSpPr>
+      <p:grpSpPr>
+        <a:xfrm>
+          <a:off x="0" y="0"/>
+          <a:ext cx="0" cy="0"/>
+          <a:chOff x="0" y="0"/>
+          <a:chExt cx="0" cy="0"/>
+        </a:xfrm>
+      </p:grpSpPr>
+      <p:sp>
+        <p:nvSpPr>
+          <p:cNvPr id="2" name="Slide Image Placeholder 1"/>
+          <p:cNvSpPr>
+            <a:spLocks noGrp="1"/>
+          </p:cNvSpPr>
+          <p:nvPr>
+            <p:ph type="sldImg" idx="2"/>
+          </p:nvPr>
+        </p:nvSpPr>
+        <p:spPr/>
+      </p:sp>
+      <p:sp>
+        <p:nvSpPr>
+          <p:cNvPr id="3" name="Notes Placeholder 2"/>
+          <p:cNvSpPr>
+            <a:spLocks noGrp="1"/>
+          </p:cNvSpPr>
+          <p:nvPr>
+            <p:ph type="body" idx="3" sz="quarter"/>
+          </p:nvPr>
+        </p:nvSpPr>
+        <p:spPr/>
+        <p:txBody>
+          <a:bodyPr/>
+          <a:lstStyle/>
+          <a:p>
+            <a:r>
+              <a:t>편집 참고용 슬라이드입니다. 영상에는 쓰지 않아도 됩니다.</a:t>
+            </a:r>
+          </a:p>
+          <a:p>
+            <a:r>
+              <a:t>원문 영어 문장을 그대로 발췌했으므로 번역·검수 후 사용하세요.</a:t>
             </a:r>
           </a:p>
         </p:txBody>
@@ -595,7 +672,7 @@
           </a:p>
           <a:p>
             <a:r>
-              <a:t>대본: 《Clinics and practice》 - Destroyed Melanocytes Manifested with Poliosis and Halo Nevi in Children: Proposed Immunopathophysiological Mechanisms with Emphasis on Hair Follicle Immune Privilege</a:t>
+              <a:t>대본: 《Pharmaceutics》 - Study on Construction of and Pharmacodynamics of Baicalin-Minoxidil Co-Loaded Nanogel</a:t>
             </a:r>
           </a:p>
           <a:p>
@@ -675,7 +752,7 @@
           </a:p>
           <a:p>
             <a:r>
-              <a:t>대본: Both poliosis (circumscribed depigmentation of the hair in any area of the body) and halo nevi (a melanocytic nevus which acquires a surrounding depigmented rim) are characterized by depigmentation driven by a T-cell-mediated loss of functional melanocytes within the epidermis and hair bulbs.</a:t>
+              <a:t>대본: Androgenetic alopecia (AGA) is a chronic and highly prevalent hair loss disorder for which current topical therapies are limited by undesirable side effects, dose-dependent efficacy, and poor skin penetration.</a:t>
             </a:r>
           </a:p>
           <a:p>
@@ -750,17 +827,17 @@
           <a:lstStyle/>
           <a:p>
             <a:r>
-              <a:t>[key_finding_2] 약 10초</a:t>
-            </a:r>
-          </a:p>
-          <a:p>
-            <a:r>
-              <a:t>대본: Halo nevi and poliosis are a relatively frequent phenomenon occurring in 1% of the children and adolescents with an average age of onset of 15 years and has no gender predisposition.</a:t>
-            </a:r>
-          </a:p>
-          <a:p>
-            <a:r>
-              <a:t>연출 노트: 핵심 포인트 2.</a:t>
+              <a:t>[paper_table] 약 8초</a:t>
+            </a:r>
+          </a:p>
+          <a:p>
+            <a:r>
+              <a:t>대본: 표로 보면 이렇습니다. In vitro release kinetic parameters and model fitting of Baicalin and Minoxidil from Bai-Min-NGs.</a:t>
+            </a:r>
+          </a:p>
+          <a:p>
+            <a:r>
+              <a:t>연출 노트: 핵심 숫자 한 칸만 짚어준다. 표는 셀을 직접 수정할 수 있다.</a:t>
             </a:r>
           </a:p>
         </p:txBody>
@@ -830,17 +907,17 @@
           <a:lstStyle/>
           <a:p>
             <a:r>
-              <a:t>[my_take] 약 10초</a:t>
-            </a:r>
-          </a:p>
-          <a:p>
-            <a:r>
-              <a:t>대본: 탈모 연구, 매일 쉽게 정리해드립니다 🙂</a:t>
-            </a:r>
-          </a:p>
-          <a:p>
-            <a:r>
-              <a:t>연출 노트: 본인 사진 + 코멘트. 문구를 직접 바꿔 쓰세요.</a:t>
+              <a:t>[key_finding_2] 약 10초</a:t>
+            </a:r>
+          </a:p>
+          <a:p>
+            <a:r>
+              <a:t>대본: Objective: Here, we developed a baicalin-minoxidil co-loaded nanogel (Bai-Min-NGs) to synergistically enhance transdermal drug delivery and promote hair regeneration.</a:t>
+            </a:r>
+          </a:p>
+          <a:p>
+            <a:r>
+              <a:t>연출 노트: 핵심 포인트 2.</a:t>
             </a:r>
           </a:p>
         </p:txBody>
@@ -910,17 +987,17 @@
           <a:lstStyle/>
           <a:p>
             <a:r>
-              <a:t>[cta] 약 8초</a:t>
-            </a:r>
-          </a:p>
-          <a:p>
-            <a:r>
-              <a:t>대본: 더 자세한 내용은 원문 링크에서 확인하세요. 매일 새로운 탈모 연구, 팔로우하고 놓치지 마세요!</a:t>
-            </a:r>
-          </a:p>
-          <a:p>
-            <a:r>
-              <a:t>연출 노트: 원문 링크는 고정 댓글로 안내.</a:t>
+              <a:t>[my_take] 약 10초</a:t>
+            </a:r>
+          </a:p>
+          <a:p>
+            <a:r>
+              <a:t>대본: 탈모 연구, 매일 쉽게 정리해드립니다 🙂</a:t>
+            </a:r>
+          </a:p>
+          <a:p>
+            <a:r>
+              <a:t>연출 노트: 본인 사진 + 코멘트. 문구를 직접 바꿔 쓰세요.</a:t>
             </a:r>
           </a:p>
         </p:txBody>
@@ -990,12 +1067,17 @@
           <a:lstStyle/>
           <a:p>
             <a:r>
-              <a:t>편집 참고용 슬라이드입니다. 영상에는 쓰지 않아도 됩니다.</a:t>
-            </a:r>
-          </a:p>
-          <a:p>
-            <a:r>
-              <a:t>원문 영어 문장을 그대로 발췌했으므로 번역·검수 후 사용하세요.</a:t>
+              <a:t>[cta] 약 8초</a:t>
+            </a:r>
+          </a:p>
+          <a:p>
+            <a:r>
+              <a:t>대본: 더 자세한 내용은 원문 링크에서 확인하세요. 매일 새로운 탈모 연구, 팔로우하고 놓치지 마세요!</a:t>
+            </a:r>
+          </a:p>
+          <a:p>
+            <a:r>
+              <a:t>연출 노트: 원문 링크는 고정 댓글로 안내.</a:t>
             </a:r>
           </a:p>
         </p:txBody>
@@ -1021,6 +1103,81 @@
 </file>
 
 <file path=ppt/notesSlides/notesSlide8.xml><?xml version="1.0" encoding="utf-8"?>
+<p:notes xmlns:a="http://schemas.openxmlformats.org/drawingml/2006/main" xmlns:p="http://schemas.openxmlformats.org/presentationml/2006/main" xmlns:r="http://schemas.openxmlformats.org/officeDocument/2006/relationships">
+  <p:cSld>
+    <p:spTree>
+      <p:nvGrpSpPr>
+        <p:cNvPr id="1" name=""/>
+        <p:cNvGrpSpPr/>
+        <p:nvPr/>
+      </p:nvGrpSpPr>
+      <p:grpSpPr>
+        <a:xfrm>
+          <a:off x="0" y="0"/>
+          <a:ext cx="0" cy="0"/>
+          <a:chOff x="0" y="0"/>
+          <a:chExt cx="0" cy="0"/>
+        </a:xfrm>
+      </p:grpSpPr>
+      <p:sp>
+        <p:nvSpPr>
+          <p:cNvPr id="2" name="Slide Image Placeholder 1"/>
+          <p:cNvSpPr>
+            <a:spLocks noGrp="1"/>
+          </p:cNvSpPr>
+          <p:nvPr>
+            <p:ph type="sldImg" idx="2"/>
+          </p:nvPr>
+        </p:nvSpPr>
+        <p:spPr/>
+      </p:sp>
+      <p:sp>
+        <p:nvSpPr>
+          <p:cNvPr id="3" name="Notes Placeholder 2"/>
+          <p:cNvSpPr>
+            <a:spLocks noGrp="1"/>
+          </p:cNvSpPr>
+          <p:nvPr>
+            <p:ph type="body" idx="3" sz="quarter"/>
+          </p:nvPr>
+        </p:nvSpPr>
+        <p:spPr/>
+        <p:txBody>
+          <a:bodyPr/>
+          <a:lstStyle/>
+          <a:p>
+            <a:r>
+              <a:t>편집 참고용 슬라이드입니다. 영상에는 쓰지 않아도 됩니다.</a:t>
+            </a:r>
+          </a:p>
+          <a:p>
+            <a:r>
+              <a:t>원문 영어 문장을 그대로 발췌했으므로 번역·검수 후 사용하세요.</a:t>
+            </a:r>
+          </a:p>
+        </p:txBody>
+      </p:sp>
+      <p:sp>
+        <p:nvSpPr>
+          <p:cNvPr id="4" name="Slide Number Placeholder 3"/>
+          <p:cNvSpPr>
+            <a:spLocks noGrp="1"/>
+          </p:cNvSpPr>
+          <p:nvPr>
+            <p:ph type="sldNum" idx="5" sz="quarter"/>
+          </p:nvPr>
+        </p:nvSpPr>
+        <p:spPr/>
+      </p:sp>
+    </p:spTree>
+  </p:cSld>
+  <p:clrMapOvr>
+    <a:masterClrMapping/>
+  </p:clrMapOvr>
+</p:notes>
+</file>
+
+<file path=ppt/notesSlides/notesSlide9.xml><?xml version="1.0" encoding="utf-8"?>
 <p:notes xmlns:a="http://schemas.openxmlformats.org/drawingml/2006/main" xmlns:p="http://schemas.openxmlformats.org/presentationml/2006/main" xmlns:r="http://schemas.openxmlformats.org/officeDocument/2006/relationships">
   <p:cSld>
     <p:spTree>
@@ -4114,7 +4271,7 @@
                 </a:solidFill>
                 <a:latin typeface="Arial"/>
               </a:rPr>
-              <a:t>CLINICS AND PRACTICE</a:t>
+              <a:t>PHARMACEUTICS</a:t>
             </a:r>
           </a:p>
         </p:txBody>
@@ -4149,7 +4306,7 @@
                 </a:solidFill>
                 <a:latin typeface="Arial"/>
               </a:rPr>
-              <a:t>오늘의 논문</a:t>
+              <a:t>미녹시딜</a:t>
             </a:r>
           </a:p>
         </p:txBody>
@@ -4184,7 +4341,7 @@
                 </a:solidFill>
                 <a:latin typeface="Arial"/>
               </a:rPr>
-              <a:t>Clinics and practice에 실린 새 연구입니다</a:t>
+              <a:t>오늘 나온 최신 연구를 정리했습니다</a:t>
             </a:r>
           </a:p>
         </p:txBody>
@@ -4219,7 +4376,253 @@
                 </a:solidFill>
                 <a:latin typeface="Arial"/>
               </a:rPr>
-              <a:t>2026 Oct 7  |  매일 아침 탈모 연구 한 편</a:t>
+              <a:t>2026 Oct 15  |  매일 아침 탈모 연구 한 편</a:t>
+            </a:r>
+          </a:p>
+        </p:txBody>
+      </p:sp>
+    </p:spTree>
+  </p:cSld>
+  <p:clrMapOvr>
+    <a:masterClrMapping/>
+  </p:clrMapOvr>
+</p:sld>
+</file>
+
+<file path=ppt/slides/slide10.xml><?xml version="1.0" encoding="utf-8"?>
+<p:sld xmlns:a="http://schemas.openxmlformats.org/drawingml/2006/main" xmlns:p="http://schemas.openxmlformats.org/presentationml/2006/main" xmlns:r="http://schemas.openxmlformats.org/officeDocument/2006/relationships">
+  <p:cSld>
+    <p:bg>
+      <p:bgPr>
+        <a:solidFill>
+          <a:srgbClr val="12142A"/>
+        </a:solidFill>
+        <a:effectLst/>
+      </p:bgPr>
+    </p:bg>
+    <p:spTree>
+      <p:nvGrpSpPr>
+        <p:cNvPr id="1" name=""/>
+        <p:cNvGrpSpPr/>
+        <p:nvPr/>
+      </p:nvGrpSpPr>
+      <p:grpSpPr/>
+      <p:sp>
+        <p:nvSpPr>
+          <p:cNvPr id="2" name="TextBox 1"/>
+          <p:cNvSpPr txBox="1"/>
+          <p:nvPr/>
+        </p:nvSpPr>
+        <p:spPr>
+          <a:xfrm>
+            <a:off x="365760" y="457200"/>
+            <a:ext cx="4828032" cy="457200"/>
+          </a:xfrm>
+          <a:prstGeom prst="rect">
+            <a:avLst/>
+          </a:prstGeom>
+          <a:noFill/>
+        </p:spPr>
+        <p:txBody>
+          <a:bodyPr wrap="square" anchor="ctr">
+            <a:spAutoFit/>
+          </a:bodyPr>
+          <a:lstStyle/>
+          <a:p>
+            <a:pPr algn="l"/>
+            <a:r>
+              <a:rPr sz="1600" b="1">
+                <a:solidFill>
+                  <a:srgbClr val="FF6B6B"/>
+                </a:solidFill>
+                <a:latin typeface="Arial"/>
+              </a:rPr>
+              <a:t>본문 요약 (편집용)</a:t>
+            </a:r>
+          </a:p>
+        </p:txBody>
+      </p:sp>
+      <p:sp>
+        <p:nvSpPr>
+          <p:cNvPr id="3" name="TextBox 2"/>
+          <p:cNvSpPr txBox="1"/>
+          <p:nvPr/>
+        </p:nvSpPr>
+        <p:spPr>
+          <a:xfrm>
+            <a:off x="365760" y="1097280"/>
+            <a:ext cx="4828032" cy="457200"/>
+          </a:xfrm>
+          <a:prstGeom prst="rect">
+            <a:avLst/>
+          </a:prstGeom>
+          <a:noFill/>
+        </p:spPr>
+        <p:txBody>
+          <a:bodyPr wrap="square" anchor="t">
+            <a:spAutoFit/>
+          </a:bodyPr>
+          <a:lstStyle/>
+          <a:p>
+            <a:pPr algn="l"/>
+            <a:r>
+              <a:rPr sz="1300" b="1">
+                <a:solidFill>
+                  <a:srgbClr val="FFFFFF"/>
+                </a:solidFill>
+                <a:latin typeface="Arial"/>
+              </a:rPr>
+              <a:t>◆ 결론 — 5. Conclusions</a:t>
+            </a:r>
+          </a:p>
+        </p:txBody>
+      </p:sp>
+      <p:sp>
+        <p:nvSpPr>
+          <p:cNvPr id="4" name="TextBox 3"/>
+          <p:cNvSpPr txBox="1"/>
+          <p:nvPr/>
+        </p:nvSpPr>
+        <p:spPr>
+          <a:xfrm>
+            <a:off x="457200" y="1600200"/>
+            <a:ext cx="4736592" cy="3566160"/>
+          </a:xfrm>
+          <a:prstGeom prst="rect">
+            <a:avLst/>
+          </a:prstGeom>
+          <a:noFill/>
+        </p:spPr>
+        <p:txBody>
+          <a:bodyPr wrap="square" anchor="t">
+            <a:spAutoFit/>
+          </a:bodyPr>
+          <a:lstStyle/>
+          <a:p>
+            <a:pPr algn="l"/>
+            <a:r>
+              <a:rPr sz="1000" b="0">
+                <a:solidFill>
+                  <a:srgbClr val="D5D8EA"/>
+                </a:solidFill>
+                <a:latin typeface="Arial"/>
+              </a:rPr>
+              <a:t>· In summary, this study successfully developed a novel dual-drug-loaded nanogel delivery system: Bai-Min-NGs, providing a highly promising and innovative strategy to overcome the bottlenecks of poor transdermal permeability and low bioavailability associated with traditional topical treatments for AGA.
+· Leveraging the three-dimensional synergistic effect between the high-pressure homogenized nanoemulsion core and the gel network, Bai-Min-NGs effectively overcome the robust physical barrier of the stratum corneum.
+· This system not only achieves prolonged retention and controlled release of Baicalin and Minoxidil within the deep layers of the skin but also targets DPCs via efficient endocytic pathways.</a:t>
+            </a:r>
+          </a:p>
+        </p:txBody>
+      </p:sp>
+    </p:spTree>
+  </p:cSld>
+  <p:clrMapOvr>
+    <a:masterClrMapping/>
+  </p:clrMapOvr>
+</p:sld>
+</file>
+
+<file path=ppt/slides/slide11.xml><?xml version="1.0" encoding="utf-8"?>
+<p:sld xmlns:a="http://schemas.openxmlformats.org/drawingml/2006/main" xmlns:p="http://schemas.openxmlformats.org/presentationml/2006/main" xmlns:r="http://schemas.openxmlformats.org/officeDocument/2006/relationships">
+  <p:cSld>
+    <p:bg>
+      <p:bgPr>
+        <a:solidFill>
+          <a:srgbClr val="12142A"/>
+        </a:solidFill>
+        <a:effectLst/>
+      </p:bgPr>
+    </p:bg>
+    <p:spTree>
+      <p:nvGrpSpPr>
+        <p:cNvPr id="1" name=""/>
+        <p:cNvGrpSpPr/>
+        <p:nvPr/>
+      </p:nvGrpSpPr>
+      <p:grpSpPr/>
+      <p:sp>
+        <p:nvSpPr>
+          <p:cNvPr id="2" name="TextBox 1"/>
+          <p:cNvSpPr txBox="1"/>
+          <p:nvPr/>
+        </p:nvSpPr>
+        <p:spPr>
+          <a:xfrm>
+            <a:off x="365760" y="731520"/>
+            <a:ext cx="4828032" cy="548640"/>
+          </a:xfrm>
+          <a:prstGeom prst="rect">
+            <a:avLst/>
+          </a:prstGeom>
+          <a:noFill/>
+        </p:spPr>
+        <p:txBody>
+          <a:bodyPr wrap="square" anchor="ctr">
+            <a:spAutoFit/>
+          </a:bodyPr>
+          <a:lstStyle/>
+          <a:p>
+            <a:pPr algn="ctr"/>
+            <a:r>
+              <a:rPr sz="2200" b="1">
+                <a:solidFill>
+                  <a:srgbClr val="FF6B6B"/>
+                </a:solidFill>
+                <a:latin typeface="Arial"/>
+              </a:rPr>
+              <a:t>출처</a:t>
+            </a:r>
+          </a:p>
+        </p:txBody>
+      </p:sp>
+      <p:sp>
+        <p:nvSpPr>
+          <p:cNvPr id="3" name="TextBox 2"/>
+          <p:cNvSpPr txBox="1"/>
+          <p:nvPr/>
+        </p:nvSpPr>
+        <p:spPr>
+          <a:xfrm>
+            <a:off x="365760" y="1463040"/>
+            <a:ext cx="4828032" cy="7680960"/>
+          </a:xfrm>
+          <a:prstGeom prst="rect">
+            <a:avLst/>
+          </a:prstGeom>
+          <a:noFill/>
+        </p:spPr>
+        <p:txBody>
+          <a:bodyPr wrap="square" anchor="t">
+            <a:spAutoFit/>
+          </a:bodyPr>
+          <a:lstStyle/>
+          <a:p>
+            <a:pPr algn="l"/>
+            <a:r>
+              <a:rPr sz="1000" b="0">
+                <a:solidFill>
+                  <a:srgbClr val="D5D8EA"/>
+                </a:solidFill>
+                <a:latin typeface="Arial"/>
+              </a:rPr>
+              <a:t>[출처]
+논문: Study on Construction of and Pharmacodynamics of Baicalin-Minoxidil Co-Loaded Nanogel
+게재: Pharmaceutics
+원문: https://pubmed.ncbi.nlm.nih.gov/42942839/
+[이미지 출처]
+- Male pattern baldness.jpg / Originally uploaded by Lkinkade (Transferred by XenonX3) / CC BY-SA 2.5
+  https://commons.wikimedia.org/wiki/File:Male_pattern_baldness.jpg
+- Male-pattern hair loss.jpg / BlaiserPascal / CC BY-SA 4.0
+  https://commons.wikimedia.org/wiki/File:Male-pattern_hair_loss.jpg
+※ CC BY-SA 이미지가 포함되어 있습니다. 저작자 표시가 필수이며,
+  동일조건변경허락(ShareAlike) 조항이 영상 전체에 적용될 수 있으니
+  상업적 이용 시 해당 이미지를 교체하는 편이 안전합니다.
+[논문 본문 그림·표]
+- PubMed Central PMC13708190 (재사용 가능 라이선스)
+  https://www.ncbi.nlm.nih.gov/pmc/articles/PMC13708190/
+  · Table 1
+  ※ 오픈액세스 논문의 그림·표이며, 위 원문 출처를 함께 표기하세요.
+</a:t>
             </a:r>
           </a:p>
         </p:txBody>
@@ -4304,7 +4707,7 @@
                 </a:solidFill>
                 <a:latin typeface="Arial"/>
               </a:rPr>
-              <a:t>Destroyed Melanocytes Manifested with Poliosis and Halo Nevi in Children: Proposed Immunopathophysiological Mechanisms with Emphasis on Hair Follicle Immune Privilege</a:t>
+              <a:t>Study on Construction of and Pharmacodynamics of Baicalin-Minoxidil Co-Loaded Nanogel</a:t>
             </a:r>
           </a:p>
         </p:txBody>
@@ -4339,7 +4742,7 @@
                 </a:solidFill>
                 <a:latin typeface="Arial"/>
               </a:rPr>
-              <a:t>Clinics and practice  ·  2026 Oct 7</a:t>
+              <a:t>Pharmaceutics  ·  2026 Oct 15</a:t>
             </a:r>
           </a:p>
         </p:txBody>
@@ -4468,7 +4871,7 @@
                 </a:solidFill>
                 <a:latin typeface="Arial"/>
               </a:rPr>
-              <a:t>Both poliosis (circumscribed depigmentation of the hair in any area of the body) and halo nevi (a melanocytic nevus which acquires a surrounding depigmented rim) are characterized by depigmentation driven by a T-cell-mediated loss of functional melanocytes within the epidermis and hair bulbs.</a:t>
+              <a:t>Androgenetic alopecia (AGA) is a chronic and highly prevalent hair loss disorder for which current topical therapies are limited by undesirable side effects, dose-dependent efficacy, and poor skin penetration.</a:t>
             </a:r>
           </a:p>
         </p:txBody>
@@ -4482,6 +4885,480 @@
 </file>
 
 <file path=ppt/slides/slide4.xml><?xml version="1.0" encoding="utf-8"?>
+<p:sld xmlns:a="http://schemas.openxmlformats.org/drawingml/2006/main" xmlns:p="http://schemas.openxmlformats.org/presentationml/2006/main" xmlns:r="http://schemas.openxmlformats.org/officeDocument/2006/relationships">
+  <p:cSld>
+    <p:bg>
+      <p:bgPr>
+        <a:solidFill>
+          <a:srgbClr val="12142A"/>
+        </a:solidFill>
+        <a:effectLst/>
+      </p:bgPr>
+    </p:bg>
+    <p:spTree>
+      <p:nvGrpSpPr>
+        <p:cNvPr id="1" name=""/>
+        <p:cNvGrpSpPr/>
+        <p:nvPr/>
+      </p:nvGrpSpPr>
+      <p:grpSpPr/>
+      <p:sp>
+        <p:nvSpPr>
+          <p:cNvPr id="2" name="TextBox 1"/>
+          <p:cNvSpPr txBox="1"/>
+          <p:nvPr/>
+        </p:nvSpPr>
+        <p:spPr>
+          <a:xfrm>
+            <a:off x="365760" y="1097280"/>
+            <a:ext cx="4828032" cy="548640"/>
+          </a:xfrm>
+          <a:prstGeom prst="rect">
+            <a:avLst/>
+          </a:prstGeom>
+          <a:noFill/>
+        </p:spPr>
+        <p:txBody>
+          <a:bodyPr wrap="square" anchor="ctr">
+            <a:spAutoFit/>
+          </a:bodyPr>
+          <a:lstStyle/>
+          <a:p>
+            <a:pPr algn="ctr"/>
+            <a:r>
+              <a:rPr sz="2000" b="1">
+                <a:solidFill>
+                  <a:srgbClr val="FF6B6B"/>
+                </a:solidFill>
+                <a:latin typeface="Arial"/>
+              </a:rPr>
+              <a:t>논문 Table 1</a:t>
+            </a:r>
+          </a:p>
+        </p:txBody>
+      </p:sp>
+      <p:sp>
+        <p:nvSpPr>
+          <p:cNvPr id="3" name="TextBox 2"/>
+          <p:cNvSpPr txBox="1"/>
+          <p:nvPr/>
+        </p:nvSpPr>
+        <p:spPr>
+          <a:xfrm>
+            <a:off x="365760" y="1737360"/>
+            <a:ext cx="4828032" cy="914400"/>
+          </a:xfrm>
+          <a:prstGeom prst="rect">
+            <a:avLst/>
+          </a:prstGeom>
+          <a:noFill/>
+        </p:spPr>
+        <p:txBody>
+          <a:bodyPr wrap="square" anchor="ctr">
+            <a:spAutoFit/>
+          </a:bodyPr>
+          <a:lstStyle/>
+          <a:p>
+            <a:pPr algn="ctr"/>
+            <a:r>
+              <a:rPr sz="1300" b="0">
+                <a:solidFill>
+                  <a:srgbClr val="AAAFCD"/>
+                </a:solidFill>
+                <a:latin typeface="Arial"/>
+              </a:rPr>
+              <a:t>In vitro release kinetic parameters and model fitting of Baicalin and Minoxidil from Bai-Min-NGs.</a:t>
+            </a:r>
+          </a:p>
+        </p:txBody>
+      </p:sp>
+      <p:graphicFrame>
+        <p:nvGraphicFramePr>
+          <p:cNvPr id="4" name="Table 3"/>
+          <p:cNvGraphicFramePr>
+            <a:graphicFrameLocks noGrp="1"/>
+          </p:cNvGraphicFramePr>
+          <p:nvPr/>
+        </p:nvGraphicFramePr>
+        <p:xfrm>
+          <a:off x="320040" y="2926080"/>
+          <a:ext cx="4919472" cy="2514600"/>
+        </p:xfrm>
+        <a:graphic>
+          <a:graphicData uri="http://schemas.openxmlformats.org/drawingml/2006/table">
+            <a:tbl>
+              <a:tblPr firstRow="1" bandRow="1">
+                <a:tableStyleId>{5C22544A-7EE6-4342-B048-85BDC9FD1C3A}</a:tableStyleId>
+              </a:tblPr>
+              <a:tblGrid>
+                <a:gridCol w="1229868"/>
+                <a:gridCol w="1229868"/>
+                <a:gridCol w="1229868"/>
+                <a:gridCol w="1229868"/>
+              </a:tblGrid>
+              <a:tr h="502920">
+                <a:tc>
+                  <a:txBody>
+                    <a:bodyPr/>
+                    <a:lstStyle/>
+                    <a:p>
+                      <a:pPr>
+                        <a:defRPr sz="1200" b="1">
+                          <a:latin typeface="Arial"/>
+                        </a:defRPr>
+                      </a:pPr>
+                      <a:r>
+                        <a:t>Kinetic Models</a:t>
+                      </a:r>
+                    </a:p>
+                  </a:txBody>
+                  <a:tcPr/>
+                </a:tc>
+                <a:tc>
+                  <a:txBody>
+                    <a:bodyPr/>
+                    <a:lstStyle/>
+                    <a:p>
+                      <a:pPr>
+                        <a:defRPr sz="1200" b="1">
+                          <a:latin typeface="Arial"/>
+                        </a:defRPr>
+                      </a:pPr>
+                      <a:r>
+                        <a:t>Mathematical Equation</a:t>
+                      </a:r>
+                    </a:p>
+                  </a:txBody>
+                  <a:tcPr/>
+                </a:tc>
+                <a:tc>
+                  <a:txBody>
+                    <a:bodyPr/>
+                    <a:lstStyle/>
+                    <a:p>
+                      <a:pPr>
+                        <a:defRPr sz="1200" b="1">
+                          <a:latin typeface="Arial"/>
+                        </a:defRPr>
+                      </a:pPr>
+                      <a:r>
+                        <a:t>Active Drug</a:t>
+                      </a:r>
+                    </a:p>
+                  </a:txBody>
+                  <a:tcPr/>
+                </a:tc>
+                <a:tc>
+                  <a:txBody>
+                    <a:bodyPr/>
+                    <a:lstStyle/>
+                    <a:p>
+                      <a:pPr>
+                        <a:defRPr sz="1200" b="1">
+                          <a:latin typeface="Arial"/>
+                        </a:defRPr>
+                      </a:pPr>
+                      <a:r>
+                        <a:t>Fitted Equation</a:t>
+                      </a:r>
+                    </a:p>
+                  </a:txBody>
+                  <a:tcPr/>
+                </a:tc>
+              </a:tr>
+              <a:tr h="502920">
+                <a:tc>
+                  <a:txBody>
+                    <a:bodyPr/>
+                    <a:lstStyle/>
+                    <a:p>
+                      <a:pPr>
+                        <a:defRPr sz="1100" b="0">
+                          <a:latin typeface="Arial"/>
+                        </a:defRPr>
+                      </a:pPr>
+                      <a:r>
+                        <a:t>Zero -order</a:t>
+                      </a:r>
+                    </a:p>
+                  </a:txBody>
+                  <a:tcPr/>
+                </a:tc>
+                <a:tc>
+                  <a:txBody>
+                    <a:bodyPr/>
+                    <a:lstStyle/>
+                    <a:p>
+                      <a:pPr>
+                        <a:defRPr sz="1100" b="0">
+                          <a:latin typeface="Arial"/>
+                        </a:defRPr>
+                      </a:pPr>
+                      <a:r>
+                        <a:t>Q = k0·t + a</a:t>
+                      </a:r>
+                    </a:p>
+                  </a:txBody>
+                  <a:tcPr/>
+                </a:tc>
+                <a:tc>
+                  <a:txBody>
+                    <a:bodyPr/>
+                    <a:lstStyle/>
+                    <a:p>
+                      <a:pPr>
+                        <a:defRPr sz="1100" b="0">
+                          <a:latin typeface="Arial"/>
+                        </a:defRPr>
+                      </a:pPr>
+                      <a:r>
+                        <a:t>Min in NGsBai in NGs</a:t>
+                      </a:r>
+                    </a:p>
+                  </a:txBody>
+                  <a:tcPr/>
+                </a:tc>
+                <a:tc>
+                  <a:txBody>
+                    <a:bodyPr/>
+                    <a:lstStyle/>
+                    <a:p>
+                      <a:pPr>
+                        <a:defRPr sz="1100" b="0">
+                          <a:latin typeface="Arial"/>
+                        </a:defRPr>
+                      </a:pPr>
+                      <a:r>
+                        <a:t>Q = 3.9713t − 4.7891Q = 0.7751t − 0.6348</a:t>
+                      </a:r>
+                    </a:p>
+                  </a:txBody>
+                  <a:tcPr/>
+                </a:tc>
+              </a:tr>
+              <a:tr h="502920">
+                <a:tc>
+                  <a:txBody>
+                    <a:bodyPr/>
+                    <a:lstStyle/>
+                    <a:p>
+                      <a:pPr>
+                        <a:defRPr sz="1100" b="0">
+                          <a:latin typeface="Arial"/>
+                        </a:defRPr>
+                      </a:pPr>
+                      <a:r>
+                        <a:t>First-order model</a:t>
+                      </a:r>
+                    </a:p>
+                  </a:txBody>
+                  <a:tcPr/>
+                </a:tc>
+                <a:tc>
+                  <a:txBody>
+                    <a:bodyPr/>
+                    <a:lstStyle/>
+                    <a:p>
+                      <a:pPr>
+                        <a:defRPr sz="1100" b="0">
+                          <a:latin typeface="Arial"/>
+                        </a:defRPr>
+                      </a:pPr>
+                      <a:r>
+                        <a:t>ln(100 − Q) = −k1·t + a</a:t>
+                      </a:r>
+                    </a:p>
+                  </a:txBody>
+                  <a:tcPr/>
+                </a:tc>
+                <a:tc>
+                  <a:txBody>
+                    <a:bodyPr/>
+                    <a:lstStyle/>
+                    <a:p>
+                      <a:pPr>
+                        <a:defRPr sz="1100" b="0">
+                          <a:latin typeface="Arial"/>
+                        </a:defRPr>
+                      </a:pPr>
+                      <a:r>
+                        <a:t>Min in NGsBai in NGs</a:t>
+                      </a:r>
+                    </a:p>
+                  </a:txBody>
+                  <a:tcPr/>
+                </a:tc>
+                <a:tc>
+                  <a:txBody>
+                    <a:bodyPr/>
+                    <a:lstStyle/>
+                    <a:p>
+                      <a:pPr>
+                        <a:defRPr sz="1100" b="0">
+                          <a:latin typeface="Arial"/>
+                        </a:defRPr>
+                      </a:pPr>
+                      <a:r>
+                        <a:t>ln(100 − Q) = −0.1011t + 4.8715ln(100 − </a:t>
+                      </a:r>
+                    </a:p>
+                  </a:txBody>
+                  <a:tcPr/>
+                </a:tc>
+              </a:tr>
+              <a:tr h="502920">
+                <a:tc>
+                  <a:txBody>
+                    <a:bodyPr/>
+                    <a:lstStyle/>
+                    <a:p>
+                      <a:pPr>
+                        <a:defRPr sz="1100" b="0">
+                          <a:latin typeface="Arial"/>
+                        </a:defRPr>
+                      </a:pPr>
+                      <a:r>
+                        <a:t>Higuchi model</a:t>
+                      </a:r>
+                    </a:p>
+                  </a:txBody>
+                  <a:tcPr/>
+                </a:tc>
+                <a:tc>
+                  <a:txBody>
+                    <a:bodyPr/>
+                    <a:lstStyle/>
+                    <a:p>
+                      <a:pPr>
+                        <a:defRPr sz="1100" b="0">
+                          <a:latin typeface="Arial"/>
+                        </a:defRPr>
+                      </a:pPr>
+                      <a:r>
+                        <a:t>Q = kH·t1/2 + a</a:t>
+                      </a:r>
+                    </a:p>
+                  </a:txBody>
+                  <a:tcPr/>
+                </a:tc>
+                <a:tc>
+                  <a:txBody>
+                    <a:bodyPr/>
+                    <a:lstStyle/>
+                    <a:p>
+                      <a:pPr>
+                        <a:defRPr sz="1100" b="0">
+                          <a:latin typeface="Arial"/>
+                        </a:defRPr>
+                      </a:pPr>
+                      <a:r>
+                        <a:t>Min in NGsBai in NGs</a:t>
+                      </a:r>
+                    </a:p>
+                  </a:txBody>
+                  <a:tcPr/>
+                </a:tc>
+                <a:tc>
+                  <a:txBody>
+                    <a:bodyPr/>
+                    <a:lstStyle/>
+                    <a:p>
+                      <a:pPr>
+                        <a:defRPr sz="1100" b="0">
+                          <a:latin typeface="Arial"/>
+                        </a:defRPr>
+                      </a:pPr>
+                      <a:r>
+                        <a:t>Q = 19.7883t1/2 − 22.7026Q = 3.8855t1/2 </a:t>
+                      </a:r>
+                    </a:p>
+                  </a:txBody>
+                  <a:tcPr/>
+                </a:tc>
+              </a:tr>
+              <a:tr h="502920">
+                <a:tc>
+                  <a:txBody>
+                    <a:bodyPr/>
+                    <a:lstStyle/>
+                    <a:p>
+                      <a:pPr>
+                        <a:defRPr sz="1100" b="0">
+                          <a:latin typeface="Arial"/>
+                        </a:defRPr>
+                      </a:pPr>
+                      <a:r>
+                        <a:t>Korsmeyer-Peppas model(Mt/M∞ ≤ 0.60)</a:t>
+                      </a:r>
+                    </a:p>
+                  </a:txBody>
+                  <a:tcPr/>
+                </a:tc>
+                <a:tc>
+                  <a:txBody>
+                    <a:bodyPr/>
+                    <a:lstStyle/>
+                    <a:p>
+                      <a:pPr>
+                        <a:defRPr sz="1100" b="0">
+                          <a:latin typeface="Arial"/>
+                        </a:defRPr>
+                      </a:pPr>
+                      <a:r>
+                        <a:t>ln(Mt/M∞) = n·ln(t) + ln(kKP)</a:t>
+                      </a:r>
+                    </a:p>
+                  </a:txBody>
+                  <a:tcPr/>
+                </a:tc>
+                <a:tc>
+                  <a:txBody>
+                    <a:bodyPr/>
+                    <a:lstStyle/>
+                    <a:p>
+                      <a:pPr>
+                        <a:defRPr sz="1100" b="0">
+                          <a:latin typeface="Arial"/>
+                        </a:defRPr>
+                      </a:pPr>
+                      <a:r>
+                        <a:t>Min in NGsBai in NGs</a:t>
+                      </a:r>
+                    </a:p>
+                  </a:txBody>
+                  <a:tcPr/>
+                </a:tc>
+                <a:tc>
+                  <a:txBody>
+                    <a:bodyPr/>
+                    <a:lstStyle/>
+                    <a:p>
+                      <a:pPr>
+                        <a:defRPr sz="1100" b="0">
+                          <a:latin typeface="Arial"/>
+                        </a:defRPr>
+                      </a:pPr>
+                      <a:r>
+                        <a:t>ln(Mt/M∞) = 1.2429ln(t) − 4.1131ln(Mt/M∞</a:t>
+                      </a:r>
+                    </a:p>
+                  </a:txBody>
+                  <a:tcPr/>
+                </a:tc>
+              </a:tr>
+            </a:tbl>
+          </a:graphicData>
+        </a:graphic>
+      </p:graphicFrame>
+    </p:spTree>
+  </p:cSld>
+  <p:clrMapOvr>
+    <a:masterClrMapping/>
+  </p:clrMapOvr>
+</p:sld>
+</file>
+
+<file path=ppt/slides/slide5.xml><?xml version="1.0" encoding="utf-8"?>
 <p:sld xmlns:a="http://schemas.openxmlformats.org/drawingml/2006/main" xmlns:p="http://schemas.openxmlformats.org/presentationml/2006/main" xmlns:r="http://schemas.openxmlformats.org/officeDocument/2006/relationships">
   <p:cSld>
     <p:bg>
@@ -4597,7 +5474,7 @@
                 </a:solidFill>
                 <a:latin typeface="Arial"/>
               </a:rPr>
-              <a:t>Halo nevi and poliosis are a relatively frequent phenomenon occurring in 1% of the children and adolescents with an average age of onset of 15 years and has no gender predisposition.</a:t>
+              <a:t>Objective: Here, we developed a baicalin-minoxidil co-loaded nanogel (Bai-Min-NGs) to synergistically enhance transdermal drug delivery and promote hair regeneration.</a:t>
             </a:r>
           </a:p>
         </p:txBody>
@@ -4610,7 +5487,7 @@
 </p:sld>
 </file>
 
-<file path=ppt/slides/slide5.xml><?xml version="1.0" encoding="utf-8"?>
+<file path=ppt/slides/slide6.xml><?xml version="1.0" encoding="utf-8"?>
 <p:sld xmlns:a="http://schemas.openxmlformats.org/drawingml/2006/main" xmlns:p="http://schemas.openxmlformats.org/presentationml/2006/main" xmlns:r="http://schemas.openxmlformats.org/officeDocument/2006/relationships">
   <p:cSld>
     <p:bg>
@@ -4739,7 +5616,7 @@
 </p:sld>
 </file>
 
-<file path=ppt/slides/slide6.xml><?xml version="1.0" encoding="utf-8"?>
+<file path=ppt/slides/slide7.xml><?xml version="1.0" encoding="utf-8"?>
 <p:sld xmlns:a="http://schemas.openxmlformats.org/drawingml/2006/main" xmlns:p="http://schemas.openxmlformats.org/presentationml/2006/main" xmlns:r="http://schemas.openxmlformats.org/officeDocument/2006/relationships">
   <p:cSld>
     <p:bg>
@@ -4788,208 +5665,6 @@
                 <a:latin typeface="Arial"/>
               </a:rPr>
               <a:t>더 자세한 내용은 원문 링크에서 확인하세요. 매일 새로운 탈모 연구, 팔로우하고 놓치지 마세요!</a:t>
-            </a:r>
-          </a:p>
-        </p:txBody>
-      </p:sp>
-    </p:spTree>
-  </p:cSld>
-  <p:clrMapOvr>
-    <a:masterClrMapping/>
-  </p:clrMapOvr>
-</p:sld>
-</file>
-
-<file path=ppt/slides/slide7.xml><?xml version="1.0" encoding="utf-8"?>
-<p:sld xmlns:a="http://schemas.openxmlformats.org/drawingml/2006/main" xmlns:p="http://schemas.openxmlformats.org/presentationml/2006/main" xmlns:r="http://schemas.openxmlformats.org/officeDocument/2006/relationships">
-  <p:cSld>
-    <p:bg>
-      <p:bgPr>
-        <a:solidFill>
-          <a:srgbClr val="12142A"/>
-        </a:solidFill>
-        <a:effectLst/>
-      </p:bgPr>
-    </p:bg>
-    <p:spTree>
-      <p:nvGrpSpPr>
-        <p:cNvPr id="1" name=""/>
-        <p:cNvGrpSpPr/>
-        <p:nvPr/>
-      </p:nvGrpSpPr>
-      <p:grpSpPr/>
-      <p:sp>
-        <p:nvSpPr>
-          <p:cNvPr id="2" name="TextBox 1"/>
-          <p:cNvSpPr txBox="1"/>
-          <p:nvPr/>
-        </p:nvSpPr>
-        <p:spPr>
-          <a:xfrm>
-            <a:off x="365760" y="457200"/>
-            <a:ext cx="4828032" cy="457200"/>
-          </a:xfrm>
-          <a:prstGeom prst="rect">
-            <a:avLst/>
-          </a:prstGeom>
-          <a:noFill/>
-        </p:spPr>
-        <p:txBody>
-          <a:bodyPr wrap="square" anchor="ctr">
-            <a:spAutoFit/>
-          </a:bodyPr>
-          <a:lstStyle/>
-          <a:p>
-            <a:pPr algn="l"/>
-            <a:r>
-              <a:rPr sz="1600" b="1">
-                <a:solidFill>
-                  <a:srgbClr val="FF6B6B"/>
-                </a:solidFill>
-                <a:latin typeface="Arial"/>
-              </a:rPr>
-              <a:t>본문 요약 (편집용)</a:t>
-            </a:r>
-          </a:p>
-        </p:txBody>
-      </p:sp>
-      <p:sp>
-        <p:nvSpPr>
-          <p:cNvPr id="3" name="TextBox 2"/>
-          <p:cNvSpPr txBox="1"/>
-          <p:nvPr/>
-        </p:nvSpPr>
-        <p:spPr>
-          <a:xfrm>
-            <a:off x="365760" y="1097280"/>
-            <a:ext cx="4828032" cy="457200"/>
-          </a:xfrm>
-          <a:prstGeom prst="rect">
-            <a:avLst/>
-          </a:prstGeom>
-          <a:noFill/>
-        </p:spPr>
-        <p:txBody>
-          <a:bodyPr wrap="square" anchor="t">
-            <a:spAutoFit/>
-          </a:bodyPr>
-          <a:lstStyle/>
-          <a:p>
-            <a:pPr algn="l"/>
-            <a:r>
-              <a:rPr sz="1300" b="1">
-                <a:solidFill>
-                  <a:srgbClr val="FFFFFF"/>
-                </a:solidFill>
-                <a:latin typeface="Arial"/>
-              </a:rPr>
-              <a:t>◆ 배경 — Background (자동 구분)</a:t>
-            </a:r>
-          </a:p>
-        </p:txBody>
-      </p:sp>
-      <p:sp>
-        <p:nvSpPr>
-          <p:cNvPr id="4" name="TextBox 3"/>
-          <p:cNvSpPr txBox="1"/>
-          <p:nvPr/>
-        </p:nvSpPr>
-        <p:spPr>
-          <a:xfrm>
-            <a:off x="457200" y="1600200"/>
-            <a:ext cx="4736592" cy="3566160"/>
-          </a:xfrm>
-          <a:prstGeom prst="rect">
-            <a:avLst/>
-          </a:prstGeom>
-          <a:noFill/>
-        </p:spPr>
-        <p:txBody>
-          <a:bodyPr wrap="square" anchor="t">
-            <a:spAutoFit/>
-          </a:bodyPr>
-          <a:lstStyle/>
-          <a:p>
-            <a:pPr algn="l"/>
-            <a:r>
-              <a:rPr sz="1000" b="0">
-                <a:solidFill>
-                  <a:srgbClr val="D5D8EA"/>
-                </a:solidFill>
-                <a:latin typeface="Arial"/>
-              </a:rPr>
-              <a:t>· Both poliosis (circumscribed depigmentation of the hair in any area of the body) and halo nevi (a melanocytic nevus which acquires a surrounding depigmented rim) are characterized by depigmentation driven by a T-cell-mediated loss of functional melanocytes within the epidermis and hair bulbs.
-· Halo nevi and poliosis are a relatively frequent phenomenon occurring in 1% of the children and adolescents with an average age of onset of 15 years and has no gender predisposition.</a:t>
-            </a:r>
-          </a:p>
-        </p:txBody>
-      </p:sp>
-      <p:sp>
-        <p:nvSpPr>
-          <p:cNvPr id="5" name="TextBox 4"/>
-          <p:cNvSpPr txBox="1"/>
-          <p:nvPr/>
-        </p:nvSpPr>
-        <p:spPr>
-          <a:xfrm>
-            <a:off x="365760" y="5303520"/>
-            <a:ext cx="4828032" cy="457200"/>
-          </a:xfrm>
-          <a:prstGeom prst="rect">
-            <a:avLst/>
-          </a:prstGeom>
-          <a:noFill/>
-        </p:spPr>
-        <p:txBody>
-          <a:bodyPr wrap="square" anchor="t">
-            <a:spAutoFit/>
-          </a:bodyPr>
-          <a:lstStyle/>
-          <a:p>
-            <a:pPr algn="l"/>
-            <a:r>
-              <a:rPr sz="1300" b="1">
-                <a:solidFill>
-                  <a:srgbClr val="FFFFFF"/>
-                </a:solidFill>
-                <a:latin typeface="Arial"/>
-              </a:rPr>
-              <a:t>◆ 연구 방법 — Methods (자동 구분)</a:t>
-            </a:r>
-          </a:p>
-        </p:txBody>
-      </p:sp>
-      <p:sp>
-        <p:nvSpPr>
-          <p:cNvPr id="6" name="TextBox 5"/>
-          <p:cNvSpPr txBox="1"/>
-          <p:nvPr/>
-        </p:nvSpPr>
-        <p:spPr>
-          <a:xfrm>
-            <a:off x="457200" y="5806440"/>
-            <a:ext cx="4736592" cy="3566160"/>
-          </a:xfrm>
-          <a:prstGeom prst="rect">
-            <a:avLst/>
-          </a:prstGeom>
-          <a:noFill/>
-        </p:spPr>
-        <p:txBody>
-          <a:bodyPr wrap="square" anchor="t">
-            <a:spAutoFit/>
-          </a:bodyPr>
-          <a:lstStyle/>
-          <a:p>
-            <a:pPr algn="l"/>
-            <a:r>
-              <a:rPr sz="1000" b="0">
-                <a:solidFill>
-                  <a:srgbClr val="D5D8EA"/>
-                </a:solidFill>
-                <a:latin typeface="Arial"/>
-              </a:rPr>
-              <a:t>· This may indicate that the halo nevi on the trunk induced a temporary systemic autoimmune reaction during the halo phenomenon, collaterally destroying melanocytes at distance on the scalp causing poliosis.</a:t>
             </a:r>
           </a:p>
         </p:txBody>
@@ -5085,7 +5760,7 @@
                 </a:solidFill>
                 <a:latin typeface="Arial"/>
               </a:rPr>
-              <a:t>◆ 주요 결과 — Results (자동 구분)</a:t>
+              <a:t>◆ 배경 — 1. Introduction</a:t>
             </a:r>
           </a:p>
         </p:txBody>
@@ -5120,9 +5795,81 @@
                 </a:solidFill>
                 <a:latin typeface="Arial"/>
               </a:rPr>
-              <a:t>· Both can be associated with vitiligo and are occasionally seen together as the same cytotoxic immune response (specifically CD8+ T cells) that destroys nevus melanocytes which can attack the same melanocyte-specific targets surrounding epidermal and follicular melanocytes.
-· While poliosis is frequently seen on the scalp, halo nevi on the scalp have been scarcely reported in the literature.
-· The timing of occurrence of the destruction of both epidermal and follicular melanocytes may be supported by a case of a 13-year-old Caucasian male with three halo nevi on the trunk which preceded the development of four scalp patches of poliosis.</a:t>
+              <a:t>· Androgenetic alopecia (AGA) is a pervasive dermatological condition affecting hundreds of millions of people worldwide, characterized by progressive follicular miniaturization and disrupted hair growth cycles.
+· Despite the availability of various therapeutic modalities, minoxidil (Min), the first-line clinical drug, still faces formidable challenges in practical application.
+· On one hand, commercially available formulations typically contain high concentrations of ethanol and propylene glycol, which frequently lead to severe allergic contact dermatitis and scalp dryness upon long-term use.</a:t>
+            </a:r>
+          </a:p>
+        </p:txBody>
+      </p:sp>
+      <p:sp>
+        <p:nvSpPr>
+          <p:cNvPr id="5" name="TextBox 4"/>
+          <p:cNvSpPr txBox="1"/>
+          <p:nvPr/>
+        </p:nvSpPr>
+        <p:spPr>
+          <a:xfrm>
+            <a:off x="365760" y="5303520"/>
+            <a:ext cx="4828032" cy="457200"/>
+          </a:xfrm>
+          <a:prstGeom prst="rect">
+            <a:avLst/>
+          </a:prstGeom>
+          <a:noFill/>
+        </p:spPr>
+        <p:txBody>
+          <a:bodyPr wrap="square" anchor="t">
+            <a:spAutoFit/>
+          </a:bodyPr>
+          <a:lstStyle/>
+          <a:p>
+            <a:pPr algn="l"/>
+            <a:r>
+              <a:rPr sz="1300" b="1">
+                <a:solidFill>
+                  <a:srgbClr val="FFFFFF"/>
+                </a:solidFill>
+                <a:latin typeface="Arial"/>
+              </a:rPr>
+              <a:t>◆ 연구 방법 — 2. Materials and Methods</a:t>
+            </a:r>
+          </a:p>
+        </p:txBody>
+      </p:sp>
+      <p:sp>
+        <p:nvSpPr>
+          <p:cNvPr id="6" name="TextBox 5"/>
+          <p:cNvSpPr txBox="1"/>
+          <p:nvPr/>
+        </p:nvSpPr>
+        <p:spPr>
+          <a:xfrm>
+            <a:off x="457200" y="5806440"/>
+            <a:ext cx="4736592" cy="3566160"/>
+          </a:xfrm>
+          <a:prstGeom prst="rect">
+            <a:avLst/>
+          </a:prstGeom>
+          <a:noFill/>
+        </p:spPr>
+        <p:txBody>
+          <a:bodyPr wrap="square" anchor="t">
+            <a:spAutoFit/>
+          </a:bodyPr>
+          <a:lstStyle/>
+          <a:p>
+            <a:pPr algn="l"/>
+            <a:r>
+              <a:rPr sz="1000" b="0">
+                <a:solidFill>
+                  <a:srgbClr val="D5D8EA"/>
+                </a:solidFill>
+                <a:latin typeface="Arial"/>
+              </a:rPr>
+              <a:t>· Cells were cultured in the medium supplemented with 10% fetal bovine serum (FBS) and 1% penicillin-streptomycin at 37 °C in a humidified atmosphere containing 5% CO2.
+· After treatment, cells were incubated with 50 μM LysoTracker Red DND-99 for 90 min to label lysosomes, followed by fixation with 4% paraformaldehyde for 15 min.
+· Statistical significance was defined as follows: ns, not significant; * p &lt; 0.05, ** p &lt; 0.01, *** p &lt; 0.001, and **** p &lt; 0.0001 (vs. model group); # p &lt; 0.05 and ## p &lt; 0.01 (vs. normal group).</a:t>
             </a:r>
           </a:p>
         </p:txBody>
@@ -5161,8 +5908,8 @@
         </p:nvSpPr>
         <p:spPr>
           <a:xfrm>
-            <a:off x="365760" y="731520"/>
-            <a:ext cx="4828032" cy="548640"/>
+            <a:off x="365760" y="457200"/>
+            <a:ext cx="4828032" cy="457200"/>
           </a:xfrm>
           <a:prstGeom prst="rect">
             <a:avLst/>
@@ -5175,15 +5922,15 @@
           </a:bodyPr>
           <a:lstStyle/>
           <a:p>
-            <a:pPr algn="ctr"/>
-            <a:r>
-              <a:rPr sz="2200" b="1">
+            <a:pPr algn="l"/>
+            <a:r>
+              <a:rPr sz="1600" b="1">
                 <a:solidFill>
                   <a:srgbClr val="FF6B6B"/>
                 </a:solidFill>
                 <a:latin typeface="Arial"/>
               </a:rPr>
-              <a:t>출처</a:t>
+              <a:t>본문 요약 (편집용)</a:t>
             </a:r>
           </a:p>
         </p:txBody>
@@ -5196,8 +5943,8 @@
         </p:nvSpPr>
         <p:spPr>
           <a:xfrm>
-            <a:off x="365760" y="1463040"/>
-            <a:ext cx="4828032" cy="7680960"/>
+            <a:off x="365760" y="1097280"/>
+            <a:ext cx="4828032" cy="457200"/>
           </a:xfrm>
           <a:prstGeom prst="rect">
             <a:avLst/>
@@ -5212,25 +5959,127 @@
           <a:p>
             <a:pPr algn="l"/>
             <a:r>
+              <a:rPr sz="1300" b="1">
+                <a:solidFill>
+                  <a:srgbClr val="FFFFFF"/>
+                </a:solidFill>
+                <a:latin typeface="Arial"/>
+              </a:rPr>
+              <a:t>◆ 주요 결과 — 3. Results</a:t>
+            </a:r>
+          </a:p>
+        </p:txBody>
+      </p:sp>
+      <p:sp>
+        <p:nvSpPr>
+          <p:cNvPr id="4" name="TextBox 3"/>
+          <p:cNvSpPr txBox="1"/>
+          <p:nvPr/>
+        </p:nvSpPr>
+        <p:spPr>
+          <a:xfrm>
+            <a:off x="457200" y="1600200"/>
+            <a:ext cx="4736592" cy="3566160"/>
+          </a:xfrm>
+          <a:prstGeom prst="rect">
+            <a:avLst/>
+          </a:prstGeom>
+          <a:noFill/>
+        </p:spPr>
+        <p:txBody>
+          <a:bodyPr wrap="square" anchor="t">
+            <a:spAutoFit/>
+          </a:bodyPr>
+          <a:lstStyle/>
+          <a:p>
+            <a:pPr algn="l"/>
+            <a:r>
               <a:rPr sz="1000" b="0">
                 <a:solidFill>
                   <a:srgbClr val="D5D8EA"/>
                 </a:solidFill>
                 <a:latin typeface="Arial"/>
               </a:rPr>
-              <a:t>[출처]
-논문: Destroyed Melanocytes Manifested with Poliosis and Halo Nevi in Children: Proposed Immunopathophysiological Mechanisms with Emphasis on Hair Follicle Immune Privilege
-게재: Clinics and practice
-원문: https://pubmed.ncbi.nlm.nih.gov/42930370/
-[이미지 출처]
-- Male pattern baldness.jpg / Originally uploaded by Lkinkade (Transferred by XenonX3) / CC BY-SA 2.5
-  https://commons.wikimedia.org/wiki/File:Male_pattern_baldness.jpg
-- Male-pattern hair loss.jpg / BlaiserPascal / CC BY-SA 4.0
-  https://commons.wikimedia.org/wiki/File:Male-pattern_hair_loss.jpg
-※ CC BY-SA 이미지가 포함되어 있습니다. 저작자 표시가 필수이며,
-  동일조건변경허락(ShareAlike) 조항이 영상 전체에 적용될 수 있으니
-  상업적 이용 시 해당 이미지를 교체하는 편이 안전합니다.
-</a:t>
+              <a:t>· The measurement results demonstrated that Bai-Min-NEs possessed an average hydrodynamic diameter of 156 ± 3.62 nm, and the size distribution curve exhibited a symmetrical unimodal distribution, indicating a homogeneous dispersion of the system.
+· Regarding the drug-loading performance, the EE of Bai-Min-NEs for baicalin and minoxidil reached 95.863 ±1.338% and 82.158 ± 2.495%, respectively, which is beneficial for the subsequent drug delivery into the deep layers of the skin.
+· As shown in Figure 2A, the crude baicalin spectrum exhibited representative characteristic absorption peaks at 3490 cm−1, 3390 cm−1, 1661 cm−1 and 1609 cm−1, corresponding to intermolecular hydroxyl groups, free hydroxyl groups, C=C double bonds, and benzene ring C-H stretching vibrations, respectively.
+· The spectrum of minoxidil showed characteristic absorption peaks at 3411 cm−1 (-NH2), 1644 cm−1 (C=C) and 1555 cm−1 (C=N).
+· Furthermore, Korsmeyer–Peppas fitting yielded release exponents (n) of 1.2429 (R2 = 0.9200) for minoxidil and 1.4553 (R2 = 0.9875) for baicalin.
+· The combination index (CI) values across all tested concentrations remained well below 1.0 (ranging from 0.100 to 0.405), reaching 0.271 at the optimal concentration of 5.0 μg/mL.
+· (* p &lt; 0.05, ** p &lt; 0.01, *** p &lt; 0.001, and **** p &lt; 0.0001 (vs. model group); # p &lt; 0.05 and ## p &lt; 0.01 (vs. normal group)).</a:t>
+            </a:r>
+          </a:p>
+        </p:txBody>
+      </p:sp>
+      <p:sp>
+        <p:nvSpPr>
+          <p:cNvPr id="5" name="TextBox 4"/>
+          <p:cNvSpPr txBox="1"/>
+          <p:nvPr/>
+        </p:nvSpPr>
+        <p:spPr>
+          <a:xfrm>
+            <a:off x="365760" y="5303520"/>
+            <a:ext cx="4828032" cy="457200"/>
+          </a:xfrm>
+          <a:prstGeom prst="rect">
+            <a:avLst/>
+          </a:prstGeom>
+          <a:noFill/>
+        </p:spPr>
+        <p:txBody>
+          <a:bodyPr wrap="square" anchor="t">
+            <a:spAutoFit/>
+          </a:bodyPr>
+          <a:lstStyle/>
+          <a:p>
+            <a:pPr algn="l"/>
+            <a:r>
+              <a:rPr sz="1300" b="1">
+                <a:solidFill>
+                  <a:srgbClr val="FFFFFF"/>
+                </a:solidFill>
+                <a:latin typeface="Arial"/>
+              </a:rPr>
+              <a:t>◆ 고찰 — 4. Discussion</a:t>
+            </a:r>
+          </a:p>
+        </p:txBody>
+      </p:sp>
+      <p:sp>
+        <p:nvSpPr>
+          <p:cNvPr id="6" name="TextBox 5"/>
+          <p:cNvSpPr txBox="1"/>
+          <p:nvPr/>
+        </p:nvSpPr>
+        <p:spPr>
+          <a:xfrm>
+            <a:off x="457200" y="5806440"/>
+            <a:ext cx="4736592" cy="3566160"/>
+          </a:xfrm>
+          <a:prstGeom prst="rect">
+            <a:avLst/>
+          </a:prstGeom>
+          <a:noFill/>
+        </p:spPr>
+        <p:txBody>
+          <a:bodyPr wrap="square" anchor="t">
+            <a:spAutoFit/>
+          </a:bodyPr>
+          <a:lstStyle/>
+          <a:p>
+            <a:pPr algn="l"/>
+            <a:r>
+              <a:rPr sz="1000" b="0">
+                <a:solidFill>
+                  <a:srgbClr val="D5D8EA"/>
+                </a:solidFill>
+                <a:latin typeface="Arial"/>
+              </a:rPr>
+              <a:t>· The prepared Bai-Min-NEs exhibited a uniform size distribution (droplet diameter &lt; 200 nm) and stable negative zeta potential.
+· Sub-micron particles are known to enhance skin penetration via intercellular and follicular routes, while surfactants within the nanoemulsion system disrupt stratum corneum lipid bilayers to improve transdermal delivery.
+· Although the negative surface charge limits non-specific adsorption, it supports colloidal stability and particle diffusion within the skin.
+· Specifically, the mathematical fitting confirmed a Super Case-II transport mechanism (n &gt; 0.89), verifying that the swelling-controlled matrix relaxation guarantees constant zero-order release kinetics, thereby preventing rapid local drug depletion.</a:t>
             </a:r>
           </a:p>
         </p:txBody>

</xml_diff>

<commit_message>
chore: daily content 2026-10-29
</commit_message>
<xml_diff>
--- a/pwa/data/latest/slides.pptx
+++ b/pwa/data/latest/slides.pptx
@@ -14,8 +14,6 @@
     <p:sldId id="262" r:id="rId14"/>
     <p:sldId id="263" r:id="rId15"/>
     <p:sldId id="264" r:id="rId16"/>
-    <p:sldId id="265" r:id="rId17"/>
-    <p:sldId id="266" r:id="rId18"/>
   </p:sldIdLst>
   <p:sldSz cx="5559552" cy="9875520" type="screen4x3"/>
   <p:notesSz cx="6858000" cy="9144000"/>
@@ -517,87 +515,12 @@
           </a:p>
           <a:p>
             <a:r>
-              <a:t>대본: 미녹시딜 오늘 나온 최신 연구를 정리했습니다</a:t>
+              <a:t>대본: 오늘의 논문 Biochemical and biophysical research communications에 실린 새 연구입니다</a:t>
             </a:r>
           </a:p>
           <a:p>
             <a:r>
               <a:t>연출 노트: 0.5초 안에 스크롤을 멈추게 하는 구간. 숫자를 크게 읽어준다.</a:t>
-            </a:r>
-          </a:p>
-        </p:txBody>
-      </p:sp>
-      <p:sp>
-        <p:nvSpPr>
-          <p:cNvPr id="4" name="Slide Number Placeholder 3"/>
-          <p:cNvSpPr>
-            <a:spLocks noGrp="1"/>
-          </p:cNvSpPr>
-          <p:nvPr>
-            <p:ph type="sldNum" idx="5" sz="quarter"/>
-          </p:nvPr>
-        </p:nvSpPr>
-        <p:spPr/>
-      </p:sp>
-    </p:spTree>
-  </p:cSld>
-  <p:clrMapOvr>
-    <a:masterClrMapping/>
-  </p:clrMapOvr>
-</p:notes>
-</file>
-
-<file path=ppt/notesSlides/notesSlide10.xml><?xml version="1.0" encoding="utf-8"?>
-<p:notes xmlns:a="http://schemas.openxmlformats.org/drawingml/2006/main" xmlns:p="http://schemas.openxmlformats.org/presentationml/2006/main" xmlns:r="http://schemas.openxmlformats.org/officeDocument/2006/relationships">
-  <p:cSld>
-    <p:spTree>
-      <p:nvGrpSpPr>
-        <p:cNvPr id="1" name=""/>
-        <p:cNvGrpSpPr/>
-        <p:nvPr/>
-      </p:nvGrpSpPr>
-      <p:grpSpPr>
-        <a:xfrm>
-          <a:off x="0" y="0"/>
-          <a:ext cx="0" cy="0"/>
-          <a:chOff x="0" y="0"/>
-          <a:chExt cx="0" cy="0"/>
-        </a:xfrm>
-      </p:grpSpPr>
-      <p:sp>
-        <p:nvSpPr>
-          <p:cNvPr id="2" name="Slide Image Placeholder 1"/>
-          <p:cNvSpPr>
-            <a:spLocks noGrp="1"/>
-          </p:cNvSpPr>
-          <p:nvPr>
-            <p:ph type="sldImg" idx="2"/>
-          </p:nvPr>
-        </p:nvSpPr>
-        <p:spPr/>
-      </p:sp>
-      <p:sp>
-        <p:nvSpPr>
-          <p:cNvPr id="3" name="Notes Placeholder 2"/>
-          <p:cNvSpPr>
-            <a:spLocks noGrp="1"/>
-          </p:cNvSpPr>
-          <p:nvPr>
-            <p:ph type="body" idx="3" sz="quarter"/>
-          </p:nvPr>
-        </p:nvSpPr>
-        <p:spPr/>
-        <p:txBody>
-          <a:bodyPr/>
-          <a:lstStyle/>
-          <a:p>
-            <a:r>
-              <a:t>편집 참고용 슬라이드입니다. 영상에는 쓰지 않아도 됩니다.</a:t>
-            </a:r>
-          </a:p>
-          <a:p>
-            <a:r>
-              <a:t>원문 영어 문장을 그대로 발췌했으므로 번역·검수 후 사용하세요.</a:t>
             </a:r>
           </a:p>
         </p:txBody>
@@ -672,7 +595,7 @@
           </a:p>
           <a:p>
             <a:r>
-              <a:t>대본: 《Pharmaceutics》 - Study on Construction of and Pharmacodynamics of Baicalin-Minoxidil Co-Loaded Nanogel</a:t>
+              <a:t>대본: 《Biochemical and biophysical research communications》 - Dermal papilla-derived BMP4 contributes to epithelial FOXP1-FGF18 signaling in human hair follicle cells</a:t>
             </a:r>
           </a:p>
           <a:p>
@@ -752,7 +675,7 @@
           </a:p>
           <a:p>
             <a:r>
-              <a:t>대본: Androgenetic alopecia (AGA) is a chronic and highly prevalent hair loss disorder for which current topical therapies are limited by undesirable side effects, dose-dependent efficacy, and poor skin penetration.</a:t>
+              <a:t>대본: Bone morphogenetic protein 4 (BMP4) has been implicated in hair follicle telogen maintenance, but its downstream mechanisms in human hair follicle cells remain incompletely understood.</a:t>
             </a:r>
           </a:p>
           <a:p>
@@ -827,17 +750,17 @@
           <a:lstStyle/>
           <a:p>
             <a:r>
-              <a:t>[paper_table] 약 8초</a:t>
-            </a:r>
-          </a:p>
-          <a:p>
-            <a:r>
-              <a:t>대본: 표로 보면 이렇습니다. In vitro release kinetic parameters and model fitting of Baicalin and Minoxidil from Bai-Min-NGs.</a:t>
-            </a:r>
-          </a:p>
-          <a:p>
-            <a:r>
-              <a:t>연출 노트: 핵심 숫자 한 칸만 짚어준다. 표는 셀을 직접 수정할 수 있다.</a:t>
+              <a:t>[key_finding_2] 약 10초</a:t>
+            </a:r>
+          </a:p>
+          <a:p>
+            <a:r>
+              <a:t>대본: We examined whether BMP4 regulates fibroblast growth factor 18 (FGF18) through FOXP1 in dermal papilla-epithelial signaling.</a:t>
+            </a:r>
+          </a:p>
+          <a:p>
+            <a:r>
+              <a:t>연출 노트: 핵심 포인트 2.</a:t>
             </a:r>
           </a:p>
         </p:txBody>
@@ -907,17 +830,17 @@
           <a:lstStyle/>
           <a:p>
             <a:r>
-              <a:t>[key_finding_2] 약 10초</a:t>
-            </a:r>
-          </a:p>
-          <a:p>
-            <a:r>
-              <a:t>대본: Objective: Here, we developed a baicalin-minoxidil co-loaded nanogel (Bai-Min-NGs) to synergistically enhance transdermal drug delivery and promote hair regeneration.</a:t>
-            </a:r>
-          </a:p>
-          <a:p>
-            <a:r>
-              <a:t>연출 노트: 핵심 포인트 2.</a:t>
+              <a:t>[my_take] 약 10초</a:t>
+            </a:r>
+          </a:p>
+          <a:p>
+            <a:r>
+              <a:t>대본: 탈모 연구, 매일 쉽게 정리해드립니다 🙂</a:t>
+            </a:r>
+          </a:p>
+          <a:p>
+            <a:r>
+              <a:t>연출 노트: 본인 사진 + 코멘트. 문구를 직접 바꿔 쓰세요.</a:t>
             </a:r>
           </a:p>
         </p:txBody>
@@ -987,17 +910,17 @@
           <a:lstStyle/>
           <a:p>
             <a:r>
-              <a:t>[my_take] 약 10초</a:t>
-            </a:r>
-          </a:p>
-          <a:p>
-            <a:r>
-              <a:t>대본: 탈모 연구, 매일 쉽게 정리해드립니다 🙂</a:t>
-            </a:r>
-          </a:p>
-          <a:p>
-            <a:r>
-              <a:t>연출 노트: 본인 사진 + 코멘트. 문구를 직접 바꿔 쓰세요.</a:t>
+              <a:t>[cta] 약 8초</a:t>
+            </a:r>
+          </a:p>
+          <a:p>
+            <a:r>
+              <a:t>대본: 더 자세한 내용은 원문 링크에서 확인하세요. 매일 새로운 탈모 연구, 팔로우하고 놓치지 마세요!</a:t>
+            </a:r>
+          </a:p>
+          <a:p>
+            <a:r>
+              <a:t>연출 노트: 원문 링크는 고정 댓글로 안내.</a:t>
             </a:r>
           </a:p>
         </p:txBody>
@@ -1067,17 +990,12 @@
           <a:lstStyle/>
           <a:p>
             <a:r>
-              <a:t>[cta] 약 8초</a:t>
-            </a:r>
-          </a:p>
-          <a:p>
-            <a:r>
-              <a:t>대본: 더 자세한 내용은 원문 링크에서 확인하세요. 매일 새로운 탈모 연구, 팔로우하고 놓치지 마세요!</a:t>
-            </a:r>
-          </a:p>
-          <a:p>
-            <a:r>
-              <a:t>연출 노트: 원문 링크는 고정 댓글로 안내.</a:t>
+              <a:t>편집 참고용 슬라이드입니다. 영상에는 쓰지 않아도 됩니다.</a:t>
+            </a:r>
+          </a:p>
+          <a:p>
+            <a:r>
+              <a:t>원문 영어 문장을 그대로 발췌했으므로 번역·검수 후 사용하세요.</a:t>
             </a:r>
           </a:p>
         </p:txBody>
@@ -1103,81 +1021,6 @@
 </file>
 
 <file path=ppt/notesSlides/notesSlide8.xml><?xml version="1.0" encoding="utf-8"?>
-<p:notes xmlns:a="http://schemas.openxmlformats.org/drawingml/2006/main" xmlns:p="http://schemas.openxmlformats.org/presentationml/2006/main" xmlns:r="http://schemas.openxmlformats.org/officeDocument/2006/relationships">
-  <p:cSld>
-    <p:spTree>
-      <p:nvGrpSpPr>
-        <p:cNvPr id="1" name=""/>
-        <p:cNvGrpSpPr/>
-        <p:nvPr/>
-      </p:nvGrpSpPr>
-      <p:grpSpPr>
-        <a:xfrm>
-          <a:off x="0" y="0"/>
-          <a:ext cx="0" cy="0"/>
-          <a:chOff x="0" y="0"/>
-          <a:chExt cx="0" cy="0"/>
-        </a:xfrm>
-      </p:grpSpPr>
-      <p:sp>
-        <p:nvSpPr>
-          <p:cNvPr id="2" name="Slide Image Placeholder 1"/>
-          <p:cNvSpPr>
-            <a:spLocks noGrp="1"/>
-          </p:cNvSpPr>
-          <p:nvPr>
-            <p:ph type="sldImg" idx="2"/>
-          </p:nvPr>
-        </p:nvSpPr>
-        <p:spPr/>
-      </p:sp>
-      <p:sp>
-        <p:nvSpPr>
-          <p:cNvPr id="3" name="Notes Placeholder 2"/>
-          <p:cNvSpPr>
-            <a:spLocks noGrp="1"/>
-          </p:cNvSpPr>
-          <p:nvPr>
-            <p:ph type="body" idx="3" sz="quarter"/>
-          </p:nvPr>
-        </p:nvSpPr>
-        <p:spPr/>
-        <p:txBody>
-          <a:bodyPr/>
-          <a:lstStyle/>
-          <a:p>
-            <a:r>
-              <a:t>편집 참고용 슬라이드입니다. 영상에는 쓰지 않아도 됩니다.</a:t>
-            </a:r>
-          </a:p>
-          <a:p>
-            <a:r>
-              <a:t>원문 영어 문장을 그대로 발췌했으므로 번역·검수 후 사용하세요.</a:t>
-            </a:r>
-          </a:p>
-        </p:txBody>
-      </p:sp>
-      <p:sp>
-        <p:nvSpPr>
-          <p:cNvPr id="4" name="Slide Number Placeholder 3"/>
-          <p:cNvSpPr>
-            <a:spLocks noGrp="1"/>
-          </p:cNvSpPr>
-          <p:nvPr>
-            <p:ph type="sldNum" idx="5" sz="quarter"/>
-          </p:nvPr>
-        </p:nvSpPr>
-        <p:spPr/>
-      </p:sp>
-    </p:spTree>
-  </p:cSld>
-  <p:clrMapOvr>
-    <a:masterClrMapping/>
-  </p:clrMapOvr>
-</p:notes>
-</file>
-
-<file path=ppt/notesSlides/notesSlide9.xml><?xml version="1.0" encoding="utf-8"?>
 <p:notes xmlns:a="http://schemas.openxmlformats.org/drawingml/2006/main" xmlns:p="http://schemas.openxmlformats.org/presentationml/2006/main" xmlns:r="http://schemas.openxmlformats.org/officeDocument/2006/relationships">
   <p:cSld>
     <p:spTree>
@@ -4271,7 +4114,7 @@
                 </a:solidFill>
                 <a:latin typeface="Arial"/>
               </a:rPr>
-              <a:t>PHARMACEUTICS</a:t>
+              <a:t>BIOCHEMICAL AND BIOPHYSICAL RESEARCH COM</a:t>
             </a:r>
           </a:p>
         </p:txBody>
@@ -4306,7 +4149,7 @@
                 </a:solidFill>
                 <a:latin typeface="Arial"/>
               </a:rPr>
-              <a:t>미녹시딜</a:t>
+              <a:t>오늘의 논문</a:t>
             </a:r>
           </a:p>
         </p:txBody>
@@ -4341,7 +4184,7 @@
                 </a:solidFill>
                 <a:latin typeface="Arial"/>
               </a:rPr>
-              <a:t>오늘 나온 최신 연구를 정리했습니다</a:t>
+              <a:t>Biochemical and biophysical research communications에 실린 새 연구입니다</a:t>
             </a:r>
           </a:p>
         </p:txBody>
@@ -4376,253 +4219,7 @@
                 </a:solidFill>
                 <a:latin typeface="Arial"/>
               </a:rPr>
-              <a:t>2026 Oct 15  |  매일 아침 탈모 연구 한 편</a:t>
-            </a:r>
-          </a:p>
-        </p:txBody>
-      </p:sp>
-    </p:spTree>
-  </p:cSld>
-  <p:clrMapOvr>
-    <a:masterClrMapping/>
-  </p:clrMapOvr>
-</p:sld>
-</file>
-
-<file path=ppt/slides/slide10.xml><?xml version="1.0" encoding="utf-8"?>
-<p:sld xmlns:a="http://schemas.openxmlformats.org/drawingml/2006/main" xmlns:p="http://schemas.openxmlformats.org/presentationml/2006/main" xmlns:r="http://schemas.openxmlformats.org/officeDocument/2006/relationships">
-  <p:cSld>
-    <p:bg>
-      <p:bgPr>
-        <a:solidFill>
-          <a:srgbClr val="12142A"/>
-        </a:solidFill>
-        <a:effectLst/>
-      </p:bgPr>
-    </p:bg>
-    <p:spTree>
-      <p:nvGrpSpPr>
-        <p:cNvPr id="1" name=""/>
-        <p:cNvGrpSpPr/>
-        <p:nvPr/>
-      </p:nvGrpSpPr>
-      <p:grpSpPr/>
-      <p:sp>
-        <p:nvSpPr>
-          <p:cNvPr id="2" name="TextBox 1"/>
-          <p:cNvSpPr txBox="1"/>
-          <p:nvPr/>
-        </p:nvSpPr>
-        <p:spPr>
-          <a:xfrm>
-            <a:off x="365760" y="457200"/>
-            <a:ext cx="4828032" cy="457200"/>
-          </a:xfrm>
-          <a:prstGeom prst="rect">
-            <a:avLst/>
-          </a:prstGeom>
-          <a:noFill/>
-        </p:spPr>
-        <p:txBody>
-          <a:bodyPr wrap="square" anchor="ctr">
-            <a:spAutoFit/>
-          </a:bodyPr>
-          <a:lstStyle/>
-          <a:p>
-            <a:pPr algn="l"/>
-            <a:r>
-              <a:rPr sz="1600" b="1">
-                <a:solidFill>
-                  <a:srgbClr val="FF6B6B"/>
-                </a:solidFill>
-                <a:latin typeface="Arial"/>
-              </a:rPr>
-              <a:t>본문 요약 (편집용)</a:t>
-            </a:r>
-          </a:p>
-        </p:txBody>
-      </p:sp>
-      <p:sp>
-        <p:nvSpPr>
-          <p:cNvPr id="3" name="TextBox 2"/>
-          <p:cNvSpPr txBox="1"/>
-          <p:nvPr/>
-        </p:nvSpPr>
-        <p:spPr>
-          <a:xfrm>
-            <a:off x="365760" y="1097280"/>
-            <a:ext cx="4828032" cy="457200"/>
-          </a:xfrm>
-          <a:prstGeom prst="rect">
-            <a:avLst/>
-          </a:prstGeom>
-          <a:noFill/>
-        </p:spPr>
-        <p:txBody>
-          <a:bodyPr wrap="square" anchor="t">
-            <a:spAutoFit/>
-          </a:bodyPr>
-          <a:lstStyle/>
-          <a:p>
-            <a:pPr algn="l"/>
-            <a:r>
-              <a:rPr sz="1300" b="1">
-                <a:solidFill>
-                  <a:srgbClr val="FFFFFF"/>
-                </a:solidFill>
-                <a:latin typeface="Arial"/>
-              </a:rPr>
-              <a:t>◆ 결론 — 5. Conclusions</a:t>
-            </a:r>
-          </a:p>
-        </p:txBody>
-      </p:sp>
-      <p:sp>
-        <p:nvSpPr>
-          <p:cNvPr id="4" name="TextBox 3"/>
-          <p:cNvSpPr txBox="1"/>
-          <p:nvPr/>
-        </p:nvSpPr>
-        <p:spPr>
-          <a:xfrm>
-            <a:off x="457200" y="1600200"/>
-            <a:ext cx="4736592" cy="3566160"/>
-          </a:xfrm>
-          <a:prstGeom prst="rect">
-            <a:avLst/>
-          </a:prstGeom>
-          <a:noFill/>
-        </p:spPr>
-        <p:txBody>
-          <a:bodyPr wrap="square" anchor="t">
-            <a:spAutoFit/>
-          </a:bodyPr>
-          <a:lstStyle/>
-          <a:p>
-            <a:pPr algn="l"/>
-            <a:r>
-              <a:rPr sz="1000" b="0">
-                <a:solidFill>
-                  <a:srgbClr val="D5D8EA"/>
-                </a:solidFill>
-                <a:latin typeface="Arial"/>
-              </a:rPr>
-              <a:t>· In summary, this study successfully developed a novel dual-drug-loaded nanogel delivery system: Bai-Min-NGs, providing a highly promising and innovative strategy to overcome the bottlenecks of poor transdermal permeability and low bioavailability associated with traditional topical treatments for AGA.
-· Leveraging the three-dimensional synergistic effect between the high-pressure homogenized nanoemulsion core and the gel network, Bai-Min-NGs effectively overcome the robust physical barrier of the stratum corneum.
-· This system not only achieves prolonged retention and controlled release of Baicalin and Minoxidil within the deep layers of the skin but also targets DPCs via efficient endocytic pathways.</a:t>
-            </a:r>
-          </a:p>
-        </p:txBody>
-      </p:sp>
-    </p:spTree>
-  </p:cSld>
-  <p:clrMapOvr>
-    <a:masterClrMapping/>
-  </p:clrMapOvr>
-</p:sld>
-</file>
-
-<file path=ppt/slides/slide11.xml><?xml version="1.0" encoding="utf-8"?>
-<p:sld xmlns:a="http://schemas.openxmlformats.org/drawingml/2006/main" xmlns:p="http://schemas.openxmlformats.org/presentationml/2006/main" xmlns:r="http://schemas.openxmlformats.org/officeDocument/2006/relationships">
-  <p:cSld>
-    <p:bg>
-      <p:bgPr>
-        <a:solidFill>
-          <a:srgbClr val="12142A"/>
-        </a:solidFill>
-        <a:effectLst/>
-      </p:bgPr>
-    </p:bg>
-    <p:spTree>
-      <p:nvGrpSpPr>
-        <p:cNvPr id="1" name=""/>
-        <p:cNvGrpSpPr/>
-        <p:nvPr/>
-      </p:nvGrpSpPr>
-      <p:grpSpPr/>
-      <p:sp>
-        <p:nvSpPr>
-          <p:cNvPr id="2" name="TextBox 1"/>
-          <p:cNvSpPr txBox="1"/>
-          <p:nvPr/>
-        </p:nvSpPr>
-        <p:spPr>
-          <a:xfrm>
-            <a:off x="365760" y="731520"/>
-            <a:ext cx="4828032" cy="548640"/>
-          </a:xfrm>
-          <a:prstGeom prst="rect">
-            <a:avLst/>
-          </a:prstGeom>
-          <a:noFill/>
-        </p:spPr>
-        <p:txBody>
-          <a:bodyPr wrap="square" anchor="ctr">
-            <a:spAutoFit/>
-          </a:bodyPr>
-          <a:lstStyle/>
-          <a:p>
-            <a:pPr algn="ctr"/>
-            <a:r>
-              <a:rPr sz="2200" b="1">
-                <a:solidFill>
-                  <a:srgbClr val="FF6B6B"/>
-                </a:solidFill>
-                <a:latin typeface="Arial"/>
-              </a:rPr>
-              <a:t>출처</a:t>
-            </a:r>
-          </a:p>
-        </p:txBody>
-      </p:sp>
-      <p:sp>
-        <p:nvSpPr>
-          <p:cNvPr id="3" name="TextBox 2"/>
-          <p:cNvSpPr txBox="1"/>
-          <p:nvPr/>
-        </p:nvSpPr>
-        <p:spPr>
-          <a:xfrm>
-            <a:off x="365760" y="1463040"/>
-            <a:ext cx="4828032" cy="7680960"/>
-          </a:xfrm>
-          <a:prstGeom prst="rect">
-            <a:avLst/>
-          </a:prstGeom>
-          <a:noFill/>
-        </p:spPr>
-        <p:txBody>
-          <a:bodyPr wrap="square" anchor="t">
-            <a:spAutoFit/>
-          </a:bodyPr>
-          <a:lstStyle/>
-          <a:p>
-            <a:pPr algn="l"/>
-            <a:r>
-              <a:rPr sz="1000" b="0">
-                <a:solidFill>
-                  <a:srgbClr val="D5D8EA"/>
-                </a:solidFill>
-                <a:latin typeface="Arial"/>
-              </a:rPr>
-              <a:t>[출처]
-논문: Study on Construction of and Pharmacodynamics of Baicalin-Minoxidil Co-Loaded Nanogel
-게재: Pharmaceutics
-원문: https://pubmed.ncbi.nlm.nih.gov/42942839/
-[이미지 출처]
-- Male pattern baldness.jpg / Originally uploaded by Lkinkade (Transferred by XenonX3) / CC BY-SA 2.5
-  https://commons.wikimedia.org/wiki/File:Male_pattern_baldness.jpg
-- Male-pattern hair loss.jpg / BlaiserPascal / CC BY-SA 4.0
-  https://commons.wikimedia.org/wiki/File:Male-pattern_hair_loss.jpg
-※ CC BY-SA 이미지가 포함되어 있습니다. 저작자 표시가 필수이며,
-  동일조건변경허락(ShareAlike) 조항이 영상 전체에 적용될 수 있으니
-  상업적 이용 시 해당 이미지를 교체하는 편이 안전합니다.
-[논문 본문 그림·표]
-- PubMed Central PMC13708190 (재사용 가능 라이선스)
-  https://www.ncbi.nlm.nih.gov/pmc/articles/PMC13708190/
-  · Table 1
-  ※ 오픈액세스 논문의 그림·표이며, 위 원문 출처를 함께 표기하세요.
-</a:t>
+              <a:t>2026 Oct 22  |  매일 아침 탈모 연구 한 편</a:t>
             </a:r>
           </a:p>
         </p:txBody>
@@ -4707,7 +4304,7 @@
                 </a:solidFill>
                 <a:latin typeface="Arial"/>
               </a:rPr>
-              <a:t>Study on Construction of and Pharmacodynamics of Baicalin-Minoxidil Co-Loaded Nanogel</a:t>
+              <a:t>Dermal papilla-derived BMP4 contributes to epithelial FOXP1-FGF18 signaling in human hair follicle cells</a:t>
             </a:r>
           </a:p>
         </p:txBody>
@@ -4742,7 +4339,7 @@
                 </a:solidFill>
                 <a:latin typeface="Arial"/>
               </a:rPr>
-              <a:t>Pharmaceutics  ·  2026 Oct 15</a:t>
+              <a:t>Biochemical and biophysical research communications  ·  2026 Oct 22</a:t>
             </a:r>
           </a:p>
         </p:txBody>
@@ -4871,7 +4468,7 @@
                 </a:solidFill>
                 <a:latin typeface="Arial"/>
               </a:rPr>
-              <a:t>Androgenetic alopecia (AGA) is a chronic and highly prevalent hair loss disorder for which current topical therapies are limited by undesirable side effects, dose-dependent efficacy, and poor skin penetration.</a:t>
+              <a:t>Bone morphogenetic protein 4 (BMP4) has been implicated in hair follicle telogen maintenance, but its downstream mechanisms in human hair follicle cells remain incompletely understood.</a:t>
             </a:r>
           </a:p>
         </p:txBody>
@@ -4885,480 +4482,6 @@
 </file>
 
 <file path=ppt/slides/slide4.xml><?xml version="1.0" encoding="utf-8"?>
-<p:sld xmlns:a="http://schemas.openxmlformats.org/drawingml/2006/main" xmlns:p="http://schemas.openxmlformats.org/presentationml/2006/main" xmlns:r="http://schemas.openxmlformats.org/officeDocument/2006/relationships">
-  <p:cSld>
-    <p:bg>
-      <p:bgPr>
-        <a:solidFill>
-          <a:srgbClr val="12142A"/>
-        </a:solidFill>
-        <a:effectLst/>
-      </p:bgPr>
-    </p:bg>
-    <p:spTree>
-      <p:nvGrpSpPr>
-        <p:cNvPr id="1" name=""/>
-        <p:cNvGrpSpPr/>
-        <p:nvPr/>
-      </p:nvGrpSpPr>
-      <p:grpSpPr/>
-      <p:sp>
-        <p:nvSpPr>
-          <p:cNvPr id="2" name="TextBox 1"/>
-          <p:cNvSpPr txBox="1"/>
-          <p:nvPr/>
-        </p:nvSpPr>
-        <p:spPr>
-          <a:xfrm>
-            <a:off x="365760" y="1097280"/>
-            <a:ext cx="4828032" cy="548640"/>
-          </a:xfrm>
-          <a:prstGeom prst="rect">
-            <a:avLst/>
-          </a:prstGeom>
-          <a:noFill/>
-        </p:spPr>
-        <p:txBody>
-          <a:bodyPr wrap="square" anchor="ctr">
-            <a:spAutoFit/>
-          </a:bodyPr>
-          <a:lstStyle/>
-          <a:p>
-            <a:pPr algn="ctr"/>
-            <a:r>
-              <a:rPr sz="2000" b="1">
-                <a:solidFill>
-                  <a:srgbClr val="FF6B6B"/>
-                </a:solidFill>
-                <a:latin typeface="Arial"/>
-              </a:rPr>
-              <a:t>논문 Table 1</a:t>
-            </a:r>
-          </a:p>
-        </p:txBody>
-      </p:sp>
-      <p:sp>
-        <p:nvSpPr>
-          <p:cNvPr id="3" name="TextBox 2"/>
-          <p:cNvSpPr txBox="1"/>
-          <p:nvPr/>
-        </p:nvSpPr>
-        <p:spPr>
-          <a:xfrm>
-            <a:off x="365760" y="1737360"/>
-            <a:ext cx="4828032" cy="914400"/>
-          </a:xfrm>
-          <a:prstGeom prst="rect">
-            <a:avLst/>
-          </a:prstGeom>
-          <a:noFill/>
-        </p:spPr>
-        <p:txBody>
-          <a:bodyPr wrap="square" anchor="ctr">
-            <a:spAutoFit/>
-          </a:bodyPr>
-          <a:lstStyle/>
-          <a:p>
-            <a:pPr algn="ctr"/>
-            <a:r>
-              <a:rPr sz="1300" b="0">
-                <a:solidFill>
-                  <a:srgbClr val="AAAFCD"/>
-                </a:solidFill>
-                <a:latin typeface="Arial"/>
-              </a:rPr>
-              <a:t>In vitro release kinetic parameters and model fitting of Baicalin and Minoxidil from Bai-Min-NGs.</a:t>
-            </a:r>
-          </a:p>
-        </p:txBody>
-      </p:sp>
-      <p:graphicFrame>
-        <p:nvGraphicFramePr>
-          <p:cNvPr id="4" name="Table 3"/>
-          <p:cNvGraphicFramePr>
-            <a:graphicFrameLocks noGrp="1"/>
-          </p:cNvGraphicFramePr>
-          <p:nvPr/>
-        </p:nvGraphicFramePr>
-        <p:xfrm>
-          <a:off x="320040" y="2926080"/>
-          <a:ext cx="4919472" cy="2514600"/>
-        </p:xfrm>
-        <a:graphic>
-          <a:graphicData uri="http://schemas.openxmlformats.org/drawingml/2006/table">
-            <a:tbl>
-              <a:tblPr firstRow="1" bandRow="1">
-                <a:tableStyleId>{5C22544A-7EE6-4342-B048-85BDC9FD1C3A}</a:tableStyleId>
-              </a:tblPr>
-              <a:tblGrid>
-                <a:gridCol w="1229868"/>
-                <a:gridCol w="1229868"/>
-                <a:gridCol w="1229868"/>
-                <a:gridCol w="1229868"/>
-              </a:tblGrid>
-              <a:tr h="502920">
-                <a:tc>
-                  <a:txBody>
-                    <a:bodyPr/>
-                    <a:lstStyle/>
-                    <a:p>
-                      <a:pPr>
-                        <a:defRPr sz="1200" b="1">
-                          <a:latin typeface="Arial"/>
-                        </a:defRPr>
-                      </a:pPr>
-                      <a:r>
-                        <a:t>Kinetic Models</a:t>
-                      </a:r>
-                    </a:p>
-                  </a:txBody>
-                  <a:tcPr/>
-                </a:tc>
-                <a:tc>
-                  <a:txBody>
-                    <a:bodyPr/>
-                    <a:lstStyle/>
-                    <a:p>
-                      <a:pPr>
-                        <a:defRPr sz="1200" b="1">
-                          <a:latin typeface="Arial"/>
-                        </a:defRPr>
-                      </a:pPr>
-                      <a:r>
-                        <a:t>Mathematical Equation</a:t>
-                      </a:r>
-                    </a:p>
-                  </a:txBody>
-                  <a:tcPr/>
-                </a:tc>
-                <a:tc>
-                  <a:txBody>
-                    <a:bodyPr/>
-                    <a:lstStyle/>
-                    <a:p>
-                      <a:pPr>
-                        <a:defRPr sz="1200" b="1">
-                          <a:latin typeface="Arial"/>
-                        </a:defRPr>
-                      </a:pPr>
-                      <a:r>
-                        <a:t>Active Drug</a:t>
-                      </a:r>
-                    </a:p>
-                  </a:txBody>
-                  <a:tcPr/>
-                </a:tc>
-                <a:tc>
-                  <a:txBody>
-                    <a:bodyPr/>
-                    <a:lstStyle/>
-                    <a:p>
-                      <a:pPr>
-                        <a:defRPr sz="1200" b="1">
-                          <a:latin typeface="Arial"/>
-                        </a:defRPr>
-                      </a:pPr>
-                      <a:r>
-                        <a:t>Fitted Equation</a:t>
-                      </a:r>
-                    </a:p>
-                  </a:txBody>
-                  <a:tcPr/>
-                </a:tc>
-              </a:tr>
-              <a:tr h="502920">
-                <a:tc>
-                  <a:txBody>
-                    <a:bodyPr/>
-                    <a:lstStyle/>
-                    <a:p>
-                      <a:pPr>
-                        <a:defRPr sz="1100" b="0">
-                          <a:latin typeface="Arial"/>
-                        </a:defRPr>
-                      </a:pPr>
-                      <a:r>
-                        <a:t>Zero -order</a:t>
-                      </a:r>
-                    </a:p>
-                  </a:txBody>
-                  <a:tcPr/>
-                </a:tc>
-                <a:tc>
-                  <a:txBody>
-                    <a:bodyPr/>
-                    <a:lstStyle/>
-                    <a:p>
-                      <a:pPr>
-                        <a:defRPr sz="1100" b="0">
-                          <a:latin typeface="Arial"/>
-                        </a:defRPr>
-                      </a:pPr>
-                      <a:r>
-                        <a:t>Q = k0·t + a</a:t>
-                      </a:r>
-                    </a:p>
-                  </a:txBody>
-                  <a:tcPr/>
-                </a:tc>
-                <a:tc>
-                  <a:txBody>
-                    <a:bodyPr/>
-                    <a:lstStyle/>
-                    <a:p>
-                      <a:pPr>
-                        <a:defRPr sz="1100" b="0">
-                          <a:latin typeface="Arial"/>
-                        </a:defRPr>
-                      </a:pPr>
-                      <a:r>
-                        <a:t>Min in NGsBai in NGs</a:t>
-                      </a:r>
-                    </a:p>
-                  </a:txBody>
-                  <a:tcPr/>
-                </a:tc>
-                <a:tc>
-                  <a:txBody>
-                    <a:bodyPr/>
-                    <a:lstStyle/>
-                    <a:p>
-                      <a:pPr>
-                        <a:defRPr sz="1100" b="0">
-                          <a:latin typeface="Arial"/>
-                        </a:defRPr>
-                      </a:pPr>
-                      <a:r>
-                        <a:t>Q = 3.9713t − 4.7891Q = 0.7751t − 0.6348</a:t>
-                      </a:r>
-                    </a:p>
-                  </a:txBody>
-                  <a:tcPr/>
-                </a:tc>
-              </a:tr>
-              <a:tr h="502920">
-                <a:tc>
-                  <a:txBody>
-                    <a:bodyPr/>
-                    <a:lstStyle/>
-                    <a:p>
-                      <a:pPr>
-                        <a:defRPr sz="1100" b="0">
-                          <a:latin typeface="Arial"/>
-                        </a:defRPr>
-                      </a:pPr>
-                      <a:r>
-                        <a:t>First-order model</a:t>
-                      </a:r>
-                    </a:p>
-                  </a:txBody>
-                  <a:tcPr/>
-                </a:tc>
-                <a:tc>
-                  <a:txBody>
-                    <a:bodyPr/>
-                    <a:lstStyle/>
-                    <a:p>
-                      <a:pPr>
-                        <a:defRPr sz="1100" b="0">
-                          <a:latin typeface="Arial"/>
-                        </a:defRPr>
-                      </a:pPr>
-                      <a:r>
-                        <a:t>ln(100 − Q) = −k1·t + a</a:t>
-                      </a:r>
-                    </a:p>
-                  </a:txBody>
-                  <a:tcPr/>
-                </a:tc>
-                <a:tc>
-                  <a:txBody>
-                    <a:bodyPr/>
-                    <a:lstStyle/>
-                    <a:p>
-                      <a:pPr>
-                        <a:defRPr sz="1100" b="0">
-                          <a:latin typeface="Arial"/>
-                        </a:defRPr>
-                      </a:pPr>
-                      <a:r>
-                        <a:t>Min in NGsBai in NGs</a:t>
-                      </a:r>
-                    </a:p>
-                  </a:txBody>
-                  <a:tcPr/>
-                </a:tc>
-                <a:tc>
-                  <a:txBody>
-                    <a:bodyPr/>
-                    <a:lstStyle/>
-                    <a:p>
-                      <a:pPr>
-                        <a:defRPr sz="1100" b="0">
-                          <a:latin typeface="Arial"/>
-                        </a:defRPr>
-                      </a:pPr>
-                      <a:r>
-                        <a:t>ln(100 − Q) = −0.1011t + 4.8715ln(100 − </a:t>
-                      </a:r>
-                    </a:p>
-                  </a:txBody>
-                  <a:tcPr/>
-                </a:tc>
-              </a:tr>
-              <a:tr h="502920">
-                <a:tc>
-                  <a:txBody>
-                    <a:bodyPr/>
-                    <a:lstStyle/>
-                    <a:p>
-                      <a:pPr>
-                        <a:defRPr sz="1100" b="0">
-                          <a:latin typeface="Arial"/>
-                        </a:defRPr>
-                      </a:pPr>
-                      <a:r>
-                        <a:t>Higuchi model</a:t>
-                      </a:r>
-                    </a:p>
-                  </a:txBody>
-                  <a:tcPr/>
-                </a:tc>
-                <a:tc>
-                  <a:txBody>
-                    <a:bodyPr/>
-                    <a:lstStyle/>
-                    <a:p>
-                      <a:pPr>
-                        <a:defRPr sz="1100" b="0">
-                          <a:latin typeface="Arial"/>
-                        </a:defRPr>
-                      </a:pPr>
-                      <a:r>
-                        <a:t>Q = kH·t1/2 + a</a:t>
-                      </a:r>
-                    </a:p>
-                  </a:txBody>
-                  <a:tcPr/>
-                </a:tc>
-                <a:tc>
-                  <a:txBody>
-                    <a:bodyPr/>
-                    <a:lstStyle/>
-                    <a:p>
-                      <a:pPr>
-                        <a:defRPr sz="1100" b="0">
-                          <a:latin typeface="Arial"/>
-                        </a:defRPr>
-                      </a:pPr>
-                      <a:r>
-                        <a:t>Min in NGsBai in NGs</a:t>
-                      </a:r>
-                    </a:p>
-                  </a:txBody>
-                  <a:tcPr/>
-                </a:tc>
-                <a:tc>
-                  <a:txBody>
-                    <a:bodyPr/>
-                    <a:lstStyle/>
-                    <a:p>
-                      <a:pPr>
-                        <a:defRPr sz="1100" b="0">
-                          <a:latin typeface="Arial"/>
-                        </a:defRPr>
-                      </a:pPr>
-                      <a:r>
-                        <a:t>Q = 19.7883t1/2 − 22.7026Q = 3.8855t1/2 </a:t>
-                      </a:r>
-                    </a:p>
-                  </a:txBody>
-                  <a:tcPr/>
-                </a:tc>
-              </a:tr>
-              <a:tr h="502920">
-                <a:tc>
-                  <a:txBody>
-                    <a:bodyPr/>
-                    <a:lstStyle/>
-                    <a:p>
-                      <a:pPr>
-                        <a:defRPr sz="1100" b="0">
-                          <a:latin typeface="Arial"/>
-                        </a:defRPr>
-                      </a:pPr>
-                      <a:r>
-                        <a:t>Korsmeyer-Peppas model(Mt/M∞ ≤ 0.60)</a:t>
-                      </a:r>
-                    </a:p>
-                  </a:txBody>
-                  <a:tcPr/>
-                </a:tc>
-                <a:tc>
-                  <a:txBody>
-                    <a:bodyPr/>
-                    <a:lstStyle/>
-                    <a:p>
-                      <a:pPr>
-                        <a:defRPr sz="1100" b="0">
-                          <a:latin typeface="Arial"/>
-                        </a:defRPr>
-                      </a:pPr>
-                      <a:r>
-                        <a:t>ln(Mt/M∞) = n·ln(t) + ln(kKP)</a:t>
-                      </a:r>
-                    </a:p>
-                  </a:txBody>
-                  <a:tcPr/>
-                </a:tc>
-                <a:tc>
-                  <a:txBody>
-                    <a:bodyPr/>
-                    <a:lstStyle/>
-                    <a:p>
-                      <a:pPr>
-                        <a:defRPr sz="1100" b="0">
-                          <a:latin typeface="Arial"/>
-                        </a:defRPr>
-                      </a:pPr>
-                      <a:r>
-                        <a:t>Min in NGsBai in NGs</a:t>
-                      </a:r>
-                    </a:p>
-                  </a:txBody>
-                  <a:tcPr/>
-                </a:tc>
-                <a:tc>
-                  <a:txBody>
-                    <a:bodyPr/>
-                    <a:lstStyle/>
-                    <a:p>
-                      <a:pPr>
-                        <a:defRPr sz="1100" b="0">
-                          <a:latin typeface="Arial"/>
-                        </a:defRPr>
-                      </a:pPr>
-                      <a:r>
-                        <a:t>ln(Mt/M∞) = 1.2429ln(t) − 4.1131ln(Mt/M∞</a:t>
-                      </a:r>
-                    </a:p>
-                  </a:txBody>
-                  <a:tcPr/>
-                </a:tc>
-              </a:tr>
-            </a:tbl>
-          </a:graphicData>
-        </a:graphic>
-      </p:graphicFrame>
-    </p:spTree>
-  </p:cSld>
-  <p:clrMapOvr>
-    <a:masterClrMapping/>
-  </p:clrMapOvr>
-</p:sld>
-</file>
-
-<file path=ppt/slides/slide5.xml><?xml version="1.0" encoding="utf-8"?>
 <p:sld xmlns:a="http://schemas.openxmlformats.org/drawingml/2006/main" xmlns:p="http://schemas.openxmlformats.org/presentationml/2006/main" xmlns:r="http://schemas.openxmlformats.org/officeDocument/2006/relationships">
   <p:cSld>
     <p:bg>
@@ -5474,7 +4597,7 @@
                 </a:solidFill>
                 <a:latin typeface="Arial"/>
               </a:rPr>
-              <a:t>Objective: Here, we developed a baicalin-minoxidil co-loaded nanogel (Bai-Min-NGs) to synergistically enhance transdermal drug delivery and promote hair regeneration.</a:t>
+              <a:t>We examined whether BMP4 regulates fibroblast growth factor 18 (FGF18) through FOXP1 in dermal papilla-epithelial signaling.</a:t>
             </a:r>
           </a:p>
         </p:txBody>
@@ -5487,7 +4610,7 @@
 </p:sld>
 </file>
 
-<file path=ppt/slides/slide6.xml><?xml version="1.0" encoding="utf-8"?>
+<file path=ppt/slides/slide5.xml><?xml version="1.0" encoding="utf-8"?>
 <p:sld xmlns:a="http://schemas.openxmlformats.org/drawingml/2006/main" xmlns:p="http://schemas.openxmlformats.org/presentationml/2006/main" xmlns:r="http://schemas.openxmlformats.org/officeDocument/2006/relationships">
   <p:cSld>
     <p:bg>
@@ -5616,7 +4739,7 @@
 </p:sld>
 </file>
 
-<file path=ppt/slides/slide7.xml><?xml version="1.0" encoding="utf-8"?>
+<file path=ppt/slides/slide6.xml><?xml version="1.0" encoding="utf-8"?>
 <p:sld xmlns:a="http://schemas.openxmlformats.org/drawingml/2006/main" xmlns:p="http://schemas.openxmlformats.org/presentationml/2006/main" xmlns:r="http://schemas.openxmlformats.org/officeDocument/2006/relationships">
   <p:cSld>
     <p:bg>
@@ -5665,6 +4788,207 @@
                 <a:latin typeface="Arial"/>
               </a:rPr>
               <a:t>더 자세한 내용은 원문 링크에서 확인하세요. 매일 새로운 탈모 연구, 팔로우하고 놓치지 마세요!</a:t>
+            </a:r>
+          </a:p>
+        </p:txBody>
+      </p:sp>
+    </p:spTree>
+  </p:cSld>
+  <p:clrMapOvr>
+    <a:masterClrMapping/>
+  </p:clrMapOvr>
+</p:sld>
+</file>
+
+<file path=ppt/slides/slide7.xml><?xml version="1.0" encoding="utf-8"?>
+<p:sld xmlns:a="http://schemas.openxmlformats.org/drawingml/2006/main" xmlns:p="http://schemas.openxmlformats.org/presentationml/2006/main" xmlns:r="http://schemas.openxmlformats.org/officeDocument/2006/relationships">
+  <p:cSld>
+    <p:bg>
+      <p:bgPr>
+        <a:solidFill>
+          <a:srgbClr val="12142A"/>
+        </a:solidFill>
+        <a:effectLst/>
+      </p:bgPr>
+    </p:bg>
+    <p:spTree>
+      <p:nvGrpSpPr>
+        <p:cNvPr id="1" name=""/>
+        <p:cNvGrpSpPr/>
+        <p:nvPr/>
+      </p:nvGrpSpPr>
+      <p:grpSpPr/>
+      <p:sp>
+        <p:nvSpPr>
+          <p:cNvPr id="2" name="TextBox 1"/>
+          <p:cNvSpPr txBox="1"/>
+          <p:nvPr/>
+        </p:nvSpPr>
+        <p:spPr>
+          <a:xfrm>
+            <a:off x="365760" y="457200"/>
+            <a:ext cx="4828032" cy="457200"/>
+          </a:xfrm>
+          <a:prstGeom prst="rect">
+            <a:avLst/>
+          </a:prstGeom>
+          <a:noFill/>
+        </p:spPr>
+        <p:txBody>
+          <a:bodyPr wrap="square" anchor="ctr">
+            <a:spAutoFit/>
+          </a:bodyPr>
+          <a:lstStyle/>
+          <a:p>
+            <a:pPr algn="l"/>
+            <a:r>
+              <a:rPr sz="1600" b="1">
+                <a:solidFill>
+                  <a:srgbClr val="FF6B6B"/>
+                </a:solidFill>
+                <a:latin typeface="Arial"/>
+              </a:rPr>
+              <a:t>본문 요약 (편집용)</a:t>
+            </a:r>
+          </a:p>
+        </p:txBody>
+      </p:sp>
+      <p:sp>
+        <p:nvSpPr>
+          <p:cNvPr id="3" name="TextBox 2"/>
+          <p:cNvSpPr txBox="1"/>
+          <p:nvPr/>
+        </p:nvSpPr>
+        <p:spPr>
+          <a:xfrm>
+            <a:off x="365760" y="1097280"/>
+            <a:ext cx="4828032" cy="457200"/>
+          </a:xfrm>
+          <a:prstGeom prst="rect">
+            <a:avLst/>
+          </a:prstGeom>
+          <a:noFill/>
+        </p:spPr>
+        <p:txBody>
+          <a:bodyPr wrap="square" anchor="t">
+            <a:spAutoFit/>
+          </a:bodyPr>
+          <a:lstStyle/>
+          <a:p>
+            <a:pPr algn="l"/>
+            <a:r>
+              <a:rPr sz="1300" b="1">
+                <a:solidFill>
+                  <a:srgbClr val="FFFFFF"/>
+                </a:solidFill>
+                <a:latin typeface="Arial"/>
+              </a:rPr>
+              <a:t>◆ 배경 — Background (자동 구분)</a:t>
+            </a:r>
+          </a:p>
+        </p:txBody>
+      </p:sp>
+      <p:sp>
+        <p:nvSpPr>
+          <p:cNvPr id="4" name="TextBox 3"/>
+          <p:cNvSpPr txBox="1"/>
+          <p:nvPr/>
+        </p:nvSpPr>
+        <p:spPr>
+          <a:xfrm>
+            <a:off x="457200" y="1600200"/>
+            <a:ext cx="4736592" cy="3566160"/>
+          </a:xfrm>
+          <a:prstGeom prst="rect">
+            <a:avLst/>
+          </a:prstGeom>
+          <a:noFill/>
+        </p:spPr>
+        <p:txBody>
+          <a:bodyPr wrap="square" anchor="t">
+            <a:spAutoFit/>
+          </a:bodyPr>
+          <a:lstStyle/>
+          <a:p>
+            <a:pPr algn="l"/>
+            <a:r>
+              <a:rPr sz="1000" b="0">
+                <a:solidFill>
+                  <a:srgbClr val="D5D8EA"/>
+                </a:solidFill>
+                <a:latin typeface="Arial"/>
+              </a:rPr>
+              <a:t>· Bone morphogenetic protein 4 (BMP4) has been implicated in hair follicle telogen maintenance, but its downstream mechanisms in human hair follicle cells remain incompletely understood.</a:t>
+            </a:r>
+          </a:p>
+        </p:txBody>
+      </p:sp>
+      <p:sp>
+        <p:nvSpPr>
+          <p:cNvPr id="5" name="TextBox 4"/>
+          <p:cNvSpPr txBox="1"/>
+          <p:nvPr/>
+        </p:nvSpPr>
+        <p:spPr>
+          <a:xfrm>
+            <a:off x="365760" y="5303520"/>
+            <a:ext cx="4828032" cy="457200"/>
+          </a:xfrm>
+          <a:prstGeom prst="rect">
+            <a:avLst/>
+          </a:prstGeom>
+          <a:noFill/>
+        </p:spPr>
+        <p:txBody>
+          <a:bodyPr wrap="square" anchor="t">
+            <a:spAutoFit/>
+          </a:bodyPr>
+          <a:lstStyle/>
+          <a:p>
+            <a:pPr algn="l"/>
+            <a:r>
+              <a:rPr sz="1300" b="1">
+                <a:solidFill>
+                  <a:srgbClr val="FFFFFF"/>
+                </a:solidFill>
+                <a:latin typeface="Arial"/>
+              </a:rPr>
+              <a:t>◆ 연구 방법 — Methods (자동 구분)</a:t>
+            </a:r>
+          </a:p>
+        </p:txBody>
+      </p:sp>
+      <p:sp>
+        <p:nvSpPr>
+          <p:cNvPr id="6" name="TextBox 5"/>
+          <p:cNvSpPr txBox="1"/>
+          <p:nvPr/>
+        </p:nvSpPr>
+        <p:spPr>
+          <a:xfrm>
+            <a:off x="457200" y="5806440"/>
+            <a:ext cx="4736592" cy="3566160"/>
+          </a:xfrm>
+          <a:prstGeom prst="rect">
+            <a:avLst/>
+          </a:prstGeom>
+          <a:noFill/>
+        </p:spPr>
+        <p:txBody>
+          <a:bodyPr wrap="square" anchor="t">
+            <a:spAutoFit/>
+          </a:bodyPr>
+          <a:lstStyle/>
+          <a:p>
+            <a:pPr algn="l"/>
+            <a:r>
+              <a:rPr sz="1000" b="0">
+                <a:solidFill>
+                  <a:srgbClr val="D5D8EA"/>
+                </a:solidFill>
+                <a:latin typeface="Arial"/>
+              </a:rPr>
+              <a:t>· We examined whether BMP4 regulates fibroblast growth factor 18 (FGF18) through FOXP1 in dermal papilla-epithelial signaling.</a:t>
             </a:r>
           </a:p>
         </p:txBody>
@@ -5760,7 +5084,7 @@
                 </a:solidFill>
                 <a:latin typeface="Arial"/>
               </a:rPr>
-              <a:t>◆ 배경 — 1. Introduction</a:t>
+              <a:t>◆ 주요 결과 — Results (자동 구분)</a:t>
             </a:r>
           </a:p>
         </p:txBody>
@@ -5795,81 +5119,13 @@
                 </a:solidFill>
                 <a:latin typeface="Arial"/>
               </a:rPr>
-              <a:t>· Androgenetic alopecia (AGA) is a pervasive dermatological condition affecting hundreds of millions of people worldwide, characterized by progressive follicular miniaturization and disrupted hair growth cycles.
-· Despite the availability of various therapeutic modalities, minoxidil (Min), the first-line clinical drug, still faces formidable challenges in practical application.
-· On one hand, commercially available formulations typically contain high concentrations of ethanol and propylene glycol, which frequently lead to severe allergic contact dermatitis and scalp dryness upon long-term use.</a:t>
-            </a:r>
-          </a:p>
-        </p:txBody>
-      </p:sp>
-      <p:sp>
-        <p:nvSpPr>
-          <p:cNvPr id="5" name="TextBox 4"/>
-          <p:cNvSpPr txBox="1"/>
-          <p:nvPr/>
-        </p:nvSpPr>
-        <p:spPr>
-          <a:xfrm>
-            <a:off x="365760" y="5303520"/>
-            <a:ext cx="4828032" cy="457200"/>
-          </a:xfrm>
-          <a:prstGeom prst="rect">
-            <a:avLst/>
-          </a:prstGeom>
-          <a:noFill/>
-        </p:spPr>
-        <p:txBody>
-          <a:bodyPr wrap="square" anchor="t">
-            <a:spAutoFit/>
-          </a:bodyPr>
-          <a:lstStyle/>
-          <a:p>
-            <a:pPr algn="l"/>
-            <a:r>
-              <a:rPr sz="1300" b="1">
-                <a:solidFill>
-                  <a:srgbClr val="FFFFFF"/>
-                </a:solidFill>
-                <a:latin typeface="Arial"/>
-              </a:rPr>
-              <a:t>◆ 연구 방법 — 2. Materials and Methods</a:t>
-            </a:r>
-          </a:p>
-        </p:txBody>
-      </p:sp>
-      <p:sp>
-        <p:nvSpPr>
-          <p:cNvPr id="6" name="TextBox 5"/>
-          <p:cNvSpPr txBox="1"/>
-          <p:nvPr/>
-        </p:nvSpPr>
-        <p:spPr>
-          <a:xfrm>
-            <a:off x="457200" y="5806440"/>
-            <a:ext cx="4736592" cy="3566160"/>
-          </a:xfrm>
-          <a:prstGeom prst="rect">
-            <a:avLst/>
-          </a:prstGeom>
-          <a:noFill/>
-        </p:spPr>
-        <p:txBody>
-          <a:bodyPr wrap="square" anchor="t">
-            <a:spAutoFit/>
-          </a:bodyPr>
-          <a:lstStyle/>
-          <a:p>
-            <a:pPr algn="l"/>
-            <a:r>
-              <a:rPr sz="1000" b="0">
-                <a:solidFill>
-                  <a:srgbClr val="D5D8EA"/>
-                </a:solidFill>
-                <a:latin typeface="Arial"/>
-              </a:rPr>
-              <a:t>· Cells were cultured in the medium supplemented with 10% fetal bovine serum (FBS) and 1% penicillin-streptomycin at 37 °C in a humidified atmosphere containing 5% CO2.
-· After treatment, cells were incubated with 50 μM LysoTracker Red DND-99 for 90 min to label lysosomes, followed by fixation with 4% paraformaldehyde for 15 min.
-· Statistical significance was defined as follows: ns, not significant; * p &lt; 0.05, ** p &lt; 0.01, *** p &lt; 0.001, and **** p &lt; 0.0001 (vs. model group); # p &lt; 0.05 and ## p &lt; 0.01 (vs. normal group).</a:t>
+              <a:t>· In immortalized human dermal papilla cells (iDPCs), cyclosporin A (CsA) decreased BMP4 expression and increased Noggin expression, and the NFAT inhibitor VIVIT produced similar effects.
+· CsA also reduced BMP4 protein levels in culture supernatants.
+· In immortalized human outer root sheath cells (iORSCs), BMP4 increased FGF18 and FOXP1 expression, with significant responses at concentrations as low as 0.1 ng/mL.
+· Noggin and the BMP type I receptor inhibitor LDN193189 suppressed these responses.
+· BMP4 induced Smad1 phosphorylation and increased FOXP1 protein levels, whereas FOXP1 knockdown prevented BMP4-induced FGF18 upregulation.
+· In primary human DPCs, CsA decreased BMP4 expression, and in primary human ORSCs, BMP4 increased FGF18 expression.
+· In Transwell co-culture, CsA pretreatment or BMP4 neutralization attenuated DPC-induced FGF18 and FOXP1 expression, whereas recombinant BMP4 significantly restored their expression.</a:t>
             </a:r>
           </a:p>
         </p:txBody>
@@ -5908,8 +5164,8 @@
         </p:nvSpPr>
         <p:spPr>
           <a:xfrm>
-            <a:off x="365760" y="457200"/>
-            <a:ext cx="4828032" cy="457200"/>
+            <a:off x="365760" y="731520"/>
+            <a:ext cx="4828032" cy="548640"/>
           </a:xfrm>
           <a:prstGeom prst="rect">
             <a:avLst/>
@@ -5922,15 +5178,15 @@
           </a:bodyPr>
           <a:lstStyle/>
           <a:p>
-            <a:pPr algn="l"/>
-            <a:r>
-              <a:rPr sz="1600" b="1">
+            <a:pPr algn="ctr"/>
+            <a:r>
+              <a:rPr sz="2200" b="1">
                 <a:solidFill>
                   <a:srgbClr val="FF6B6B"/>
                 </a:solidFill>
                 <a:latin typeface="Arial"/>
               </a:rPr>
-              <a:t>본문 요약 (편집용)</a:t>
+              <a:t>출처</a:t>
             </a:r>
           </a:p>
         </p:txBody>
@@ -5943,8 +5199,8 @@
         </p:nvSpPr>
         <p:spPr>
           <a:xfrm>
-            <a:off x="365760" y="1097280"/>
-            <a:ext cx="4828032" cy="457200"/>
+            <a:off x="365760" y="1463040"/>
+            <a:ext cx="4828032" cy="7680960"/>
           </a:xfrm>
           <a:prstGeom prst="rect">
             <a:avLst/>
@@ -5959,127 +5215,25 @@
           <a:p>
             <a:pPr algn="l"/>
             <a:r>
-              <a:rPr sz="1300" b="1">
-                <a:solidFill>
-                  <a:srgbClr val="FFFFFF"/>
-                </a:solidFill>
-                <a:latin typeface="Arial"/>
-              </a:rPr>
-              <a:t>◆ 주요 결과 — 3. Results</a:t>
-            </a:r>
-          </a:p>
-        </p:txBody>
-      </p:sp>
-      <p:sp>
-        <p:nvSpPr>
-          <p:cNvPr id="4" name="TextBox 3"/>
-          <p:cNvSpPr txBox="1"/>
-          <p:nvPr/>
-        </p:nvSpPr>
-        <p:spPr>
-          <a:xfrm>
-            <a:off x="457200" y="1600200"/>
-            <a:ext cx="4736592" cy="3566160"/>
-          </a:xfrm>
-          <a:prstGeom prst="rect">
-            <a:avLst/>
-          </a:prstGeom>
-          <a:noFill/>
-        </p:spPr>
-        <p:txBody>
-          <a:bodyPr wrap="square" anchor="t">
-            <a:spAutoFit/>
-          </a:bodyPr>
-          <a:lstStyle/>
-          <a:p>
-            <a:pPr algn="l"/>
-            <a:r>
               <a:rPr sz="1000" b="0">
                 <a:solidFill>
                   <a:srgbClr val="D5D8EA"/>
                 </a:solidFill>
                 <a:latin typeface="Arial"/>
               </a:rPr>
-              <a:t>· The measurement results demonstrated that Bai-Min-NEs possessed an average hydrodynamic diameter of 156 ± 3.62 nm, and the size distribution curve exhibited a symmetrical unimodal distribution, indicating a homogeneous dispersion of the system.
-· Regarding the drug-loading performance, the EE of Bai-Min-NEs for baicalin and minoxidil reached 95.863 ±1.338% and 82.158 ± 2.495%, respectively, which is beneficial for the subsequent drug delivery into the deep layers of the skin.
-· As shown in Figure 2A, the crude baicalin spectrum exhibited representative characteristic absorption peaks at 3490 cm−1, 3390 cm−1, 1661 cm−1 and 1609 cm−1, corresponding to intermolecular hydroxyl groups, free hydroxyl groups, C=C double bonds, and benzene ring C-H stretching vibrations, respectively.
-· The spectrum of minoxidil showed characteristic absorption peaks at 3411 cm−1 (-NH2), 1644 cm−1 (C=C) and 1555 cm−1 (C=N).
-· Furthermore, Korsmeyer–Peppas fitting yielded release exponents (n) of 1.2429 (R2 = 0.9200) for minoxidil and 1.4553 (R2 = 0.9875) for baicalin.
-· The combination index (CI) values across all tested concentrations remained well below 1.0 (ranging from 0.100 to 0.405), reaching 0.271 at the optimal concentration of 5.0 μg/mL.
-· (* p &lt; 0.05, ** p &lt; 0.01, *** p &lt; 0.001, and **** p &lt; 0.0001 (vs. model group); # p &lt; 0.05 and ## p &lt; 0.01 (vs. normal group)).</a:t>
-            </a:r>
-          </a:p>
-        </p:txBody>
-      </p:sp>
-      <p:sp>
-        <p:nvSpPr>
-          <p:cNvPr id="5" name="TextBox 4"/>
-          <p:cNvSpPr txBox="1"/>
-          <p:nvPr/>
-        </p:nvSpPr>
-        <p:spPr>
-          <a:xfrm>
-            <a:off x="365760" y="5303520"/>
-            <a:ext cx="4828032" cy="457200"/>
-          </a:xfrm>
-          <a:prstGeom prst="rect">
-            <a:avLst/>
-          </a:prstGeom>
-          <a:noFill/>
-        </p:spPr>
-        <p:txBody>
-          <a:bodyPr wrap="square" anchor="t">
-            <a:spAutoFit/>
-          </a:bodyPr>
-          <a:lstStyle/>
-          <a:p>
-            <a:pPr algn="l"/>
-            <a:r>
-              <a:rPr sz="1300" b="1">
-                <a:solidFill>
-                  <a:srgbClr val="FFFFFF"/>
-                </a:solidFill>
-                <a:latin typeface="Arial"/>
-              </a:rPr>
-              <a:t>◆ 고찰 — 4. Discussion</a:t>
-            </a:r>
-          </a:p>
-        </p:txBody>
-      </p:sp>
-      <p:sp>
-        <p:nvSpPr>
-          <p:cNvPr id="6" name="TextBox 5"/>
-          <p:cNvSpPr txBox="1"/>
-          <p:nvPr/>
-        </p:nvSpPr>
-        <p:spPr>
-          <a:xfrm>
-            <a:off x="457200" y="5806440"/>
-            <a:ext cx="4736592" cy="3566160"/>
-          </a:xfrm>
-          <a:prstGeom prst="rect">
-            <a:avLst/>
-          </a:prstGeom>
-          <a:noFill/>
-        </p:spPr>
-        <p:txBody>
-          <a:bodyPr wrap="square" anchor="t">
-            <a:spAutoFit/>
-          </a:bodyPr>
-          <a:lstStyle/>
-          <a:p>
-            <a:pPr algn="l"/>
-            <a:r>
-              <a:rPr sz="1000" b="0">
-                <a:solidFill>
-                  <a:srgbClr val="D5D8EA"/>
-                </a:solidFill>
-                <a:latin typeface="Arial"/>
-              </a:rPr>
-              <a:t>· The prepared Bai-Min-NEs exhibited a uniform size distribution (droplet diameter &lt; 200 nm) and stable negative zeta potential.
-· Sub-micron particles are known to enhance skin penetration via intercellular and follicular routes, while surfactants within the nanoemulsion system disrupt stratum corneum lipid bilayers to improve transdermal delivery.
-· Although the negative surface charge limits non-specific adsorption, it supports colloidal stability and particle diffusion within the skin.
-· Specifically, the mathematical fitting confirmed a Super Case-II transport mechanism (n &gt; 0.89), verifying that the swelling-controlled matrix relaxation guarantees constant zero-order release kinetics, thereby preventing rapid local drug depletion.</a:t>
+              <a:t>[출처]
+논문: Dermal papilla-derived BMP4 contributes to epithelial FOXP1-FGF18 signaling in human hair follicle cells
+게재: Biochemical and biophysical research communications
+원문: https://pubmed.ncbi.nlm.nih.gov/42945804/
+[이미지 출처]
+- Male pattern baldness.jpg / Originally uploaded by Lkinkade (Transferred by XenonX3) / CC BY-SA 2.5
+  https://commons.wikimedia.org/wiki/File:Male_pattern_baldness.jpg
+- Male-pattern hair loss.jpg / BlaiserPascal / CC BY-SA 4.0
+  https://commons.wikimedia.org/wiki/File:Male-pattern_hair_loss.jpg
+※ CC BY-SA 이미지가 포함되어 있습니다. 저작자 표시가 필수이며,
+  동일조건변경허락(ShareAlike) 조항이 영상 전체에 적용될 수 있으니
+  상업적 이용 시 해당 이미지를 교체하는 편이 안전합니다.
+</a:t>
             </a:r>
           </a:p>
         </p:txBody>

</xml_diff>

<commit_message>
chore: daily content 2026-10-30
</commit_message>
<xml_diff>
--- a/pwa/data/latest/slides.pptx
+++ b/pwa/data/latest/slides.pptx
@@ -515,7 +515,7 @@
           </a:p>
           <a:p>
             <a:r>
-              <a:t>대본: 오늘의 논문 Biochemical and biophysical research communications에 실린 새 연구입니다</a:t>
+              <a:t>대본: 원형탈모 오늘 나온 최신 연구를 정리했습니다</a:t>
             </a:r>
           </a:p>
           <a:p>
@@ -595,7 +595,7 @@
           </a:p>
           <a:p>
             <a:r>
-              <a:t>대본: 《Biochemical and biophysical research communications》 - Dermal papilla-derived BMP4 contributes to epithelial FOXP1-FGF18 signaling in human hair follicle cells</a:t>
+              <a:t>대본: 《International ophthalmology》 - Decreased superficial retinal microvascular density in alopecia areata: an OCT angiography study</a:t>
             </a:r>
           </a:p>
           <a:p>
@@ -675,7 +675,7 @@
           </a:p>
           <a:p>
             <a:r>
-              <a:t>대본: Bone morphogenetic protein 4 (BMP4) has been implicated in hair follicle telogen maintenance, but its downstream mechanisms in human hair follicle cells remain incompletely understood.</a:t>
+              <a:t>대본: Methods: This prospective study included 40 patients with newly diagnosed AA and 42 healthy controls.</a:t>
             </a:r>
           </a:p>
           <a:p>
@@ -755,7 +755,7 @@
           </a:p>
           <a:p>
             <a:r>
-              <a:t>대본: We examined whether BMP4 regulates fibroblast growth factor 18 (FGF18) through FOXP1 in dermal papilla-epithelial signaling.</a:t>
+              <a:t>대본: Results: VD-SCP was significantly reduced in the whole image (p = 0.001), parafoveal (p = 0.001), and perifoveal regions (p = 0.007) in patients with AA compared with controls.</a:t>
             </a:r>
           </a:p>
           <a:p>
@@ -4114,7 +4114,7 @@
                 </a:solidFill>
                 <a:latin typeface="Arial"/>
               </a:rPr>
-              <a:t>BIOCHEMICAL AND BIOPHYSICAL RESEARCH COM</a:t>
+              <a:t>INTERNATIONAL OPHTHALMOLOGY</a:t>
             </a:r>
           </a:p>
         </p:txBody>
@@ -4149,7 +4149,7 @@
                 </a:solidFill>
                 <a:latin typeface="Arial"/>
               </a:rPr>
-              <a:t>오늘의 논문</a:t>
+              <a:t>원형탈모</a:t>
             </a:r>
           </a:p>
         </p:txBody>
@@ -4184,7 +4184,7 @@
                 </a:solidFill>
                 <a:latin typeface="Arial"/>
               </a:rPr>
-              <a:t>Biochemical and biophysical research communications에 실린 새 연구입니다</a:t>
+              <a:t>오늘 나온 최신 연구를 정리했습니다</a:t>
             </a:r>
           </a:p>
         </p:txBody>
@@ -4219,7 +4219,7 @@
                 </a:solidFill>
                 <a:latin typeface="Arial"/>
               </a:rPr>
-              <a:t>2026 Oct 22  |  매일 아침 탈모 연구 한 편</a:t>
+              <a:t>2026 Oct 29  |  매일 아침 탈모 연구 한 편</a:t>
             </a:r>
           </a:p>
         </p:txBody>
@@ -4304,7 +4304,7 @@
                 </a:solidFill>
                 <a:latin typeface="Arial"/>
               </a:rPr>
-              <a:t>Dermal papilla-derived BMP4 contributes to epithelial FOXP1-FGF18 signaling in human hair follicle cells</a:t>
+              <a:t>Decreased superficial retinal microvascular density in alopecia areata: an OCT angiography study</a:t>
             </a:r>
           </a:p>
         </p:txBody>
@@ -4339,7 +4339,7 @@
                 </a:solidFill>
                 <a:latin typeface="Arial"/>
               </a:rPr>
-              <a:t>Biochemical and biophysical research communications  ·  2026 Oct 22</a:t>
+              <a:t>International ophthalmology  ·  2026 Oct 29</a:t>
             </a:r>
           </a:p>
         </p:txBody>
@@ -4468,7 +4468,7 @@
                 </a:solidFill>
                 <a:latin typeface="Arial"/>
               </a:rPr>
-              <a:t>Bone morphogenetic protein 4 (BMP4) has been implicated in hair follicle telogen maintenance, but its downstream mechanisms in human hair follicle cells remain incompletely understood.</a:t>
+              <a:t>Methods: This prospective study included 40 patients with newly diagnosed AA and 42 healthy controls.</a:t>
             </a:r>
           </a:p>
         </p:txBody>
@@ -4597,7 +4597,7 @@
                 </a:solidFill>
                 <a:latin typeface="Arial"/>
               </a:rPr>
-              <a:t>We examined whether BMP4 regulates fibroblast growth factor 18 (FGF18) through FOXP1 in dermal papilla-epithelial signaling.</a:t>
+              <a:t>Results: VD-SCP was significantly reduced in the whole image (p = 0.001), parafoveal (p = 0.001), and perifoveal regions (p = 0.007) in patients with AA compared with controls.</a:t>
             </a:r>
           </a:p>
         </p:txBody>
@@ -4883,7 +4883,7 @@
                 </a:solidFill>
                 <a:latin typeface="Arial"/>
               </a:rPr>
-              <a:t>◆ 배경 — Background (자동 구분)</a:t>
+              <a:t>◆ 배경 — Purpose</a:t>
             </a:r>
           </a:p>
         </p:txBody>
@@ -4918,7 +4918,8 @@
                 </a:solidFill>
                 <a:latin typeface="Arial"/>
               </a:rPr>
-              <a:t>· Bone morphogenetic protein 4 (BMP4) has been implicated in hair follicle telogen maintenance, but its downstream mechanisms in human hair follicle cells remain incompletely understood.</a:t>
+              <a:t>· This study aimed to evaluate retinal microvascular and structural changes in patients with alopecia areata (AA) using optical coherence tomography angiography (OCTA).
+· To our knowledge, retinal microvascular alterations have not been investigated via OCTA in AA before.</a:t>
             </a:r>
           </a:p>
         </p:txBody>
@@ -4953,7 +4954,7 @@
                 </a:solidFill>
                 <a:latin typeface="Arial"/>
               </a:rPr>
-              <a:t>◆ 연구 방법 — Methods (자동 구분)</a:t>
+              <a:t>◆ 연구 방법 — Methods</a:t>
             </a:r>
           </a:p>
         </p:txBody>
@@ -4988,7 +4989,8 @@
                 </a:solidFill>
                 <a:latin typeface="Arial"/>
               </a:rPr>
-              <a:t>· We examined whether BMP4 regulates fibroblast growth factor 18 (FGF18) through FOXP1 in dermal papilla-epithelial signaling.</a:t>
+              <a:t>· This prospective study included 40 patients with newly diagnosed AA and 42 healthy controls.
+· Superficial capillary plexus vessel densities (VD-SCP) and deep capillary plexus vessel densities (VD-DCP), choriocapillaris flow area, foveal avascular zone (FAZ), retinal nerve fiber layer (RNFL) thickness, optic disc vascular parameters, and central corneal thickness (CCT) were measured.</a:t>
             </a:r>
           </a:p>
         </p:txBody>
@@ -5084,7 +5086,7 @@
                 </a:solidFill>
                 <a:latin typeface="Arial"/>
               </a:rPr>
-              <a:t>◆ 주요 결과 — Results (자동 구분)</a:t>
+              <a:t>◆ 주요 결과 — Results</a:t>
             </a:r>
           </a:p>
         </p:txBody>
@@ -5119,13 +5121,83 @@
                 </a:solidFill>
                 <a:latin typeface="Arial"/>
               </a:rPr>
-              <a:t>· In immortalized human dermal papilla cells (iDPCs), cyclosporin A (CsA) decreased BMP4 expression and increased Noggin expression, and the NFAT inhibitor VIVIT produced similar effects.
-· CsA also reduced BMP4 protein levels in culture supernatants.
-· In immortalized human outer root sheath cells (iORSCs), BMP4 increased FGF18 and FOXP1 expression, with significant responses at concentrations as low as 0.1 ng/mL.
-· Noggin and the BMP type I receptor inhibitor LDN193189 suppressed these responses.
-· BMP4 induced Smad1 phosphorylation and increased FOXP1 protein levels, whereas FOXP1 knockdown prevented BMP4-induced FGF18 upregulation.
-· In primary human DPCs, CsA decreased BMP4 expression, and in primary human ORSCs, BMP4 increased FGF18 expression.
-· In Transwell co-culture, CsA pretreatment or BMP4 neutralization attenuated DPC-induced FGF18 and FOXP1 expression, whereas recombinant BMP4 significantly restored their expression.</a:t>
+              <a:t>· VD-SCP was significantly reduced in the whole image (p = 0.001), parafoveal (p = 0.001), and perifoveal regions (p = 0.007) in patients with AA compared with controls.
+· These differences remained significant after FDR correction (adjusted p = 0.011, 0.011, and 0.049, respectively).
+· However, foveal VD-SCP did not differ significantly (p = 0.221).
+· An unadjusted difference in inferior RNFL thickness (p = 0.044) did not remain statistically significant after FDR correction (adjusted p = 0.231), whereas global RNFL thickness showed no significant difference.
+· No significant differences were observed between groups in VD-DCP, FAZ area, choriocapillaris flow, optic disc vascular parameters, foveal thickness, or CCT (all p &gt; 0.05).</a:t>
+            </a:r>
+          </a:p>
+        </p:txBody>
+      </p:sp>
+      <p:sp>
+        <p:nvSpPr>
+          <p:cNvPr id="5" name="TextBox 4"/>
+          <p:cNvSpPr txBox="1"/>
+          <p:nvPr/>
+        </p:nvSpPr>
+        <p:spPr>
+          <a:xfrm>
+            <a:off x="365760" y="5303520"/>
+            <a:ext cx="4828032" cy="457200"/>
+          </a:xfrm>
+          <a:prstGeom prst="rect">
+            <a:avLst/>
+          </a:prstGeom>
+          <a:noFill/>
+        </p:spPr>
+        <p:txBody>
+          <a:bodyPr wrap="square" anchor="t">
+            <a:spAutoFit/>
+          </a:bodyPr>
+          <a:lstStyle/>
+          <a:p>
+            <a:pPr algn="l"/>
+            <a:r>
+              <a:rPr sz="1300" b="1">
+                <a:solidFill>
+                  <a:srgbClr val="FFFFFF"/>
+                </a:solidFill>
+                <a:latin typeface="Arial"/>
+              </a:rPr>
+              <a:t>◆ 결론 — Conclusion</a:t>
+            </a:r>
+          </a:p>
+        </p:txBody>
+      </p:sp>
+      <p:sp>
+        <p:nvSpPr>
+          <p:cNvPr id="6" name="TextBox 5"/>
+          <p:cNvSpPr txBox="1"/>
+          <p:nvPr/>
+        </p:nvSpPr>
+        <p:spPr>
+          <a:xfrm>
+            <a:off x="457200" y="5806440"/>
+            <a:ext cx="4736592" cy="3566160"/>
+          </a:xfrm>
+          <a:prstGeom prst="rect">
+            <a:avLst/>
+          </a:prstGeom>
+          <a:noFill/>
+        </p:spPr>
+        <p:txBody>
+          <a:bodyPr wrap="square" anchor="t">
+            <a:spAutoFit/>
+          </a:bodyPr>
+          <a:lstStyle/>
+          <a:p>
+            <a:pPr algn="l"/>
+            <a:r>
+              <a:rPr sz="1000" b="0">
+                <a:solidFill>
+                  <a:srgbClr val="D5D8EA"/>
+                </a:solidFill>
+                <a:latin typeface="Arial"/>
+              </a:rPr>
+              <a:t>· Patients with AA demonstrate reduced VD-SCP except in the foveal region, without evidence of widespread retinal or choroidal vascular impairment.
+· These findings suggest that AA may be associated with early subclinical alterations in retinal microcirculation.
+· OCTA may serve as a useful non-invasive tool for detecting subtle ocular microvascular changes in patients with AA.</a:t>
             </a:r>
           </a:p>
         </p:txBody>
@@ -5222,9 +5294,9 @@
                 <a:latin typeface="Arial"/>
               </a:rPr>
               <a:t>[출처]
-논문: Dermal papilla-derived BMP4 contributes to epithelial FOXP1-FGF18 signaling in human hair follicle cells
-게재: Biochemical and biophysical research communications
-원문: https://pubmed.ncbi.nlm.nih.gov/42945804/
+논문: Decreased superficial retinal microvascular density in alopecia areata: an OCT angiography study
+게재: International ophthalmology
+원문: https://pubmed.ncbi.nlm.nih.gov/42955436/
 [이미지 출처]
 - Male pattern baldness.jpg / Originally uploaded by Lkinkade (Transferred by XenonX3) / CC BY-SA 2.5
   https://commons.wikimedia.org/wiki/File:Male_pattern_baldness.jpg

</xml_diff>

<commit_message>
chore: daily content 2026-10-31
</commit_message>
<xml_diff>
--- a/pwa/data/latest/slides.pptx
+++ b/pwa/data/latest/slides.pptx
@@ -515,7 +515,7 @@
           </a:p>
           <a:p>
             <a:r>
-              <a:t>대본: 원형탈모 오늘 나온 최신 연구를 정리했습니다</a:t>
+              <a:t>대본: 오늘의 논문 Science advances에 실린 새 연구입니다</a:t>
             </a:r>
           </a:p>
           <a:p>
@@ -595,7 +595,7 @@
           </a:p>
           <a:p>
             <a:r>
-              <a:t>대본: 《International ophthalmology》 - Decreased superficial retinal microvascular density in alopecia areata: an OCT angiography study</a:t>
+              <a:t>대본: 《Science advances》 - Human hair-bearing skin organoids reveal cell type-specific susceptibility and innate immune responses to herpes simplex virus 1</a:t>
             </a:r>
           </a:p>
           <a:p>
@@ -675,7 +675,7 @@
           </a:p>
           <a:p>
             <a:r>
-              <a:t>대본: Methods: This prospective study included 40 patients with newly diagnosed AA and 42 healthy controls.</a:t>
+              <a:t>대본: Epithelial surfaces are the primary sites of lytic herpes simplex virus 1 (HSV-1) infection following initial exposure or reactivation from latency.</a:t>
             </a:r>
           </a:p>
           <a:p>
@@ -755,7 +755,7 @@
           </a:p>
           <a:p>
             <a:r>
-              <a:t>대본: Results: VD-SCP was significantly reduced in the whole image (p = 0.001), parafoveal (p = 0.001), and perifoveal regions (p = 0.007) in patients with AA compared with controls.</a:t>
+              <a:t>대본: Our data suggest delayed progression of the HSV-1 life cycle in epidermal keratinocytes and hair follicle cells compared to the dermis.</a:t>
             </a:r>
           </a:p>
           <a:p>
@@ -4114,7 +4114,7 @@
                 </a:solidFill>
                 <a:latin typeface="Arial"/>
               </a:rPr>
-              <a:t>INTERNATIONAL OPHTHALMOLOGY</a:t>
+              <a:t>SCIENCE ADVANCES</a:t>
             </a:r>
           </a:p>
         </p:txBody>
@@ -4149,7 +4149,7 @@
                 </a:solidFill>
                 <a:latin typeface="Arial"/>
               </a:rPr>
-              <a:t>원형탈모</a:t>
+              <a:t>오늘의 논문</a:t>
             </a:r>
           </a:p>
         </p:txBody>
@@ -4184,7 +4184,7 @@
                 </a:solidFill>
                 <a:latin typeface="Arial"/>
               </a:rPr>
-              <a:t>오늘 나온 최신 연구를 정리했습니다</a:t>
+              <a:t>Science advances에 실린 새 연구입니다</a:t>
             </a:r>
           </a:p>
         </p:txBody>
@@ -4219,7 +4219,7 @@
                 </a:solidFill>
                 <a:latin typeface="Arial"/>
               </a:rPr>
-              <a:t>2026 Oct 29  |  매일 아침 탈모 연구 한 편</a:t>
+              <a:t>2026 Oct 30  |  매일 아침 탈모 연구 한 편</a:t>
             </a:r>
           </a:p>
         </p:txBody>
@@ -4304,7 +4304,7 @@
                 </a:solidFill>
                 <a:latin typeface="Arial"/>
               </a:rPr>
-              <a:t>Decreased superficial retinal microvascular density in alopecia areata: an OCT angiography study</a:t>
+              <a:t>Human hair-bearing skin organoids reveal cell type-specific susceptibility and innate immune responses to herpes simplex virus 1</a:t>
             </a:r>
           </a:p>
         </p:txBody>
@@ -4339,7 +4339,7 @@
                 </a:solidFill>
                 <a:latin typeface="Arial"/>
               </a:rPr>
-              <a:t>International ophthalmology  ·  2026 Oct 29</a:t>
+              <a:t>Science advances  ·  2026 Oct 30</a:t>
             </a:r>
           </a:p>
         </p:txBody>
@@ -4468,7 +4468,7 @@
                 </a:solidFill>
                 <a:latin typeface="Arial"/>
               </a:rPr>
-              <a:t>Methods: This prospective study included 40 patients with newly diagnosed AA and 42 healthy controls.</a:t>
+              <a:t>Epithelial surfaces are the primary sites of lytic herpes simplex virus 1 (HSV-1) infection following initial exposure or reactivation from latency.</a:t>
             </a:r>
           </a:p>
         </p:txBody>
@@ -4597,7 +4597,7 @@
                 </a:solidFill>
                 <a:latin typeface="Arial"/>
               </a:rPr>
-              <a:t>Results: VD-SCP was significantly reduced in the whole image (p = 0.001), parafoveal (p = 0.001), and perifoveal regions (p = 0.007) in patients with AA compared with controls.</a:t>
+              <a:t>Our data suggest delayed progression of the HSV-1 life cycle in epidermal keratinocytes and hair follicle cells compared to the dermis.</a:t>
             </a:r>
           </a:p>
         </p:txBody>
@@ -4883,7 +4883,7 @@
                 </a:solidFill>
                 <a:latin typeface="Arial"/>
               </a:rPr>
-              <a:t>◆ 배경 — Purpose</a:t>
+              <a:t>◆ 배경 — Background (자동 구분)</a:t>
             </a:r>
           </a:p>
         </p:txBody>
@@ -4918,8 +4918,8 @@
                 </a:solidFill>
                 <a:latin typeface="Arial"/>
               </a:rPr>
-              <a:t>· This study aimed to evaluate retinal microvascular and structural changes in patients with alopecia areata (AA) using optical coherence tomography angiography (OCTA).
-· To our knowledge, retinal microvascular alterations have not been investigated via OCTA in AA before.</a:t>
+              <a:t>· Epithelial surfaces are the primary sites of lytic herpes simplex virus 1 (HSV-1) infection following initial exposure or reactivation from latency.
+· Our data suggest delayed progression of the HSV-1 life cycle in epidermal keratinocytes and hair follicle cells compared to the dermis.</a:t>
             </a:r>
           </a:p>
         </p:txBody>
@@ -4954,7 +4954,7 @@
                 </a:solidFill>
                 <a:latin typeface="Arial"/>
               </a:rPr>
-              <a:t>◆ 연구 방법 — Methods</a:t>
+              <a:t>◆ 연구 방법 — Methods (자동 구분)</a:t>
             </a:r>
           </a:p>
         </p:txBody>
@@ -4989,8 +4989,7 @@
                 </a:solidFill>
                 <a:latin typeface="Arial"/>
               </a:rPr>
-              <a:t>· This prospective study included 40 patients with newly diagnosed AA and 42 healthy controls.
-· Superficial capillary plexus vessel densities (VD-SCP) and deep capillary plexus vessel densities (VD-DCP), choriocapillaris flow area, foveal avascular zone (FAZ), retinal nerve fiber layer (RNFL) thickness, optic disc vascular parameters, and central corneal thickness (CCT) were measured.</a:t>
+              <a:t>· To model this complex environment, we used human hair-bearing skin organoids and combined single-cell spatial transcriptomics with imaging to map viral spread and host responses across skin architecture.</a:t>
             </a:r>
           </a:p>
         </p:txBody>
@@ -5086,7 +5085,7 @@
                 </a:solidFill>
                 <a:latin typeface="Arial"/>
               </a:rPr>
-              <a:t>◆ 주요 결과 — Results</a:t>
+              <a:t>◆ 주요 결과 — Results (자동 구분)</a:t>
             </a:r>
           </a:p>
         </p:txBody>
@@ -5121,11 +5120,11 @@
                 </a:solidFill>
                 <a:latin typeface="Arial"/>
               </a:rPr>
-              <a:t>· VD-SCP was significantly reduced in the whole image (p = 0.001), parafoveal (p = 0.001), and perifoveal regions (p = 0.007) in patients with AA compared with controls.
-· These differences remained significant after FDR correction (adjusted p = 0.011, 0.011, and 0.049, respectively).
-· However, foveal VD-SCP did not differ significantly (p = 0.221).
-· An unadjusted difference in inferior RNFL thickness (p = 0.044) did not remain statistically significant after FDR correction (adjusted p = 0.231), whereas global RNFL thickness showed no significant difference.
-· No significant differences were observed between groups in VD-DCP, FAZ area, choriocapillaris flow, optic disc vascular parameters, foveal thickness, or CCT (all p &gt; 0.05).</a:t>
+              <a:t>· Infection triggered spatially organized host responses, including induction of IER3 in papillary fibroblasts.
+· In basal keratinocytes, IRF3 was up-regulated in both infected and neighboring uninfected cells, consistent with paracrine activation of antiviral signaling.
+· Inflammatory responses were compartmentalized in a cell type-specific manner, with TNFSF9 (4-1BBL) induced in papillary fibroblasts and tumor necrosis factor-α (TNF-α) induced in keratinocytes.
+· Enzyme-linked immunosorbent assays confirmed secretion of these cytokines and the TNF-α-responsive chemokines CXCL2 and CXCL10.
+· CXCL2 expression was enriched in cells adjacent to TNF-α-expressing cells, highlighting spatial coordination of inflammatory signaling.</a:t>
             </a:r>
           </a:p>
         </p:txBody>
@@ -5160,7 +5159,7 @@
                 </a:solidFill>
                 <a:latin typeface="Arial"/>
               </a:rPr>
-              <a:t>◆ 결론 — Conclusion</a:t>
+              <a:t>◆ 결론 — Conclusion (자동 구분)</a:t>
             </a:r>
           </a:p>
         </p:txBody>
@@ -5195,9 +5194,7 @@
                 </a:solidFill>
                 <a:latin typeface="Arial"/>
               </a:rPr>
-              <a:t>· Patients with AA demonstrate reduced VD-SCP except in the foveal region, without evidence of widespread retinal or choroidal vascular impairment.
-· These findings suggest that AA may be associated with early subclinical alterations in retinal microcirculation.
-· OCTA may serve as a useful non-invasive tool for detecting subtle ocular microvascular changes in patients with AA.</a:t>
+              <a:t>· While interferon-β reduced viral replication, TNF-α and 4-1BBL did not, suggesting that their primary role is to orchestrate immune cell recruitment and activation.</a:t>
             </a:r>
           </a:p>
         </p:txBody>
@@ -5294,9 +5291,9 @@
                 <a:latin typeface="Arial"/>
               </a:rPr>
               <a:t>[출처]
-논문: Decreased superficial retinal microvascular density in alopecia areata: an OCT angiography study
-게재: International ophthalmology
-원문: https://pubmed.ncbi.nlm.nih.gov/42955436/
+논문: Human hair-bearing skin organoids reveal cell type-specific susceptibility and innate immune responses to herpes simplex virus 1
+게재: Science advances
+원문: https://pubmed.ncbi.nlm.nih.gov/42962008/
 [이미지 출처]
 - Male pattern baldness.jpg / Originally uploaded by Lkinkade (Transferred by XenonX3) / CC BY-SA 2.5
   https://commons.wikimedia.org/wiki/File:Male_pattern_baldness.jpg

</xml_diff>